<commit_message>
docs: clarify presentation conclusion and remove bullet markers
</commit_message>
<xml_diff>
--- a/docs/presentation/Sherlock_Review_16-10-2026.pptx
+++ b/docs/presentation/Sherlock_Review_16-10-2026.pptx
@@ -620,7 +620,7 @@
 </file>
 
 <file path=ppt/notesSlides/notesSlide11.xml><?xml version="1.0" encoding="utf-8"?>
-<p:notes xmlns:p="http://schemas.openxmlformats.org/presentationml/2006/main">
+<p:notes xmlns:a="http://schemas.openxmlformats.org/drawingml/2006/main" xmlns:p="http://schemas.openxmlformats.org/presentationml/2006/main">
   <p:cSld>
     <p:spTree>
       <p:nvGrpSpPr>
@@ -629,13 +629,13 @@
         <p:nvPr/>
       </p:nvGrpSpPr>
       <p:grpSpPr>
-        <a:xfrm xmlns:a="http://schemas.openxmlformats.org/drawingml/2006/main"/>
+        <a:xfrm/>
       </p:grpSpPr>
       <p:sp>
         <p:nvSpPr>
           <p:cNvPr id="2" name="Slide Image Placeholder 1"/>
           <p:cNvSpPr>
-            <a:spLocks xmlns:a="http://schemas.openxmlformats.org/drawingml/2006/main" noGrp="1"/>
+            <a:spLocks noGrp="1"/>
           </p:cNvSpPr>
           <p:nvPr>
             <p:ph type="sldImg" idx="0"/>
@@ -647,7 +647,7 @@
         <p:nvSpPr>
           <p:cNvPr id="3" name="Notes Placeholder 2"/>
           <p:cNvSpPr>
-            <a:spLocks xmlns:a="http://schemas.openxmlformats.org/drawingml/2006/main" noGrp="1"/>
+            <a:spLocks noGrp="1"/>
           </p:cNvSpPr>
           <p:nvPr>
             <p:ph type="body" idx="1"/>
@@ -655,39 +655,39 @@
         </p:nvSpPr>
         <p:spPr/>
         <p:txBody>
-          <a:bodyPr xmlns:a="http://schemas.openxmlformats.org/drawingml/2006/main"/>
-          <a:lstStyle xmlns:a="http://schemas.openxmlformats.org/drawingml/2006/main"/>
-          <a:p xmlns:a="http://schemas.openxmlformats.org/drawingml/2006/main">
+          <a:bodyPr/>
+          <a:lstStyle/>
+          <a:p>
             <a:r>
               <a:t>Moayed · 25 Sekunden</a:t>
             </a:r>
           </a:p>
-          <a:p xmlns:a="http://schemas.openxmlformats.org/drawingml/2006/main">
+          <a:p>
             <a:r>
               <a:t/>
             </a:r>
           </a:p>
-          <a:p xmlns:a="http://schemas.openxmlformats.org/drawingml/2006/main">
-            <a:r>
-              <a:t>Unser Zwischenstand ist ein trainierter und lauffähiger Agent, der sich Informationen merkt und mehrere Netzbewertungen kombiniert. Gegen default ist er auf unserem Benchmark stark, gegen Solution_92 ist noch Luft nach oben. Als Nächstes wollen wir gezielt die frühen Entscheidungen verbessern und sauber auf neuen Karten prüfen. Vielen Dank – wir freuen uns auf eure Fragen.</a:t>
-            </a:r>
-          </a:p>
-          <a:p xmlns:a="http://schemas.openxmlformats.org/drawingml/2006/main">
+          <a:p>
+            <a:r>
+              <a:t>Sherlock verbindet ein Gedächtnis für die Karte mit sechs trainierten Netzen. Auf unserem Benchmark gewinnen wir alle 60 Spiele gegen default und 28 von 60 gegen Solution_92. Gegen den stärkeren Gegner bleibt also Verbesserungspotenzial. Als Nächstes wollen wir die frühe Erkundung verbessern und auf neuen Karten prüfen. Vielen Dank – welche Fragen habt ihr?</a:t>
+            </a:r>
+          </a:p>
+          <a:p>
             <a:r>
               <a:t/>
             </a:r>
           </a:p>
-          <a:p xmlns:a="http://schemas.openxmlformats.org/drawingml/2006/main">
+          <a:p>
             <a:r>
               <a:t>Quellen / Nachweise (Repository, Stand 14.10.2026):</a:t>
             </a:r>
           </a:p>
-          <a:p xmlns:a="http://schemas.openxmlformats.org/drawingml/2006/main">
+          <a:p>
             <a:r>
               <a:t>README.md</a:t>
             </a:r>
           </a:p>
-          <a:p xmlns:a="http://schemas.openxmlformats.org/drawingml/2006/main">
+          <a:p>
             <a:r>
               <a:t>docs/EXPERIMENT_PROTOKOLL.md</a:t>
             </a:r>
@@ -698,7 +698,7 @@
         <p:nvSpPr>
           <p:cNvPr id="4" name="Slide Number Placeholder 3"/>
           <p:cNvSpPr>
-            <a:spLocks xmlns:a="http://schemas.openxmlformats.org/drawingml/2006/main" noGrp="1"/>
+            <a:spLocks noGrp="1"/>
           </p:cNvSpPr>
           <p:nvPr>
             <p:ph type="sldNum" idx="5"/>
@@ -706,15 +706,15 @@
         </p:nvSpPr>
         <p:spPr/>
         <p:txBody>
-          <a:bodyPr xmlns:a="http://schemas.openxmlformats.org/drawingml/2006/main"/>
-          <a:lstStyle xmlns:a="http://schemas.openxmlformats.org/drawingml/2006/main"/>
-          <a:p xmlns:a="http://schemas.openxmlformats.org/drawingml/2006/main"/>
+          <a:bodyPr/>
+          <a:lstStyle/>
+          <a:p/>
         </p:txBody>
       </p:sp>
     </p:spTree>
   </p:cSld>
   <p:clrMapOvr>
-    <a:masterClrMapping xmlns:a="http://schemas.openxmlformats.org/drawingml/2006/main"/>
+    <a:masterClrMapping/>
   </p:clrMapOvr>
 </p:notes>
 </file>
@@ -5910,9 +5910,11 @@
           </a:ln>
         </p:spPr>
         <p:txBody>
-          <a:bodyPr/>
+          <a:bodyPr>
+            <a:noAutofit/>
+          </a:bodyPr>
           <a:lstStyle>
-            <a:defPPr>
+            <a:defPPr algn="l">
               <a:defRPr sz="4275" b="1">
                 <a:solidFill>
                   <a:srgbClr val="FFFFFF"/>
@@ -5924,7 +5926,14 @@
             </a:defPPr>
           </a:lstStyle>
           <a:p>
-            <a:pPr>
+            <a:pPr marL="0" indent="0" algn="l">
+              <a:spcBef>
+                <a:spcPts val="0"/>
+              </a:spcBef>
+              <a:spcAft>
+                <a:spcPts val="0"/>
+              </a:spcAft>
+              <a:buNone/>
               <a:defRPr sz="4275" b="1">
                 <a:solidFill>
                   <a:srgbClr val="FFFFFF"/>
@@ -5943,7 +5952,7 @@
                 <a:ea typeface="Helvetica Neue"/>
                 <a:cs typeface="Helvetica Neue"/>
               </a:rPr>
-              <a:t>Merken. Bewerten. Handeln.</a:t>
+              <a:t>Gedächtnis + sechs Netze</a:t>
             </a:r>
           </a:p>
         </p:txBody>
@@ -5981,7 +5990,7 @@
           </a:bodyPr>
           <a:lstStyle>
             <a:defPPr algn="l">
-              <a:defRPr sz="2400" b="0">
+              <a:defRPr sz="2250" b="0">
                 <a:solidFill>
                   <a:srgbClr val="B7D8D0"/>
                 </a:solidFill>
@@ -5992,11 +6001,44 @@
             </a:defPPr>
           </a:lstStyle>
           <a:p>
-            <a:pPr marL="228600" indent="-152400" algn="l">
+            <a:pPr marL="0" indent="0" algn="l">
+              <a:spcBef>
+                <a:spcPts val="0"/>
+              </a:spcBef>
               <a:spcAft>
-                <a:spcPts val="500"/>
+                <a:spcPts val="0"/>
               </a:spcAft>
-              <a:buChar char="•"/>
+              <a:buNone/>
+              <a:defRPr sz="2250" b="0">
+                <a:solidFill>
+                  <a:srgbClr val="B7D8D0"/>
+                </a:solidFill>
+                <a:latin typeface="Helvetica Neue"/>
+                <a:ea typeface="Helvetica Neue"/>
+                <a:cs typeface="Helvetica Neue"/>
+              </a:defRPr>
+            </a:pPr>
+            <a:r>
+              <a:rPr sz="2250">
+                <a:solidFill>
+                  <a:srgbClr val="B7D8D0"/>
+                </a:solidFill>
+                <a:latin typeface="Helvetica Neue"/>
+                <a:ea typeface="Helvetica Neue"/>
+                <a:cs typeface="Helvetica Neue"/>
+              </a:rPr>
+              <a:t>Im Benchmark: 60/60 Siege gegen default, 28/60 gegen Solution_92.</a:t>
+            </a:r>
+          </a:p>
+          <a:p>
+            <a:pPr marL="0" indent="0" algn="l">
+              <a:spcBef>
+                <a:spcPts val="0"/>
+              </a:spcBef>
+              <a:spcAft>
+                <a:spcPts val="0"/>
+              </a:spcAft>
+              <a:buNone/>
               <a:defRPr sz="2400" b="0">
                 <a:solidFill>
                   <a:srgbClr val="B7D8D0"/>
@@ -6007,69 +6049,37 @@
               </a:defRPr>
             </a:pPr>
             <a:r>
-              <a:rPr sz="2400">
+              <a:t/>
+            </a:r>
+          </a:p>
+          <a:p>
+            <a:pPr marL="0" indent="0" algn="l">
+              <a:spcBef>
+                <a:spcPts val="0"/>
+              </a:spcBef>
+              <a:spcAft>
+                <a:spcPts val="0"/>
+              </a:spcAft>
+              <a:buNone/>
+              <a:defRPr sz="2250" b="0">
                 <a:solidFill>
                   <a:srgbClr val="B7D8D0"/>
                 </a:solidFill>
                 <a:latin typeface="Helvetica Neue"/>
                 <a:ea typeface="Helvetica Neue"/>
                 <a:cs typeface="Helvetica Neue"/>
+              </a:defRPr>
+            </a:pPr>
+            <a:r>
+              <a:rPr sz="2250">
+                <a:solidFill>
+                  <a:srgbClr val="B7D8D0"/>
+                </a:solidFill>
+                <a:latin typeface="Helvetica Neue"/>
+                <a:ea typeface="Helvetica Neue"/>
+                <a:cs typeface="Helvetica Neue"/>
               </a:rPr>
-              <a:t>Trainierter Agent</a:t>
-            </a:r>
-          </a:p>
-          <a:p>
-            <a:pPr marL="228600" indent="-152400" algn="l">
-              <a:spcAft>
-                <a:spcPts val="500"/>
-              </a:spcAft>
-              <a:buChar char="•"/>
-              <a:defRPr sz="2400" b="0">
-                <a:solidFill>
-                  <a:srgbClr val="B7D8D0"/>
-                </a:solidFill>
-                <a:latin typeface="Helvetica Neue"/>
-                <a:ea typeface="Helvetica Neue"/>
-                <a:cs typeface="Helvetica Neue"/>
-              </a:defRPr>
-            </a:pPr>
-            <a:r>
-              <a:rPr sz="2400">
-                <a:solidFill>
-                  <a:srgbClr val="B7D8D0"/>
-                </a:solidFill>
-                <a:latin typeface="Helvetica Neue"/>
-                <a:ea typeface="Helvetica Neue"/>
-                <a:cs typeface="Helvetica Neue"/>
-              </a:rPr>
-              <a:t>Nachvollziehbare Auswertung</a:t>
-            </a:r>
-          </a:p>
-          <a:p>
-            <a:pPr marL="228600" indent="-152400" algn="l">
-              <a:spcAft>
-                <a:spcPts val="500"/>
-              </a:spcAft>
-              <a:buChar char="•"/>
-              <a:defRPr sz="2400" b="0">
-                <a:solidFill>
-                  <a:srgbClr val="B7D8D0"/>
-                </a:solidFill>
-                <a:latin typeface="Helvetica Neue"/>
-                <a:ea typeface="Helvetica Neue"/>
-                <a:cs typeface="Helvetica Neue"/>
-              </a:defRPr>
-            </a:pPr>
-            <a:r>
-              <a:rPr sz="2400">
-                <a:solidFill>
-                  <a:srgbClr val="B7D8D0"/>
-                </a:solidFill>
-                <a:latin typeface="Helvetica Neue"/>
-                <a:ea typeface="Helvetica Neue"/>
-                <a:cs typeface="Helvetica Neue"/>
-              </a:rPr>
-              <a:t>Klarer nächster Schritt</a:t>
+              <a:t>Nächster Schritt: Frühe Erkundung verbessern und neue Testkarten nutzen.</a:t>
             </a:r>
           </a:p>
         </p:txBody>
@@ -12678,11 +12688,14 @@
             </a:defPPr>
           </a:lstStyle>
           <a:p>
-            <a:pPr marL="228600" indent="-152400" algn="l">
+            <a:pPr marL="0" indent="0" algn="l">
+              <a:spcBef>
+                <a:spcPts val="0"/>
+              </a:spcBef>
               <a:spcAft>
                 <a:spcPts val="0"/>
               </a:spcAft>
-              <a:buChar char="•"/>
+              <a:buNone/>
               <a:defRPr sz="2400" b="1">
                 <a:solidFill>
                   <a:srgbClr val="102D35"/>
@@ -12701,7 +12714,37 @@
                 <a:ea typeface="Helvetica Neue"/>
                 <a:cs typeface="Helvetica Neue"/>
               </a:rPr>
-              <a:t>60 / 60 Siege gegen default</a:t>
+              <a:t>60 / 60 Siege</a:t>
+            </a:r>
+          </a:p>
+          <a:p>
+            <a:pPr marL="0" indent="0" algn="l">
+              <a:spcBef>
+                <a:spcPts val="0"/>
+              </a:spcBef>
+              <a:spcAft>
+                <a:spcPts val="0"/>
+              </a:spcAft>
+              <a:buNone/>
+              <a:defRPr sz="2400" b="1">
+                <a:solidFill>
+                  <a:srgbClr val="102D35"/>
+                </a:solidFill>
+                <a:latin typeface="Helvetica Neue"/>
+                <a:ea typeface="Helvetica Neue"/>
+                <a:cs typeface="Helvetica Neue"/>
+              </a:defRPr>
+            </a:pPr>
+            <a:r>
+              <a:rPr sz="2400" b="1">
+                <a:solidFill>
+                  <a:srgbClr val="102D35"/>
+                </a:solidFill>
+                <a:latin typeface="Helvetica Neue"/>
+                <a:ea typeface="Helvetica Neue"/>
+                <a:cs typeface="Helvetica Neue"/>
+              </a:rPr>
+              <a:t>gegen default</a:t>
             </a:r>
           </a:p>
         </p:txBody>
@@ -12750,11 +12793,14 @@
             </a:defPPr>
           </a:lstStyle>
           <a:p>
-            <a:pPr marL="228600" indent="-152400" algn="l">
+            <a:pPr marL="0" indent="0" algn="l">
+              <a:spcBef>
+                <a:spcPts val="0"/>
+              </a:spcBef>
               <a:spcAft>
                 <a:spcPts val="0"/>
               </a:spcAft>
-              <a:buChar char="•"/>
+              <a:buNone/>
               <a:defRPr sz="2400" b="1">
                 <a:solidFill>
                   <a:srgbClr val="102D35"/>
@@ -12773,7 +12819,37 @@
                 <a:ea typeface="Helvetica Neue"/>
                 <a:cs typeface="Helvetica Neue"/>
               </a:rPr>
-              <a:t>28 / 60 Siege gegen Solution_92</a:t>
+              <a:t>28 / 60 Siege</a:t>
+            </a:r>
+          </a:p>
+          <a:p>
+            <a:pPr marL="0" indent="0" algn="l">
+              <a:spcBef>
+                <a:spcPts val="0"/>
+              </a:spcBef>
+              <a:spcAft>
+                <a:spcPts val="0"/>
+              </a:spcAft>
+              <a:buNone/>
+              <a:defRPr sz="2400" b="1">
+                <a:solidFill>
+                  <a:srgbClr val="102D35"/>
+                </a:solidFill>
+                <a:latin typeface="Helvetica Neue"/>
+                <a:ea typeface="Helvetica Neue"/>
+                <a:cs typeface="Helvetica Neue"/>
+              </a:defRPr>
+            </a:pPr>
+            <a:r>
+              <a:rPr sz="2400" b="1">
+                <a:solidFill>
+                  <a:srgbClr val="102D35"/>
+                </a:solidFill>
+                <a:latin typeface="Helvetica Neue"/>
+                <a:ea typeface="Helvetica Neue"/>
+                <a:cs typeface="Helvetica Neue"/>
+              </a:rPr>
+              <a:t>gegen Solution_92</a:t>
             </a:r>
           </a:p>
         </p:txBody>
@@ -12822,11 +12898,14 @@
             </a:defPPr>
           </a:lstStyle>
           <a:p>
-            <a:pPr marL="228600" indent="-152400" algn="l">
+            <a:pPr marL="0" indent="0" algn="l">
+              <a:spcBef>
+                <a:spcPts val="0"/>
+              </a:spcBef>
               <a:spcAft>
                 <a:spcPts val="0"/>
               </a:spcAft>
-              <a:buChar char="•"/>
+              <a:buNone/>
               <a:defRPr sz="1800" b="0">
                 <a:solidFill>
                   <a:srgbClr val="526B70"/>
@@ -13376,11 +13455,14 @@
             </a:defPPr>
           </a:lstStyle>
           <a:p>
-            <a:pPr marL="228600" indent="-152400" algn="l">
+            <a:pPr marL="0" indent="0" algn="l">
+              <a:spcBef>
+                <a:spcPts val="0"/>
+              </a:spcBef>
               <a:spcAft>
-                <a:spcPts val="800"/>
+                <a:spcPts val="0"/>
               </a:spcAft>
-              <a:buChar char="•"/>
+              <a:buNone/>
               <a:defRPr sz="2025" b="1">
                 <a:solidFill>
                   <a:srgbClr val="007D7B"/>
@@ -13403,11 +13485,14 @@
             </a:r>
           </a:p>
           <a:p>
-            <a:pPr marL="228600" indent="-152400" algn="l">
+            <a:pPr marL="0" indent="0" algn="l">
+              <a:spcBef>
+                <a:spcPts val="0"/>
+              </a:spcBef>
               <a:spcAft>
-                <a:spcPts val="800"/>
+                <a:spcPts val="0"/>
               </a:spcAft>
-              <a:buChar char="•"/>
+              <a:buNone/>
               <a:defRPr sz="2025" b="1">
                 <a:solidFill>
                   <a:srgbClr val="007D7B"/>
@@ -13475,11 +13560,14 @@
             </a:defPPr>
           </a:lstStyle>
           <a:p>
-            <a:pPr marL="228600" indent="-152400" algn="l">
+            <a:pPr marL="0" indent="0" algn="l">
+              <a:spcBef>
+                <a:spcPts val="0"/>
+              </a:spcBef>
               <a:spcAft>
-                <a:spcPts val="1200"/>
+                <a:spcPts val="0"/>
               </a:spcAft>
-              <a:buChar char="•"/>
+              <a:buNone/>
               <a:defRPr sz="2025" b="0">
                 <a:solidFill>
                   <a:srgbClr val="102D35"/>
@@ -13498,15 +13586,18 @@
                 <a:ea typeface="Helvetica Neue"/>
                 <a:cs typeface="Helvetica Neue"/>
               </a:rPr>
-              <a:t>Blaue Einheiten besetzen Punktefelder</a:t>
+              <a:t>Blaue Einheiten</a:t>
             </a:r>
           </a:p>
           <a:p>
-            <a:pPr marL="228600" indent="-152400" algn="l">
+            <a:pPr marL="0" indent="0" algn="l">
+              <a:spcBef>
+                <a:spcPts val="0"/>
+              </a:spcBef>
               <a:spcAft>
-                <a:spcPts val="1200"/>
+                <a:spcPts val="0"/>
               </a:spcAft>
-              <a:buChar char="•"/>
+              <a:buNone/>
               <a:defRPr sz="2025" b="0">
                 <a:solidFill>
                   <a:srgbClr val="102D35"/>
@@ -13525,7 +13616,89 @@
                 <a:ea typeface="Helvetica Neue"/>
                 <a:cs typeface="Helvetica Neue"/>
               </a:rPr>
-              <a:t>Stehenbleiben kann sinnvoll sein</a:t>
+              <a:t>besetzen Punktefelder.</a:t>
+            </a:r>
+          </a:p>
+          <a:p>
+            <a:pPr marL="0" indent="0" algn="l">
+              <a:spcBef>
+                <a:spcPts val="0"/>
+              </a:spcBef>
+              <a:spcAft>
+                <a:spcPts val="0"/>
+              </a:spcAft>
+              <a:buNone/>
+              <a:defRPr sz="2025" b="0">
+                <a:solidFill>
+                  <a:srgbClr val="102D35"/>
+                </a:solidFill>
+                <a:latin typeface="Helvetica Neue"/>
+                <a:ea typeface="Helvetica Neue"/>
+                <a:cs typeface="Helvetica Neue"/>
+              </a:defRPr>
+            </a:pPr>
+            <a:r>
+              <a:t/>
+            </a:r>
+          </a:p>
+          <a:p>
+            <a:pPr marL="0" indent="0" algn="l">
+              <a:spcBef>
+                <a:spcPts val="0"/>
+              </a:spcBef>
+              <a:spcAft>
+                <a:spcPts val="0"/>
+              </a:spcAft>
+              <a:buNone/>
+              <a:defRPr sz="2025" b="0">
+                <a:solidFill>
+                  <a:srgbClr val="102D35"/>
+                </a:solidFill>
+                <a:latin typeface="Helvetica Neue"/>
+                <a:ea typeface="Helvetica Neue"/>
+                <a:cs typeface="Helvetica Neue"/>
+              </a:defRPr>
+            </a:pPr>
+            <a:r>
+              <a:rPr sz="2025">
+                <a:solidFill>
+                  <a:srgbClr val="102D35"/>
+                </a:solidFill>
+                <a:latin typeface="Helvetica Neue"/>
+                <a:ea typeface="Helvetica Neue"/>
+                <a:cs typeface="Helvetica Neue"/>
+              </a:rPr>
+              <a:t>Stehenbleiben kann</a:t>
+            </a:r>
+          </a:p>
+          <a:p>
+            <a:pPr marL="0" indent="0" algn="l">
+              <a:spcBef>
+                <a:spcPts val="0"/>
+              </a:spcBef>
+              <a:spcAft>
+                <a:spcPts val="0"/>
+              </a:spcAft>
+              <a:buNone/>
+              <a:defRPr sz="2025" b="0">
+                <a:solidFill>
+                  <a:srgbClr val="102D35"/>
+                </a:solidFill>
+                <a:latin typeface="Helvetica Neue"/>
+                <a:ea typeface="Helvetica Neue"/>
+                <a:cs typeface="Helvetica Neue"/>
+              </a:defRPr>
+            </a:pPr>
+            <a:r>
+              <a:rPr sz="2025">
+                <a:solidFill>
+                  <a:srgbClr val="102D35"/>
+                </a:solidFill>
+                <a:latin typeface="Helvetica Neue"/>
+                <a:ea typeface="Helvetica Neue"/>
+                <a:cs typeface="Helvetica Neue"/>
+              </a:rPr>
+              <a:t>sinnvoll sein.</a:t>
             </a:r>
           </a:p>
         </p:txBody>

</xml_diff>

<commit_message>
docs: use centered dash bullets in presentation
</commit_message>
<xml_diff>
--- a/docs/presentation/Sherlock_Review_16-10-2026.pptx
+++ b/docs/presentation/Sherlock_Review_16-10-2026.pptx
@@ -6001,14 +6001,12 @@
             </a:defPPr>
           </a:lstStyle>
           <a:p>
-            <a:pPr marL="0" indent="0" algn="l">
-              <a:spcBef>
-                <a:spcPts val="0"/>
-              </a:spcBef>
+            <a:pPr marL="330200" indent="-254000" algn="l">
               <a:spcAft>
-                <a:spcPts val="0"/>
+                <a:spcPts val="1600"/>
               </a:spcAft>
-              <a:buNone/>
+              <a:buFont typeface="Helvetica Neue"/>
+              <a:buChar char="–"/>
               <a:defRPr sz="2250" b="0">
                 <a:solidFill>
                   <a:srgbClr val="B7D8D0"/>
@@ -6031,36 +6029,12 @@
             </a:r>
           </a:p>
           <a:p>
-            <a:pPr marL="0" indent="0" algn="l">
-              <a:spcBef>
-                <a:spcPts val="0"/>
-              </a:spcBef>
+            <a:pPr marL="330200" indent="-254000" algn="l">
               <a:spcAft>
-                <a:spcPts val="0"/>
+                <a:spcPts val="1600"/>
               </a:spcAft>
-              <a:buNone/>
-              <a:defRPr sz="2400" b="0">
-                <a:solidFill>
-                  <a:srgbClr val="B7D8D0"/>
-                </a:solidFill>
-                <a:latin typeface="Helvetica Neue"/>
-                <a:ea typeface="Helvetica Neue"/>
-                <a:cs typeface="Helvetica Neue"/>
-              </a:defRPr>
-            </a:pPr>
-            <a:r>
-              <a:t/>
-            </a:r>
-          </a:p>
-          <a:p>
-            <a:pPr marL="0" indent="0" algn="l">
-              <a:spcBef>
-                <a:spcPts val="0"/>
-              </a:spcBef>
-              <a:spcAft>
-                <a:spcPts val="0"/>
-              </a:spcAft>
-              <a:buNone/>
+              <a:buFont typeface="Helvetica Neue"/>
+              <a:buChar char="–"/>
               <a:defRPr sz="2250" b="0">
                 <a:solidFill>
                   <a:srgbClr val="B7D8D0"/>
@@ -8102,11 +8076,12 @@
             </a:defPPr>
           </a:lstStyle>
           <a:p>
-            <a:pPr marL="228600" indent="-152400" algn="l">
+            <a:pPr marL="330200" indent="-254000" algn="l">
               <a:spcAft>
                 <a:spcPts val="800"/>
               </a:spcAft>
-              <a:buChar char="•"/>
+              <a:buFont typeface="Helvetica Neue"/>
+              <a:buChar char="–"/>
               <a:defRPr sz="2400" b="1">
                 <a:solidFill>
                   <a:srgbClr val="102D35"/>
@@ -8129,11 +8104,12 @@
             </a:r>
           </a:p>
           <a:p>
-            <a:pPr marL="228600" indent="-152400" algn="l">
+            <a:pPr marL="330200" indent="-254000" algn="l">
               <a:spcAft>
                 <a:spcPts val="800"/>
               </a:spcAft>
-              <a:buChar char="•"/>
+              <a:buFont typeface="Helvetica Neue"/>
+              <a:buChar char="–"/>
               <a:defRPr sz="2400" b="1">
                 <a:solidFill>
                   <a:srgbClr val="102D35"/>
@@ -8201,11 +8177,12 @@
             </a:defPPr>
           </a:lstStyle>
           <a:p>
-            <a:pPr marL="228600" indent="-152400" algn="l">
+            <a:pPr marL="330200" indent="-254000" algn="l">
               <a:spcAft>
                 <a:spcPts val="800"/>
               </a:spcAft>
-              <a:buChar char="•"/>
+              <a:buFont typeface="Helvetica Neue"/>
+              <a:buChar char="–"/>
               <a:defRPr sz="2175" b="0">
                 <a:solidFill>
                   <a:srgbClr val="526B70"/>
@@ -8228,11 +8205,12 @@
             </a:r>
           </a:p>
           <a:p>
-            <a:pPr marL="228600" indent="-152400" algn="l">
+            <a:pPr marL="330200" indent="-254000" algn="l">
               <a:spcAft>
                 <a:spcPts val="800"/>
               </a:spcAft>
-              <a:buChar char="•"/>
+              <a:buFont typeface="Helvetica Neue"/>
+              <a:buChar char="–"/>
               <a:defRPr sz="2175" b="0">
                 <a:solidFill>
                   <a:srgbClr val="526B70"/>
@@ -8255,11 +8233,12 @@
             </a:r>
           </a:p>
           <a:p>
-            <a:pPr marL="228600" indent="-152400" algn="l">
+            <a:pPr marL="330200" indent="-254000" algn="l">
               <a:spcAft>
                 <a:spcPts val="800"/>
               </a:spcAft>
-              <a:buChar char="•"/>
+              <a:buFont typeface="Helvetica Neue"/>
+              <a:buChar char="–"/>
               <a:defRPr sz="2175" b="0">
                 <a:solidFill>
                   <a:srgbClr val="526B70"/>
@@ -8327,11 +8306,12 @@
             </a:defPPr>
           </a:lstStyle>
           <a:p>
-            <a:pPr marL="228600" indent="-152400" algn="l">
+            <a:pPr marL="330200" indent="-254000" algn="l">
               <a:spcAft>
                 <a:spcPts val="0"/>
               </a:spcAft>
-              <a:buChar char="•"/>
+              <a:buFont typeface="Helvetica Neue"/>
+              <a:buChar char="–"/>
               <a:defRPr sz="2175" b="1">
                 <a:solidFill>
                   <a:srgbClr val="007D7B"/>
@@ -12688,14 +12668,12 @@
             </a:defPPr>
           </a:lstStyle>
           <a:p>
-            <a:pPr marL="0" indent="0" algn="l">
-              <a:spcBef>
-                <a:spcPts val="0"/>
-              </a:spcBef>
+            <a:pPr marL="330200" indent="-254000" algn="l">
               <a:spcAft>
                 <a:spcPts val="0"/>
               </a:spcAft>
-              <a:buNone/>
+              <a:buFont typeface="Helvetica Neue"/>
+              <a:buChar char="–"/>
               <a:defRPr sz="2400" b="1">
                 <a:solidFill>
                   <a:srgbClr val="102D35"/>
@@ -12714,37 +12692,7 @@
                 <a:ea typeface="Helvetica Neue"/>
                 <a:cs typeface="Helvetica Neue"/>
               </a:rPr>
-              <a:t>60 / 60 Siege</a:t>
-            </a:r>
-          </a:p>
-          <a:p>
-            <a:pPr marL="0" indent="0" algn="l">
-              <a:spcBef>
-                <a:spcPts val="0"/>
-              </a:spcBef>
-              <a:spcAft>
-                <a:spcPts val="0"/>
-              </a:spcAft>
-              <a:buNone/>
-              <a:defRPr sz="2400" b="1">
-                <a:solidFill>
-                  <a:srgbClr val="102D35"/>
-                </a:solidFill>
-                <a:latin typeface="Helvetica Neue"/>
-                <a:ea typeface="Helvetica Neue"/>
-                <a:cs typeface="Helvetica Neue"/>
-              </a:defRPr>
-            </a:pPr>
-            <a:r>
-              <a:rPr sz="2400" b="1">
-                <a:solidFill>
-                  <a:srgbClr val="102D35"/>
-                </a:solidFill>
-                <a:latin typeface="Helvetica Neue"/>
-                <a:ea typeface="Helvetica Neue"/>
-                <a:cs typeface="Helvetica Neue"/>
-              </a:rPr>
-              <a:t>gegen default</a:t>
+              <a:t>60 / 60 Siege gegen default</a:t>
             </a:r>
           </a:p>
         </p:txBody>
@@ -12793,14 +12741,12 @@
             </a:defPPr>
           </a:lstStyle>
           <a:p>
-            <a:pPr marL="0" indent="0" algn="l">
-              <a:spcBef>
-                <a:spcPts val="0"/>
-              </a:spcBef>
+            <a:pPr marL="330200" indent="-254000" algn="l">
               <a:spcAft>
                 <a:spcPts val="0"/>
               </a:spcAft>
-              <a:buNone/>
+              <a:buFont typeface="Helvetica Neue"/>
+              <a:buChar char="–"/>
               <a:defRPr sz="2400" b="1">
                 <a:solidFill>
                   <a:srgbClr val="102D35"/>
@@ -12819,37 +12765,7 @@
                 <a:ea typeface="Helvetica Neue"/>
                 <a:cs typeface="Helvetica Neue"/>
               </a:rPr>
-              <a:t>28 / 60 Siege</a:t>
-            </a:r>
-          </a:p>
-          <a:p>
-            <a:pPr marL="0" indent="0" algn="l">
-              <a:spcBef>
-                <a:spcPts val="0"/>
-              </a:spcBef>
-              <a:spcAft>
-                <a:spcPts val="0"/>
-              </a:spcAft>
-              <a:buNone/>
-              <a:defRPr sz="2400" b="1">
-                <a:solidFill>
-                  <a:srgbClr val="102D35"/>
-                </a:solidFill>
-                <a:latin typeface="Helvetica Neue"/>
-                <a:ea typeface="Helvetica Neue"/>
-                <a:cs typeface="Helvetica Neue"/>
-              </a:defRPr>
-            </a:pPr>
-            <a:r>
-              <a:rPr sz="2400" b="1">
-                <a:solidFill>
-                  <a:srgbClr val="102D35"/>
-                </a:solidFill>
-                <a:latin typeface="Helvetica Neue"/>
-                <a:ea typeface="Helvetica Neue"/>
-                <a:cs typeface="Helvetica Neue"/>
-              </a:rPr>
-              <a:t>gegen Solution_92</a:t>
+              <a:t>28 / 60 Siege gegen Solution_92</a:t>
             </a:r>
           </a:p>
         </p:txBody>
@@ -13455,14 +13371,12 @@
             </a:defPPr>
           </a:lstStyle>
           <a:p>
-            <a:pPr marL="0" indent="0" algn="l">
-              <a:spcBef>
-                <a:spcPts val="0"/>
-              </a:spcBef>
+            <a:pPr marL="330200" indent="-254000" algn="l">
               <a:spcAft>
-                <a:spcPts val="0"/>
+                <a:spcPts val="800"/>
               </a:spcAft>
-              <a:buNone/>
+              <a:buFont typeface="Helvetica Neue"/>
+              <a:buChar char="–"/>
               <a:defRPr sz="2025" b="1">
                 <a:solidFill>
                   <a:srgbClr val="007D7B"/>
@@ -13485,14 +13399,12 @@
             </a:r>
           </a:p>
           <a:p>
-            <a:pPr marL="0" indent="0" algn="l">
-              <a:spcBef>
-                <a:spcPts val="0"/>
-              </a:spcBef>
+            <a:pPr marL="330200" indent="-254000" algn="l">
               <a:spcAft>
-                <a:spcPts val="0"/>
+                <a:spcPts val="800"/>
               </a:spcAft>
-              <a:buNone/>
+              <a:buFont typeface="Helvetica Neue"/>
+              <a:buChar char="–"/>
               <a:defRPr sz="2025" b="1">
                 <a:solidFill>
                   <a:srgbClr val="007D7B"/>
@@ -13560,14 +13472,12 @@
             </a:defPPr>
           </a:lstStyle>
           <a:p>
-            <a:pPr marL="0" indent="0" algn="l">
-              <a:spcBef>
-                <a:spcPts val="0"/>
-              </a:spcBef>
+            <a:pPr marL="330200" indent="-254000" algn="l">
               <a:spcAft>
-                <a:spcPts val="0"/>
+                <a:spcPts val="1200"/>
               </a:spcAft>
-              <a:buNone/>
+              <a:buFont typeface="Helvetica Neue"/>
+              <a:buChar char="–"/>
               <a:defRPr sz="2025" b="0">
                 <a:solidFill>
                   <a:srgbClr val="102D35"/>
@@ -13586,18 +13496,16 @@
                 <a:ea typeface="Helvetica Neue"/>
                 <a:cs typeface="Helvetica Neue"/>
               </a:rPr>
-              <a:t>Blaue Einheiten</a:t>
+              <a:t>Blaue Einheiten besetzen Punktefelder</a:t>
             </a:r>
           </a:p>
           <a:p>
-            <a:pPr marL="0" indent="0" algn="l">
-              <a:spcBef>
-                <a:spcPts val="0"/>
-              </a:spcBef>
+            <a:pPr marL="330200" indent="-254000" algn="l">
               <a:spcAft>
-                <a:spcPts val="0"/>
+                <a:spcPts val="1200"/>
               </a:spcAft>
-              <a:buNone/>
+              <a:buFont typeface="Helvetica Neue"/>
+              <a:buChar char="–"/>
               <a:defRPr sz="2025" b="0">
                 <a:solidFill>
                   <a:srgbClr val="102D35"/>
@@ -13616,89 +13524,7 @@
                 <a:ea typeface="Helvetica Neue"/>
                 <a:cs typeface="Helvetica Neue"/>
               </a:rPr>
-              <a:t>besetzen Punktefelder.</a:t>
-            </a:r>
-          </a:p>
-          <a:p>
-            <a:pPr marL="0" indent="0" algn="l">
-              <a:spcBef>
-                <a:spcPts val="0"/>
-              </a:spcBef>
-              <a:spcAft>
-                <a:spcPts val="0"/>
-              </a:spcAft>
-              <a:buNone/>
-              <a:defRPr sz="2025" b="0">
-                <a:solidFill>
-                  <a:srgbClr val="102D35"/>
-                </a:solidFill>
-                <a:latin typeface="Helvetica Neue"/>
-                <a:ea typeface="Helvetica Neue"/>
-                <a:cs typeface="Helvetica Neue"/>
-              </a:defRPr>
-            </a:pPr>
-            <a:r>
-              <a:t/>
-            </a:r>
-          </a:p>
-          <a:p>
-            <a:pPr marL="0" indent="0" algn="l">
-              <a:spcBef>
-                <a:spcPts val="0"/>
-              </a:spcBef>
-              <a:spcAft>
-                <a:spcPts val="0"/>
-              </a:spcAft>
-              <a:buNone/>
-              <a:defRPr sz="2025" b="0">
-                <a:solidFill>
-                  <a:srgbClr val="102D35"/>
-                </a:solidFill>
-                <a:latin typeface="Helvetica Neue"/>
-                <a:ea typeface="Helvetica Neue"/>
-                <a:cs typeface="Helvetica Neue"/>
-              </a:defRPr>
-            </a:pPr>
-            <a:r>
-              <a:rPr sz="2025">
-                <a:solidFill>
-                  <a:srgbClr val="102D35"/>
-                </a:solidFill>
-                <a:latin typeface="Helvetica Neue"/>
-                <a:ea typeface="Helvetica Neue"/>
-                <a:cs typeface="Helvetica Neue"/>
-              </a:rPr>
-              <a:t>Stehenbleiben kann</a:t>
-            </a:r>
-          </a:p>
-          <a:p>
-            <a:pPr marL="0" indent="0" algn="l">
-              <a:spcBef>
-                <a:spcPts val="0"/>
-              </a:spcBef>
-              <a:spcAft>
-                <a:spcPts val="0"/>
-              </a:spcAft>
-              <a:buNone/>
-              <a:defRPr sz="2025" b="0">
-                <a:solidFill>
-                  <a:srgbClr val="102D35"/>
-                </a:solidFill>
-                <a:latin typeface="Helvetica Neue"/>
-                <a:ea typeface="Helvetica Neue"/>
-                <a:cs typeface="Helvetica Neue"/>
-              </a:defRPr>
-            </a:pPr>
-            <a:r>
-              <a:rPr sz="2025">
-                <a:solidFill>
-                  <a:srgbClr val="102D35"/>
-                </a:solidFill>
-                <a:latin typeface="Helvetica Neue"/>
-                <a:ea typeface="Helvetica Neue"/>
-                <a:cs typeface="Helvetica Neue"/>
-              </a:rPr>
-              <a:t>sinnvoll sein.</a:t>
+              <a:t>Stehenbleiben kann sinnvoll sein</a:t>
             </a:r>
           </a:p>
         </p:txBody>

</xml_diff>

<commit_message>
docs: add agent pseudocode and visible training parameters
</commit_message>
<xml_diff>
--- a/docs/presentation/Sherlock_Review_16-10-2026.pptx
+++ b/docs/presentation/Sherlock_Review_16-10-2026.pptx
@@ -1055,7 +1055,7 @@
 </file>
 
 <file path=ppt/notesSlides/notesSlide3.xml><?xml version="1.0" encoding="utf-8"?>
-<p:notes xmlns:p="http://schemas.openxmlformats.org/presentationml/2006/main">
+<p:notes xmlns:a="http://schemas.openxmlformats.org/drawingml/2006/main" xmlns:p="http://schemas.openxmlformats.org/presentationml/2006/main">
   <p:cSld>
     <p:spTree>
       <p:nvGrpSpPr>
@@ -1064,13 +1064,13 @@
         <p:nvPr/>
       </p:nvGrpSpPr>
       <p:grpSpPr>
-        <a:xfrm xmlns:a="http://schemas.openxmlformats.org/drawingml/2006/main"/>
+        <a:xfrm/>
       </p:grpSpPr>
       <p:sp>
         <p:nvSpPr>
           <p:cNvPr id="2" name="Slide Image Placeholder 1"/>
           <p:cNvSpPr>
-            <a:spLocks xmlns:a="http://schemas.openxmlformats.org/drawingml/2006/main" noGrp="1"/>
+            <a:spLocks noGrp="1"/>
           </p:cNvSpPr>
           <p:nvPr>
             <p:ph type="sldImg" idx="0"/>
@@ -1082,7 +1082,7 @@
         <p:nvSpPr>
           <p:cNvPr id="3" name="Notes Placeholder 2"/>
           <p:cNvSpPr>
-            <a:spLocks xmlns:a="http://schemas.openxmlformats.org/drawingml/2006/main" noGrp="1"/>
+            <a:spLocks noGrp="1"/>
           </p:cNvSpPr>
           <p:nvPr>
             <p:ph type="body" idx="1"/>
@@ -1090,46 +1090,48 @@
         </p:nvSpPr>
         <p:spPr/>
         <p:txBody>
-          <a:bodyPr xmlns:a="http://schemas.openxmlformats.org/drawingml/2006/main"/>
-          <a:lstStyle xmlns:a="http://schemas.openxmlformats.org/drawingml/2006/main"/>
-          <a:p xmlns:a="http://schemas.openxmlformats.org/drawingml/2006/main">
+          <a:bodyPr/>
+          <a:lstStyle/>
+          <a:p>
             <a:r>
               <a:t>Moayed · 55 Sekunden</a:t>
             </a:r>
           </a:p>
-          <a:p xmlns:a="http://schemas.openxmlformats.org/drawingml/2006/main">
+          <a:p>
             <a:r>
               <a:t/>
             </a:r>
           </a:p>
-          <a:p xmlns:a="http://schemas.openxmlformats.org/drawingml/2006/main">
-            <a:r>
-              <a:t>Die Grundidee lässt sich in drei Schritten erklären. Zuerst merkt Sherlock sich, was er schon gesehen hat. Dieses Gedächtnis nennen wir Belief. Danach erhält jede Einheit eine kompakte Beschreibung ihrer Situation. Sechs trainierte Netze bewerten die möglichen Aktionen. Schließlich wählen wir aus den erlaubten Aktionen die mit dem höchsten gemittelten Wert aus. Das Gedächtnis lernt nicht durch ein neuronales Netz: Es folgt programmierten Regeln und nutzt Beobachtungen. Die Bewertung der Aktionen wird dagegen im Training gelernt. Während der Auswertung wird nicht weitergelernt. Mahmoud erklärt jetzt, welche Informationen in die Netze eingehen und wie das Training funktioniert.</a:t>
-            </a:r>
-          </a:p>
-          <a:p xmlns:a="http://schemas.openxmlformats.org/drawingml/2006/main">
+          <a:p>
+            <a:r>
+              <a:t>Links stehen die drei Grundideen, rechts derselbe Ablauf als Pseudocode. Bei jedem Spielschritt aktualisiert Sherlock zuerst sein Gedächtnis mit den neuen Beobachtungen. Für jede eigene aktive Einheit berechnet er dann 79 Merkmale. Sechs trainierte Netze bewerten ihre möglichen Aktionen; wir mitteln diese Bewertungen und wählen die beste erlaubte Aktion. Die Aktionen aller Einheiten gehen anschließend an das Spiel. Das Gedächtnis folgt programmierten Regeln, die Netzbewertungen wurden gelernt. Beim Spielen bleiben die Gewichte fest. Der Pseudocode zeigt den vereinfachten Hauptablauf. Mahmoud erklärt jetzt die Merkmale und das Training.</a:t>
+            </a:r>
+          </a:p>
+          <a:p>
             <a:r>
               <a:t/>
             </a:r>
           </a:p>
-          <a:p xmlns:a="http://schemas.openxmlformats.org/drawingml/2006/main">
+          <a:p>
             <a:r>
               <a:t>Quellen / Nachweise (Repository, Stand 14.10.2026):</a:t>
             </a:r>
           </a:p>
-          <a:p xmlns:a="http://schemas.openxmlformats.org/drawingml/2006/main">
+          <a:p>
             <a:r>
               <a:t>agents/sherlock/main.py</a:t>
             </a:r>
           </a:p>
-          <a:p xmlns:a="http://schemas.openxmlformats.org/drawingml/2006/main">
+          <a:p>
             <a:r>
               <a:t>agents/sherlock/belief.py</a:t>
             </a:r>
           </a:p>
-          <a:p xmlns:a="http://schemas.openxmlformats.org/drawingml/2006/main">
-            <a:r>
-              <a:t>agents/sherlock/model.py</a:t>
+          <a:p>
+            <a:r>
+              <a:t>agents/sherlock/model.py
+Gestaltungsreferenz: team20-presentation3.pdf, Folie 4 (vom Team bereitgestellt).
+Vereinfachung: Match-Reset, Sap-Zielwahl und Aktionsformat sind nicht ausgeschrieben.</a:t>
             </a:r>
           </a:p>
         </p:txBody>
@@ -1138,7 +1140,7 @@
         <p:nvSpPr>
           <p:cNvPr id="4" name="Slide Number Placeholder 3"/>
           <p:cNvSpPr>
-            <a:spLocks xmlns:a="http://schemas.openxmlformats.org/drawingml/2006/main" noGrp="1"/>
+            <a:spLocks noGrp="1"/>
           </p:cNvSpPr>
           <p:nvPr>
             <p:ph type="sldNum" idx="5"/>
@@ -1146,15 +1148,15 @@
         </p:nvSpPr>
         <p:spPr/>
         <p:txBody>
-          <a:bodyPr xmlns:a="http://schemas.openxmlformats.org/drawingml/2006/main"/>
-          <a:lstStyle xmlns:a="http://schemas.openxmlformats.org/drawingml/2006/main"/>
-          <a:p xmlns:a="http://schemas.openxmlformats.org/drawingml/2006/main"/>
+          <a:bodyPr/>
+          <a:lstStyle/>
+          <a:p/>
         </p:txBody>
       </p:sp>
     </p:spTree>
   </p:cSld>
   <p:clrMapOvr>
-    <a:masterClrMapping xmlns:a="http://schemas.openxmlformats.org/drawingml/2006/main"/>
+    <a:masterClrMapping/>
   </p:clrMapOvr>
 </p:notes>
 </file>
@@ -1470,7 +1472,7 @@
 </file>
 
 <file path=ppt/notesSlides/notesSlide7.xml><?xml version="1.0" encoding="utf-8"?>
-<p:notes xmlns:p="http://schemas.openxmlformats.org/presentationml/2006/main">
+<p:notes xmlns:a="http://schemas.openxmlformats.org/drawingml/2006/main" xmlns:p="http://schemas.openxmlformats.org/presentationml/2006/main">
   <p:cSld>
     <p:spTree>
       <p:nvGrpSpPr>
@@ -1479,13 +1481,13 @@
         <p:nvPr/>
       </p:nvGrpSpPr>
       <p:grpSpPr>
-        <a:xfrm xmlns:a="http://schemas.openxmlformats.org/drawingml/2006/main"/>
+        <a:xfrm/>
       </p:grpSpPr>
       <p:sp>
         <p:nvSpPr>
           <p:cNvPr id="2" name="Slide Image Placeholder 1"/>
           <p:cNvSpPr>
-            <a:spLocks xmlns:a="http://schemas.openxmlformats.org/drawingml/2006/main" noGrp="1"/>
+            <a:spLocks noGrp="1"/>
           </p:cNvSpPr>
           <p:nvPr>
             <p:ph type="sldImg" idx="0"/>
@@ -1497,7 +1499,7 @@
         <p:nvSpPr>
           <p:cNvPr id="3" name="Notes Placeholder 2"/>
           <p:cNvSpPr>
-            <a:spLocks xmlns:a="http://schemas.openxmlformats.org/drawingml/2006/main" noGrp="1"/>
+            <a:spLocks noGrp="1"/>
           </p:cNvSpPr>
           <p:nvPr>
             <p:ph type="body" idx="1"/>
@@ -1505,49 +1507,49 @@
         </p:nvSpPr>
         <p:spPr/>
         <p:txBody>
-          <a:bodyPr xmlns:a="http://schemas.openxmlformats.org/drawingml/2006/main"/>
-          <a:lstStyle xmlns:a="http://schemas.openxmlformats.org/drawingml/2006/main"/>
-          <a:p xmlns:a="http://schemas.openxmlformats.org/drawingml/2006/main">
+          <a:bodyPr/>
+          <a:lstStyle/>
+          <a:p>
             <a:r>
               <a:t>Mahmoud · 65 Sekunden</a:t>
             </a:r>
           </a:p>
-          <a:p xmlns:a="http://schemas.openxmlformats.org/drawingml/2006/main">
+          <a:p>
             <a:r>
               <a:t/>
             </a:r>
           </a:p>
-          <a:p xmlns:a="http://schemas.openxmlformats.org/drawingml/2006/main">
-            <a:r>
-              <a:t>Die sechs Basisläufe des aktuellen Ensembles hatten jeweils ein Budget von 3.000 Spielen. Das sind zusammen 18.000 Trainingsspiele über diese Läufe. Die ausgewählten Checkpoints können früher im Lauf liegen. Andere Varianten und Validierungsspiele sind hier nicht mitgezählt. In den ersten 25 Prozent wird gegen default trainiert, anschließend abwechselnd gegen default und Solution_92. Die Spielseite wechselt. Wir prüfen regelmäßig auf getrennten Validierungskarten und wählen dort Checkpoints aus. Wichtige Einstellungen sind Gamma 0,99, Lernrate 0,0003, Batchgröße 256 und ein Buffer mit 300.000 Übergängen. Epsilon fällt in 60.000 Umgebungsschritten von 1 auf 0,05. Für die Ergebnisfolie gilt dagegen Epsilon null: Die Gewichte sind fest, es wird nicht gelernt.</a:t>
-            </a:r>
-          </a:p>
-          <a:p xmlns:a="http://schemas.openxmlformats.org/drawingml/2006/main">
+          <a:p>
+            <a:r>
+              <a:t>Die sechs Basisläufe umfassen jeweils 3.000 Spiele, zusammen 18.000. Die ausgewählten Checkpoints können früher liegen. Zuerst trainieren wir gegen default, danach abwechselnd gegen default und Solution_92. Checkpoints wählen wir auf getrennten Validierungskarten. Rechts stehen die wichtigsten Einstellungen: Lernrate 0,0003, Gamma 0,99, Batchgröße 256 und 300.000 Einheitenübergänge im Buffer. Epsilon steuert die zufällige Exploration: Es sinkt über 60.000 Umgebungsschritte von eins auf 0,05. Das Target-Netz wird alle 500 Lernupdates aktualisiert. In der Auswertung spielen wir beide Seiten mit Epsilon null und festen Gewichten. Moayed zeigt jetzt die Ergebnisse.</a:t>
+            </a:r>
+          </a:p>
+          <a:p>
             <a:r>
               <a:t/>
             </a:r>
           </a:p>
-          <a:p xmlns:a="http://schemas.openxmlformats.org/drawingml/2006/main">
+          <a:p>
             <a:r>
               <a:t>Quellen / Nachweise (Repository, Stand 14.10.2026):</a:t>
             </a:r>
           </a:p>
-          <a:p xmlns:a="http://schemas.openxmlformats.org/drawingml/2006/main">
+          <a:p>
             <a:r>
               <a:t>experiments/runs/20261010_full_s{0,1,2}/manifest.json</a:t>
             </a:r>
           </a:p>
-          <a:p xmlns:a="http://schemas.openxmlformats.org/drawingml/2006/main">
+          <a:p>
             <a:r>
               <a:t>experiments/runs/20261011_full_sym_s{0,1,2}/manifest.json</a:t>
             </a:r>
           </a:p>
-          <a:p xmlns:a="http://schemas.openxmlformats.org/drawingml/2006/main">
+          <a:p>
             <a:r>
               <a:t>scripts/protocol.py</a:t>
             </a:r>
           </a:p>
-          <a:p xmlns:a="http://schemas.openxmlformats.org/drawingml/2006/main">
+          <a:p>
             <a:r>
               <a:t>agents/sherlock/weights/agent_p0.pth · cfg</a:t>
             </a:r>
@@ -1558,7 +1560,7 @@
         <p:nvSpPr>
           <p:cNvPr id="4" name="Slide Number Placeholder 3"/>
           <p:cNvSpPr>
-            <a:spLocks xmlns:a="http://schemas.openxmlformats.org/drawingml/2006/main" noGrp="1"/>
+            <a:spLocks noGrp="1"/>
           </p:cNvSpPr>
           <p:nvPr>
             <p:ph type="sldNum" idx="5"/>
@@ -1566,15 +1568,15 @@
         </p:nvSpPr>
         <p:spPr/>
         <p:txBody>
-          <a:bodyPr xmlns:a="http://schemas.openxmlformats.org/drawingml/2006/main"/>
-          <a:lstStyle xmlns:a="http://schemas.openxmlformats.org/drawingml/2006/main"/>
-          <a:p xmlns:a="http://schemas.openxmlformats.org/drawingml/2006/main"/>
+          <a:bodyPr/>
+          <a:lstStyle/>
+          <a:p/>
         </p:txBody>
       </p:sp>
     </p:spTree>
   </p:cSld>
   <p:clrMapOvr>
-    <a:masterClrMapping xmlns:a="http://schemas.openxmlformats.org/drawingml/2006/main"/>
+    <a:masterClrMapping/>
   </p:clrMapOvr>
 </p:notes>
 </file>
@@ -8385,7 +8387,7 @@
     </p:bg>
     <p:spTree>
       <p:nvGrpSpPr>
-        <p:cNvPr id="1" name=""/>
+        <p:cNvPr id="15" name=""/>
         <p:cNvGrpSpPr/>
         <p:nvPr/>
       </p:nvGrpSpPr>
@@ -8659,10 +8661,10 @@
       </p:sp>
       <p:sp>
         <p:nvSpPr>
-          <p:cNvPr id="5" name="01">
+          <p:cNvPr id="16" name="revision-code-panel">
             <a:extLst>
               <a:ext uri="{FF2B5EF4-FFF2-40B4-BE49-F238E27FC236}">
-                <ns2:creationId id="{ED7862FB-44B4-470F-B98E-E69C219DB3FA}"/>
+                <ns2:creationId id="{2780FA82-746A-4A3C-835D-70842E3DD1B8}"/>
               </a:ext>
             </a:extLst>
           </p:cNvPr>
@@ -8673,8 +8675,42 @@
         </p:nvSpPr>
         <p:spPr>
           <a:xfrm>
-            <a:off x="609600" y="2000250"/>
-            <a:ext cx="666750" cy="523875"/>
+            <a:off x="3714750" y="1847850"/>
+            <a:ext cx="7867650" cy="4000500"/>
+          </a:xfrm>
+          <a:prstGeom prst="roundRect">
+            <a:avLst>
+              <a:gd name="adj" fmla="val 1905"/>
+            </a:avLst>
+          </a:prstGeom>
+          <a:solidFill>
+            <a:srgbClr val="EDF2F2"/>
+          </a:solidFill>
+          <a:ln w="11430">
+            <a:solidFill>
+              <a:srgbClr val="CFDBD7"/>
+            </a:solidFill>
+          </a:ln>
+        </p:spPr>
+      </p:sp>
+      <p:sp>
+        <p:nvSpPr>
+          <p:cNvPr id="17" name="revision-Merken">
+            <a:extLst>
+              <a:ext uri="{FF2B5EF4-FFF2-40B4-BE49-F238E27FC236}">
+                <ns2:creationId id="{8968B2E5-9369-4A57-AC44-245AAF905467}"/>
+              </a:ext>
+            </a:extLst>
+          </p:cNvPr>
+          <p:cNvSpPr>
+            <a:spLocks noGrp="1"/>
+          </p:cNvSpPr>
+          <p:nvPr/>
+        </p:nvSpPr>
+        <p:spPr>
+          <a:xfrm>
+            <a:off x="609600" y="2028825"/>
+            <a:ext cx="2714625" cy="400050"/>
           </a:xfrm>
           <a:prstGeom prst="rect">
             <a:avLst/>
@@ -8685,10 +8721,12 @@
           </a:ln>
         </p:spPr>
         <p:txBody>
-          <a:bodyPr/>
+          <a:bodyPr>
+            <a:noAutofit/>
+          </a:bodyPr>
           <a:lstStyle>
             <a:defPPr>
-              <a:defRPr sz="2850" b="1">
+              <a:defRPr sz="2175" b="1">
                 <a:solidFill>
                   <a:srgbClr val="007D7B"/>
                 </a:solidFill>
@@ -8700,7 +8738,7 @@
           </a:lstStyle>
           <a:p>
             <a:pPr>
-              <a:defRPr sz="2850" b="1">
+              <a:defRPr sz="2175" b="1">
                 <a:solidFill>
                   <a:srgbClr val="007D7B"/>
                 </a:solidFill>
@@ -8710,7 +8748,7 @@
               </a:defRPr>
             </a:pPr>
             <a:r>
-              <a:rPr sz="2850" b="1">
+              <a:rPr sz="2175" b="1">
                 <a:solidFill>
                   <a:srgbClr val="007D7B"/>
                 </a:solidFill>
@@ -8718,17 +8756,17 @@
                 <a:ea typeface="Helvetica Neue"/>
                 <a:cs typeface="Helvetica Neue"/>
               </a:rPr>
-              <a:t>01</a:t>
+              <a:t>Merken</a:t>
             </a:r>
           </a:p>
         </p:txBody>
       </p:sp>
       <p:sp>
         <p:nvSpPr>
-          <p:cNvPr id="6" name="Merken">
+          <p:cNvPr id="18" name="revision-Beobachtungen im&#10;Gedächtnis sammeln.">
             <a:extLst>
               <a:ext uri="{FF2B5EF4-FFF2-40B4-BE49-F238E27FC236}">
-                <ns2:creationId id="{2F64C5E2-D580-4106-A6D9-1A59256FFC05}"/>
+                <ns2:creationId id="{2B532376-CCC7-42B5-A4D3-07979C9C8BA6}"/>
               </a:ext>
             </a:extLst>
           </p:cNvPr>
@@ -8739,8 +8777,8 @@
         </p:nvSpPr>
         <p:spPr>
           <a:xfrm>
-            <a:off x="1524000" y="2000250"/>
-            <a:ext cx="9715500" cy="428625"/>
+            <a:off x="609600" y="2476500"/>
+            <a:ext cx="2714625" cy="742950"/>
           </a:xfrm>
           <a:prstGeom prst="rect">
             <a:avLst/>
@@ -8751,12 +8789,14 @@
           </a:ln>
         </p:spPr>
         <p:txBody>
-          <a:bodyPr/>
+          <a:bodyPr>
+            <a:noAutofit/>
+          </a:bodyPr>
           <a:lstStyle>
             <a:defPPr>
-              <a:defRPr sz="2250" b="1">
-                <a:solidFill>
-                  <a:srgbClr val="102D35"/>
+              <a:defRPr sz="1875" b="0">
+                <a:solidFill>
+                  <a:srgbClr val="526B70"/>
                 </a:solidFill>
                 <a:latin typeface="Helvetica Neue"/>
                 <a:ea typeface="Helvetica Neue"/>
@@ -8766,9 +8806,9 @@
           </a:lstStyle>
           <a:p>
             <a:pPr>
-              <a:defRPr sz="2250" b="1">
-                <a:solidFill>
-                  <a:srgbClr val="102D35"/>
+              <a:defRPr sz="1875" b="0">
+                <a:solidFill>
+                  <a:srgbClr val="526B70"/>
                 </a:solidFill>
                 <a:latin typeface="Helvetica Neue"/>
                 <a:ea typeface="Helvetica Neue"/>
@@ -8776,25 +8816,48 @@
               </a:defRPr>
             </a:pPr>
             <a:r>
-              <a:rPr sz="2250" b="1">
-                <a:solidFill>
-                  <a:srgbClr val="102D35"/>
+              <a:rPr sz="1875" b="0">
+                <a:solidFill>
+                  <a:srgbClr val="526B70"/>
                 </a:solidFill>
                 <a:latin typeface="Helvetica Neue"/>
                 <a:ea typeface="Helvetica Neue"/>
                 <a:cs typeface="Helvetica Neue"/>
               </a:rPr>
-              <a:t>Merken</a:t>
+              <a:t>Beobachtungen im</a:t>
+            </a:r>
+          </a:p>
+          <a:p>
+            <a:pPr>
+              <a:defRPr sz="1875" b="0">
+                <a:solidFill>
+                  <a:srgbClr val="526B70"/>
+                </a:solidFill>
+                <a:latin typeface="Helvetica Neue"/>
+                <a:ea typeface="Helvetica Neue"/>
+                <a:cs typeface="Helvetica Neue"/>
+              </a:defRPr>
+            </a:pPr>
+            <a:r>
+              <a:rPr sz="1875" b="0">
+                <a:solidFill>
+                  <a:srgbClr val="526B70"/>
+                </a:solidFill>
+                <a:latin typeface="Helvetica Neue"/>
+                <a:ea typeface="Helvetica Neue"/>
+                <a:cs typeface="Helvetica Neue"/>
+              </a:rPr>
+              <a:t>Gedächtnis sammeln.</a:t>
             </a:r>
           </a:p>
         </p:txBody>
       </p:sp>
       <p:sp>
         <p:nvSpPr>
-          <p:cNvPr id="7" name="Beobachtungen sammeln und Punktefelder erschl">
+          <p:cNvPr id="19" name="revision-Bewerten">
             <a:extLst>
               <a:ext uri="{FF2B5EF4-FFF2-40B4-BE49-F238E27FC236}">
-                <ns2:creationId id="{E1CA507A-5374-4805-820C-574C75A805AC}"/>
+                <ns2:creationId id="{B34027A2-F6EB-4EF2-A3C7-5B31C3E64695}"/>
               </a:ext>
             </a:extLst>
           </p:cNvPr>
@@ -8805,8 +8868,8 @@
         </p:nvSpPr>
         <p:spPr>
           <a:xfrm>
-            <a:off x="1524000" y="2466975"/>
-            <a:ext cx="9715500" cy="619125"/>
+            <a:off x="609600" y="3371850"/>
+            <a:ext cx="2714625" cy="400050"/>
           </a:xfrm>
           <a:prstGeom prst="rect">
             <a:avLst/>
@@ -8817,12 +8880,14 @@
           </a:ln>
         </p:spPr>
         <p:txBody>
-          <a:bodyPr/>
+          <a:bodyPr>
+            <a:noAutofit/>
+          </a:bodyPr>
           <a:lstStyle>
             <a:defPPr>
-              <a:defRPr sz="1950" b="0">
-                <a:solidFill>
-                  <a:srgbClr val="526B70"/>
+              <a:defRPr sz="2175" b="1">
+                <a:solidFill>
+                  <a:srgbClr val="007D7B"/>
                 </a:solidFill>
                 <a:latin typeface="Helvetica Neue"/>
                 <a:ea typeface="Helvetica Neue"/>
@@ -8832,9 +8897,9 @@
           </a:lstStyle>
           <a:p>
             <a:pPr>
-              <a:defRPr sz="1950" b="0">
-                <a:solidFill>
-                  <a:srgbClr val="526B70"/>
+              <a:defRPr sz="2175" b="1">
+                <a:solidFill>
+                  <a:srgbClr val="007D7B"/>
                 </a:solidFill>
                 <a:latin typeface="Helvetica Neue"/>
                 <a:ea typeface="Helvetica Neue"/>
@@ -8842,25 +8907,25 @@
               </a:defRPr>
             </a:pPr>
             <a:r>
-              <a:rPr sz="1950" b="0">
-                <a:solidFill>
-                  <a:srgbClr val="526B70"/>
+              <a:rPr sz="2175" b="1">
+                <a:solidFill>
+                  <a:srgbClr val="007D7B"/>
                 </a:solidFill>
                 <a:latin typeface="Helvetica Neue"/>
                 <a:ea typeface="Helvetica Neue"/>
                 <a:cs typeface="Helvetica Neue"/>
               </a:rPr>
-              <a:t>Beobachtungen sammeln und Punktefelder erschließen.</a:t>
+              <a:t>Bewerten</a:t>
             </a:r>
           </a:p>
         </p:txBody>
       </p:sp>
       <p:sp>
         <p:nvSpPr>
-          <p:cNvPr id="8" name="02">
+          <p:cNvPr id="20" name="revision-Sechs Netze schätzen&#10;den Aktionsnutzen.">
             <a:extLst>
               <a:ext uri="{FF2B5EF4-FFF2-40B4-BE49-F238E27FC236}">
-                <ns2:creationId id="{40D0CE8F-6C2B-46ED-AF8F-D2EC8A148249}"/>
+                <ns2:creationId id="{A7EA7DD1-2E75-4371-B3AD-9612EA697DB0}"/>
               </a:ext>
             </a:extLst>
           </p:cNvPr>
@@ -8871,8 +8936,8 @@
         </p:nvSpPr>
         <p:spPr>
           <a:xfrm>
-            <a:off x="609600" y="3333750"/>
-            <a:ext cx="666750" cy="523875"/>
+            <a:off x="609600" y="3819525"/>
+            <a:ext cx="2714625" cy="742950"/>
           </a:xfrm>
           <a:prstGeom prst="rect">
             <a:avLst/>
@@ -8883,12 +8948,14 @@
           </a:ln>
         </p:spPr>
         <p:txBody>
-          <a:bodyPr/>
+          <a:bodyPr>
+            <a:noAutofit/>
+          </a:bodyPr>
           <a:lstStyle>
             <a:defPPr>
-              <a:defRPr sz="2850" b="1">
-                <a:solidFill>
-                  <a:srgbClr val="007D7B"/>
+              <a:defRPr sz="1875" b="0">
+                <a:solidFill>
+                  <a:srgbClr val="526B70"/>
                 </a:solidFill>
                 <a:latin typeface="Helvetica Neue"/>
                 <a:ea typeface="Helvetica Neue"/>
@@ -8898,9 +8965,9 @@
           </a:lstStyle>
           <a:p>
             <a:pPr>
-              <a:defRPr sz="2850" b="1">
-                <a:solidFill>
-                  <a:srgbClr val="007D7B"/>
+              <a:defRPr sz="1875" b="0">
+                <a:solidFill>
+                  <a:srgbClr val="526B70"/>
                 </a:solidFill>
                 <a:latin typeface="Helvetica Neue"/>
                 <a:ea typeface="Helvetica Neue"/>
@@ -8908,25 +8975,48 @@
               </a:defRPr>
             </a:pPr>
             <a:r>
-              <a:rPr sz="2850" b="1">
-                <a:solidFill>
-                  <a:srgbClr val="007D7B"/>
+              <a:rPr sz="1875" b="0">
+                <a:solidFill>
+                  <a:srgbClr val="526B70"/>
                 </a:solidFill>
                 <a:latin typeface="Helvetica Neue"/>
                 <a:ea typeface="Helvetica Neue"/>
                 <a:cs typeface="Helvetica Neue"/>
               </a:rPr>
-              <a:t>02</a:t>
+              <a:t>Sechs Netze schätzen</a:t>
+            </a:r>
+          </a:p>
+          <a:p>
+            <a:pPr>
+              <a:defRPr sz="1875" b="0">
+                <a:solidFill>
+                  <a:srgbClr val="526B70"/>
+                </a:solidFill>
+                <a:latin typeface="Helvetica Neue"/>
+                <a:ea typeface="Helvetica Neue"/>
+                <a:cs typeface="Helvetica Neue"/>
+              </a:defRPr>
+            </a:pPr>
+            <a:r>
+              <a:rPr sz="1875" b="0">
+                <a:solidFill>
+                  <a:srgbClr val="526B70"/>
+                </a:solidFill>
+                <a:latin typeface="Helvetica Neue"/>
+                <a:ea typeface="Helvetica Neue"/>
+                <a:cs typeface="Helvetica Neue"/>
+              </a:rPr>
+              <a:t>den Aktionsnutzen.</a:t>
             </a:r>
           </a:p>
         </p:txBody>
       </p:sp>
       <p:sp>
         <p:nvSpPr>
-          <p:cNvPr id="9" name="Bewerten">
+          <p:cNvPr id="21" name="revision-Handeln">
             <a:extLst>
               <a:ext uri="{FF2B5EF4-FFF2-40B4-BE49-F238E27FC236}">
-                <ns2:creationId id="{D065DFD0-DA3A-47B0-8E64-1F6A94A14B98}"/>
+                <ns2:creationId id="{AEBA7F50-A02A-4E60-99E9-D5B92A0E056D}"/>
               </a:ext>
             </a:extLst>
           </p:cNvPr>
@@ -8937,8 +9027,8 @@
         </p:nvSpPr>
         <p:spPr>
           <a:xfrm>
-            <a:off x="1524000" y="3333750"/>
-            <a:ext cx="9715500" cy="428625"/>
+            <a:off x="609600" y="4714875"/>
+            <a:ext cx="2714625" cy="400050"/>
           </a:xfrm>
           <a:prstGeom prst="rect">
             <a:avLst/>
@@ -8949,12 +9039,14 @@
           </a:ln>
         </p:spPr>
         <p:txBody>
-          <a:bodyPr/>
+          <a:bodyPr>
+            <a:noAutofit/>
+          </a:bodyPr>
           <a:lstStyle>
             <a:defPPr>
-              <a:defRPr sz="2250" b="1">
-                <a:solidFill>
-                  <a:srgbClr val="102D35"/>
+              <a:defRPr sz="2175" b="1">
+                <a:solidFill>
+                  <a:srgbClr val="007D7B"/>
                 </a:solidFill>
                 <a:latin typeface="Helvetica Neue"/>
                 <a:ea typeface="Helvetica Neue"/>
@@ -8964,9 +9056,9 @@
           </a:lstStyle>
           <a:p>
             <a:pPr>
-              <a:defRPr sz="2250" b="1">
-                <a:solidFill>
-                  <a:srgbClr val="102D35"/>
+              <a:defRPr sz="2175" b="1">
+                <a:solidFill>
+                  <a:srgbClr val="007D7B"/>
                 </a:solidFill>
                 <a:latin typeface="Helvetica Neue"/>
                 <a:ea typeface="Helvetica Neue"/>
@@ -8974,25 +9066,25 @@
               </a:defRPr>
             </a:pPr>
             <a:r>
-              <a:rPr sz="2250" b="1">
-                <a:solidFill>
-                  <a:srgbClr val="102D35"/>
+              <a:rPr sz="2175" b="1">
+                <a:solidFill>
+                  <a:srgbClr val="007D7B"/>
                 </a:solidFill>
                 <a:latin typeface="Helvetica Neue"/>
                 <a:ea typeface="Helvetica Neue"/>
                 <a:cs typeface="Helvetica Neue"/>
               </a:rPr>
-              <a:t>Bewerten</a:t>
+              <a:t>Handeln</a:t>
             </a:r>
           </a:p>
         </p:txBody>
       </p:sp>
       <p:sp>
         <p:nvSpPr>
-          <p:cNvPr id="10" name="Sechs trainierte Netze schätzen den Nutzen de">
+          <p:cNvPr id="22" name="revision-Die beste erlaubte&#10;Aktion auswählen.">
             <a:extLst>
               <a:ext uri="{FF2B5EF4-FFF2-40B4-BE49-F238E27FC236}">
-                <ns2:creationId id="{788A43DC-A97D-47B4-82E7-1C018E5B7B83}"/>
+                <ns2:creationId id="{807F6D00-8ED9-474F-82E1-2CF931D65185}"/>
               </a:ext>
             </a:extLst>
           </p:cNvPr>
@@ -9003,8 +9095,8 @@
         </p:nvSpPr>
         <p:spPr>
           <a:xfrm>
-            <a:off x="1524000" y="3800475"/>
-            <a:ext cx="9715500" cy="619125"/>
+            <a:off x="609600" y="5162550"/>
+            <a:ext cx="2714625" cy="742950"/>
           </a:xfrm>
           <a:prstGeom prst="rect">
             <a:avLst/>
@@ -9015,10 +9107,12 @@
           </a:ln>
         </p:spPr>
         <p:txBody>
-          <a:bodyPr/>
+          <a:bodyPr>
+            <a:noAutofit/>
+          </a:bodyPr>
           <a:lstStyle>
             <a:defPPr>
-              <a:defRPr sz="1950" b="0">
+              <a:defRPr sz="1875" b="0">
                 <a:solidFill>
                   <a:srgbClr val="526B70"/>
                 </a:solidFill>
@@ -9030,7 +9124,7 @@
           </a:lstStyle>
           <a:p>
             <a:pPr>
-              <a:defRPr sz="1950" b="0">
+              <a:defRPr sz="1875" b="0">
                 <a:solidFill>
                   <a:srgbClr val="526B70"/>
                 </a:solidFill>
@@ -9040,7 +9134,7 @@
               </a:defRPr>
             </a:pPr>
             <a:r>
-              <a:rPr sz="1950" b="0">
+              <a:rPr sz="1875" b="0">
                 <a:solidFill>
                   <a:srgbClr val="526B70"/>
                 </a:solidFill>
@@ -9048,17 +9142,40 @@
                 <a:ea typeface="Helvetica Neue"/>
                 <a:cs typeface="Helvetica Neue"/>
               </a:rPr>
-              <a:t>Sechs trainierte Netze schätzen den Nutzen der Aktionen.</a:t>
+              <a:t>Die beste erlaubte</a:t>
+            </a:r>
+          </a:p>
+          <a:p>
+            <a:pPr>
+              <a:defRPr sz="1875" b="0">
+                <a:solidFill>
+                  <a:srgbClr val="526B70"/>
+                </a:solidFill>
+                <a:latin typeface="Helvetica Neue"/>
+                <a:ea typeface="Helvetica Neue"/>
+                <a:cs typeface="Helvetica Neue"/>
+              </a:defRPr>
+            </a:pPr>
+            <a:r>
+              <a:rPr sz="1875" b="0">
+                <a:solidFill>
+                  <a:srgbClr val="526B70"/>
+                </a:solidFill>
+                <a:latin typeface="Helvetica Neue"/>
+                <a:ea typeface="Helvetica Neue"/>
+                <a:cs typeface="Helvetica Neue"/>
+              </a:rPr>
+              <a:t>Aktion auswählen.</a:t>
             </a:r>
           </a:p>
         </p:txBody>
       </p:sp>
       <p:sp>
         <p:nvSpPr>
-          <p:cNvPr id="11" name="03">
+          <p:cNvPr id="23" name="revision-Ablauf beim Spielen · Pseudocode">
             <a:extLst>
               <a:ext uri="{FF2B5EF4-FFF2-40B4-BE49-F238E27FC236}">
-                <ns2:creationId id="{8710FC37-FDCB-44DD-A652-80F6D6866F8B}"/>
+                <ns2:creationId id="{4D0143FA-87C7-4A60-86CF-F20C799E4824}"/>
               </a:ext>
             </a:extLst>
           </p:cNvPr>
@@ -9069,8 +9186,8 @@
         </p:nvSpPr>
         <p:spPr>
           <a:xfrm>
-            <a:off x="609600" y="4667250"/>
-            <a:ext cx="666750" cy="523875"/>
+            <a:off x="3943350" y="2028825"/>
+            <a:ext cx="7334250" cy="361950"/>
           </a:xfrm>
           <a:prstGeom prst="rect">
             <a:avLst/>
@@ -9081,12 +9198,14 @@
           </a:ln>
         </p:spPr>
         <p:txBody>
-          <a:bodyPr/>
+          <a:bodyPr>
+            <a:noAutofit/>
+          </a:bodyPr>
           <a:lstStyle>
             <a:defPPr>
-              <a:defRPr sz="2850" b="1">
-                <a:solidFill>
-                  <a:srgbClr val="007D7B"/>
+              <a:defRPr sz="1725" b="1">
+                <a:solidFill>
+                  <a:srgbClr val="526B70"/>
                 </a:solidFill>
                 <a:latin typeface="Helvetica Neue"/>
                 <a:ea typeface="Helvetica Neue"/>
@@ -9096,9 +9215,9 @@
           </a:lstStyle>
           <a:p>
             <a:pPr>
-              <a:defRPr sz="2850" b="1">
-                <a:solidFill>
-                  <a:srgbClr val="007D7B"/>
+              <a:defRPr sz="1725" b="1">
+                <a:solidFill>
+                  <a:srgbClr val="526B70"/>
                 </a:solidFill>
                 <a:latin typeface="Helvetica Neue"/>
                 <a:ea typeface="Helvetica Neue"/>
@@ -9106,25 +9225,25 @@
               </a:defRPr>
             </a:pPr>
             <a:r>
-              <a:rPr sz="2850" b="1">
-                <a:solidFill>
-                  <a:srgbClr val="007D7B"/>
+              <a:rPr sz="1725" b="1">
+                <a:solidFill>
+                  <a:srgbClr val="526B70"/>
                 </a:solidFill>
                 <a:latin typeface="Helvetica Neue"/>
                 <a:ea typeface="Helvetica Neue"/>
                 <a:cs typeface="Helvetica Neue"/>
               </a:rPr>
-              <a:t>03</a:t>
+              <a:t>Ablauf beim Spielen · Pseudocode</a:t>
             </a:r>
           </a:p>
         </p:txBody>
       </p:sp>
       <p:sp>
         <p:nvSpPr>
-          <p:cNvPr id="12" name="Handeln">
+          <p:cNvPr id="24" name="revision-FÜR jeden Spielschritt:">
             <a:extLst>
               <a:ext uri="{FF2B5EF4-FFF2-40B4-BE49-F238E27FC236}">
-                <ns2:creationId id="{9735AB79-6EE4-4E1A-BCA5-2D98EB711E5E}"/>
+                <ns2:creationId id="{8AFAFB75-1296-4C53-B33B-6F67F9580352}"/>
               </a:ext>
             </a:extLst>
           </p:cNvPr>
@@ -9135,8 +9254,8 @@
         </p:nvSpPr>
         <p:spPr>
           <a:xfrm>
-            <a:off x="1524000" y="4667250"/>
-            <a:ext cx="9715500" cy="428625"/>
+            <a:off x="4010025" y="2552700"/>
+            <a:ext cx="7334250" cy="323850"/>
           </a:xfrm>
           <a:prstGeom prst="rect">
             <a:avLst/>
@@ -9147,50 +9266,52 @@
           </a:ln>
         </p:spPr>
         <p:txBody>
-          <a:bodyPr/>
+          <a:bodyPr>
+            <a:noAutofit/>
+          </a:bodyPr>
           <a:lstStyle>
             <a:defPPr>
-              <a:defRPr sz="2250" b="1">
+              <a:defRPr sz="1800" b="0">
                 <a:solidFill>
                   <a:srgbClr val="102D35"/>
                 </a:solidFill>
-                <a:latin typeface="Helvetica Neue"/>
-                <a:ea typeface="Helvetica Neue"/>
-                <a:cs typeface="Helvetica Neue"/>
+                <a:latin typeface="Courier New"/>
+                <a:ea typeface="Courier New"/>
+                <a:cs typeface="Courier New"/>
               </a:defRPr>
             </a:defPPr>
           </a:lstStyle>
           <a:p>
             <a:pPr>
-              <a:defRPr sz="2250" b="1">
+              <a:defRPr sz="1800" b="0">
                 <a:solidFill>
                   <a:srgbClr val="102D35"/>
                 </a:solidFill>
-                <a:latin typeface="Helvetica Neue"/>
-                <a:ea typeface="Helvetica Neue"/>
-                <a:cs typeface="Helvetica Neue"/>
+                <a:latin typeface="Courier New"/>
+                <a:ea typeface="Courier New"/>
+                <a:cs typeface="Courier New"/>
               </a:defRPr>
             </a:pPr>
             <a:r>
-              <a:rPr sz="2250" b="1">
+              <a:rPr sz="1800" b="0">
                 <a:solidFill>
                   <a:srgbClr val="102D35"/>
                 </a:solidFill>
-                <a:latin typeface="Helvetica Neue"/>
-                <a:ea typeface="Helvetica Neue"/>
-                <a:cs typeface="Helvetica Neue"/>
+                <a:latin typeface="Courier New"/>
+                <a:ea typeface="Courier New"/>
+                <a:cs typeface="Courier New"/>
               </a:rPr>
-              <a:t>Handeln</a:t>
+              <a:t>FÜR jeden Spielschritt:</a:t>
             </a:r>
           </a:p>
         </p:txBody>
       </p:sp>
       <p:sp>
         <p:nvSpPr>
-          <p:cNvPr id="13" name="Q-Werte mitteln; die beste erlaubte Aktion au">
+          <p:cNvPr id="25" name="revision-    Belief mit Beobachtung aktualisieren">
             <a:extLst>
               <a:ext uri="{FF2B5EF4-FFF2-40B4-BE49-F238E27FC236}">
-                <ns2:creationId id="{F22B44A2-A65A-4B4D-BC32-93BBE55B3289}"/>
+                <ns2:creationId id="{779C5D59-5951-4252-9E69-5567F03FD728}"/>
               </a:ext>
             </a:extLst>
           </p:cNvPr>
@@ -9201,8 +9322,8 @@
         </p:nvSpPr>
         <p:spPr>
           <a:xfrm>
-            <a:off x="1524000" y="5133975"/>
-            <a:ext cx="9715500" cy="619125"/>
+            <a:off x="4010025" y="2876550"/>
+            <a:ext cx="7334250" cy="323850"/>
           </a:xfrm>
           <a:prstGeom prst="rect">
             <a:avLst/>
@@ -9213,40 +9334,518 @@
           </a:ln>
         </p:spPr>
         <p:txBody>
-          <a:bodyPr/>
+          <a:bodyPr>
+            <a:noAutofit/>
+          </a:bodyPr>
           <a:lstStyle>
             <a:defPPr>
-              <a:defRPr sz="1950" b="0">
-                <a:solidFill>
-                  <a:srgbClr val="526B70"/>
-                </a:solidFill>
-                <a:latin typeface="Helvetica Neue"/>
-                <a:ea typeface="Helvetica Neue"/>
-                <a:cs typeface="Helvetica Neue"/>
+              <a:defRPr sz="1800" b="0">
+                <a:solidFill>
+                  <a:srgbClr val="102D35"/>
+                </a:solidFill>
+                <a:latin typeface="Courier New"/>
+                <a:ea typeface="Courier New"/>
+                <a:cs typeface="Courier New"/>
               </a:defRPr>
             </a:defPPr>
           </a:lstStyle>
           <a:p>
             <a:pPr>
-              <a:defRPr sz="1950" b="0">
+              <a:defRPr sz="1800" b="0">
+                <a:solidFill>
+                  <a:srgbClr val="102D35"/>
+                </a:solidFill>
+                <a:latin typeface="Courier New"/>
+                <a:ea typeface="Courier New"/>
+                <a:cs typeface="Courier New"/>
+              </a:defRPr>
+            </a:pPr>
+            <a:r>
+              <a:rPr sz="1800" b="0">
+                <a:solidFill>
+                  <a:srgbClr val="102D35"/>
+                </a:solidFill>
+                <a:latin typeface="Courier New"/>
+                <a:ea typeface="Courier New"/>
+                <a:cs typeface="Courier New"/>
+              </a:rPr>
+              <a:t>    Belief mit Beobachtung aktualisieren</a:t>
+            </a:r>
+          </a:p>
+        </p:txBody>
+      </p:sp>
+      <p:sp>
+        <p:nvSpPr>
+          <p:cNvPr id="26" name="revision-    FÜR jede aktive eigene Einheit:">
+            <a:extLst>
+              <a:ext uri="{FF2B5EF4-FFF2-40B4-BE49-F238E27FC236}">
+                <ns2:creationId id="{685BEE9F-0852-4F38-A942-A915B37051DB}"/>
+              </a:ext>
+            </a:extLst>
+          </p:cNvPr>
+          <p:cNvSpPr>
+            <a:spLocks noGrp="1"/>
+          </p:cNvSpPr>
+          <p:nvPr/>
+        </p:nvSpPr>
+        <p:spPr>
+          <a:xfrm>
+            <a:off x="4010025" y="3200400"/>
+            <a:ext cx="7334250" cy="323850"/>
+          </a:xfrm>
+          <a:prstGeom prst="rect">
+            <a:avLst/>
+          </a:prstGeom>
+          <a:noFill/>
+          <a:ln w="0">
+            <a:noFill/>
+          </a:ln>
+        </p:spPr>
+        <p:txBody>
+          <a:bodyPr>
+            <a:noAutofit/>
+          </a:bodyPr>
+          <a:lstStyle>
+            <a:defPPr>
+              <a:defRPr sz="1800" b="0">
+                <a:solidFill>
+                  <a:srgbClr val="102D35"/>
+                </a:solidFill>
+                <a:latin typeface="Courier New"/>
+                <a:ea typeface="Courier New"/>
+                <a:cs typeface="Courier New"/>
+              </a:defRPr>
+            </a:defPPr>
+          </a:lstStyle>
+          <a:p>
+            <a:pPr>
+              <a:defRPr sz="1800" b="0">
+                <a:solidFill>
+                  <a:srgbClr val="102D35"/>
+                </a:solidFill>
+                <a:latin typeface="Courier New"/>
+                <a:ea typeface="Courier New"/>
+                <a:cs typeface="Courier New"/>
+              </a:defRPr>
+            </a:pPr>
+            <a:r>
+              <a:rPr sz="1800" b="0">
+                <a:solidFill>
+                  <a:srgbClr val="102D35"/>
+                </a:solidFill>
+                <a:latin typeface="Courier New"/>
+                <a:ea typeface="Courier New"/>
+                <a:cs typeface="Courier New"/>
+              </a:rPr>
+              <a:t>    FÜR jede aktive eigene Einheit:</a:t>
+            </a:r>
+          </a:p>
+        </p:txBody>
+      </p:sp>
+      <p:sp>
+        <p:nvSpPr>
+          <p:cNvPr id="27" name="revision-        x = 79 Merkmale berechnen">
+            <a:extLst>
+              <a:ext uri="{FF2B5EF4-FFF2-40B4-BE49-F238E27FC236}">
+                <ns2:creationId id="{46190EBE-D59B-4DB8-B354-6C21D5616FC3}"/>
+              </a:ext>
+            </a:extLst>
+          </p:cNvPr>
+          <p:cNvSpPr>
+            <a:spLocks noGrp="1"/>
+          </p:cNvSpPr>
+          <p:nvPr/>
+        </p:nvSpPr>
+        <p:spPr>
+          <a:xfrm>
+            <a:off x="4010025" y="3524250"/>
+            <a:ext cx="7334250" cy="323850"/>
+          </a:xfrm>
+          <a:prstGeom prst="rect">
+            <a:avLst/>
+          </a:prstGeom>
+          <a:noFill/>
+          <a:ln w="0">
+            <a:noFill/>
+          </a:ln>
+        </p:spPr>
+        <p:txBody>
+          <a:bodyPr>
+            <a:noAutofit/>
+          </a:bodyPr>
+          <a:lstStyle>
+            <a:defPPr>
+              <a:defRPr sz="1800" b="0">
+                <a:solidFill>
+                  <a:srgbClr val="102D35"/>
+                </a:solidFill>
+                <a:latin typeface="Courier New"/>
+                <a:ea typeface="Courier New"/>
+                <a:cs typeface="Courier New"/>
+              </a:defRPr>
+            </a:defPPr>
+          </a:lstStyle>
+          <a:p>
+            <a:pPr>
+              <a:defRPr sz="1800" b="0">
+                <a:solidFill>
+                  <a:srgbClr val="102D35"/>
+                </a:solidFill>
+                <a:latin typeface="Courier New"/>
+                <a:ea typeface="Courier New"/>
+                <a:cs typeface="Courier New"/>
+              </a:defRPr>
+            </a:pPr>
+            <a:r>
+              <a:rPr sz="1800" b="0">
+                <a:solidFill>
+                  <a:srgbClr val="102D35"/>
+                </a:solidFill>
+                <a:latin typeface="Courier New"/>
+                <a:ea typeface="Courier New"/>
+                <a:cs typeface="Courier New"/>
+              </a:rPr>
+              <a:t>        x = 79 Merkmale berechnen</a:t>
+            </a:r>
+          </a:p>
+        </p:txBody>
+      </p:sp>
+      <p:sp>
+        <p:nvSpPr>
+          <p:cNvPr id="28" name="revision-        Q = Mittelwert der sechs Netze(x">
+            <a:extLst>
+              <a:ext uri="{FF2B5EF4-FFF2-40B4-BE49-F238E27FC236}">
+                <ns2:creationId id="{EF630A91-F254-4892-95C3-C5F3BE9F0575}"/>
+              </a:ext>
+            </a:extLst>
+          </p:cNvPr>
+          <p:cNvSpPr>
+            <a:spLocks noGrp="1"/>
+          </p:cNvSpPr>
+          <p:nvPr/>
+        </p:nvSpPr>
+        <p:spPr>
+          <a:xfrm>
+            <a:off x="4010025" y="3848100"/>
+            <a:ext cx="7334250" cy="323850"/>
+          </a:xfrm>
+          <a:prstGeom prst="rect">
+            <a:avLst/>
+          </a:prstGeom>
+          <a:noFill/>
+          <a:ln w="0">
+            <a:noFill/>
+          </a:ln>
+        </p:spPr>
+        <p:txBody>
+          <a:bodyPr>
+            <a:noAutofit/>
+          </a:bodyPr>
+          <a:lstStyle>
+            <a:defPPr>
+              <a:defRPr sz="1800" b="0">
+                <a:solidFill>
+                  <a:srgbClr val="102D35"/>
+                </a:solidFill>
+                <a:latin typeface="Courier New"/>
+                <a:ea typeface="Courier New"/>
+                <a:cs typeface="Courier New"/>
+              </a:defRPr>
+            </a:defPPr>
+          </a:lstStyle>
+          <a:p>
+            <a:pPr>
+              <a:defRPr sz="1800" b="0">
+                <a:solidFill>
+                  <a:srgbClr val="102D35"/>
+                </a:solidFill>
+                <a:latin typeface="Courier New"/>
+                <a:ea typeface="Courier New"/>
+                <a:cs typeface="Courier New"/>
+              </a:defRPr>
+            </a:pPr>
+            <a:r>
+              <a:rPr sz="1800" b="0">
+                <a:solidFill>
+                  <a:srgbClr val="102D35"/>
+                </a:solidFill>
+                <a:latin typeface="Courier New"/>
+                <a:ea typeface="Courier New"/>
+                <a:cs typeface="Courier New"/>
+              </a:rPr>
+              <a:t>        Q = Mittelwert der sechs Netze(x)</a:t>
+            </a:r>
+          </a:p>
+        </p:txBody>
+      </p:sp>
+      <p:sp>
+        <p:nvSpPr>
+          <p:cNvPr id="29" name="revision-        a = beste erlaubte Aktion aus Q">
+            <a:extLst>
+              <a:ext uri="{FF2B5EF4-FFF2-40B4-BE49-F238E27FC236}">
+                <ns2:creationId id="{F4E09BE0-8537-4C9C-8030-8A49FE5E4DC3}"/>
+              </a:ext>
+            </a:extLst>
+          </p:cNvPr>
+          <p:cNvSpPr>
+            <a:spLocks noGrp="1"/>
+          </p:cNvSpPr>
+          <p:nvPr/>
+        </p:nvSpPr>
+        <p:spPr>
+          <a:xfrm>
+            <a:off x="4010025" y="4171950"/>
+            <a:ext cx="7334250" cy="323850"/>
+          </a:xfrm>
+          <a:prstGeom prst="rect">
+            <a:avLst/>
+          </a:prstGeom>
+          <a:noFill/>
+          <a:ln w="0">
+            <a:noFill/>
+          </a:ln>
+        </p:spPr>
+        <p:txBody>
+          <a:bodyPr>
+            <a:noAutofit/>
+          </a:bodyPr>
+          <a:lstStyle>
+            <a:defPPr>
+              <a:defRPr sz="1800" b="0">
+                <a:solidFill>
+                  <a:srgbClr val="102D35"/>
+                </a:solidFill>
+                <a:latin typeface="Courier New"/>
+                <a:ea typeface="Courier New"/>
+                <a:cs typeface="Courier New"/>
+              </a:defRPr>
+            </a:defPPr>
+          </a:lstStyle>
+          <a:p>
+            <a:pPr>
+              <a:defRPr sz="1800" b="0">
+                <a:solidFill>
+                  <a:srgbClr val="102D35"/>
+                </a:solidFill>
+                <a:latin typeface="Courier New"/>
+                <a:ea typeface="Courier New"/>
+                <a:cs typeface="Courier New"/>
+              </a:defRPr>
+            </a:pPr>
+            <a:r>
+              <a:rPr sz="1800" b="0">
+                <a:solidFill>
+                  <a:srgbClr val="102D35"/>
+                </a:solidFill>
+                <a:latin typeface="Courier New"/>
+                <a:ea typeface="Courier New"/>
+                <a:cs typeface="Courier New"/>
+              </a:rPr>
+              <a:t>        a = beste erlaubte Aktion aus Q</a:t>
+            </a:r>
+          </a:p>
+        </p:txBody>
+      </p:sp>
+      <p:sp>
+        <p:nvSpPr>
+          <p:cNvPr id="30" name="revision-        Aktion für die Einheit speichern">
+            <a:extLst>
+              <a:ext uri="{FF2B5EF4-FFF2-40B4-BE49-F238E27FC236}">
+                <ns2:creationId id="{48D8B9ED-EB9D-493A-8BF8-FEE33A23B6EC}"/>
+              </a:ext>
+            </a:extLst>
+          </p:cNvPr>
+          <p:cNvSpPr>
+            <a:spLocks noGrp="1"/>
+          </p:cNvSpPr>
+          <p:nvPr/>
+        </p:nvSpPr>
+        <p:spPr>
+          <a:xfrm>
+            <a:off x="4010025" y="4495800"/>
+            <a:ext cx="7334250" cy="323850"/>
+          </a:xfrm>
+          <a:prstGeom prst="rect">
+            <a:avLst/>
+          </a:prstGeom>
+          <a:noFill/>
+          <a:ln w="0">
+            <a:noFill/>
+          </a:ln>
+        </p:spPr>
+        <p:txBody>
+          <a:bodyPr>
+            <a:noAutofit/>
+          </a:bodyPr>
+          <a:lstStyle>
+            <a:defPPr>
+              <a:defRPr sz="1800" b="0">
+                <a:solidFill>
+                  <a:srgbClr val="102D35"/>
+                </a:solidFill>
+                <a:latin typeface="Courier New"/>
+                <a:ea typeface="Courier New"/>
+                <a:cs typeface="Courier New"/>
+              </a:defRPr>
+            </a:defPPr>
+          </a:lstStyle>
+          <a:p>
+            <a:pPr>
+              <a:defRPr sz="1800" b="0">
+                <a:solidFill>
+                  <a:srgbClr val="102D35"/>
+                </a:solidFill>
+                <a:latin typeface="Courier New"/>
+                <a:ea typeface="Courier New"/>
+                <a:cs typeface="Courier New"/>
+              </a:defRPr>
+            </a:pPr>
+            <a:r>
+              <a:rPr sz="1800" b="0">
+                <a:solidFill>
+                  <a:srgbClr val="102D35"/>
+                </a:solidFill>
+                <a:latin typeface="Courier New"/>
+                <a:ea typeface="Courier New"/>
+                <a:cs typeface="Courier New"/>
+              </a:rPr>
+              <a:t>        Aktion für die Einheit speichern</a:t>
+            </a:r>
+          </a:p>
+        </p:txBody>
+      </p:sp>
+      <p:sp>
+        <p:nvSpPr>
+          <p:cNvPr id="31" name="revision-    Aktionen zurückgeben">
+            <a:extLst>
+              <a:ext uri="{FF2B5EF4-FFF2-40B4-BE49-F238E27FC236}">
+                <ns2:creationId id="{60E7E1AA-33BA-46A1-AAEA-012350AE007B}"/>
+              </a:ext>
+            </a:extLst>
+          </p:cNvPr>
+          <p:cNvSpPr>
+            <a:spLocks noGrp="1"/>
+          </p:cNvSpPr>
+          <p:nvPr/>
+        </p:nvSpPr>
+        <p:spPr>
+          <a:xfrm>
+            <a:off x="4010025" y="4819650"/>
+            <a:ext cx="7334250" cy="323850"/>
+          </a:xfrm>
+          <a:prstGeom prst="rect">
+            <a:avLst/>
+          </a:prstGeom>
+          <a:noFill/>
+          <a:ln w="0">
+            <a:noFill/>
+          </a:ln>
+        </p:spPr>
+        <p:txBody>
+          <a:bodyPr>
+            <a:noAutofit/>
+          </a:bodyPr>
+          <a:lstStyle>
+            <a:defPPr>
+              <a:defRPr sz="1800" b="0">
+                <a:solidFill>
+                  <a:srgbClr val="102D35"/>
+                </a:solidFill>
+                <a:latin typeface="Courier New"/>
+                <a:ea typeface="Courier New"/>
+                <a:cs typeface="Courier New"/>
+              </a:defRPr>
+            </a:defPPr>
+          </a:lstStyle>
+          <a:p>
+            <a:pPr>
+              <a:defRPr sz="1800" b="0">
+                <a:solidFill>
+                  <a:srgbClr val="102D35"/>
+                </a:solidFill>
+                <a:latin typeface="Courier New"/>
+                <a:ea typeface="Courier New"/>
+                <a:cs typeface="Courier New"/>
+              </a:defRPr>
+            </a:pPr>
+            <a:r>
+              <a:rPr sz="1800" b="0">
+                <a:solidFill>
+                  <a:srgbClr val="102D35"/>
+                </a:solidFill>
+                <a:latin typeface="Courier New"/>
+                <a:ea typeface="Courier New"/>
+                <a:cs typeface="Courier New"/>
+              </a:rPr>
+              <a:t>    Aktionen zurückgeben</a:t>
+            </a:r>
+          </a:p>
+        </p:txBody>
+      </p:sp>
+      <p:sp>
+        <p:nvSpPr>
+          <p:cNvPr id="32" name="revision-# Auswertung: kein Lernen, ε = 0">
+            <a:extLst>
+              <a:ext uri="{FF2B5EF4-FFF2-40B4-BE49-F238E27FC236}">
+                <ns2:creationId id="{DD9B22D8-4C67-4666-AD85-A3C0B837AF44}"/>
+              </a:ext>
+            </a:extLst>
+          </p:cNvPr>
+          <p:cNvSpPr>
+            <a:spLocks noGrp="1"/>
+          </p:cNvSpPr>
+          <p:nvPr/>
+        </p:nvSpPr>
+        <p:spPr>
+          <a:xfrm>
+            <a:off x="4010025" y="5410200"/>
+            <a:ext cx="7334250" cy="304800"/>
+          </a:xfrm>
+          <a:prstGeom prst="rect">
+            <a:avLst/>
+          </a:prstGeom>
+          <a:noFill/>
+          <a:ln w="0">
+            <a:noFill/>
+          </a:ln>
+        </p:spPr>
+        <p:txBody>
+          <a:bodyPr>
+            <a:noAutofit/>
+          </a:bodyPr>
+          <a:lstStyle>
+            <a:defPPr>
+              <a:defRPr sz="1575" b="0">
                 <a:solidFill>
                   <a:srgbClr val="526B70"/>
                 </a:solidFill>
-                <a:latin typeface="Helvetica Neue"/>
-                <a:ea typeface="Helvetica Neue"/>
-                <a:cs typeface="Helvetica Neue"/>
+                <a:latin typeface="Courier New"/>
+                <a:ea typeface="Courier New"/>
+                <a:cs typeface="Courier New"/>
+              </a:defRPr>
+            </a:defPPr>
+          </a:lstStyle>
+          <a:p>
+            <a:pPr>
+              <a:defRPr sz="1575" b="0">
+                <a:solidFill>
+                  <a:srgbClr val="526B70"/>
+                </a:solidFill>
+                <a:latin typeface="Courier New"/>
+                <a:ea typeface="Courier New"/>
+                <a:cs typeface="Courier New"/>
               </a:defRPr>
             </a:pPr>
             <a:r>
-              <a:rPr sz="1950" b="0">
+              <a:rPr sz="1575" b="0">
                 <a:solidFill>
                   <a:srgbClr val="526B70"/>
                 </a:solidFill>
-                <a:latin typeface="Helvetica Neue"/>
-                <a:ea typeface="Helvetica Neue"/>
-                <a:cs typeface="Helvetica Neue"/>
+                <a:latin typeface="Courier New"/>
+                <a:ea typeface="Courier New"/>
+                <a:cs typeface="Courier New"/>
               </a:rPr>
-              <a:t>Q-Werte mitteln; die beste erlaubte Aktion auswählen.</a:t>
+              <a:t># Auswertung: kein Lernen, ε = 0</a:t>
             </a:r>
           </a:p>
         </p:txBody>
@@ -11544,7 +12143,7 @@
     </p:bg>
     <p:spTree>
       <p:nvGrpSpPr>
-        <p:cNvPr id="1" name=""/>
+        <p:cNvPr id="9" name=""/>
         <p:cNvGrpSpPr/>
         <p:nvPr/>
       </p:nvGrpSpPr>
@@ -11818,10 +12417,10 @@
       </p:sp>
       <p:sp>
         <p:nvSpPr>
-          <p:cNvPr id="5" name="6 × 3.000 = 18.000">
+          <p:cNvPr id="10" name="revision-6 × 3.000 = 18.000">
             <a:extLst>
               <a:ext uri="{FF2B5EF4-FFF2-40B4-BE49-F238E27FC236}">
-                <ns2:creationId id="{88F18B35-47A4-46DF-AC96-36E0F5FA6277}"/>
+                <ns2:creationId id="{4A88757F-4863-4249-B890-50B26A2C99D5}"/>
               </a:ext>
             </a:extLst>
           </p:cNvPr>
@@ -11832,8 +12431,8 @@
         </p:nvSpPr>
         <p:spPr>
           <a:xfrm>
-            <a:off x="609600" y="1952625"/>
-            <a:ext cx="10972800" cy="838200"/>
+            <a:off x="609600" y="1762125"/>
+            <a:ext cx="10972800" cy="628650"/>
           </a:xfrm>
           <a:prstGeom prst="rect">
             <a:avLst/>
@@ -11844,10 +12443,12 @@
           </a:ln>
         </p:spPr>
         <p:txBody>
-          <a:bodyPr/>
+          <a:bodyPr>
+            <a:noAutofit/>
+          </a:bodyPr>
           <a:lstStyle>
             <a:defPPr>
-              <a:defRPr sz="4500" b="1">
+              <a:defRPr sz="3900" b="1">
                 <a:solidFill>
                   <a:srgbClr val="007D7B"/>
                 </a:solidFill>
@@ -11859,7 +12460,7 @@
           </a:lstStyle>
           <a:p>
             <a:pPr>
-              <a:defRPr sz="4500" b="1">
+              <a:defRPr sz="3900" b="1">
                 <a:solidFill>
                   <a:srgbClr val="007D7B"/>
                 </a:solidFill>
@@ -11869,7 +12470,7 @@
               </a:defRPr>
             </a:pPr>
             <a:r>
-              <a:rPr sz="4500" b="1">
+              <a:rPr sz="3900" b="1">
                 <a:solidFill>
                   <a:srgbClr val="007D7B"/>
                 </a:solidFill>
@@ -11884,10 +12485,10 @@
       </p:sp>
       <p:sp>
         <p:nvSpPr>
-          <p:cNvPr id="6" name="Trainingsspiele der sechs Basisläufe des aktu">
+          <p:cNvPr id="11" name="revision-Trainingsspiele der sechs Basisläufe des">
             <a:extLst>
               <a:ext uri="{FF2B5EF4-FFF2-40B4-BE49-F238E27FC236}">
-                <ns2:creationId id="{61F13189-35EF-45D8-9B6A-42E9F3DDB008}"/>
+                <ns2:creationId id="{1304225F-3324-4D09-89C9-6C6C60280466}"/>
               </a:ext>
             </a:extLst>
           </p:cNvPr>
@@ -11898,8 +12499,8 @@
         </p:nvSpPr>
         <p:spPr>
           <a:xfrm>
-            <a:off x="609600" y="2847975"/>
-            <a:ext cx="10972800" cy="571500"/>
+            <a:off x="609600" y="2457450"/>
+            <a:ext cx="10972800" cy="381000"/>
           </a:xfrm>
           <a:prstGeom prst="rect">
             <a:avLst/>
@@ -11910,10 +12511,12 @@
           </a:ln>
         </p:spPr>
         <p:txBody>
-          <a:bodyPr/>
+          <a:bodyPr>
+            <a:noAutofit/>
+          </a:bodyPr>
           <a:lstStyle>
             <a:defPPr>
-              <a:defRPr sz="2100" b="0">
+              <a:defRPr sz="2025" b="0">
                 <a:solidFill>
                   <a:srgbClr val="526B70"/>
                 </a:solidFill>
@@ -11925,7 +12528,7 @@
           </a:lstStyle>
           <a:p>
             <a:pPr>
-              <a:defRPr sz="2100" b="0">
+              <a:defRPr sz="2025" b="0">
                 <a:solidFill>
                   <a:srgbClr val="526B70"/>
                 </a:solidFill>
@@ -11935,7 +12538,7 @@
               </a:defRPr>
             </a:pPr>
             <a:r>
-              <a:rPr sz="2100" b="0">
+              <a:rPr sz="2025" b="0">
                 <a:solidFill>
                   <a:srgbClr val="526B70"/>
                 </a:solidFill>
@@ -11948,12 +12551,80 @@
           </a:p>
         </p:txBody>
       </p:sp>
+      <p:sp>
+        <p:nvSpPr>
+          <p:cNvPr id="12" name="revision-Weitere Einstellungen: Reservefolie 12">
+            <a:extLst>
+              <a:ext uri="{FF2B5EF4-FFF2-40B4-BE49-F238E27FC236}">
+                <ns2:creationId id="{8EE07D97-1DC7-4B5C-822F-088950E6C680}"/>
+              </a:ext>
+            </a:extLst>
+          </p:cNvPr>
+          <p:cNvSpPr>
+            <a:spLocks noGrp="1"/>
+          </p:cNvSpPr>
+          <p:nvPr/>
+        </p:nvSpPr>
+        <p:spPr>
+          <a:xfrm>
+            <a:off x="6629400" y="5905500"/>
+            <a:ext cx="4953000" cy="266700"/>
+          </a:xfrm>
+          <a:prstGeom prst="rect">
+            <a:avLst/>
+          </a:prstGeom>
+          <a:noFill/>
+          <a:ln w="0">
+            <a:noFill/>
+          </a:ln>
+        </p:spPr>
+        <p:txBody>
+          <a:bodyPr>
+            <a:noAutofit/>
+          </a:bodyPr>
+          <a:lstStyle>
+            <a:defPPr>
+              <a:defRPr sz="1350" b="0">
+                <a:solidFill>
+                  <a:srgbClr val="526B70"/>
+                </a:solidFill>
+                <a:latin typeface="Helvetica Neue"/>
+                <a:ea typeface="Helvetica Neue"/>
+                <a:cs typeface="Helvetica Neue"/>
+              </a:defRPr>
+            </a:defPPr>
+          </a:lstStyle>
+          <a:p>
+            <a:pPr>
+              <a:defRPr sz="1350" b="0">
+                <a:solidFill>
+                  <a:srgbClr val="526B70"/>
+                </a:solidFill>
+                <a:latin typeface="Helvetica Neue"/>
+                <a:ea typeface="Helvetica Neue"/>
+                <a:cs typeface="Helvetica Neue"/>
+              </a:defRPr>
+            </a:pPr>
+            <a:r>
+              <a:rPr sz="1350" b="0">
+                <a:solidFill>
+                  <a:srgbClr val="526B70"/>
+                </a:solidFill>
+                <a:latin typeface="Helvetica Neue"/>
+                <a:ea typeface="Helvetica Neue"/>
+                <a:cs typeface="Helvetica Neue"/>
+              </a:rPr>
+              <a:t>Weitere Einstellungen: Reservefolie 12</a:t>
+            </a:r>
+          </a:p>
+        </p:txBody>
+      </p:sp>
       <p:graphicFrame>
         <p:nvGraphicFramePr>
-          <p:cNvPr id="7" name="">
+          <p:cNvPr id="13" name="">
             <a:extLst>
               <a:ext uri="{FF2B5EF4-FFF2-40B4-BE49-F238E27FC236}">
-                <ns2:creationId id="{B4EC1B60-74EF-4AA6-A8CA-DD9126A3E20F}"/>
+                <ns2:creationId id="{DCE0B4C2-D2BF-45AA-A08A-6418D21F6B81}"/>
               </a:ext>
             </a:extLst>
           </p:cNvPr>
@@ -11961,25 +12632,25 @@
           <p:nvPr/>
         </p:nvGraphicFramePr>
         <p:xfrm>
-          <a:off x="609600" y="3648075"/>
-          <a:ext cx="10972800" cy="2152650"/>
+          <a:off x="609600" y="3105150"/>
+          <a:ext cx="5334000" cy="2667000"/>
         </p:xfrm>
         <a:graphic>
           <a:graphicData uri="http://schemas.openxmlformats.org/drawingml/2006/table">
             <a:tbl>
               <a:tblPr/>
               <a:tblGrid>
-                <a:gridCol w="2857500"/>
-                <a:gridCol w="8115300"/>
+                <a:gridCol w="1619250"/>
+                <a:gridCol w="3714750"/>
               </a:tblGrid>
-              <a:tr h="538163">
+              <a:tr h="666750">
                 <a:tc>
                   <a:txBody>
                     <a:bodyPr/>
                     <a:lstStyle/>
                     <a:p>
                       <a:r>
-                        <a:rPr sz="2100" b="1">
+                        <a:rPr sz="1800" b="1">
                           <a:solidFill>
                             <a:srgbClr val="FFFFFF"/>
                           </a:solidFill>
@@ -12027,7 +12698,7 @@
                     <a:lstStyle/>
                     <a:p>
                       <a:r>
-                        <a:rPr sz="2100" b="1">
+                        <a:rPr sz="1800" b="1">
                           <a:solidFill>
                             <a:srgbClr val="FFFFFF"/>
                           </a:solidFill>
@@ -12064,14 +12735,14 @@
                   </a:tcPr>
                 </a:tc>
               </a:tr>
-              <a:tr h="538163">
+              <a:tr h="666750">
                 <a:tc>
                   <a:txBody>
                     <a:bodyPr/>
                     <a:lstStyle/>
                     <a:p>
                       <a:r>
-                        <a:rPr sz="2100" b="0">
+                        <a:rPr sz="1800" b="0">
                           <a:solidFill>
                             <a:srgbClr val="102D35"/>
                           </a:solidFill>
@@ -12113,7 +12784,7 @@
                     <a:lstStyle/>
                     <a:p>
                       <a:r>
-                        <a:rPr sz="2100" b="0">
+                        <a:rPr sz="1800" b="0">
                           <a:solidFill>
                             <a:srgbClr val="102D35"/>
                           </a:solidFill>
@@ -12121,7 +12792,20 @@
                           <a:ea typeface="Helvetica Neue"/>
                           <a:cs typeface="Helvetica Neue"/>
                         </a:rPr>
-                        <a:t>Zuerst default; danach default und Solution_92</a:t>
+                        <a:t>Erst default; danach default</a:t>
+                      </a:r>
+                    </a:p>
+                    <a:p>
+                      <a:r>
+                        <a:rPr sz="1800" b="0">
+                          <a:solidFill>
+                            <a:srgbClr val="102D35"/>
+                          </a:solidFill>
+                          <a:latin typeface="Helvetica Neue"/>
+                          <a:ea typeface="Helvetica Neue"/>
+                          <a:cs typeface="Helvetica Neue"/>
+                        </a:rPr>
+                        <a:t>und Solution_92 im Wechsel</a:t>
                       </a:r>
                     </a:p>
                   </a:txBody>
@@ -12144,14 +12828,14 @@
                   </a:tcPr>
                 </a:tc>
               </a:tr>
-              <a:tr h="538163">
+              <a:tr h="666750">
                 <a:tc>
                   <a:txBody>
                     <a:bodyPr/>
                     <a:lstStyle/>
                     <a:p>
                       <a:r>
-                        <a:rPr sz="2100" b="0">
+                        <a:rPr sz="1800" b="0">
                           <a:solidFill>
                             <a:srgbClr val="102D35"/>
                           </a:solidFill>
@@ -12193,7 +12877,7 @@
                     <a:lstStyle/>
                     <a:p>
                       <a:r>
-                        <a:rPr sz="2100" b="0">
+                        <a:rPr sz="1800" b="0">
                           <a:solidFill>
                             <a:srgbClr val="102D35"/>
                           </a:solidFill>
@@ -12201,7 +12885,20 @@
                           <a:ea typeface="Helvetica Neue"/>
                           <a:cs typeface="Helvetica Neue"/>
                         </a:rPr>
-                        <a:t>Getrennte Karten; Checkpoints vergleichen</a:t>
+                        <a:t>Getrennte Karten;</a:t>
+                      </a:r>
+                    </a:p>
+                    <a:p>
+                      <a:r>
+                        <a:rPr sz="1800" b="0">
+                          <a:solidFill>
+                            <a:srgbClr val="102D35"/>
+                          </a:solidFill>
+                          <a:latin typeface="Helvetica Neue"/>
+                          <a:ea typeface="Helvetica Neue"/>
+                          <a:cs typeface="Helvetica Neue"/>
+                        </a:rPr>
+                        <a:t>Checkpoints vergleichen</a:t>
                       </a:r>
                     </a:p>
                   </a:txBody>
@@ -12224,14 +12921,14 @@
                   </a:tcPr>
                 </a:tc>
               </a:tr>
-              <a:tr h="538163">
+              <a:tr h="666750">
                 <a:tc>
                   <a:txBody>
                     <a:bodyPr/>
                     <a:lstStyle/>
                     <a:p>
                       <a:r>
-                        <a:rPr sz="2100" b="0">
+                        <a:rPr sz="1800" b="0">
                           <a:solidFill>
                             <a:srgbClr val="102D35"/>
                           </a:solidFill>
@@ -12273,7 +12970,7 @@
                     <a:lstStyle/>
                     <a:p>
                       <a:r>
-                        <a:rPr sz="2100" b="0">
+                        <a:rPr sz="1800" b="0">
                           <a:solidFill>
                             <a:srgbClr val="102D35"/>
                           </a:solidFill>
@@ -12281,7 +12978,20 @@
                           <a:ea typeface="Helvetica Neue"/>
                           <a:cs typeface="Helvetica Neue"/>
                         </a:rPr>
-                        <a:t>Beide Seiten; ε = 0; kein weiteres Lernen</a:t>
+                        <a:t>Beide Seiten; ε = 0;</a:t>
+                      </a:r>
+                    </a:p>
+                    <a:p>
+                      <a:r>
+                        <a:rPr sz="1800" b="0">
+                          <a:solidFill>
+                            <a:srgbClr val="102D35"/>
+                          </a:solidFill>
+                          <a:latin typeface="Helvetica Neue"/>
+                          <a:ea typeface="Helvetica Neue"/>
+                          <a:cs typeface="Helvetica Neue"/>
+                        </a:rPr>
+                        <a:t>kein weiteres Lernen</a:t>
                       </a:r>
                     </a:p>
                   </a:txBody>
@@ -12300,6 +13010,459 @@
                     </a:lnB>
                     <a:solidFill>
                       <a:srgbClr val="FFFFFF"/>
+                    </a:solidFill>
+                  </a:tcPr>
+                </a:tc>
+              </a:tr>
+            </a:tbl>
+          </a:graphicData>
+        </a:graphic>
+      </p:graphicFrame>
+      <p:graphicFrame>
+        <p:nvGraphicFramePr>
+          <p:cNvPr id="14" name="">
+            <a:extLst>
+              <a:ext uri="{FF2B5EF4-FFF2-40B4-BE49-F238E27FC236}">
+                <ns2:creationId id="{C6B6C1E9-8D27-4254-99C7-70D3780B10EA}"/>
+              </a:ext>
+            </a:extLst>
+          </p:cNvPr>
+          <p:cNvGraphicFramePr/>
+          <p:nvPr/>
+        </p:nvGraphicFramePr>
+        <p:xfrm>
+          <a:off x="6629400" y="3105150"/>
+          <a:ext cx="4953000" cy="2667000"/>
+        </p:xfrm>
+        <a:graphic>
+          <a:graphicData uri="http://schemas.openxmlformats.org/drawingml/2006/table">
+            <a:tbl>
+              <a:tblPr/>
+              <a:tblGrid>
+                <a:gridCol w="1809750"/>
+                <a:gridCol w="3143250"/>
+              </a:tblGrid>
+              <a:tr h="533400">
+                <a:tc>
+                  <a:txBody>
+                    <a:bodyPr/>
+                    <a:lstStyle/>
+                    <a:p>
+                      <a:r>
+                        <a:rPr sz="1725" b="1">
+                          <a:solidFill>
+                            <a:srgbClr val="FFFFFF"/>
+                          </a:solidFill>
+                          <a:latin typeface="Helvetica Neue"/>
+                          <a:ea typeface="Helvetica Neue"/>
+                          <a:cs typeface="Helvetica Neue"/>
+                        </a:rPr>
+                        <a:t>Parameter</a:t>
+                      </a:r>
+                    </a:p>
+                  </a:txBody>
+                  <a:tcPr marL="91440" marR="91440" marT="45720" marB="45720">
+                    <a:lnL w="9525">
+                      <a:solidFill>
+                        <a:srgbClr val="CFDBD7"/>
+                      </a:solidFill>
+                      <a:prstDash val="solid"/>
+                    </a:lnL>
+                    <a:lnR w="9525">
+                      <a:solidFill>
+                        <a:srgbClr val="CFDBD7"/>
+                      </a:solidFill>
+                      <a:prstDash val="solid"/>
+                    </a:lnR>
+                    <a:lnT w="9525">
+                      <a:solidFill>
+                        <a:srgbClr val="CFDBD7"/>
+                      </a:solidFill>
+                      <a:prstDash val="solid"/>
+                    </a:lnT>
+                    <a:lnB w="9525">
+                      <a:solidFill>
+                        <a:srgbClr val="CFDBD7"/>
+                      </a:solidFill>
+                      <a:prstDash val="solid"/>
+                    </a:lnB>
+                    <a:solidFill>
+                      <a:srgbClr val="102D35"/>
+                    </a:solidFill>
+                  </a:tcPr>
+                </a:tc>
+                <a:tc>
+                  <a:txBody>
+                    <a:bodyPr/>
+                    <a:lstStyle/>
+                    <a:p>
+                      <a:r>
+                        <a:rPr sz="1725" b="1">
+                          <a:solidFill>
+                            <a:srgbClr val="FFFFFF"/>
+                          </a:solidFill>
+                          <a:latin typeface="Helvetica Neue"/>
+                          <a:ea typeface="Helvetica Neue"/>
+                          <a:cs typeface="Helvetica Neue"/>
+                        </a:rPr>
+                        <a:t>Wert</a:t>
+                      </a:r>
+                    </a:p>
+                  </a:txBody>
+                  <a:tcPr marL="91440" marR="91440" marT="45720" marB="45720">
+                    <a:lnR w="9525">
+                      <a:solidFill>
+                        <a:srgbClr val="CFDBD7"/>
+                      </a:solidFill>
+                      <a:prstDash val="solid"/>
+                    </a:lnR>
+                    <a:lnT w="9525">
+                      <a:solidFill>
+                        <a:srgbClr val="CFDBD7"/>
+                      </a:solidFill>
+                      <a:prstDash val="solid"/>
+                    </a:lnT>
+                    <a:lnB w="9525">
+                      <a:solidFill>
+                        <a:srgbClr val="CFDBD7"/>
+                      </a:solidFill>
+                      <a:prstDash val="solid"/>
+                    </a:lnB>
+                    <a:solidFill>
+                      <a:srgbClr val="102D35"/>
+                    </a:solidFill>
+                  </a:tcPr>
+                </a:tc>
+              </a:tr>
+              <a:tr h="533400">
+                <a:tc>
+                  <a:txBody>
+                    <a:bodyPr/>
+                    <a:lstStyle/>
+                    <a:p>
+                      <a:r>
+                        <a:rPr sz="1725" b="0">
+                          <a:solidFill>
+                            <a:srgbClr val="102D35"/>
+                          </a:solidFill>
+                          <a:latin typeface="Helvetica Neue"/>
+                          <a:ea typeface="Helvetica Neue"/>
+                          <a:cs typeface="Helvetica Neue"/>
+                        </a:rPr>
+                        <a:t>Lernrate / γ</a:t>
+                      </a:r>
+                    </a:p>
+                  </a:txBody>
+                  <a:tcPr marL="91440" marR="91440" marT="45720" marB="45720">
+                    <a:lnL w="9525">
+                      <a:solidFill>
+                        <a:srgbClr val="CFDBD7"/>
+                      </a:solidFill>
+                      <a:prstDash val="solid"/>
+                    </a:lnL>
+                    <a:lnR w="9525">
+                      <a:solidFill>
+                        <a:srgbClr val="CFDBD7"/>
+                      </a:solidFill>
+                      <a:prstDash val="solid"/>
+                    </a:lnR>
+                    <a:lnB w="9525">
+                      <a:solidFill>
+                        <a:srgbClr val="CFDBD7"/>
+                      </a:solidFill>
+                      <a:prstDash val="solid"/>
+                    </a:lnB>
+                    <a:solidFill>
+                      <a:srgbClr val="FFFFFF"/>
+                    </a:solidFill>
+                  </a:tcPr>
+                </a:tc>
+                <a:tc>
+                  <a:txBody>
+                    <a:bodyPr/>
+                    <a:lstStyle/>
+                    <a:p>
+                      <a:r>
+                        <a:rPr sz="1725" b="0">
+                          <a:solidFill>
+                            <a:srgbClr val="102D35"/>
+                          </a:solidFill>
+                          <a:latin typeface="Helvetica Neue"/>
+                          <a:ea typeface="Helvetica Neue"/>
+                          <a:cs typeface="Helvetica Neue"/>
+                        </a:rPr>
+                        <a:t>0,0003 / 0,99</a:t>
+                      </a:r>
+                    </a:p>
+                  </a:txBody>
+                  <a:tcPr marL="91440" marR="91440" marT="45720" marB="45720">
+                    <a:lnR w="9525">
+                      <a:solidFill>
+                        <a:srgbClr val="CFDBD7"/>
+                      </a:solidFill>
+                      <a:prstDash val="solid"/>
+                    </a:lnR>
+                    <a:lnB w="9525">
+                      <a:solidFill>
+                        <a:srgbClr val="CFDBD7"/>
+                      </a:solidFill>
+                      <a:prstDash val="solid"/>
+                    </a:lnB>
+                    <a:solidFill>
+                      <a:srgbClr val="FFFFFF"/>
+                    </a:solidFill>
+                  </a:tcPr>
+                </a:tc>
+              </a:tr>
+              <a:tr h="533400">
+                <a:tc>
+                  <a:txBody>
+                    <a:bodyPr/>
+                    <a:lstStyle/>
+                    <a:p>
+                      <a:r>
+                        <a:rPr sz="1725" b="0">
+                          <a:solidFill>
+                            <a:srgbClr val="102D35"/>
+                          </a:solidFill>
+                          <a:latin typeface="Helvetica Neue"/>
+                          <a:ea typeface="Helvetica Neue"/>
+                          <a:cs typeface="Helvetica Neue"/>
+                        </a:rPr>
+                        <a:t>Batch / Buffer</a:t>
+                      </a:r>
+                    </a:p>
+                  </a:txBody>
+                  <a:tcPr marL="91440" marR="91440" marT="45720" marB="45720">
+                    <a:lnL w="9525">
+                      <a:solidFill>
+                        <a:srgbClr val="CFDBD7"/>
+                      </a:solidFill>
+                      <a:prstDash val="solid"/>
+                    </a:lnL>
+                    <a:lnR w="9525">
+                      <a:solidFill>
+                        <a:srgbClr val="CFDBD7"/>
+                      </a:solidFill>
+                      <a:prstDash val="solid"/>
+                    </a:lnR>
+                    <a:lnB w="9525">
+                      <a:solidFill>
+                        <a:srgbClr val="CFDBD7"/>
+                      </a:solidFill>
+                      <a:prstDash val="solid"/>
+                    </a:lnB>
+                    <a:solidFill>
+                      <a:srgbClr val="EDF2ED"/>
+                    </a:solidFill>
+                  </a:tcPr>
+                </a:tc>
+                <a:tc>
+                  <a:txBody>
+                    <a:bodyPr/>
+                    <a:lstStyle/>
+                    <a:p>
+                      <a:r>
+                        <a:rPr sz="1725" b="0">
+                          <a:solidFill>
+                            <a:srgbClr val="102D35"/>
+                          </a:solidFill>
+                          <a:latin typeface="Helvetica Neue"/>
+                          <a:ea typeface="Helvetica Neue"/>
+                          <a:cs typeface="Helvetica Neue"/>
+                        </a:rPr>
+                        <a:t>256 / 300.000 Übergänge</a:t>
+                      </a:r>
+                    </a:p>
+                  </a:txBody>
+                  <a:tcPr marL="91440" marR="91440" marT="45720" marB="45720">
+                    <a:lnR w="9525">
+                      <a:solidFill>
+                        <a:srgbClr val="CFDBD7"/>
+                      </a:solidFill>
+                      <a:prstDash val="solid"/>
+                    </a:lnR>
+                    <a:lnB w="9525">
+                      <a:solidFill>
+                        <a:srgbClr val="CFDBD7"/>
+                      </a:solidFill>
+                      <a:prstDash val="solid"/>
+                    </a:lnB>
+                    <a:solidFill>
+                      <a:srgbClr val="EDF2ED"/>
+                    </a:solidFill>
+                  </a:tcPr>
+                </a:tc>
+              </a:tr>
+              <a:tr h="533400">
+                <a:tc>
+                  <a:txBody>
+                    <a:bodyPr/>
+                    <a:lstStyle/>
+                    <a:p>
+                      <a:r>
+                        <a:rPr sz="1725" b="0">
+                          <a:solidFill>
+                            <a:srgbClr val="102D35"/>
+                          </a:solidFill>
+                          <a:latin typeface="Helvetica Neue"/>
+                          <a:ea typeface="Helvetica Neue"/>
+                          <a:cs typeface="Helvetica Neue"/>
+                        </a:rPr>
+                        <a:t>Exploration ε</a:t>
+                      </a:r>
+                    </a:p>
+                  </a:txBody>
+                  <a:tcPr marL="91440" marR="91440" marT="45720" marB="45720">
+                    <a:lnL w="9525">
+                      <a:solidFill>
+                        <a:srgbClr val="CFDBD7"/>
+                      </a:solidFill>
+                      <a:prstDash val="solid"/>
+                    </a:lnL>
+                    <a:lnR w="9525">
+                      <a:solidFill>
+                        <a:srgbClr val="CFDBD7"/>
+                      </a:solidFill>
+                      <a:prstDash val="solid"/>
+                    </a:lnR>
+                    <a:lnB w="9525">
+                      <a:solidFill>
+                        <a:srgbClr val="CFDBD7"/>
+                      </a:solidFill>
+                      <a:prstDash val="solid"/>
+                    </a:lnB>
+                    <a:solidFill>
+                      <a:srgbClr val="FFFFFF"/>
+                    </a:solidFill>
+                  </a:tcPr>
+                </a:tc>
+                <a:tc>
+                  <a:txBody>
+                    <a:bodyPr/>
+                    <a:lstStyle/>
+                    <a:p>
+                      <a:r>
+                        <a:rPr sz="1725" b="0">
+                          <a:solidFill>
+                            <a:srgbClr val="102D35"/>
+                          </a:solidFill>
+                          <a:latin typeface="Helvetica Neue"/>
+                          <a:ea typeface="Helvetica Neue"/>
+                          <a:cs typeface="Helvetica Neue"/>
+                        </a:rPr>
+                        <a:t>1,0 → 0,05 in 60.000</a:t>
+                      </a:r>
+                    </a:p>
+                    <a:p>
+                      <a:r>
+                        <a:rPr sz="1725" b="0">
+                          <a:solidFill>
+                            <a:srgbClr val="102D35"/>
+                          </a:solidFill>
+                          <a:latin typeface="Helvetica Neue"/>
+                          <a:ea typeface="Helvetica Neue"/>
+                          <a:cs typeface="Helvetica Neue"/>
+                        </a:rPr>
+                        <a:t>Umgebungsschritten</a:t>
+                      </a:r>
+                    </a:p>
+                  </a:txBody>
+                  <a:tcPr marL="91440" marR="91440" marT="45720" marB="45720">
+                    <a:lnR w="9525">
+                      <a:solidFill>
+                        <a:srgbClr val="CFDBD7"/>
+                      </a:solidFill>
+                      <a:prstDash val="solid"/>
+                    </a:lnR>
+                    <a:lnB w="9525">
+                      <a:solidFill>
+                        <a:srgbClr val="CFDBD7"/>
+                      </a:solidFill>
+                      <a:prstDash val="solid"/>
+                    </a:lnB>
+                    <a:solidFill>
+                      <a:srgbClr val="FFFFFF"/>
+                    </a:solidFill>
+                  </a:tcPr>
+                </a:tc>
+              </a:tr>
+              <a:tr h="533400">
+                <a:tc>
+                  <a:txBody>
+                    <a:bodyPr/>
+                    <a:lstStyle/>
+                    <a:p>
+                      <a:r>
+                        <a:rPr sz="1725" b="0">
+                          <a:solidFill>
+                            <a:srgbClr val="102D35"/>
+                          </a:solidFill>
+                          <a:latin typeface="Helvetica Neue"/>
+                          <a:ea typeface="Helvetica Neue"/>
+                          <a:cs typeface="Helvetica Neue"/>
+                        </a:rPr>
+                        <a:t>Target-Kopie</a:t>
+                      </a:r>
+                    </a:p>
+                  </a:txBody>
+                  <a:tcPr marL="91440" marR="91440" marT="45720" marB="45720">
+                    <a:lnL w="9525">
+                      <a:solidFill>
+                        <a:srgbClr val="CFDBD7"/>
+                      </a:solidFill>
+                      <a:prstDash val="solid"/>
+                    </a:lnL>
+                    <a:lnR w="9525">
+                      <a:solidFill>
+                        <a:srgbClr val="CFDBD7"/>
+                      </a:solidFill>
+                      <a:prstDash val="solid"/>
+                    </a:lnR>
+                    <a:lnB w="9525">
+                      <a:solidFill>
+                        <a:srgbClr val="CFDBD7"/>
+                      </a:solidFill>
+                      <a:prstDash val="solid"/>
+                    </a:lnB>
+                    <a:solidFill>
+                      <a:srgbClr val="EDF2ED"/>
+                    </a:solidFill>
+                  </a:tcPr>
+                </a:tc>
+                <a:tc>
+                  <a:txBody>
+                    <a:bodyPr/>
+                    <a:lstStyle/>
+                    <a:p>
+                      <a:r>
+                        <a:rPr sz="1725" b="0">
+                          <a:solidFill>
+                            <a:srgbClr val="102D35"/>
+                          </a:solidFill>
+                          <a:latin typeface="Helvetica Neue"/>
+                          <a:ea typeface="Helvetica Neue"/>
+                          <a:cs typeface="Helvetica Neue"/>
+                        </a:rPr>
+                        <a:t>Alle 500 Lernupdates</a:t>
+                      </a:r>
+                    </a:p>
+                  </a:txBody>
+                  <a:tcPr marL="91440" marR="91440" marT="45720" marB="45720">
+                    <a:lnR w="9525">
+                      <a:solidFill>
+                        <a:srgbClr val="CFDBD7"/>
+                      </a:solidFill>
+                      <a:prstDash val="solid"/>
+                    </a:lnR>
+                    <a:lnB w="9525">
+                      <a:solidFill>
+                        <a:srgbClr val="CFDBD7"/>
+                      </a:solidFill>
+                      <a:prstDash val="solid"/>
+                    </a:lnB>
+                    <a:solidFill>
+                      <a:srgbClr val="EDF2ED"/>
                     </a:solidFill>
                   </a:tcPr>
                 </a:tc>

</xml_diff>

<commit_message>
docs: align presentation table sizes on slide 7
</commit_message>
<xml_diff>
--- a/docs/presentation/Sherlock_Review_16-10-2026.pptx
+++ b/docs/presentation/Sherlock_Review_16-10-2026.pptx
@@ -12567,8 +12567,8 @@
         </p:nvSpPr>
         <p:spPr>
           <a:xfrm>
-            <a:off x="6629400" y="5905500"/>
-            <a:ext cx="4953000" cy="266700"/>
+            <a:off x="6286500" y="6019800"/>
+            <a:ext cx="5295900" cy="266700"/>
           </a:xfrm>
           <a:prstGeom prst="rect">
             <a:avLst/>
@@ -12624,7 +12624,7 @@
           <p:cNvPr id="13" name="">
             <a:extLst>
               <a:ext uri="{FF2B5EF4-FFF2-40B4-BE49-F238E27FC236}">
-                <ns2:creationId id="{DCE0B4C2-D2BF-45AA-A08A-6418D21F6B81}"/>
+                <ns2:creationId id="{837EE017-2FAA-40E9-B2FA-4F859F1CED9A}"/>
               </a:ext>
             </a:extLst>
           </p:cNvPr>
@@ -12633,7 +12633,7 @@
         </p:nvGraphicFramePr>
         <p:xfrm>
           <a:off x="609600" y="3105150"/>
-          <a:ext cx="5334000" cy="2667000"/>
+          <a:ext cx="5295900" cy="2857500"/>
         </p:xfrm>
         <a:graphic>
           <a:graphicData uri="http://schemas.openxmlformats.org/drawingml/2006/table">
@@ -12641,9 +12641,9 @@
               <a:tblPr/>
               <a:tblGrid>
                 <a:gridCol w="1619250"/>
-                <a:gridCol w="3714750"/>
+                <a:gridCol w="3676650"/>
               </a:tblGrid>
-              <a:tr h="666750">
+              <a:tr h="495300">
                 <a:tc>
                   <a:txBody>
                     <a:bodyPr/>
@@ -12735,7 +12735,7 @@
                   </a:tcPr>
                 </a:tc>
               </a:tr>
-              <a:tr h="666750">
+              <a:tr h="781050">
                 <a:tc>
                   <a:txBody>
                     <a:bodyPr/>
@@ -12828,7 +12828,7 @@
                   </a:tcPr>
                 </a:tc>
               </a:tr>
-              <a:tr h="666750">
+              <a:tr h="790575">
                 <a:tc>
                   <a:txBody>
                     <a:bodyPr/>
@@ -12921,7 +12921,7 @@
                   </a:tcPr>
                 </a:tc>
               </a:tr>
-              <a:tr h="666750">
+              <a:tr h="790575">
                 <a:tc>
                   <a:txBody>
                     <a:bodyPr/>
@@ -13023,7 +13023,7 @@
           <p:cNvPr id="14" name="">
             <a:extLst>
               <a:ext uri="{FF2B5EF4-FFF2-40B4-BE49-F238E27FC236}">
-                <ns2:creationId id="{C6B6C1E9-8D27-4254-99C7-70D3780B10EA}"/>
+                <ns2:creationId id="{2B94D99E-4265-4049-BBD7-C4073FC3BAF1}"/>
               </a:ext>
             </a:extLst>
           </p:cNvPr>
@@ -13031,8 +13031,8 @@
           <p:nvPr/>
         </p:nvGraphicFramePr>
         <p:xfrm>
-          <a:off x="6629400" y="3105150"/>
-          <a:ext cx="4953000" cy="2667000"/>
+          <a:off x="6286500" y="3105150"/>
+          <a:ext cx="5295900" cy="2857500"/>
         </p:xfrm>
         <a:graphic>
           <a:graphicData uri="http://schemas.openxmlformats.org/drawingml/2006/table">
@@ -13040,16 +13040,16 @@
               <a:tblPr/>
               <a:tblGrid>
                 <a:gridCol w="1809750"/>
-                <a:gridCol w="3143250"/>
+                <a:gridCol w="3486150"/>
               </a:tblGrid>
-              <a:tr h="533400">
+              <a:tr h="495300">
                 <a:tc>
                   <a:txBody>
                     <a:bodyPr/>
                     <a:lstStyle/>
                     <a:p>
                       <a:r>
-                        <a:rPr sz="1725" b="1">
+                        <a:rPr sz="1800" b="1">
                           <a:solidFill>
                             <a:srgbClr val="FFFFFF"/>
                           </a:solidFill>
@@ -13097,7 +13097,7 @@
                     <a:lstStyle/>
                     <a:p>
                       <a:r>
-                        <a:rPr sz="1725" b="1">
+                        <a:rPr sz="1800" b="1">
                           <a:solidFill>
                             <a:srgbClr val="FFFFFF"/>
                           </a:solidFill>
@@ -13134,14 +13134,14 @@
                   </a:tcPr>
                 </a:tc>
               </a:tr>
-              <a:tr h="533400">
+              <a:tr h="552450">
                 <a:tc>
                   <a:txBody>
                     <a:bodyPr/>
                     <a:lstStyle/>
                     <a:p>
                       <a:r>
-                        <a:rPr sz="1725" b="0">
+                        <a:rPr sz="1800" b="0">
                           <a:solidFill>
                             <a:srgbClr val="102D35"/>
                           </a:solidFill>
@@ -13183,7 +13183,7 @@
                     <a:lstStyle/>
                     <a:p>
                       <a:r>
-                        <a:rPr sz="1725" b="0">
+                        <a:rPr sz="1800" b="0">
                           <a:solidFill>
                             <a:srgbClr val="102D35"/>
                           </a:solidFill>
@@ -13214,14 +13214,14 @@
                   </a:tcPr>
                 </a:tc>
               </a:tr>
-              <a:tr h="533400">
+              <a:tr h="552450">
                 <a:tc>
                   <a:txBody>
                     <a:bodyPr/>
                     <a:lstStyle/>
                     <a:p>
                       <a:r>
-                        <a:rPr sz="1725" b="0">
+                        <a:rPr sz="1800" b="0">
                           <a:solidFill>
                             <a:srgbClr val="102D35"/>
                           </a:solidFill>
@@ -13263,7 +13263,7 @@
                     <a:lstStyle/>
                     <a:p>
                       <a:r>
-                        <a:rPr sz="1725" b="0">
+                        <a:rPr sz="1800" b="0">
                           <a:solidFill>
                             <a:srgbClr val="102D35"/>
                           </a:solidFill>
@@ -13294,14 +13294,14 @@
                   </a:tcPr>
                 </a:tc>
               </a:tr>
-              <a:tr h="533400">
+              <a:tr h="704850">
                 <a:tc>
                   <a:txBody>
                     <a:bodyPr/>
                     <a:lstStyle/>
                     <a:p>
                       <a:r>
-                        <a:rPr sz="1725" b="0">
+                        <a:rPr sz="1800" b="0">
                           <a:solidFill>
                             <a:srgbClr val="102D35"/>
                           </a:solidFill>
@@ -13343,7 +13343,7 @@
                     <a:lstStyle/>
                     <a:p>
                       <a:r>
-                        <a:rPr sz="1725" b="0">
+                        <a:rPr sz="1800" b="0">
                           <a:solidFill>
                             <a:srgbClr val="102D35"/>
                           </a:solidFill>
@@ -13356,7 +13356,7 @@
                     </a:p>
                     <a:p>
                       <a:r>
-                        <a:rPr sz="1725" b="0">
+                        <a:rPr sz="1800" b="0">
                           <a:solidFill>
                             <a:srgbClr val="102D35"/>
                           </a:solidFill>
@@ -13387,14 +13387,14 @@
                   </a:tcPr>
                 </a:tc>
               </a:tr>
-              <a:tr h="533400">
+              <a:tr h="552450">
                 <a:tc>
                   <a:txBody>
                     <a:bodyPr/>
                     <a:lstStyle/>
                     <a:p>
                       <a:r>
-                        <a:rPr sz="1725" b="0">
+                        <a:rPr sz="1800" b="0">
                           <a:solidFill>
                             <a:srgbClr val="102D35"/>
                           </a:solidFill>
@@ -13436,7 +13436,7 @@
                     <a:lstStyle/>
                     <a:p>
                       <a:r>
-                        <a:rPr sz="1725" b="0">
+                        <a:rPr sz="1800" b="0">
                           <a:solidFill>
                             <a:srgbClr val="102D35"/>
                           </a:solidFill>

</xml_diff>

<commit_message>
docs: add training pseudocode and remove presenter-only slide hint
</commit_message>
<xml_diff>
--- a/docs/presentation/Sherlock_Review_16-10-2026.pptx
+++ b/docs/presentation/Sherlock_Review_16-10-2026.pptx
@@ -11833,10 +11833,10 @@
       </p:sp>
       <p:sp>
         <p:nvSpPr>
-          <p:cNvPr id="5" name="Vereinfachter Trainingsschritt">
+          <p:cNvPr id="9" name="revision-code-panel">
             <a:extLst>
               <a:ext uri="{FF2B5EF4-FFF2-40B4-BE49-F238E27FC236}">
-                <ns2:creationId id="{B829BE7C-C0A7-4CFF-A291-1084E281D8CE}"/>
+                <ns2:creationId id="{31916FFF-E749-417D-9080-2C442A44ACB1}"/>
               </a:ext>
             </a:extLst>
           </p:cNvPr>
@@ -11847,8 +11847,42 @@
         </p:nvSpPr>
         <p:spPr>
           <a:xfrm>
-            <a:off x="609600" y="1885950"/>
-            <a:ext cx="10972800" cy="476250"/>
+            <a:off x="3714750" y="1847850"/>
+            <a:ext cx="7867650" cy="4000500"/>
+          </a:xfrm>
+          <a:prstGeom prst="roundRect">
+            <a:avLst>
+              <a:gd name="adj" fmla="val 1905"/>
+            </a:avLst>
+          </a:prstGeom>
+          <a:solidFill>
+            <a:srgbClr val="EDF2F2"/>
+          </a:solidFill>
+          <a:ln w="11430">
+            <a:solidFill>
+              <a:srgbClr val="CFDBD7"/>
+            </a:solidFill>
+          </a:ln>
+        </p:spPr>
+      </p:sp>
+      <p:sp>
+        <p:nvSpPr>
+          <p:cNvPr id="10" name="revision-Erfahrungen">
+            <a:extLst>
+              <a:ext uri="{FF2B5EF4-FFF2-40B4-BE49-F238E27FC236}">
+                <ns2:creationId id="{AF51FF84-4A61-4137-8EF6-D9BFABF22566}"/>
+              </a:ext>
+            </a:extLst>
+          </p:cNvPr>
+          <p:cNvSpPr>
+            <a:spLocks noGrp="1"/>
+          </p:cNvSpPr>
+          <p:nvPr/>
+        </p:nvSpPr>
+        <p:spPr>
+          <a:xfrm>
+            <a:off x="609600" y="2028825"/>
+            <a:ext cx="2714625" cy="400050"/>
           </a:xfrm>
           <a:prstGeom prst="rect">
             <a:avLst/>
@@ -11859,7 +11893,9 @@
           </a:ln>
         </p:spPr>
         <p:txBody>
-          <a:bodyPr/>
+          <a:bodyPr>
+            <a:noAutofit/>
+          </a:bodyPr>
           <a:lstStyle>
             <a:defPPr>
               <a:defRPr sz="2175" b="1">
@@ -11892,17 +11928,17 @@
                 <a:ea typeface="Helvetica Neue"/>
                 <a:cs typeface="Helvetica Neue"/>
               </a:rPr>
-              <a:t>Vereinfachter Trainingsschritt</a:t>
+              <a:t>Erfahrungen</a:t>
             </a:r>
           </a:p>
         </p:txBody>
       </p:sp>
       <p:sp>
         <p:nvSpPr>
-          <p:cNvPr id="6" name="1   Ziehe Übergänge (s, a, r, s′, Ende) aus d">
+          <p:cNvPr id="11" name="revision-Zufällige Erfahrungen&#10;aus dem Buffer zie">
             <a:extLst>
               <a:ext uri="{FF2B5EF4-FFF2-40B4-BE49-F238E27FC236}">
-                <ns2:creationId id="{CDCF703F-9844-4F00-B13C-2643C05DCE0B}"/>
+                <ns2:creationId id="{384F6DC7-46F7-4483-993F-A78FBA893216}"/>
               </a:ext>
             </a:extLst>
           </p:cNvPr>
@@ -11913,8 +11949,8 @@
         </p:nvSpPr>
         <p:spPr>
           <a:xfrm>
-            <a:off x="609600" y="2543175"/>
-            <a:ext cx="10972800" cy="2590800"/>
+            <a:off x="609600" y="2476500"/>
+            <a:ext cx="2714625" cy="742950"/>
           </a:xfrm>
           <a:prstGeom prst="rect">
             <a:avLst/>
@@ -11925,12 +11961,14 @@
           </a:ln>
         </p:spPr>
         <p:txBody>
-          <a:bodyPr/>
+          <a:bodyPr>
+            <a:noAutofit/>
+          </a:bodyPr>
           <a:lstStyle>
             <a:defPPr>
-              <a:defRPr sz="2175" b="0">
-                <a:solidFill>
-                  <a:srgbClr val="102D35"/>
+              <a:defRPr sz="1875" b="0">
+                <a:solidFill>
+                  <a:srgbClr val="526B70"/>
                 </a:solidFill>
                 <a:latin typeface="Helvetica Neue"/>
                 <a:ea typeface="Helvetica Neue"/>
@@ -11940,9 +11978,9 @@
           </a:lstStyle>
           <a:p>
             <a:pPr>
-              <a:defRPr sz="2175" b="0">
-                <a:solidFill>
-                  <a:srgbClr val="102D35"/>
+              <a:defRPr sz="1875" b="0">
+                <a:solidFill>
+                  <a:srgbClr val="526B70"/>
                 </a:solidFill>
                 <a:latin typeface="Helvetica Neue"/>
                 <a:ea typeface="Helvetica Neue"/>
@@ -11950,22 +11988,22 @@
               </a:defRPr>
             </a:pPr>
             <a:r>
-              <a:rPr sz="2175" b="0">
-                <a:solidFill>
-                  <a:srgbClr val="102D35"/>
+              <a:rPr sz="1875" b="0">
+                <a:solidFill>
+                  <a:srgbClr val="526B70"/>
                 </a:solidFill>
                 <a:latin typeface="Helvetica Neue"/>
                 <a:ea typeface="Helvetica Neue"/>
                 <a:cs typeface="Helvetica Neue"/>
               </a:rPr>
-              <a:t>1   Ziehe Übergänge (s, a, r, s′, Ende) aus dem Buffer.</a:t>
+              <a:t>Zufällige Erfahrungen</a:t>
             </a:r>
           </a:p>
           <a:p>
             <a:pPr>
-              <a:defRPr sz="2175" b="0">
-                <a:solidFill>
-                  <a:srgbClr val="102D35"/>
+              <a:defRPr sz="1875" b="0">
+                <a:solidFill>
+                  <a:srgbClr val="526B70"/>
                 </a:solidFill>
                 <a:latin typeface="Helvetica Neue"/>
                 <a:ea typeface="Helvetica Neue"/>
@@ -11973,94 +12011,25 @@
               </a:defRPr>
             </a:pPr>
             <a:r>
-              <a:rPr sz="2175" b="0">
-                <a:solidFill>
-                  <a:srgbClr val="102D35"/>
+              <a:rPr sz="1875" b="0">
+                <a:solidFill>
+                  <a:srgbClr val="526B70"/>
                 </a:solidFill>
                 <a:latin typeface="Helvetica Neue"/>
                 <a:ea typeface="Helvetica Neue"/>
                 <a:cs typeface="Helvetica Neue"/>
               </a:rPr>
-              <a:t>2   a* = beste erlaubte Folgeaktion laut Online-Netz</a:t>
-            </a:r>
-          </a:p>
-          <a:p>
-            <a:pPr>
-              <a:defRPr sz="2175" b="0">
-                <a:solidFill>
-                  <a:srgbClr val="102D35"/>
-                </a:solidFill>
-                <a:latin typeface="Helvetica Neue"/>
-                <a:ea typeface="Helvetica Neue"/>
-                <a:cs typeface="Helvetica Neue"/>
-              </a:defRPr>
-            </a:pPr>
-            <a:r>
-              <a:rPr sz="2175" b="0">
-                <a:solidFill>
-                  <a:srgbClr val="102D35"/>
-                </a:solidFill>
-                <a:latin typeface="Helvetica Neue"/>
-                <a:ea typeface="Helvetica Neue"/>
-                <a:cs typeface="Helvetica Neue"/>
-              </a:rPr>
-              <a:t>3   Ziel = r + γ · Q_Target(s′, a*)  [ohne Folgewert bei Ende]</a:t>
-            </a:r>
-          </a:p>
-          <a:p>
-            <a:pPr>
-              <a:defRPr sz="2175" b="0">
-                <a:solidFill>
-                  <a:srgbClr val="102D35"/>
-                </a:solidFill>
-                <a:latin typeface="Helvetica Neue"/>
-                <a:ea typeface="Helvetica Neue"/>
-                <a:cs typeface="Helvetica Neue"/>
-              </a:defRPr>
-            </a:pPr>
-            <a:r>
-              <a:rPr sz="2175" b="0">
-                <a:solidFill>
-                  <a:srgbClr val="102D35"/>
-                </a:solidFill>
-                <a:latin typeface="Helvetica Neue"/>
-                <a:ea typeface="Helvetica Neue"/>
-                <a:cs typeface="Helvetica Neue"/>
-              </a:rPr>
-              <a:t>4   Passe Q_Online(s, a) an das Ziel an.</a:t>
-            </a:r>
-          </a:p>
-          <a:p>
-            <a:pPr>
-              <a:defRPr sz="2175" b="0">
-                <a:solidFill>
-                  <a:srgbClr val="102D35"/>
-                </a:solidFill>
-                <a:latin typeface="Helvetica Neue"/>
-                <a:ea typeface="Helvetica Neue"/>
-                <a:cs typeface="Helvetica Neue"/>
-              </a:defRPr>
-            </a:pPr>
-            <a:r>
-              <a:rPr sz="2175" b="0">
-                <a:solidFill>
-                  <a:srgbClr val="102D35"/>
-                </a:solidFill>
-                <a:latin typeface="Helvetica Neue"/>
-                <a:ea typeface="Helvetica Neue"/>
-                <a:cs typeface="Helvetica Neue"/>
-              </a:rPr>
-              <a:t>5   Kopiere das Online-Netz periodisch ins Target-Netz.</a:t>
+              <a:t>aus dem Buffer ziehen.</a:t>
             </a:r>
           </a:p>
         </p:txBody>
       </p:sp>
       <p:sp>
         <p:nvSpPr>
-          <p:cNvPr id="7" name="Belohnung: Punkte + Matchsieg + zusätzliche S">
+          <p:cNvPr id="12" name="revision-Lernen">
             <a:extLst>
               <a:ext uri="{FF2B5EF4-FFF2-40B4-BE49-F238E27FC236}">
-                <ns2:creationId id="{FE5B8263-3A52-4F38-9DE1-4A65083C9701}"/>
+                <ns2:creationId id="{FA940F2B-2912-4133-8F25-C27913D241D8}"/>
               </a:ext>
             </a:extLst>
           </p:cNvPr>
@@ -12071,8 +12040,8 @@
         </p:nvSpPr>
         <p:spPr>
           <a:xfrm>
-            <a:off x="609600" y="5495925"/>
-            <a:ext cx="10972800" cy="619125"/>
+            <a:off x="609600" y="3371850"/>
+            <a:ext cx="2714625" cy="400050"/>
           </a:xfrm>
           <a:prstGeom prst="rect">
             <a:avLst/>
@@ -12083,10 +12052,12 @@
           </a:ln>
         </p:spPr>
         <p:txBody>
-          <a:bodyPr/>
+          <a:bodyPr>
+            <a:noAutofit/>
+          </a:bodyPr>
           <a:lstStyle>
             <a:defPPr>
-              <a:defRPr sz="2100" b="1">
+              <a:defRPr sz="2175" b="1">
                 <a:solidFill>
                   <a:srgbClr val="007D7B"/>
                 </a:solidFill>
@@ -12098,7 +12069,7 @@
           </a:lstStyle>
           <a:p>
             <a:pPr>
-              <a:defRPr sz="2100" b="1">
+              <a:defRPr sz="2175" b="1">
                 <a:solidFill>
                   <a:srgbClr val="007D7B"/>
                 </a:solidFill>
@@ -12108,7 +12079,7 @@
               </a:defRPr>
             </a:pPr>
             <a:r>
-              <a:rPr sz="2100" b="1">
+              <a:rPr sz="2175" b="1">
                 <a:solidFill>
                   <a:srgbClr val="007D7B"/>
                 </a:solidFill>
@@ -12116,7 +12087,1005 @@
                 <a:ea typeface="Helvetica Neue"/>
                 <a:cs typeface="Helvetica Neue"/>
               </a:rPr>
-              <a:t>Belohnung: Punkte + Matchsieg + zusätzliche Shaping-Signale</a:t>
+              <a:t>Lernen</a:t>
+            </a:r>
+          </a:p>
+        </p:txBody>
+      </p:sp>
+      <p:sp>
+        <p:nvSpPr>
+          <p:cNvPr id="13" name="revision-Online-Netz wählt;&#10;Target-Netz bewertet.">
+            <a:extLst>
+              <a:ext uri="{FF2B5EF4-FFF2-40B4-BE49-F238E27FC236}">
+                <ns2:creationId id="{66586737-48FF-484D-B1B9-FDF87B6B2237}"/>
+              </a:ext>
+            </a:extLst>
+          </p:cNvPr>
+          <p:cNvSpPr>
+            <a:spLocks noGrp="1"/>
+          </p:cNvSpPr>
+          <p:nvPr/>
+        </p:nvSpPr>
+        <p:spPr>
+          <a:xfrm>
+            <a:off x="609600" y="3819525"/>
+            <a:ext cx="2714625" cy="742950"/>
+          </a:xfrm>
+          <a:prstGeom prst="rect">
+            <a:avLst/>
+          </a:prstGeom>
+          <a:noFill/>
+          <a:ln w="0">
+            <a:noFill/>
+          </a:ln>
+        </p:spPr>
+        <p:txBody>
+          <a:bodyPr>
+            <a:noAutofit/>
+          </a:bodyPr>
+          <a:lstStyle>
+            <a:defPPr>
+              <a:defRPr sz="1875" b="0">
+                <a:solidFill>
+                  <a:srgbClr val="526B70"/>
+                </a:solidFill>
+                <a:latin typeface="Helvetica Neue"/>
+                <a:ea typeface="Helvetica Neue"/>
+                <a:cs typeface="Helvetica Neue"/>
+              </a:defRPr>
+            </a:defPPr>
+          </a:lstStyle>
+          <a:p>
+            <a:pPr>
+              <a:defRPr sz="1875" b="0">
+                <a:solidFill>
+                  <a:srgbClr val="526B70"/>
+                </a:solidFill>
+                <a:latin typeface="Helvetica Neue"/>
+                <a:ea typeface="Helvetica Neue"/>
+                <a:cs typeface="Helvetica Neue"/>
+              </a:defRPr>
+            </a:pPr>
+            <a:r>
+              <a:rPr sz="1875" b="0">
+                <a:solidFill>
+                  <a:srgbClr val="526B70"/>
+                </a:solidFill>
+                <a:latin typeface="Helvetica Neue"/>
+                <a:ea typeface="Helvetica Neue"/>
+                <a:cs typeface="Helvetica Neue"/>
+              </a:rPr>
+              <a:t>Online-Netz wählt;</a:t>
+            </a:r>
+          </a:p>
+          <a:p>
+            <a:pPr>
+              <a:defRPr sz="1875" b="0">
+                <a:solidFill>
+                  <a:srgbClr val="526B70"/>
+                </a:solidFill>
+                <a:latin typeface="Helvetica Neue"/>
+                <a:ea typeface="Helvetica Neue"/>
+                <a:cs typeface="Helvetica Neue"/>
+              </a:defRPr>
+            </a:pPr>
+            <a:r>
+              <a:rPr sz="1875" b="0">
+                <a:solidFill>
+                  <a:srgbClr val="526B70"/>
+                </a:solidFill>
+                <a:latin typeface="Helvetica Neue"/>
+                <a:ea typeface="Helvetica Neue"/>
+                <a:cs typeface="Helvetica Neue"/>
+              </a:rPr>
+              <a:t>Target-Netz bewertet.</a:t>
+            </a:r>
+          </a:p>
+        </p:txBody>
+      </p:sp>
+      <p:sp>
+        <p:nvSpPr>
+          <p:cNvPr id="14" name="revision-Belohnung">
+            <a:extLst>
+              <a:ext uri="{FF2B5EF4-FFF2-40B4-BE49-F238E27FC236}">
+                <ns2:creationId id="{43FE2FA4-8653-4290-963D-21B57DA63D90}"/>
+              </a:ext>
+            </a:extLst>
+          </p:cNvPr>
+          <p:cNvSpPr>
+            <a:spLocks noGrp="1"/>
+          </p:cNvSpPr>
+          <p:nvPr/>
+        </p:nvSpPr>
+        <p:spPr>
+          <a:xfrm>
+            <a:off x="609600" y="4714875"/>
+            <a:ext cx="2714625" cy="400050"/>
+          </a:xfrm>
+          <a:prstGeom prst="rect">
+            <a:avLst/>
+          </a:prstGeom>
+          <a:noFill/>
+          <a:ln w="0">
+            <a:noFill/>
+          </a:ln>
+        </p:spPr>
+        <p:txBody>
+          <a:bodyPr>
+            <a:noAutofit/>
+          </a:bodyPr>
+          <a:lstStyle>
+            <a:defPPr>
+              <a:defRPr sz="2175" b="1">
+                <a:solidFill>
+                  <a:srgbClr val="007D7B"/>
+                </a:solidFill>
+                <a:latin typeface="Helvetica Neue"/>
+                <a:ea typeface="Helvetica Neue"/>
+                <a:cs typeface="Helvetica Neue"/>
+              </a:defRPr>
+            </a:defPPr>
+          </a:lstStyle>
+          <a:p>
+            <a:pPr>
+              <a:defRPr sz="2175" b="1">
+                <a:solidFill>
+                  <a:srgbClr val="007D7B"/>
+                </a:solidFill>
+                <a:latin typeface="Helvetica Neue"/>
+                <a:ea typeface="Helvetica Neue"/>
+                <a:cs typeface="Helvetica Neue"/>
+              </a:defRPr>
+            </a:pPr>
+            <a:r>
+              <a:rPr sz="2175" b="1">
+                <a:solidFill>
+                  <a:srgbClr val="007D7B"/>
+                </a:solidFill>
+                <a:latin typeface="Helvetica Neue"/>
+                <a:ea typeface="Helvetica Neue"/>
+                <a:cs typeface="Helvetica Neue"/>
+              </a:rPr>
+              <a:t>Belohnung</a:t>
+            </a:r>
+          </a:p>
+        </p:txBody>
+      </p:sp>
+      <p:sp>
+        <p:nvSpPr>
+          <p:cNvPr id="15" name="revision-Punkte, Matchsieg&#10;und Shaping-Signale.">
+            <a:extLst>
+              <a:ext uri="{FF2B5EF4-FFF2-40B4-BE49-F238E27FC236}">
+                <ns2:creationId id="{26925455-EFF4-45B4-9562-A68EA5E8F199}"/>
+              </a:ext>
+            </a:extLst>
+          </p:cNvPr>
+          <p:cNvSpPr>
+            <a:spLocks noGrp="1"/>
+          </p:cNvSpPr>
+          <p:nvPr/>
+        </p:nvSpPr>
+        <p:spPr>
+          <a:xfrm>
+            <a:off x="609600" y="5162550"/>
+            <a:ext cx="2714625" cy="742950"/>
+          </a:xfrm>
+          <a:prstGeom prst="rect">
+            <a:avLst/>
+          </a:prstGeom>
+          <a:noFill/>
+          <a:ln w="0">
+            <a:noFill/>
+          </a:ln>
+        </p:spPr>
+        <p:txBody>
+          <a:bodyPr>
+            <a:noAutofit/>
+          </a:bodyPr>
+          <a:lstStyle>
+            <a:defPPr>
+              <a:defRPr sz="1875" b="0">
+                <a:solidFill>
+                  <a:srgbClr val="526B70"/>
+                </a:solidFill>
+                <a:latin typeface="Helvetica Neue"/>
+                <a:ea typeface="Helvetica Neue"/>
+                <a:cs typeface="Helvetica Neue"/>
+              </a:defRPr>
+            </a:defPPr>
+          </a:lstStyle>
+          <a:p>
+            <a:pPr>
+              <a:defRPr sz="1875" b="0">
+                <a:solidFill>
+                  <a:srgbClr val="526B70"/>
+                </a:solidFill>
+                <a:latin typeface="Helvetica Neue"/>
+                <a:ea typeface="Helvetica Neue"/>
+                <a:cs typeface="Helvetica Neue"/>
+              </a:defRPr>
+            </a:pPr>
+            <a:r>
+              <a:rPr sz="1875" b="0">
+                <a:solidFill>
+                  <a:srgbClr val="526B70"/>
+                </a:solidFill>
+                <a:latin typeface="Helvetica Neue"/>
+                <a:ea typeface="Helvetica Neue"/>
+                <a:cs typeface="Helvetica Neue"/>
+              </a:rPr>
+              <a:t>Punkte, Matchsieg</a:t>
+            </a:r>
+          </a:p>
+          <a:p>
+            <a:pPr>
+              <a:defRPr sz="1875" b="0">
+                <a:solidFill>
+                  <a:srgbClr val="526B70"/>
+                </a:solidFill>
+                <a:latin typeface="Helvetica Neue"/>
+                <a:ea typeface="Helvetica Neue"/>
+                <a:cs typeface="Helvetica Neue"/>
+              </a:defRPr>
+            </a:pPr>
+            <a:r>
+              <a:rPr sz="1875" b="0">
+                <a:solidFill>
+                  <a:srgbClr val="526B70"/>
+                </a:solidFill>
+                <a:latin typeface="Helvetica Neue"/>
+                <a:ea typeface="Helvetica Neue"/>
+                <a:cs typeface="Helvetica Neue"/>
+              </a:rPr>
+              <a:t>und Shaping-Signale.</a:t>
+            </a:r>
+          </a:p>
+        </p:txBody>
+      </p:sp>
+      <p:sp>
+        <p:nvSpPr>
+          <p:cNvPr id="16" name="revision-Double DQN · Pseudocode">
+            <a:extLst>
+              <a:ext uri="{FF2B5EF4-FFF2-40B4-BE49-F238E27FC236}">
+                <ns2:creationId id="{048EE7C3-8DE3-4F42-8DBA-A291D22D142B}"/>
+              </a:ext>
+            </a:extLst>
+          </p:cNvPr>
+          <p:cNvSpPr>
+            <a:spLocks noGrp="1"/>
+          </p:cNvSpPr>
+          <p:nvPr/>
+        </p:nvSpPr>
+        <p:spPr>
+          <a:xfrm>
+            <a:off x="3943350" y="2028825"/>
+            <a:ext cx="7334250" cy="361950"/>
+          </a:xfrm>
+          <a:prstGeom prst="rect">
+            <a:avLst/>
+          </a:prstGeom>
+          <a:noFill/>
+          <a:ln w="0">
+            <a:noFill/>
+          </a:ln>
+        </p:spPr>
+        <p:txBody>
+          <a:bodyPr>
+            <a:noAutofit/>
+          </a:bodyPr>
+          <a:lstStyle>
+            <a:defPPr>
+              <a:defRPr sz="1725" b="1">
+                <a:solidFill>
+                  <a:srgbClr val="526B70"/>
+                </a:solidFill>
+                <a:latin typeface="Helvetica Neue"/>
+                <a:ea typeface="Helvetica Neue"/>
+                <a:cs typeface="Helvetica Neue"/>
+              </a:defRPr>
+            </a:defPPr>
+          </a:lstStyle>
+          <a:p>
+            <a:pPr>
+              <a:defRPr sz="1725" b="1">
+                <a:solidFill>
+                  <a:srgbClr val="526B70"/>
+                </a:solidFill>
+                <a:latin typeface="Helvetica Neue"/>
+                <a:ea typeface="Helvetica Neue"/>
+                <a:cs typeface="Helvetica Neue"/>
+              </a:defRPr>
+            </a:pPr>
+            <a:r>
+              <a:rPr sz="1725" b="1">
+                <a:solidFill>
+                  <a:srgbClr val="526B70"/>
+                </a:solidFill>
+                <a:latin typeface="Helvetica Neue"/>
+                <a:ea typeface="Helvetica Neue"/>
+                <a:cs typeface="Helvetica Neue"/>
+              </a:rPr>
+              <a:t>Double DQN · Pseudocode</a:t>
+            </a:r>
+          </a:p>
+        </p:txBody>
+      </p:sp>
+      <p:sp>
+        <p:nvSpPr>
+          <p:cNvPr id="17" name="revision-BEI jedem Lernupdate:">
+            <a:extLst>
+              <a:ext uri="{FF2B5EF4-FFF2-40B4-BE49-F238E27FC236}">
+                <ns2:creationId id="{4B31EEA0-CB12-4D3C-A400-9725F2E8C7C7}"/>
+              </a:ext>
+            </a:extLst>
+          </p:cNvPr>
+          <p:cNvSpPr>
+            <a:spLocks noGrp="1"/>
+          </p:cNvSpPr>
+          <p:nvPr/>
+        </p:nvSpPr>
+        <p:spPr>
+          <a:xfrm>
+            <a:off x="4010025" y="2552700"/>
+            <a:ext cx="7334250" cy="323850"/>
+          </a:xfrm>
+          <a:prstGeom prst="rect">
+            <a:avLst/>
+          </a:prstGeom>
+          <a:noFill/>
+          <a:ln w="0">
+            <a:noFill/>
+          </a:ln>
+        </p:spPr>
+        <p:txBody>
+          <a:bodyPr>
+            <a:noAutofit/>
+          </a:bodyPr>
+          <a:lstStyle>
+            <a:defPPr>
+              <a:defRPr sz="1800" b="0">
+                <a:solidFill>
+                  <a:srgbClr val="102D35"/>
+                </a:solidFill>
+                <a:latin typeface="Courier New"/>
+                <a:ea typeface="Courier New"/>
+                <a:cs typeface="Courier New"/>
+              </a:defRPr>
+            </a:defPPr>
+          </a:lstStyle>
+          <a:p>
+            <a:pPr>
+              <a:defRPr sz="1800" b="0">
+                <a:solidFill>
+                  <a:srgbClr val="102D35"/>
+                </a:solidFill>
+                <a:latin typeface="Courier New"/>
+                <a:ea typeface="Courier New"/>
+                <a:cs typeface="Courier New"/>
+              </a:defRPr>
+            </a:pPr>
+            <a:r>
+              <a:rPr sz="1800" b="0">
+                <a:solidFill>
+                  <a:srgbClr val="102D35"/>
+                </a:solidFill>
+                <a:latin typeface="Courier New"/>
+                <a:ea typeface="Courier New"/>
+                <a:cs typeface="Courier New"/>
+              </a:rPr>
+              <a:t>BEI jedem Lernupdate:</a:t>
+            </a:r>
+          </a:p>
+        </p:txBody>
+      </p:sp>
+      <p:sp>
+        <p:nvSpPr>
+          <p:cNvPr id="18" name="revision-    Batch = 256 Übergänge aus dem Buffer">
+            <a:extLst>
+              <a:ext uri="{FF2B5EF4-FFF2-40B4-BE49-F238E27FC236}">
+                <ns2:creationId id="{BFAA9AA4-8C49-4579-A94F-9E87C22FCCE7}"/>
+              </a:ext>
+            </a:extLst>
+          </p:cNvPr>
+          <p:cNvSpPr>
+            <a:spLocks noGrp="1"/>
+          </p:cNvSpPr>
+          <p:nvPr/>
+        </p:nvSpPr>
+        <p:spPr>
+          <a:xfrm>
+            <a:off x="4010025" y="2867025"/>
+            <a:ext cx="7334250" cy="323850"/>
+          </a:xfrm>
+          <a:prstGeom prst="rect">
+            <a:avLst/>
+          </a:prstGeom>
+          <a:noFill/>
+          <a:ln w="0">
+            <a:noFill/>
+          </a:ln>
+        </p:spPr>
+        <p:txBody>
+          <a:bodyPr>
+            <a:noAutofit/>
+          </a:bodyPr>
+          <a:lstStyle>
+            <a:defPPr>
+              <a:defRPr sz="1800" b="0">
+                <a:solidFill>
+                  <a:srgbClr val="102D35"/>
+                </a:solidFill>
+                <a:latin typeface="Courier New"/>
+                <a:ea typeface="Courier New"/>
+                <a:cs typeface="Courier New"/>
+              </a:defRPr>
+            </a:defPPr>
+          </a:lstStyle>
+          <a:p>
+            <a:pPr>
+              <a:defRPr sz="1800" b="0">
+                <a:solidFill>
+                  <a:srgbClr val="102D35"/>
+                </a:solidFill>
+                <a:latin typeface="Courier New"/>
+                <a:ea typeface="Courier New"/>
+                <a:cs typeface="Courier New"/>
+              </a:defRPr>
+            </a:pPr>
+            <a:r>
+              <a:rPr sz="1800" b="0">
+                <a:solidFill>
+                  <a:srgbClr val="102D35"/>
+                </a:solidFill>
+                <a:latin typeface="Courier New"/>
+                <a:ea typeface="Courier New"/>
+                <a:cs typeface="Courier New"/>
+              </a:rPr>
+              <a:t>    Batch = 256 Übergänge aus dem Buffer</a:t>
+            </a:r>
+          </a:p>
+        </p:txBody>
+      </p:sp>
+      <p:sp>
+        <p:nvSpPr>
+          <p:cNvPr id="19" name="revision-    FÜR jeden Übergang (s, a, r, s', End">
+            <a:extLst>
+              <a:ext uri="{FF2B5EF4-FFF2-40B4-BE49-F238E27FC236}">
+                <ns2:creationId id="{FF609B7D-55EF-4289-94D3-F86DFA94EDFB}"/>
+              </a:ext>
+            </a:extLst>
+          </p:cNvPr>
+          <p:cNvSpPr>
+            <a:spLocks noGrp="1"/>
+          </p:cNvSpPr>
+          <p:nvPr/>
+        </p:nvSpPr>
+        <p:spPr>
+          <a:xfrm>
+            <a:off x="4010025" y="3181350"/>
+            <a:ext cx="7334250" cy="323850"/>
+          </a:xfrm>
+          <a:prstGeom prst="rect">
+            <a:avLst/>
+          </a:prstGeom>
+          <a:noFill/>
+          <a:ln w="0">
+            <a:noFill/>
+          </a:ln>
+        </p:spPr>
+        <p:txBody>
+          <a:bodyPr>
+            <a:noAutofit/>
+          </a:bodyPr>
+          <a:lstStyle>
+            <a:defPPr>
+              <a:defRPr sz="1800" b="0">
+                <a:solidFill>
+                  <a:srgbClr val="102D35"/>
+                </a:solidFill>
+                <a:latin typeface="Courier New"/>
+                <a:ea typeface="Courier New"/>
+                <a:cs typeface="Courier New"/>
+              </a:defRPr>
+            </a:defPPr>
+          </a:lstStyle>
+          <a:p>
+            <a:pPr>
+              <a:defRPr sz="1800" b="0">
+                <a:solidFill>
+                  <a:srgbClr val="102D35"/>
+                </a:solidFill>
+                <a:latin typeface="Courier New"/>
+                <a:ea typeface="Courier New"/>
+                <a:cs typeface="Courier New"/>
+              </a:defRPr>
+            </a:pPr>
+            <a:r>
+              <a:rPr sz="1800" b="0">
+                <a:solidFill>
+                  <a:srgbClr val="102D35"/>
+                </a:solidFill>
+                <a:latin typeface="Courier New"/>
+                <a:ea typeface="Courier New"/>
+                <a:cs typeface="Courier New"/>
+              </a:rPr>
+              <a:t>    FÜR jeden Übergang (s, a, r, s', Ende):</a:t>
+            </a:r>
+          </a:p>
+        </p:txBody>
+      </p:sp>
+      <p:sp>
+        <p:nvSpPr>
+          <p:cNvPr id="20" name="revision-        a* = beste erlaubte Folgeaktion">
+            <a:extLst>
+              <a:ext uri="{FF2B5EF4-FFF2-40B4-BE49-F238E27FC236}">
+                <ns2:creationId id="{83735135-0A41-49D4-BB53-FFBB4709A50E}"/>
+              </a:ext>
+            </a:extLst>
+          </p:cNvPr>
+          <p:cNvSpPr>
+            <a:spLocks noGrp="1"/>
+          </p:cNvSpPr>
+          <p:nvPr/>
+        </p:nvSpPr>
+        <p:spPr>
+          <a:xfrm>
+            <a:off x="4010025" y="3495675"/>
+            <a:ext cx="7334250" cy="323850"/>
+          </a:xfrm>
+          <a:prstGeom prst="rect">
+            <a:avLst/>
+          </a:prstGeom>
+          <a:noFill/>
+          <a:ln w="0">
+            <a:noFill/>
+          </a:ln>
+        </p:spPr>
+        <p:txBody>
+          <a:bodyPr>
+            <a:noAutofit/>
+          </a:bodyPr>
+          <a:lstStyle>
+            <a:defPPr>
+              <a:defRPr sz="1800" b="0">
+                <a:solidFill>
+                  <a:srgbClr val="102D35"/>
+                </a:solidFill>
+                <a:latin typeface="Courier New"/>
+                <a:ea typeface="Courier New"/>
+                <a:cs typeface="Courier New"/>
+              </a:defRPr>
+            </a:defPPr>
+          </a:lstStyle>
+          <a:p>
+            <a:pPr>
+              <a:defRPr sz="1800" b="0">
+                <a:solidFill>
+                  <a:srgbClr val="102D35"/>
+                </a:solidFill>
+                <a:latin typeface="Courier New"/>
+                <a:ea typeface="Courier New"/>
+                <a:cs typeface="Courier New"/>
+              </a:defRPr>
+            </a:pPr>
+            <a:r>
+              <a:rPr sz="1800" b="0">
+                <a:solidFill>
+                  <a:srgbClr val="102D35"/>
+                </a:solidFill>
+                <a:latin typeface="Courier New"/>
+                <a:ea typeface="Courier New"/>
+                <a:cs typeface="Courier New"/>
+              </a:rPr>
+              <a:t>        a* = beste erlaubte Folgeaktion</a:t>
+            </a:r>
+          </a:p>
+        </p:txBody>
+      </p:sp>
+      <p:sp>
+        <p:nvSpPr>
+          <p:cNvPr id="21" name="revision-             laut Online-Netz">
+            <a:extLst>
+              <a:ext uri="{FF2B5EF4-FFF2-40B4-BE49-F238E27FC236}">
+                <ns2:creationId id="{0B17DB1A-03D1-4792-869E-11C4A5D35C33}"/>
+              </a:ext>
+            </a:extLst>
+          </p:cNvPr>
+          <p:cNvSpPr>
+            <a:spLocks noGrp="1"/>
+          </p:cNvSpPr>
+          <p:nvPr/>
+        </p:nvSpPr>
+        <p:spPr>
+          <a:xfrm>
+            <a:off x="4010025" y="3810000"/>
+            <a:ext cx="7334250" cy="323850"/>
+          </a:xfrm>
+          <a:prstGeom prst="rect">
+            <a:avLst/>
+          </a:prstGeom>
+          <a:noFill/>
+          <a:ln w="0">
+            <a:noFill/>
+          </a:ln>
+        </p:spPr>
+        <p:txBody>
+          <a:bodyPr>
+            <a:noAutofit/>
+          </a:bodyPr>
+          <a:lstStyle>
+            <a:defPPr>
+              <a:defRPr sz="1800" b="0">
+                <a:solidFill>
+                  <a:srgbClr val="102D35"/>
+                </a:solidFill>
+                <a:latin typeface="Courier New"/>
+                <a:ea typeface="Courier New"/>
+                <a:cs typeface="Courier New"/>
+              </a:defRPr>
+            </a:defPPr>
+          </a:lstStyle>
+          <a:p>
+            <a:pPr>
+              <a:defRPr sz="1800" b="0">
+                <a:solidFill>
+                  <a:srgbClr val="102D35"/>
+                </a:solidFill>
+                <a:latin typeface="Courier New"/>
+                <a:ea typeface="Courier New"/>
+                <a:cs typeface="Courier New"/>
+              </a:defRPr>
+            </a:pPr>
+            <a:r>
+              <a:rPr sz="1800" b="0">
+                <a:solidFill>
+                  <a:srgbClr val="102D35"/>
+                </a:solidFill>
+                <a:latin typeface="Courier New"/>
+                <a:ea typeface="Courier New"/>
+                <a:cs typeface="Courier New"/>
+              </a:rPr>
+              <a:t>             laut Online-Netz</a:t>
+            </a:r>
+          </a:p>
+        </p:txBody>
+      </p:sp>
+      <p:sp>
+        <p:nvSpPr>
+          <p:cNvPr id="22" name="revision-        Ziel = r, falls Ende">
+            <a:extLst>
+              <a:ext uri="{FF2B5EF4-FFF2-40B4-BE49-F238E27FC236}">
+                <ns2:creationId id="{BAB1719A-526D-44C9-8415-17625F7C25DC}"/>
+              </a:ext>
+            </a:extLst>
+          </p:cNvPr>
+          <p:cNvSpPr>
+            <a:spLocks noGrp="1"/>
+          </p:cNvSpPr>
+          <p:nvPr/>
+        </p:nvSpPr>
+        <p:spPr>
+          <a:xfrm>
+            <a:off x="4010025" y="4124325"/>
+            <a:ext cx="7334250" cy="323850"/>
+          </a:xfrm>
+          <a:prstGeom prst="rect">
+            <a:avLst/>
+          </a:prstGeom>
+          <a:noFill/>
+          <a:ln w="0">
+            <a:noFill/>
+          </a:ln>
+        </p:spPr>
+        <p:txBody>
+          <a:bodyPr>
+            <a:noAutofit/>
+          </a:bodyPr>
+          <a:lstStyle>
+            <a:defPPr>
+              <a:defRPr sz="1800" b="0">
+                <a:solidFill>
+                  <a:srgbClr val="102D35"/>
+                </a:solidFill>
+                <a:latin typeface="Courier New"/>
+                <a:ea typeface="Courier New"/>
+                <a:cs typeface="Courier New"/>
+              </a:defRPr>
+            </a:defPPr>
+          </a:lstStyle>
+          <a:p>
+            <a:pPr>
+              <a:defRPr sz="1800" b="0">
+                <a:solidFill>
+                  <a:srgbClr val="102D35"/>
+                </a:solidFill>
+                <a:latin typeface="Courier New"/>
+                <a:ea typeface="Courier New"/>
+                <a:cs typeface="Courier New"/>
+              </a:defRPr>
+            </a:pPr>
+            <a:r>
+              <a:rPr sz="1800" b="0">
+                <a:solidFill>
+                  <a:srgbClr val="102D35"/>
+                </a:solidFill>
+                <a:latin typeface="Courier New"/>
+                <a:ea typeface="Courier New"/>
+                <a:cs typeface="Courier New"/>
+              </a:rPr>
+              <a:t>        Ziel = r, falls Ende</a:t>
+            </a:r>
+          </a:p>
+        </p:txBody>
+      </p:sp>
+      <p:sp>
+        <p:nvSpPr>
+          <p:cNvPr id="23" name="revision-        SONST: Ziel = r + γ · Q_Target(s">
+            <a:extLst>
+              <a:ext uri="{FF2B5EF4-FFF2-40B4-BE49-F238E27FC236}">
+                <ns2:creationId id="{B0858CA5-F652-4669-B92F-D5D93637AE16}"/>
+              </a:ext>
+            </a:extLst>
+          </p:cNvPr>
+          <p:cNvSpPr>
+            <a:spLocks noGrp="1"/>
+          </p:cNvSpPr>
+          <p:nvPr/>
+        </p:nvSpPr>
+        <p:spPr>
+          <a:xfrm>
+            <a:off x="4010025" y="4438650"/>
+            <a:ext cx="7334250" cy="323850"/>
+          </a:xfrm>
+          <a:prstGeom prst="rect">
+            <a:avLst/>
+          </a:prstGeom>
+          <a:noFill/>
+          <a:ln w="0">
+            <a:noFill/>
+          </a:ln>
+        </p:spPr>
+        <p:txBody>
+          <a:bodyPr>
+            <a:noAutofit/>
+          </a:bodyPr>
+          <a:lstStyle>
+            <a:defPPr>
+              <a:defRPr sz="1800" b="0">
+                <a:solidFill>
+                  <a:srgbClr val="102D35"/>
+                </a:solidFill>
+                <a:latin typeface="Courier New"/>
+                <a:ea typeface="Courier New"/>
+                <a:cs typeface="Courier New"/>
+              </a:defRPr>
+            </a:defPPr>
+          </a:lstStyle>
+          <a:p>
+            <a:pPr>
+              <a:defRPr sz="1800" b="0">
+                <a:solidFill>
+                  <a:srgbClr val="102D35"/>
+                </a:solidFill>
+                <a:latin typeface="Courier New"/>
+                <a:ea typeface="Courier New"/>
+                <a:cs typeface="Courier New"/>
+              </a:defRPr>
+            </a:pPr>
+            <a:r>
+              <a:rPr sz="1800" b="0">
+                <a:solidFill>
+                  <a:srgbClr val="102D35"/>
+                </a:solidFill>
+                <a:latin typeface="Courier New"/>
+                <a:ea typeface="Courier New"/>
+                <a:cs typeface="Courier New"/>
+              </a:rPr>
+              <a:t>        SONST: Ziel = r + γ · Q_Target(s', a*)</a:t>
+            </a:r>
+          </a:p>
+        </p:txBody>
+      </p:sp>
+      <p:sp>
+        <p:nvSpPr>
+          <p:cNvPr id="24" name="revision-    Online-Netz an die Ziele anpassen">
+            <a:extLst>
+              <a:ext uri="{FF2B5EF4-FFF2-40B4-BE49-F238E27FC236}">
+                <ns2:creationId id="{7BFD4AEE-E9A9-4B13-9061-1B1F24A7E399}"/>
+              </a:ext>
+            </a:extLst>
+          </p:cNvPr>
+          <p:cNvSpPr>
+            <a:spLocks noGrp="1"/>
+          </p:cNvSpPr>
+          <p:nvPr/>
+        </p:nvSpPr>
+        <p:spPr>
+          <a:xfrm>
+            <a:off x="4010025" y="4752975"/>
+            <a:ext cx="7334250" cy="323850"/>
+          </a:xfrm>
+          <a:prstGeom prst="rect">
+            <a:avLst/>
+          </a:prstGeom>
+          <a:noFill/>
+          <a:ln w="0">
+            <a:noFill/>
+          </a:ln>
+        </p:spPr>
+        <p:txBody>
+          <a:bodyPr>
+            <a:noAutofit/>
+          </a:bodyPr>
+          <a:lstStyle>
+            <a:defPPr>
+              <a:defRPr sz="1800" b="0">
+                <a:solidFill>
+                  <a:srgbClr val="102D35"/>
+                </a:solidFill>
+                <a:latin typeface="Courier New"/>
+                <a:ea typeface="Courier New"/>
+                <a:cs typeface="Courier New"/>
+              </a:defRPr>
+            </a:defPPr>
+          </a:lstStyle>
+          <a:p>
+            <a:pPr>
+              <a:defRPr sz="1800" b="0">
+                <a:solidFill>
+                  <a:srgbClr val="102D35"/>
+                </a:solidFill>
+                <a:latin typeface="Courier New"/>
+                <a:ea typeface="Courier New"/>
+                <a:cs typeface="Courier New"/>
+              </a:defRPr>
+            </a:pPr>
+            <a:r>
+              <a:rPr sz="1800" b="0">
+                <a:solidFill>
+                  <a:srgbClr val="102D35"/>
+                </a:solidFill>
+                <a:latin typeface="Courier New"/>
+                <a:ea typeface="Courier New"/>
+                <a:cs typeface="Courier New"/>
+              </a:rPr>
+              <a:t>    Online-Netz an die Ziele anpassen</a:t>
+            </a:r>
+          </a:p>
+        </p:txBody>
+      </p:sp>
+      <p:sp>
+        <p:nvSpPr>
+          <p:cNvPr id="25" name="revision-    ALLE 500 Updates: Target = Online">
+            <a:extLst>
+              <a:ext uri="{FF2B5EF4-FFF2-40B4-BE49-F238E27FC236}">
+                <ns2:creationId id="{11E73118-01BB-4673-A71B-0C0ACEEB2696}"/>
+              </a:ext>
+            </a:extLst>
+          </p:cNvPr>
+          <p:cNvSpPr>
+            <a:spLocks noGrp="1"/>
+          </p:cNvSpPr>
+          <p:nvPr/>
+        </p:nvSpPr>
+        <p:spPr>
+          <a:xfrm>
+            <a:off x="4010025" y="5067300"/>
+            <a:ext cx="7334250" cy="323850"/>
+          </a:xfrm>
+          <a:prstGeom prst="rect">
+            <a:avLst/>
+          </a:prstGeom>
+          <a:noFill/>
+          <a:ln w="0">
+            <a:noFill/>
+          </a:ln>
+        </p:spPr>
+        <p:txBody>
+          <a:bodyPr>
+            <a:noAutofit/>
+          </a:bodyPr>
+          <a:lstStyle>
+            <a:defPPr>
+              <a:defRPr sz="1800" b="0">
+                <a:solidFill>
+                  <a:srgbClr val="102D35"/>
+                </a:solidFill>
+                <a:latin typeface="Courier New"/>
+                <a:ea typeface="Courier New"/>
+                <a:cs typeface="Courier New"/>
+              </a:defRPr>
+            </a:defPPr>
+          </a:lstStyle>
+          <a:p>
+            <a:pPr>
+              <a:defRPr sz="1800" b="0">
+                <a:solidFill>
+                  <a:srgbClr val="102D35"/>
+                </a:solidFill>
+                <a:latin typeface="Courier New"/>
+                <a:ea typeface="Courier New"/>
+                <a:cs typeface="Courier New"/>
+              </a:defRPr>
+            </a:pPr>
+            <a:r>
+              <a:rPr sz="1800" b="0">
+                <a:solidFill>
+                  <a:srgbClr val="102D35"/>
+                </a:solidFill>
+                <a:latin typeface="Courier New"/>
+                <a:ea typeface="Courier New"/>
+                <a:cs typeface="Courier New"/>
+              </a:rPr>
+              <a:t>    ALLE 500 Updates: Target = Online</a:t>
+            </a:r>
+          </a:p>
+        </p:txBody>
+      </p:sp>
+      <p:sp>
+        <p:nvSpPr>
+          <p:cNvPr id="26" name="revision-# Online wählt, Target bewertet">
+            <a:extLst>
+              <a:ext uri="{FF2B5EF4-FFF2-40B4-BE49-F238E27FC236}">
+                <ns2:creationId id="{F43E4925-E5B1-44A2-B250-15C62AE0F985}"/>
+              </a:ext>
+            </a:extLst>
+          </p:cNvPr>
+          <p:cNvSpPr>
+            <a:spLocks noGrp="1"/>
+          </p:cNvSpPr>
+          <p:nvPr/>
+        </p:nvSpPr>
+        <p:spPr>
+          <a:xfrm>
+            <a:off x="4010025" y="5505450"/>
+            <a:ext cx="7334250" cy="285750"/>
+          </a:xfrm>
+          <a:prstGeom prst="rect">
+            <a:avLst/>
+          </a:prstGeom>
+          <a:noFill/>
+          <a:ln w="0">
+            <a:noFill/>
+          </a:ln>
+        </p:spPr>
+        <p:txBody>
+          <a:bodyPr>
+            <a:noAutofit/>
+          </a:bodyPr>
+          <a:lstStyle>
+            <a:defPPr>
+              <a:defRPr sz="1575" b="0">
+                <a:solidFill>
+                  <a:srgbClr val="526B70"/>
+                </a:solidFill>
+                <a:latin typeface="Courier New"/>
+                <a:ea typeface="Courier New"/>
+                <a:cs typeface="Courier New"/>
+              </a:defRPr>
+            </a:defPPr>
+          </a:lstStyle>
+          <a:p>
+            <a:pPr>
+              <a:defRPr sz="1575" b="0">
+                <a:solidFill>
+                  <a:srgbClr val="526B70"/>
+                </a:solidFill>
+                <a:latin typeface="Courier New"/>
+                <a:ea typeface="Courier New"/>
+                <a:cs typeface="Courier New"/>
+              </a:defRPr>
+            </a:pPr>
+            <a:r>
+              <a:rPr sz="1575" b="0">
+                <a:solidFill>
+                  <a:srgbClr val="526B70"/>
+                </a:solidFill>
+                <a:latin typeface="Courier New"/>
+                <a:ea typeface="Courier New"/>
+                <a:cs typeface="Courier New"/>
+              </a:rPr>
+              <a:t># Online wählt, Target bewertet</a:t>
             </a:r>
           </a:p>
         </p:txBody>
@@ -12547,74 +13516,6 @@
                 <a:cs typeface="Helvetica Neue"/>
               </a:rPr>
               <a:t>Trainingsspiele der sechs Basisläufe des aktuellen Ensembles</a:t>
-            </a:r>
-          </a:p>
-        </p:txBody>
-      </p:sp>
-      <p:sp>
-        <p:nvSpPr>
-          <p:cNvPr id="12" name="revision-Weitere Einstellungen: Reservefolie 12">
-            <a:extLst>
-              <a:ext uri="{FF2B5EF4-FFF2-40B4-BE49-F238E27FC236}">
-                <ns2:creationId id="{8EE07D97-1DC7-4B5C-822F-088950E6C680}"/>
-              </a:ext>
-            </a:extLst>
-          </p:cNvPr>
-          <p:cNvSpPr>
-            <a:spLocks noGrp="1"/>
-          </p:cNvSpPr>
-          <p:nvPr/>
-        </p:nvSpPr>
-        <p:spPr>
-          <a:xfrm>
-            <a:off x="6286500" y="6019800"/>
-            <a:ext cx="5295900" cy="266700"/>
-          </a:xfrm>
-          <a:prstGeom prst="rect">
-            <a:avLst/>
-          </a:prstGeom>
-          <a:noFill/>
-          <a:ln w="0">
-            <a:noFill/>
-          </a:ln>
-        </p:spPr>
-        <p:txBody>
-          <a:bodyPr>
-            <a:noAutofit/>
-          </a:bodyPr>
-          <a:lstStyle>
-            <a:defPPr>
-              <a:defRPr sz="1350" b="0">
-                <a:solidFill>
-                  <a:srgbClr val="526B70"/>
-                </a:solidFill>
-                <a:latin typeface="Helvetica Neue"/>
-                <a:ea typeface="Helvetica Neue"/>
-                <a:cs typeface="Helvetica Neue"/>
-              </a:defRPr>
-            </a:defPPr>
-          </a:lstStyle>
-          <a:p>
-            <a:pPr>
-              <a:defRPr sz="1350" b="0">
-                <a:solidFill>
-                  <a:srgbClr val="526B70"/>
-                </a:solidFill>
-                <a:latin typeface="Helvetica Neue"/>
-                <a:ea typeface="Helvetica Neue"/>
-                <a:cs typeface="Helvetica Neue"/>
-              </a:defRPr>
-            </a:pPr>
-            <a:r>
-              <a:rPr sz="1350" b="0">
-                <a:solidFill>
-                  <a:srgbClr val="526B70"/>
-                </a:solidFill>
-                <a:latin typeface="Helvetica Neue"/>
-                <a:ea typeface="Helvetica Neue"/>
-                <a:cs typeface="Helvetica Neue"/>
-              </a:rPr>
-              <a:t>Weitere Einstellungen: Reservefolie 12</a:t>
             </a:r>
           </a:p>
         </p:txBody>
@@ -13039,8 +13940,8 @@
             <a:tbl>
               <a:tblPr/>
               <a:tblGrid>
-                <a:gridCol w="1809750"/>
-                <a:gridCol w="3486150"/>
+                <a:gridCol w="1619250"/>
+                <a:gridCol w="3676650"/>
               </a:tblGrid>
               <a:tr h="495300">
                 <a:tc>

</xml_diff>

<commit_message>
docs: add presentation agenda and update slide references
</commit_message>
<xml_diff>
--- a/docs/presentation/Sherlock_Review_16-10-2026.pptx
+++ b/docs/presentation/Sherlock_Review_16-10-2026.pptx
@@ -1,26 +1,27 @@
 
 <file path=ppt/presentation.xml><?xml version="1.0" encoding="utf-8"?>
-<p:presentation xmlns:p="http://schemas.openxmlformats.org/presentationml/2006/main">
+<p:presentation xmlns:p="http://schemas.openxmlformats.org/presentationml/2006/main" xmlns:r="http://schemas.openxmlformats.org/officeDocument/2006/relationships">
   <p:sldMasterIdLst>
-    <p:sldMasterId xmlns:r="http://schemas.openxmlformats.org/officeDocument/2006/relationships" id="2147483648" r:id="Rd53c6d305e6d4d2c"/>
+    <p:sldMasterId id="2147483648" r:id="Rd53c6d305e6d4d2c"/>
   </p:sldMasterIdLst>
   <p:notesMasterIdLst>
-    <p:notesMasterId xmlns:r="http://schemas.openxmlformats.org/officeDocument/2006/relationships" r:id="R037e31a0b2814472"/>
+    <p:notesMasterId r:id="R037e31a0b2814472"/>
   </p:notesMasterIdLst>
   <p:sldIdLst>
-    <p:sldId xmlns:r="http://schemas.openxmlformats.org/officeDocument/2006/relationships" id="256" r:id="Rdfe272e66ea8428c"/>
-    <p:sldId xmlns:r="http://schemas.openxmlformats.org/officeDocument/2006/relationships" id="257" r:id="R866c04c225d34bad"/>
-    <p:sldId xmlns:r="http://schemas.openxmlformats.org/officeDocument/2006/relationships" id="258" r:id="Rbe5b31d8e6704758"/>
-    <p:sldId xmlns:r="http://schemas.openxmlformats.org/officeDocument/2006/relationships" id="259" r:id="R3cbb029642a2410a"/>
-    <p:sldId xmlns:r="http://schemas.openxmlformats.org/officeDocument/2006/relationships" id="260" r:id="R83d06ea26f714a1e"/>
-    <p:sldId xmlns:r="http://schemas.openxmlformats.org/officeDocument/2006/relationships" id="261" r:id="R0a7ba96cb70543df"/>
-    <p:sldId xmlns:r="http://schemas.openxmlformats.org/officeDocument/2006/relationships" id="262" r:id="Reece4f0d48964c47"/>
-    <p:sldId xmlns:r="http://schemas.openxmlformats.org/officeDocument/2006/relationships" id="263" r:id="Rf2e3dfae2c4c46f6"/>
-    <p:sldId xmlns:r="http://schemas.openxmlformats.org/officeDocument/2006/relationships" id="264" r:id="R60833eb504304b20"/>
-    <p:sldId xmlns:r="http://schemas.openxmlformats.org/officeDocument/2006/relationships" id="265" r:id="Rded6d969fc204e7b"/>
-    <p:sldId xmlns:r="http://schemas.openxmlformats.org/officeDocument/2006/relationships" id="266" r:id="R14fd2b0f78a1438d"/>
-    <p:sldId xmlns:r="http://schemas.openxmlformats.org/officeDocument/2006/relationships" id="267" r:id="Rb6dbdcbeed01465d"/>
-    <p:sldId xmlns:r="http://schemas.openxmlformats.org/officeDocument/2006/relationships" id="268" r:id="Rd16c706467ac45df"/>
+    <p:sldId id="256" r:id="Rdfe272e66ea8428c"/>
+    <p:sldId id="269" r:id="rIdAgenda20261015"/>
+    <p:sldId id="257" r:id="R866c04c225d34bad"/>
+    <p:sldId id="258" r:id="Rbe5b31d8e6704758"/>
+    <p:sldId id="259" r:id="R3cbb029642a2410a"/>
+    <p:sldId id="260" r:id="R83d06ea26f714a1e"/>
+    <p:sldId id="261" r:id="R0a7ba96cb70543df"/>
+    <p:sldId id="262" r:id="Reece4f0d48964c47"/>
+    <p:sldId id="263" r:id="Rf2e3dfae2c4c46f6"/>
+    <p:sldId id="264" r:id="R60833eb504304b20"/>
+    <p:sldId id="265" r:id="Rded6d969fc204e7b"/>
+    <p:sldId id="266" r:id="R14fd2b0f78a1438d"/>
+    <p:sldId id="267" r:id="Rb6dbdcbeed01465d"/>
+    <p:sldId id="268" r:id="Rd16c706467ac45df"/>
   </p:sldIdLst>
   <p:sldSz cx="12192000" cy="6858000"/>
   <p:notesSz cx="6858000" cy="9144000"/>
@@ -554,7 +555,7 @@
           <a:lstStyle xmlns:a="http://schemas.openxmlformats.org/drawingml/2006/main"/>
           <a:p xmlns:a="http://schemas.openxmlformats.org/drawingml/2006/main">
             <a:r>
-              <a:t>Mahmoud · 55 Sekunden</a:t>
+              <a:t>Moayed · 80 Sekunden</a:t>
             </a:r>
           </a:p>
           <a:p xmlns:a="http://schemas.openxmlformats.org/drawingml/2006/main">
@@ -564,7 +565,7 @@
           </a:p>
           <a:p xmlns:a="http://schemas.openxmlformats.org/drawingml/2006/main">
             <a:r>
-              <a:t>Unser Agent kombiniert gelernte Entscheidungen mit explizitem Wissen über das Spiel. Die bisherigen Versuche sprechen dafür, Gedächtnis und mehrere Netzbewertungen zu kombinieren. Weitertraining und Self-Play haben in den getesteten Varianten keinen klaren zusätzlichen Gewinn gebracht; das ist keine allgemeine Aussage gegen diese Verfahren. Eine Arbeitshypothese ist, dass bessere frühe Erkundung und frühere Inferenz im ersten Match helfen. Der Kandidat m1_early ist untersucht, aber noch nicht in der Abgabe aktiviert. Vor weiterem Training prüfen wir außerdem Reward und Einheitenübergänge. Für die nächste belastbare Bewertung wollen wir neue Testkarten zurückhalten. Der Präsentationsstand und seine Gewichte bleiben dabei fest.</a:t>
+              <a:t>Das sind zwei echte Bilder aus demselben Spiel gegen default. Sherlock ist blau, der Gegner rot. Links, bei Schritt 23, sind unsere Einheiten noch über die Karte verteilt und beide Teams haben null Punkte. Rechts, bei Schritt 90 im ersten Match, stehen viele blaue Einheiten im Bereich der gelb markierten Punktefelder. Der Zwischenstand ist 374 zu 11. Man sieht: Bewegung allein ist nicht das Ziel. Sobald geeignete Punktefelder bekannt sind, kann Stehenbleiben sinnvoll sein, weil ein besetztes Feld wiederholt Punkte bringt. Das Gedächtnis hilft dabei, einmal gewonnene Informationen weiterzuverwenden. Die Bilder zeigen die vollständige Zuschaueransicht, nicht den Wissensstand des Agenten. Dieses Spiel veranschaulicht einen gelungenen Ablauf; es beweist nicht, dass Sherlock in jedem Spiel so handelt. Die Niederlagen gegen Solution_92 gehören ebenfalls zu unserer Auswertung.</a:t>
             </a:r>
           </a:p>
           <a:p xmlns:a="http://schemas.openxmlformats.org/drawingml/2006/main">
@@ -579,17 +580,12 @@
           </a:p>
           <a:p xmlns:a="http://schemas.openxmlformats.org/drawingml/2006/main">
             <a:r>
-              <a:t>docs/EXPERIMENT_PROTOKOLL.md</a:t>
+              <a:t>docs/presentation/replays/sherlock_sieg_vs_default.json · Frames 23 und 90</a:t>
             </a:r>
           </a:p>
           <a:p xmlns:a="http://schemas.openxmlformats.org/drawingml/2006/main">
             <a:r>
-              <a:t>docs/ARBEITSSTAND.md</a:t>
-            </a:r>
-          </a:p>
-          <a:p xmlns:a="http://schemas.openxmlformats.org/drawingml/2006/main">
-            <a:r>
-              <a:t>docs/STATISTIK_20261014.md</a:t>
+              <a:t>Screenshot: https://s3vis.lux-ai.org/ · Seed 900011, Sherlock player_0</a:t>
             </a:r>
           </a:p>
         </p:txBody>
@@ -620,6 +616,111 @@
 </file>
 
 <file path=ppt/notesSlides/notesSlide11.xml><?xml version="1.0" encoding="utf-8"?>
+<p:notes xmlns:p="http://schemas.openxmlformats.org/presentationml/2006/main">
+  <p:cSld>
+    <p:spTree>
+      <p:nvGrpSpPr>
+        <p:cNvPr id="1" name=""/>
+        <p:cNvGrpSpPr/>
+        <p:nvPr/>
+      </p:nvGrpSpPr>
+      <p:grpSpPr>
+        <a:xfrm xmlns:a="http://schemas.openxmlformats.org/drawingml/2006/main"/>
+      </p:grpSpPr>
+      <p:sp>
+        <p:nvSpPr>
+          <p:cNvPr id="2" name="Slide Image Placeholder 1"/>
+          <p:cNvSpPr>
+            <a:spLocks xmlns:a="http://schemas.openxmlformats.org/drawingml/2006/main" noGrp="1"/>
+          </p:cNvSpPr>
+          <p:nvPr>
+            <p:ph type="sldImg" idx="0"/>
+          </p:nvPr>
+        </p:nvSpPr>
+        <p:spPr/>
+      </p:sp>
+      <p:sp>
+        <p:nvSpPr>
+          <p:cNvPr id="3" name="Notes Placeholder 2"/>
+          <p:cNvSpPr>
+            <a:spLocks xmlns:a="http://schemas.openxmlformats.org/drawingml/2006/main" noGrp="1"/>
+          </p:cNvSpPr>
+          <p:nvPr>
+            <p:ph type="body" idx="1"/>
+          </p:nvPr>
+        </p:nvSpPr>
+        <p:spPr/>
+        <p:txBody>
+          <a:bodyPr xmlns:a="http://schemas.openxmlformats.org/drawingml/2006/main"/>
+          <a:lstStyle xmlns:a="http://schemas.openxmlformats.org/drawingml/2006/main"/>
+          <a:p xmlns:a="http://schemas.openxmlformats.org/drawingml/2006/main">
+            <a:r>
+              <a:t>Mahmoud · 55 Sekunden</a:t>
+            </a:r>
+          </a:p>
+          <a:p xmlns:a="http://schemas.openxmlformats.org/drawingml/2006/main">
+            <a:r>
+              <a:t/>
+            </a:r>
+          </a:p>
+          <a:p xmlns:a="http://schemas.openxmlformats.org/drawingml/2006/main">
+            <a:r>
+              <a:t>Unser Agent kombiniert gelernte Entscheidungen mit explizitem Wissen über das Spiel. Die bisherigen Versuche sprechen dafür, Gedächtnis und mehrere Netzbewertungen zu kombinieren. Weitertraining und Self-Play haben in den getesteten Varianten keinen klaren zusätzlichen Gewinn gebracht; das ist keine allgemeine Aussage gegen diese Verfahren. Eine Arbeitshypothese ist, dass bessere frühe Erkundung und frühere Inferenz im ersten Match helfen. Der Kandidat m1_early ist untersucht, aber noch nicht in der Abgabe aktiviert. Vor weiterem Training prüfen wir außerdem Reward und Einheitenübergänge. Für die nächste belastbare Bewertung wollen wir neue Testkarten zurückhalten. Der Präsentationsstand und seine Gewichte bleiben dabei fest.</a:t>
+            </a:r>
+          </a:p>
+          <a:p xmlns:a="http://schemas.openxmlformats.org/drawingml/2006/main">
+            <a:r>
+              <a:t/>
+            </a:r>
+          </a:p>
+          <a:p xmlns:a="http://schemas.openxmlformats.org/drawingml/2006/main">
+            <a:r>
+              <a:t>Quellen / Nachweise (Repository, Stand 14.10.2026):</a:t>
+            </a:r>
+          </a:p>
+          <a:p xmlns:a="http://schemas.openxmlformats.org/drawingml/2006/main">
+            <a:r>
+              <a:t>docs/EXPERIMENT_PROTOKOLL.md</a:t>
+            </a:r>
+          </a:p>
+          <a:p xmlns:a="http://schemas.openxmlformats.org/drawingml/2006/main">
+            <a:r>
+              <a:t>docs/ARBEITSSTAND.md</a:t>
+            </a:r>
+          </a:p>
+          <a:p xmlns:a="http://schemas.openxmlformats.org/drawingml/2006/main">
+            <a:r>
+              <a:t>docs/STATISTIK_20261014.md</a:t>
+            </a:r>
+          </a:p>
+        </p:txBody>
+      </p:sp>
+      <p:sp>
+        <p:nvSpPr>
+          <p:cNvPr id="4" name="Slide Number Placeholder 3"/>
+          <p:cNvSpPr>
+            <a:spLocks xmlns:a="http://schemas.openxmlformats.org/drawingml/2006/main" noGrp="1"/>
+          </p:cNvSpPr>
+          <p:nvPr>
+            <p:ph type="sldNum" idx="5"/>
+          </p:nvPr>
+        </p:nvSpPr>
+        <p:spPr/>
+        <p:txBody>
+          <a:bodyPr xmlns:a="http://schemas.openxmlformats.org/drawingml/2006/main"/>
+          <a:lstStyle xmlns:a="http://schemas.openxmlformats.org/drawingml/2006/main"/>
+          <a:p xmlns:a="http://schemas.openxmlformats.org/drawingml/2006/main"/>
+        </p:txBody>
+      </p:sp>
+    </p:spTree>
+  </p:cSld>
+  <p:clrMapOvr>
+    <a:masterClrMapping xmlns:a="http://schemas.openxmlformats.org/drawingml/2006/main"/>
+  </p:clrMapOvr>
+</p:notes>
+</file>
+
+<file path=ppt/notesSlides/notesSlide12.xml><?xml version="1.0" encoding="utf-8"?>
 <p:notes xmlns:a="http://schemas.openxmlformats.org/drawingml/2006/main" xmlns:p="http://schemas.openxmlformats.org/presentationml/2006/main">
   <p:cSld>
     <p:spTree>
@@ -719,7 +820,7 @@
 </p:notes>
 </file>
 
-<file path=ppt/notesSlides/notesSlide12.xml><?xml version="1.0" encoding="utf-8"?>
+<file path=ppt/notesSlides/notesSlide13.xml><?xml version="1.0" encoding="utf-8"?>
 <p:notes xmlns:p="http://schemas.openxmlformats.org/presentationml/2006/main">
   <p:cSld>
     <p:spTree>
@@ -824,7 +925,7 @@
 </p:notes>
 </file>
 
-<file path=ppt/notesSlides/notesSlide13.xml><?xml version="1.0" encoding="utf-8"?>
+<file path=ppt/notesSlides/notesSlide14.xml><?xml version="1.0" encoding="utf-8"?>
 <p:notes xmlns:p="http://schemas.openxmlformats.org/presentationml/2006/main">
   <p:cSld>
     <p:spTree>
@@ -979,7 +1080,7 @@
           <a:lstStyle xmlns:a="http://schemas.openxmlformats.org/drawingml/2006/main"/>
           <a:p xmlns:a="http://schemas.openxmlformats.org/drawingml/2006/main">
             <a:r>
-              <a:t>Moayed · 60 Sekunden</a:t>
+              <a:t>Moayed · 20 Sekunden</a:t>
             </a:r>
           </a:p>
           <a:p xmlns:a="http://schemas.openxmlformats.org/drawingml/2006/main">
@@ -989,7 +1090,7 @@
           </a:p>
           <a:p xmlns:a="http://schemas.openxmlformats.org/drawingml/2006/main">
             <a:r>
-              <a:t>Lux AI ist ein Strategiespiel auf einer Karte mit 24 mal 24 Feldern. Zwei Teams steuern jeweils bis zu 16 Einheiten. Im Kurs besteht ein Spiel aus drei Matches. Wer mehr Matches gewinnt, gewinnt das Spiel. Die Herausforderung ist, dass der Agent nicht die ganze Karte sieht und die Punktefelder zunächst unbekannt sind. Er muss erkunden, Energie sinnvoll einsetzen und geeignete Felder besetzen. Auf dem Bild ist Sherlock blau und der Gegner rot. Die gelben Markierungen gehören zu Relics und Punktefeldern. Wichtig: Das ist die vollständige Replay-Ansicht für uns Zuschauer. Der Agent bekommt diese vollständige Information nicht.</a:t>
+              <a:t>Wir beginnen mit der Spielidee und dem Aufbau unseres Agenten. Danach zeigen wir seine Merkmale, die Netzarchitektur und das Lernverfahren. Anschließend geht es um Training und Auswertung. Zum Schluss folgen unsere Ergebnisse, ein Spielbeispiel und die nächsten Schritte.</a:t>
             </a:r>
           </a:p>
           <a:p xmlns:a="http://schemas.openxmlformats.org/drawingml/2006/main">
@@ -999,32 +1100,7 @@
           </a:p>
           <a:p xmlns:a="http://schemas.openxmlformats.org/drawingml/2006/main">
             <a:r>
-              <a:t>Quellen / Nachweise (Repository, Stand 14.10.2026):</a:t>
-            </a:r>
-          </a:p>
-          <a:p xmlns:a="http://schemas.openxmlformats.org/drawingml/2006/main">
-            <a:r>
-              <a:t>lux/specs.md</a:t>
-            </a:r>
-          </a:p>
-          <a:p xmlns:a="http://schemas.openxmlformats.org/drawingml/2006/main">
-            <a:r>
-              <a:t>lux/Instructions.md</a:t>
-            </a:r>
-          </a:p>
-          <a:p xmlns:a="http://schemas.openxmlformats.org/drawingml/2006/main">
-            <a:r>
-              <a:t>CLAUDE.md</a:t>
-            </a:r>
-          </a:p>
-          <a:p xmlns:a="http://schemas.openxmlformats.org/drawingml/2006/main">
-            <a:r>
-              <a:t>docs/presentation/replays/sherlock_sieg_vs_default.json · Frame 61</a:t>
-            </a:r>
-          </a:p>
-          <a:p xmlns:a="http://schemas.openxmlformats.org/drawingml/2006/main">
-            <a:r>
-              <a:t>Screenshot: https://s3vis.lux-ai.org/</a:t>
+              <a:t>Gliederung der eigenen Sherlock-Präsentation.</a:t>
             </a:r>
           </a:p>
         </p:txBody>
@@ -1055,6 +1131,121 @@
 </file>
 
 <file path=ppt/notesSlides/notesSlide3.xml><?xml version="1.0" encoding="utf-8"?>
+<p:notes xmlns:p="http://schemas.openxmlformats.org/presentationml/2006/main">
+  <p:cSld>
+    <p:spTree>
+      <p:nvGrpSpPr>
+        <p:cNvPr id="1" name=""/>
+        <p:cNvGrpSpPr/>
+        <p:nvPr/>
+      </p:nvGrpSpPr>
+      <p:grpSpPr>
+        <a:xfrm xmlns:a="http://schemas.openxmlformats.org/drawingml/2006/main"/>
+      </p:grpSpPr>
+      <p:sp>
+        <p:nvSpPr>
+          <p:cNvPr id="2" name="Slide Image Placeholder 1"/>
+          <p:cNvSpPr>
+            <a:spLocks xmlns:a="http://schemas.openxmlformats.org/drawingml/2006/main" noGrp="1"/>
+          </p:cNvSpPr>
+          <p:nvPr>
+            <p:ph type="sldImg" idx="0"/>
+          </p:nvPr>
+        </p:nvSpPr>
+        <p:spPr/>
+      </p:sp>
+      <p:sp>
+        <p:nvSpPr>
+          <p:cNvPr id="3" name="Notes Placeholder 2"/>
+          <p:cNvSpPr>
+            <a:spLocks xmlns:a="http://schemas.openxmlformats.org/drawingml/2006/main" noGrp="1"/>
+          </p:cNvSpPr>
+          <p:nvPr>
+            <p:ph type="body" idx="1"/>
+          </p:nvPr>
+        </p:nvSpPr>
+        <p:spPr/>
+        <p:txBody>
+          <a:bodyPr xmlns:a="http://schemas.openxmlformats.org/drawingml/2006/main"/>
+          <a:lstStyle xmlns:a="http://schemas.openxmlformats.org/drawingml/2006/main"/>
+          <a:p xmlns:a="http://schemas.openxmlformats.org/drawingml/2006/main">
+            <a:r>
+              <a:t>Moayed · 60 Sekunden</a:t>
+            </a:r>
+          </a:p>
+          <a:p xmlns:a="http://schemas.openxmlformats.org/drawingml/2006/main">
+            <a:r>
+              <a:t/>
+            </a:r>
+          </a:p>
+          <a:p xmlns:a="http://schemas.openxmlformats.org/drawingml/2006/main">
+            <a:r>
+              <a:t>Lux AI ist ein Strategiespiel auf einer Karte mit 24 mal 24 Feldern. Zwei Teams steuern jeweils bis zu 16 Einheiten. Im Kurs besteht ein Spiel aus drei Matches. Wer mehr Matches gewinnt, gewinnt das Spiel. Die Herausforderung ist, dass der Agent nicht die ganze Karte sieht und die Punktefelder zunächst unbekannt sind. Er muss erkunden, Energie sinnvoll einsetzen und geeignete Felder besetzen. Auf dem Bild ist Sherlock blau und der Gegner rot. Die gelben Markierungen gehören zu Relics und Punktefeldern. Wichtig: Das ist die vollständige Replay-Ansicht für uns Zuschauer. Der Agent bekommt diese vollständige Information nicht.</a:t>
+            </a:r>
+          </a:p>
+          <a:p xmlns:a="http://schemas.openxmlformats.org/drawingml/2006/main">
+            <a:r>
+              <a:t/>
+            </a:r>
+          </a:p>
+          <a:p xmlns:a="http://schemas.openxmlformats.org/drawingml/2006/main">
+            <a:r>
+              <a:t>Quellen / Nachweise (Repository, Stand 14.10.2026):</a:t>
+            </a:r>
+          </a:p>
+          <a:p xmlns:a="http://schemas.openxmlformats.org/drawingml/2006/main">
+            <a:r>
+              <a:t>lux/specs.md</a:t>
+            </a:r>
+          </a:p>
+          <a:p xmlns:a="http://schemas.openxmlformats.org/drawingml/2006/main">
+            <a:r>
+              <a:t>lux/Instructions.md</a:t>
+            </a:r>
+          </a:p>
+          <a:p xmlns:a="http://schemas.openxmlformats.org/drawingml/2006/main">
+            <a:r>
+              <a:t>CLAUDE.md</a:t>
+            </a:r>
+          </a:p>
+          <a:p xmlns:a="http://schemas.openxmlformats.org/drawingml/2006/main">
+            <a:r>
+              <a:t>docs/presentation/replays/sherlock_sieg_vs_default.json · Frame 61</a:t>
+            </a:r>
+          </a:p>
+          <a:p xmlns:a="http://schemas.openxmlformats.org/drawingml/2006/main">
+            <a:r>
+              <a:t>Screenshot: https://s3vis.lux-ai.org/</a:t>
+            </a:r>
+          </a:p>
+        </p:txBody>
+      </p:sp>
+      <p:sp>
+        <p:nvSpPr>
+          <p:cNvPr id="4" name="Slide Number Placeholder 3"/>
+          <p:cNvSpPr>
+            <a:spLocks xmlns:a="http://schemas.openxmlformats.org/drawingml/2006/main" noGrp="1"/>
+          </p:cNvSpPr>
+          <p:nvPr>
+            <p:ph type="sldNum" idx="5"/>
+          </p:nvPr>
+        </p:nvSpPr>
+        <p:spPr/>
+        <p:txBody>
+          <a:bodyPr xmlns:a="http://schemas.openxmlformats.org/drawingml/2006/main"/>
+          <a:lstStyle xmlns:a="http://schemas.openxmlformats.org/drawingml/2006/main"/>
+          <a:p xmlns:a="http://schemas.openxmlformats.org/drawingml/2006/main"/>
+        </p:txBody>
+      </p:sp>
+    </p:spTree>
+  </p:cSld>
+  <p:clrMapOvr>
+    <a:masterClrMapping xmlns:a="http://schemas.openxmlformats.org/drawingml/2006/main"/>
+  </p:clrMapOvr>
+</p:notes>
+</file>
+
+<file path=ppt/notesSlides/notesSlide4.xml><?xml version="1.0" encoding="utf-8"?>
 <p:notes xmlns:a="http://schemas.openxmlformats.org/drawingml/2006/main" xmlns:p="http://schemas.openxmlformats.org/presentationml/2006/main">
   <p:cSld>
     <p:spTree>
@@ -1157,106 +1348,6 @@
   </p:cSld>
   <p:clrMapOvr>
     <a:masterClrMapping/>
-  </p:clrMapOvr>
-</p:notes>
-</file>
-
-<file path=ppt/notesSlides/notesSlide4.xml><?xml version="1.0" encoding="utf-8"?>
-<p:notes xmlns:p="http://schemas.openxmlformats.org/presentationml/2006/main">
-  <p:cSld>
-    <p:spTree>
-      <p:nvGrpSpPr>
-        <p:cNvPr id="1" name=""/>
-        <p:cNvGrpSpPr/>
-        <p:nvPr/>
-      </p:nvGrpSpPr>
-      <p:grpSpPr>
-        <a:xfrm xmlns:a="http://schemas.openxmlformats.org/drawingml/2006/main"/>
-      </p:grpSpPr>
-      <p:sp>
-        <p:nvSpPr>
-          <p:cNvPr id="2" name="Slide Image Placeholder 1"/>
-          <p:cNvSpPr>
-            <a:spLocks xmlns:a="http://schemas.openxmlformats.org/drawingml/2006/main" noGrp="1"/>
-          </p:cNvSpPr>
-          <p:nvPr>
-            <p:ph type="sldImg" idx="0"/>
-          </p:nvPr>
-        </p:nvSpPr>
-        <p:spPr/>
-      </p:sp>
-      <p:sp>
-        <p:nvSpPr>
-          <p:cNvPr id="3" name="Notes Placeholder 2"/>
-          <p:cNvSpPr>
-            <a:spLocks xmlns:a="http://schemas.openxmlformats.org/drawingml/2006/main" noGrp="1"/>
-          </p:cNvSpPr>
-          <p:nvPr>
-            <p:ph type="body" idx="1"/>
-          </p:nvPr>
-        </p:nvSpPr>
-        <p:spPr/>
-        <p:txBody>
-          <a:bodyPr xmlns:a="http://schemas.openxmlformats.org/drawingml/2006/main"/>
-          <a:lstStyle xmlns:a="http://schemas.openxmlformats.org/drawingml/2006/main"/>
-          <a:p xmlns:a="http://schemas.openxmlformats.org/drawingml/2006/main">
-            <a:r>
-              <a:t>Mahmoud · 65 Sekunden</a:t>
-            </a:r>
-          </a:p>
-          <a:p xmlns:a="http://schemas.openxmlformats.org/drawingml/2006/main">
-            <a:r>
-              <a:t/>
-            </a:r>
-          </a:p>
-          <a:p xmlns:a="http://schemas.openxmlformats.org/drawingml/2006/main">
-            <a:r>
-              <a:t>Wir verwenden ein MLP mit 79 numerischen Merkmalen pro Einheit, keine vollständige Bildkarte. Die Merkmale beschreiben zum Beispiel Energie und Position, Umgebung, Ziele und Gegner. Das Belief speichert bekannte Relics, erkundete Bereiche und erschlossene Punktefelder. Vereinfachtes Beispiel: Eine einzige eigene Einheit steht auf einem noch unbekannten Kandidatenfeld und der Punktestand steigt um eins. Unter diesen Voraussetzungen lässt sich das Feld als Punktefeld erkennen. Bei mehreren Kandidaten braucht man weitere Beobachtungen. Außerdem verwenden wir die Kartensymmetrie. Davon zu unterscheiden sind kanonische Koordinaten: Beide Spielseiten werden aus vergleichbarer Perspektive beschrieben. Diese Regeln liefern Informationen an die gelernte Aktionsbewertung; sie ersetzen sie nicht.</a:t>
-            </a:r>
-          </a:p>
-          <a:p xmlns:a="http://schemas.openxmlformats.org/drawingml/2006/main">
-            <a:r>
-              <a:t/>
-            </a:r>
-          </a:p>
-          <a:p xmlns:a="http://schemas.openxmlformats.org/drawingml/2006/main">
-            <a:r>
-              <a:t>Quellen / Nachweise (Repository, Stand 14.10.2026):</a:t>
-            </a:r>
-          </a:p>
-          <a:p xmlns:a="http://schemas.openxmlformats.org/drawingml/2006/main">
-            <a:r>
-              <a:t>agents/sherlock/features.py</a:t>
-            </a:r>
-          </a:p>
-          <a:p xmlns:a="http://schemas.openxmlformats.org/drawingml/2006/main">
-            <a:r>
-              <a:t>agents/sherlock/belief.py</a:t>
-            </a:r>
-          </a:p>
-        </p:txBody>
-      </p:sp>
-      <p:sp>
-        <p:nvSpPr>
-          <p:cNvPr id="4" name="Slide Number Placeholder 3"/>
-          <p:cNvSpPr>
-            <a:spLocks xmlns:a="http://schemas.openxmlformats.org/drawingml/2006/main" noGrp="1"/>
-          </p:cNvSpPr>
-          <p:nvPr>
-            <p:ph type="sldNum" idx="5"/>
-          </p:nvPr>
-        </p:nvSpPr>
-        <p:spPr/>
-        <p:txBody>
-          <a:bodyPr xmlns:a="http://schemas.openxmlformats.org/drawingml/2006/main"/>
-          <a:lstStyle xmlns:a="http://schemas.openxmlformats.org/drawingml/2006/main"/>
-          <a:p xmlns:a="http://schemas.openxmlformats.org/drawingml/2006/main"/>
-        </p:txBody>
-      </p:sp>
-    </p:spTree>
-  </p:cSld>
-  <p:clrMapOvr>
-    <a:masterClrMapping xmlns:a="http://schemas.openxmlformats.org/drawingml/2006/main"/>
   </p:clrMapOvr>
 </p:notes>
 </file>
@@ -1311,7 +1402,7 @@
           </a:p>
           <a:p xmlns:a="http://schemas.openxmlformats.org/drawingml/2006/main">
             <a:r>
-              <a:t>Jedes Mitglied des Ensembles ist ein Dueling-Netz. Es bekommt 79 Merkmale. Der gemeinsame Teil besteht aus zwei voll verbundenen Schichten mit jeweils 256 Neuronen und ReLU. Danach gibt es einen Kopf für den Zustandswert und einen Kopf für die Vorteile der sechs Aktionen; beide haben eine Zwischenschicht mit 128 Neuronen. Daraus entstehen sechs Q-Werte. Beim Spielen mitteln wir die Q-Werte der sechs trainierten Netze und wählen dann die beste erlaubte Aktion. Die sechs Aktionen sind Stehenbleiben, vier Bewegungsrichtungen und Sap. Das konkrete Sap-Ziel wird heuristisch gewählt. Double DQN bezeichnet unser Lernverfahren, Dueling die Netzarchitektur und Ensemble die Kombination mehrerer trainierter Netze.</a:t>
+              <a:t>Wir verwenden ein MLP mit 79 numerischen Merkmalen pro Einheit, keine vollständige Bildkarte. Die Merkmale beschreiben zum Beispiel Energie und Position, Umgebung, Ziele und Gegner. Das Belief speichert bekannte Relics, erkundete Bereiche und erschlossene Punktefelder. Vereinfachtes Beispiel: Eine einzige eigene Einheit steht auf einem noch unbekannten Kandidatenfeld und der Punktestand steigt um eins. Unter diesen Voraussetzungen lässt sich das Feld als Punktefeld erkennen. Bei mehreren Kandidaten braucht man weitere Beobachtungen. Außerdem verwenden wir die Kartensymmetrie. Davon zu unterscheiden sind kanonische Koordinaten: Beide Spielseiten werden aus vergleichbarer Perspektive beschrieben. Diese Regeln liefern Informationen an die gelernte Aktionsbewertung; sie ersetzen sie nicht.</a:t>
             </a:r>
           </a:p>
           <a:p xmlns:a="http://schemas.openxmlformats.org/drawingml/2006/main">
@@ -1326,17 +1417,12 @@
           </a:p>
           <a:p xmlns:a="http://schemas.openxmlformats.org/drawingml/2006/main">
             <a:r>
-              <a:t>agents/sherlock/model.py</a:t>
+              <a:t>agents/sherlock/features.py</a:t>
             </a:r>
           </a:p>
           <a:p xmlns:a="http://schemas.openxmlformats.org/drawingml/2006/main">
             <a:r>
-              <a:t>agents/sherlock/main.py</a:t>
-            </a:r>
-          </a:p>
-          <a:p xmlns:a="http://schemas.openxmlformats.org/drawingml/2006/main">
-            <a:r>
-              <a:t>agents/sherlock/weights/agent_p0.pth · gespeicherte cfg</a:t>
+              <a:t>agents/sherlock/belief.py</a:t>
             </a:r>
           </a:p>
         </p:txBody>
@@ -1406,7 +1492,7 @@
           <a:lstStyle xmlns:a="http://schemas.openxmlformats.org/drawingml/2006/main"/>
           <a:p xmlns:a="http://schemas.openxmlformats.org/drawingml/2006/main">
             <a:r>
-              <a:t>Mahmoud · 75 Sekunden</a:t>
+              <a:t>Mahmoud · 65 Sekunden</a:t>
             </a:r>
           </a:p>
           <a:p xmlns:a="http://schemas.openxmlformats.org/drawingml/2006/main">
@@ -1416,7 +1502,7 @@
           </a:p>
           <a:p xmlns:a="http://schemas.openxmlformats.org/drawingml/2006/main">
             <a:r>
-              <a:t>Im Training sammeln wir Erfahrungen pro Einheit: Situation, Aktion, Belohnung und Folgesituation. Zufällige Mini-Batches aus dem Replay Buffer verringern die direkte Abhängigkeit aufeinanderfolgender Erfahrungen. Double DQN trennt die Wahl der nächsten Aktion von ihrer Bewertung: Das aktuelle Online-Netz wählt die beste erlaubte Folgeaktion, das verzögert aktualisierte Target-Netz bewertet genau diese Aktion. Aus Belohnung und diskontiertem Folgewert entsteht das Lernziel. Am Ende eines Übergangs entfällt der Folgewert. Das Online-Netz wird an dieses Ziel angepasst; das Target-Netz wird alle 500 Lernupdates kopiert. Im Training probiert der Agent mit abnehmender Wahrscheinlichkeit Aktionen aus. Zusätzlich zu Punkten und Matchsiegen gibt es Shaping-Signale, etwa für Annäherung, Erkundung und Energie. Deren Gestaltung ist eine Modellierungsentscheidung mit eigenen Grenzen.</a:t>
+              <a:t>Jedes Mitglied des Ensembles ist ein Dueling-Netz. Es bekommt 79 Merkmale. Der gemeinsame Teil besteht aus zwei voll verbundenen Schichten mit jeweils 256 Neuronen und ReLU. Danach gibt es einen Kopf für den Zustandswert und einen Kopf für die Vorteile der sechs Aktionen; beide haben eine Zwischenschicht mit 128 Neuronen. Daraus entstehen sechs Q-Werte. Beim Spielen mitteln wir die Q-Werte der sechs trainierten Netze und wählen dann die beste erlaubte Aktion. Die sechs Aktionen sind Stehenbleiben, vier Bewegungsrichtungen und Sap. Das konkrete Sap-Ziel wird heuristisch gewählt. Double DQN bezeichnet unser Lernverfahren, Dueling die Netzarchitektur und Ensemble die Kombination mehrerer trainierter Netze.</a:t>
             </a:r>
           </a:p>
           <a:p xmlns:a="http://schemas.openxmlformats.org/drawingml/2006/main">
@@ -1431,17 +1517,17 @@
           </a:p>
           <a:p xmlns:a="http://schemas.openxmlformats.org/drawingml/2006/main">
             <a:r>
-              <a:t>agents/sherlock/main.py · _learn und epsilon</a:t>
+              <a:t>agents/sherlock/model.py</a:t>
             </a:r>
           </a:p>
           <a:p xmlns:a="http://schemas.openxmlformats.org/drawingml/2006/main">
             <a:r>
-              <a:t>agents/sherlock/replay_buffer.py</a:t>
+              <a:t>agents/sherlock/main.py</a:t>
             </a:r>
           </a:p>
           <a:p xmlns:a="http://schemas.openxmlformats.org/drawingml/2006/main">
             <a:r>
-              <a:t>agents/sherlock/reward.py</a:t>
+              <a:t>agents/sherlock/weights/agent_p0.pth · gespeicherte cfg</a:t>
             </a:r>
           </a:p>
         </p:txBody>
@@ -1472,6 +1558,111 @@
 </file>
 
 <file path=ppt/notesSlides/notesSlide7.xml><?xml version="1.0" encoding="utf-8"?>
+<p:notes xmlns:p="http://schemas.openxmlformats.org/presentationml/2006/main">
+  <p:cSld>
+    <p:spTree>
+      <p:nvGrpSpPr>
+        <p:cNvPr id="1" name=""/>
+        <p:cNvGrpSpPr/>
+        <p:nvPr/>
+      </p:nvGrpSpPr>
+      <p:grpSpPr>
+        <a:xfrm xmlns:a="http://schemas.openxmlformats.org/drawingml/2006/main"/>
+      </p:grpSpPr>
+      <p:sp>
+        <p:nvSpPr>
+          <p:cNvPr id="2" name="Slide Image Placeholder 1"/>
+          <p:cNvSpPr>
+            <a:spLocks xmlns:a="http://schemas.openxmlformats.org/drawingml/2006/main" noGrp="1"/>
+          </p:cNvSpPr>
+          <p:nvPr>
+            <p:ph type="sldImg" idx="0"/>
+          </p:nvPr>
+        </p:nvSpPr>
+        <p:spPr/>
+      </p:sp>
+      <p:sp>
+        <p:nvSpPr>
+          <p:cNvPr id="3" name="Notes Placeholder 2"/>
+          <p:cNvSpPr>
+            <a:spLocks xmlns:a="http://schemas.openxmlformats.org/drawingml/2006/main" noGrp="1"/>
+          </p:cNvSpPr>
+          <p:nvPr>
+            <p:ph type="body" idx="1"/>
+          </p:nvPr>
+        </p:nvSpPr>
+        <p:spPr/>
+        <p:txBody>
+          <a:bodyPr xmlns:a="http://schemas.openxmlformats.org/drawingml/2006/main"/>
+          <a:lstStyle xmlns:a="http://schemas.openxmlformats.org/drawingml/2006/main"/>
+          <a:p xmlns:a="http://schemas.openxmlformats.org/drawingml/2006/main">
+            <a:r>
+              <a:t>Mahmoud · 75 Sekunden</a:t>
+            </a:r>
+          </a:p>
+          <a:p xmlns:a="http://schemas.openxmlformats.org/drawingml/2006/main">
+            <a:r>
+              <a:t/>
+            </a:r>
+          </a:p>
+          <a:p xmlns:a="http://schemas.openxmlformats.org/drawingml/2006/main">
+            <a:r>
+              <a:t>Im Training sammeln wir Erfahrungen pro Einheit: Situation, Aktion, Belohnung und Folgesituation. Zufällige Mini-Batches aus dem Replay Buffer verringern die direkte Abhängigkeit aufeinanderfolgender Erfahrungen. Double DQN trennt die Wahl der nächsten Aktion von ihrer Bewertung: Das aktuelle Online-Netz wählt die beste erlaubte Folgeaktion, das verzögert aktualisierte Target-Netz bewertet genau diese Aktion. Aus Belohnung und diskontiertem Folgewert entsteht das Lernziel. Am Ende eines Übergangs entfällt der Folgewert. Das Online-Netz wird an dieses Ziel angepasst; das Target-Netz wird alle 500 Lernupdates kopiert. Im Training probiert der Agent mit abnehmender Wahrscheinlichkeit Aktionen aus. Zusätzlich zu Punkten und Matchsiegen gibt es Shaping-Signale, etwa für Annäherung, Erkundung und Energie. Deren Gestaltung ist eine Modellierungsentscheidung mit eigenen Grenzen.</a:t>
+            </a:r>
+          </a:p>
+          <a:p xmlns:a="http://schemas.openxmlformats.org/drawingml/2006/main">
+            <a:r>
+              <a:t/>
+            </a:r>
+          </a:p>
+          <a:p xmlns:a="http://schemas.openxmlformats.org/drawingml/2006/main">
+            <a:r>
+              <a:t>Quellen / Nachweise (Repository, Stand 14.10.2026):</a:t>
+            </a:r>
+          </a:p>
+          <a:p xmlns:a="http://schemas.openxmlformats.org/drawingml/2006/main">
+            <a:r>
+              <a:t>agents/sherlock/main.py · _learn und epsilon</a:t>
+            </a:r>
+          </a:p>
+          <a:p xmlns:a="http://schemas.openxmlformats.org/drawingml/2006/main">
+            <a:r>
+              <a:t>agents/sherlock/replay_buffer.py</a:t>
+            </a:r>
+          </a:p>
+          <a:p xmlns:a="http://schemas.openxmlformats.org/drawingml/2006/main">
+            <a:r>
+              <a:t>agents/sherlock/reward.py</a:t>
+            </a:r>
+          </a:p>
+        </p:txBody>
+      </p:sp>
+      <p:sp>
+        <p:nvSpPr>
+          <p:cNvPr id="4" name="Slide Number Placeholder 3"/>
+          <p:cNvSpPr>
+            <a:spLocks xmlns:a="http://schemas.openxmlformats.org/drawingml/2006/main" noGrp="1"/>
+          </p:cNvSpPr>
+          <p:nvPr>
+            <p:ph type="sldNum" idx="5"/>
+          </p:nvPr>
+        </p:nvSpPr>
+        <p:spPr/>
+        <p:txBody>
+          <a:bodyPr xmlns:a="http://schemas.openxmlformats.org/drawingml/2006/main"/>
+          <a:lstStyle xmlns:a="http://schemas.openxmlformats.org/drawingml/2006/main"/>
+          <a:p xmlns:a="http://schemas.openxmlformats.org/drawingml/2006/main"/>
+        </p:txBody>
+      </p:sp>
+    </p:spTree>
+  </p:cSld>
+  <p:clrMapOvr>
+    <a:masterClrMapping xmlns:a="http://schemas.openxmlformats.org/drawingml/2006/main"/>
+  </p:clrMapOvr>
+</p:notes>
+</file>
+
+<file path=ppt/notesSlides/notesSlide8.xml><?xml version="1.0" encoding="utf-8"?>
 <p:notes xmlns:a="http://schemas.openxmlformats.org/drawingml/2006/main" xmlns:p="http://schemas.openxmlformats.org/presentationml/2006/main">
   <p:cSld>
     <p:spTree>
@@ -1577,111 +1768,6 @@
   </p:cSld>
   <p:clrMapOvr>
     <a:masterClrMapping/>
-  </p:clrMapOvr>
-</p:notes>
-</file>
-
-<file path=ppt/notesSlides/notesSlide8.xml><?xml version="1.0" encoding="utf-8"?>
-<p:notes xmlns:p="http://schemas.openxmlformats.org/presentationml/2006/main">
-  <p:cSld>
-    <p:spTree>
-      <p:nvGrpSpPr>
-        <p:cNvPr id="1" name=""/>
-        <p:cNvGrpSpPr/>
-        <p:nvPr/>
-      </p:nvGrpSpPr>
-      <p:grpSpPr>
-        <a:xfrm xmlns:a="http://schemas.openxmlformats.org/drawingml/2006/main"/>
-      </p:grpSpPr>
-      <p:sp>
-        <p:nvSpPr>
-          <p:cNvPr id="2" name="Slide Image Placeholder 1"/>
-          <p:cNvSpPr>
-            <a:spLocks xmlns:a="http://schemas.openxmlformats.org/drawingml/2006/main" noGrp="1"/>
-          </p:cNvSpPr>
-          <p:nvPr>
-            <p:ph type="sldImg" idx="0"/>
-          </p:nvPr>
-        </p:nvSpPr>
-        <p:spPr/>
-      </p:sp>
-      <p:sp>
-        <p:nvSpPr>
-          <p:cNvPr id="3" name="Notes Placeholder 2"/>
-          <p:cNvSpPr>
-            <a:spLocks xmlns:a="http://schemas.openxmlformats.org/drawingml/2006/main" noGrp="1"/>
-          </p:cNvSpPr>
-          <p:nvPr>
-            <p:ph type="body" idx="1"/>
-          </p:nvPr>
-        </p:nvSpPr>
-        <p:spPr/>
-        <p:txBody>
-          <a:bodyPr xmlns:a="http://schemas.openxmlformats.org/drawingml/2006/main"/>
-          <a:lstStyle xmlns:a="http://schemas.openxmlformats.org/drawingml/2006/main"/>
-          <a:p xmlns:a="http://schemas.openxmlformats.org/drawingml/2006/main">
-            <a:r>
-              <a:t>Moayed · 65 Sekunden</a:t>
-            </a:r>
-          </a:p>
-          <a:p xmlns:a="http://schemas.openxmlformats.org/drawingml/2006/main">
-            <a:r>
-              <a:t/>
-            </a:r>
-          </a:p>
-          <a:p xmlns:a="http://schemas.openxmlformats.org/drawingml/2006/main">
-            <a:r>
-              <a:t>Hier sehen wir die Ergebnisse des aktuellen Agenten. Gegen default gewinnt Sherlock 60 von 60 Spielen. Gegen den stärkeren regelbasierten Gegner Solution_92 sind es 28 von 60, also ungefähr 47 Prozent. Pro Gegner wurden 30 Karten auf beiden Spielseiten gespielt. Damit sind es 60 Spiele, aber nicht 60 unabhängige Karten. Diese Zahlen wurden mit den unveränderten Gewichten erneut bestätigt. Wir sollten daraus nicht ableiten, dass Sherlock immer gegen default gewinnt: Das Ergebnis gilt für diese Stichprobe. Außerdem wurden die Karten im Projekt bereits mehrfach ausgewertet. Für eine unabhängige Schlussbewertung brauchen wir später neue, zurückgehaltene Karten. Insgesamt funktioniert unser Ansatz, aber gegen den stärkeren Gegner gibt es noch deutliches Verbesserungspotenzial.</a:t>
-            </a:r>
-          </a:p>
-          <a:p xmlns:a="http://schemas.openxmlformats.org/drawingml/2006/main">
-            <a:r>
-              <a:t/>
-            </a:r>
-          </a:p>
-          <a:p xmlns:a="http://schemas.openxmlformats.org/drawingml/2006/main">
-            <a:r>
-              <a:t>Quellen / Nachweise (Repository, Stand 14.10.2026):</a:t>
-            </a:r>
-          </a:p>
-          <a:p xmlns:a="http://schemas.openxmlformats.org/drawingml/2006/main">
-            <a:r>
-              <a:t>experiments/compare/TEST_old3_sym3_points_v2.csv</a:t>
-            </a:r>
-          </a:p>
-          <a:p xmlns:a="http://schemas.openxmlformats.org/drawingml/2006/main">
-            <a:r>
-              <a:t>experiments/compare/TEST_old3_sym3_points_v2.json</a:t>
-            </a:r>
-          </a:p>
-          <a:p xmlns:a="http://schemas.openxmlformats.org/drawingml/2006/main">
-            <a:r>
-              <a:t>docs/STATISTIK_20261014.md</a:t>
-            </a:r>
-          </a:p>
-        </p:txBody>
-      </p:sp>
-      <p:sp>
-        <p:nvSpPr>
-          <p:cNvPr id="4" name="Slide Number Placeholder 3"/>
-          <p:cNvSpPr>
-            <a:spLocks xmlns:a="http://schemas.openxmlformats.org/drawingml/2006/main" noGrp="1"/>
-          </p:cNvSpPr>
-          <p:nvPr>
-            <p:ph type="sldNum" idx="5"/>
-          </p:nvPr>
-        </p:nvSpPr>
-        <p:spPr/>
-        <p:txBody>
-          <a:bodyPr xmlns:a="http://schemas.openxmlformats.org/drawingml/2006/main"/>
-          <a:lstStyle xmlns:a="http://schemas.openxmlformats.org/drawingml/2006/main"/>
-          <a:p xmlns:a="http://schemas.openxmlformats.org/drawingml/2006/main"/>
-        </p:txBody>
-      </p:sp>
-    </p:spTree>
-  </p:cSld>
-  <p:clrMapOvr>
-    <a:masterClrMapping xmlns:a="http://schemas.openxmlformats.org/drawingml/2006/main"/>
   </p:clrMapOvr>
 </p:notes>
 </file>
@@ -1726,7 +1812,7 @@
           <a:lstStyle xmlns:a="http://schemas.openxmlformats.org/drawingml/2006/main"/>
           <a:p xmlns:a="http://schemas.openxmlformats.org/drawingml/2006/main">
             <a:r>
-              <a:t>Moayed · 80 Sekunden</a:t>
+              <a:t>Moayed · 65 Sekunden</a:t>
             </a:r>
           </a:p>
           <a:p xmlns:a="http://schemas.openxmlformats.org/drawingml/2006/main">
@@ -1736,7 +1822,7 @@
           </a:p>
           <a:p xmlns:a="http://schemas.openxmlformats.org/drawingml/2006/main">
             <a:r>
-              <a:t>Das sind zwei echte Bilder aus demselben Spiel gegen default. Sherlock ist blau, der Gegner rot. Links, bei Schritt 23, sind unsere Einheiten noch über die Karte verteilt und beide Teams haben null Punkte. Rechts, bei Schritt 90 im ersten Match, stehen viele blaue Einheiten im Bereich der gelb markierten Punktefelder. Der Zwischenstand ist 374 zu 11. Man sieht: Bewegung allein ist nicht das Ziel. Sobald geeignete Punktefelder bekannt sind, kann Stehenbleiben sinnvoll sein, weil ein besetztes Feld wiederholt Punkte bringt. Das Gedächtnis hilft dabei, einmal gewonnene Informationen weiterzuverwenden. Die Bilder zeigen die vollständige Zuschaueransicht, nicht den Wissensstand des Agenten. Dieses Spiel veranschaulicht einen gelungenen Ablauf; es beweist nicht, dass Sherlock in jedem Spiel so handelt. Die Niederlagen gegen Solution_92 gehören ebenfalls zu unserer Auswertung.</a:t>
+              <a:t>Hier sehen wir die Ergebnisse des aktuellen Agenten. Gegen default gewinnt Sherlock 60 von 60 Spielen. Gegen den stärkeren regelbasierten Gegner Solution_92 sind es 28 von 60, also ungefähr 47 Prozent. Pro Gegner wurden 30 Karten auf beiden Spielseiten gespielt. Damit sind es 60 Spiele, aber nicht 60 unabhängige Karten. Diese Zahlen wurden mit den unveränderten Gewichten erneut bestätigt. Wir sollten daraus nicht ableiten, dass Sherlock immer gegen default gewinnt: Das Ergebnis gilt für diese Stichprobe. Außerdem wurden die Karten im Projekt bereits mehrfach ausgewertet. Für eine unabhängige Schlussbewertung brauchen wir später neue, zurückgehaltene Karten. Insgesamt funktioniert unser Ansatz, aber gegen den stärkeren Gegner gibt es noch deutliches Verbesserungspotenzial.</a:t>
             </a:r>
           </a:p>
           <a:p xmlns:a="http://schemas.openxmlformats.org/drawingml/2006/main">
@@ -1751,12 +1837,17 @@
           </a:p>
           <a:p xmlns:a="http://schemas.openxmlformats.org/drawingml/2006/main">
             <a:r>
-              <a:t>docs/presentation/replays/sherlock_sieg_vs_default.json · Frames 23 und 90</a:t>
+              <a:t>experiments/compare/TEST_old3_sym3_points_v2.csv</a:t>
             </a:r>
           </a:p>
           <a:p xmlns:a="http://schemas.openxmlformats.org/drawingml/2006/main">
             <a:r>
-              <a:t>Screenshot: https://s3vis.lux-ai.org/ · Seed 900011, Sherlock player_0</a:t>
+              <a:t>experiments/compare/TEST_old3_sym3_points_v2.json</a:t>
+            </a:r>
+          </a:p>
+          <a:p xmlns:a="http://schemas.openxmlformats.org/drawingml/2006/main">
+            <a:r>
+              <a:t>docs/STATISTIK_20261014.md</a:t>
             </a:r>
           </a:p>
         </p:txBody>
@@ -4713,6 +4804,779 @@
 </file>
 
 <file path=ppt/slides/slide10.xml><?xml version="1.0" encoding="utf-8"?>
+<p:sld xmlns:a="http://schemas.openxmlformats.org/drawingml/2006/main" xmlns:ns2="http://schemas.microsoft.com/office/drawing/2014/main" xmlns:ns4="http://schemas.microsoft.com/office/powerpoint/2010/main" xmlns:p="http://schemas.openxmlformats.org/presentationml/2006/main" xmlns:r="http://schemas.openxmlformats.org/officeDocument/2006/relationships">
+  <p:cSld>
+    <p:bg>
+      <p:bgPr>
+        <a:solidFill>
+          <a:srgbClr val="F7F7F0"/>
+        </a:solidFill>
+      </p:bgPr>
+    </p:bg>
+    <p:spTree>
+      <p:nvGrpSpPr>
+        <p:cNvPr id="1" name=""/>
+        <p:cNvGrpSpPr/>
+        <p:nvPr/>
+      </p:nvGrpSpPr>
+      <p:grpSpPr>
+        <a:xfrm/>
+      </p:grpSpPr>
+      <p:sp>
+        <p:nvSpPr>
+          <p:cNvPr id="12" name="SHERLOCK / REVIEW 01">
+            <a:extLst>
+              <a:ext uri="{FF2B5EF4-FFF2-40B4-BE49-F238E27FC236}">
+                <ns2:creationId id="{D649A959-7497-4988-9EFE-00D58627A301}"/>
+              </a:ext>
+            </a:extLst>
+          </p:cNvPr>
+          <p:cNvSpPr>
+            <a:spLocks noGrp="1"/>
+          </p:cNvSpPr>
+          <p:nvPr/>
+        </p:nvSpPr>
+        <p:spPr>
+          <a:xfrm>
+            <a:off x="609600" y="266700"/>
+            <a:ext cx="8572500" cy="304800"/>
+          </a:xfrm>
+          <a:prstGeom prst="rect">
+            <a:avLst/>
+          </a:prstGeom>
+          <a:noFill/>
+          <a:ln w="0">
+            <a:noFill/>
+          </a:ln>
+        </p:spPr>
+        <p:txBody>
+          <a:bodyPr/>
+          <a:lstStyle>
+            <a:defPPr>
+              <a:defRPr sz="1350" b="1">
+                <a:solidFill>
+                  <a:srgbClr val="007D7B"/>
+                </a:solidFill>
+                <a:latin typeface="Helvetica Neue"/>
+                <a:ea typeface="Helvetica Neue"/>
+                <a:cs typeface="Helvetica Neue"/>
+              </a:defRPr>
+            </a:defPPr>
+          </a:lstStyle>
+          <a:p>
+            <a:pPr>
+              <a:defRPr sz="1350" b="1">
+                <a:solidFill>
+                  <a:srgbClr val="007D7B"/>
+                </a:solidFill>
+                <a:latin typeface="Helvetica Neue"/>
+                <a:ea typeface="Helvetica Neue"/>
+                <a:cs typeface="Helvetica Neue"/>
+              </a:defRPr>
+            </a:pPr>
+            <a:r>
+              <a:rPr sz="1350" b="1">
+                <a:solidFill>
+                  <a:srgbClr val="007D7B"/>
+                </a:solidFill>
+                <a:latin typeface="Helvetica Neue"/>
+                <a:ea typeface="Helvetica Neue"/>
+                <a:cs typeface="Helvetica Neue"/>
+              </a:rPr>
+              <a:t>SHERLOCK / REVIEW 01</a:t>
+            </a:r>
+          </a:p>
+        </p:txBody>
+      </p:sp>
+      <p:sp>
+        <p:nvSpPr>
+          <p:cNvPr id="2" name="Ein Spiel: erst verteilen, dann Punktefelder ">
+            <a:extLst>
+              <a:ext uri="{FF2B5EF4-FFF2-40B4-BE49-F238E27FC236}">
+                <ns2:creationId id="{57BEE2ED-FC67-4D2F-B7FA-21C62FDCD0DD}"/>
+              </a:ext>
+            </a:extLst>
+          </p:cNvPr>
+          <p:cNvSpPr>
+            <a:spLocks noGrp="1"/>
+          </p:cNvSpPr>
+          <p:nvPr/>
+        </p:nvSpPr>
+        <p:spPr>
+          <a:xfrm>
+            <a:off x="609600" y="781050"/>
+            <a:ext cx="10972800" cy="1028700"/>
+          </a:xfrm>
+          <a:prstGeom prst="rect">
+            <a:avLst/>
+          </a:prstGeom>
+          <a:noFill/>
+          <a:ln w="0">
+            <a:noFill/>
+          </a:ln>
+        </p:spPr>
+        <p:txBody>
+          <a:bodyPr/>
+          <a:lstStyle>
+            <a:defPPr>
+              <a:defRPr sz="3300" b="1">
+                <a:solidFill>
+                  <a:srgbClr val="102D35"/>
+                </a:solidFill>
+                <a:latin typeface="Helvetica Neue"/>
+                <a:ea typeface="Helvetica Neue"/>
+                <a:cs typeface="Helvetica Neue"/>
+              </a:defRPr>
+            </a:defPPr>
+          </a:lstStyle>
+          <a:p>
+            <a:pPr>
+              <a:buNone/>
+              <a:defRPr sz="3300" b="1">
+                <a:solidFill>
+                  <a:srgbClr val="102D35"/>
+                </a:solidFill>
+                <a:latin typeface="Helvetica Neue"/>
+                <a:ea typeface="Helvetica Neue"/>
+                <a:cs typeface="Helvetica Neue"/>
+              </a:defRPr>
+            </a:pPr>
+            <a:r>
+              <a:rPr sz="3300" b="1">
+                <a:solidFill>
+                  <a:srgbClr val="102D35"/>
+                </a:solidFill>
+                <a:latin typeface="Helvetica Neue"/>
+                <a:ea typeface="Helvetica Neue"/>
+                <a:cs typeface="Helvetica Neue"/>
+              </a:rPr>
+              <a:t>Spielbeispiel</a:t>
+            </a:r>
+          </a:p>
+        </p:txBody>
+      </p:sp>
+      <p:sp>
+        <p:nvSpPr>
+          <p:cNvPr id="3" name="Team 15 · Mahmoud El-Hassan &amp; Moayed Shawesh">
+            <a:extLst>
+              <a:ext uri="{FF2B5EF4-FFF2-40B4-BE49-F238E27FC236}">
+                <ns2:creationId id="{8A6E3A1D-ACC3-4871-9E94-ADE9E4C15B2C}"/>
+              </a:ext>
+            </a:extLst>
+          </p:cNvPr>
+          <p:cNvSpPr>
+            <a:spLocks noGrp="1"/>
+          </p:cNvSpPr>
+          <p:nvPr/>
+        </p:nvSpPr>
+        <p:spPr>
+          <a:xfrm>
+            <a:off x="609600" y="6419850"/>
+            <a:ext cx="9906000" cy="266700"/>
+          </a:xfrm>
+          <a:prstGeom prst="rect">
+            <a:avLst/>
+          </a:prstGeom>
+          <a:noFill/>
+          <a:ln w="0">
+            <a:noFill/>
+          </a:ln>
+        </p:spPr>
+        <p:txBody>
+          <a:bodyPr/>
+          <a:lstStyle>
+            <a:defPPr>
+              <a:defRPr sz="1200" b="0">
+                <a:solidFill>
+                  <a:srgbClr val="526B70"/>
+                </a:solidFill>
+                <a:latin typeface="Helvetica Neue"/>
+                <a:ea typeface="Helvetica Neue"/>
+                <a:cs typeface="Helvetica Neue"/>
+              </a:defRPr>
+            </a:defPPr>
+          </a:lstStyle>
+          <a:p>
+            <a:pPr>
+              <a:defRPr sz="1200" b="0">
+                <a:solidFill>
+                  <a:srgbClr val="526B70"/>
+                </a:solidFill>
+                <a:latin typeface="Helvetica Neue"/>
+                <a:ea typeface="Helvetica Neue"/>
+                <a:cs typeface="Helvetica Neue"/>
+              </a:defRPr>
+            </a:pPr>
+            <a:r>
+              <a:rPr sz="1200" b="0">
+                <a:solidFill>
+                  <a:srgbClr val="526B70"/>
+                </a:solidFill>
+                <a:latin typeface="Helvetica Neue"/>
+                <a:ea typeface="Helvetica Neue"/>
+                <a:cs typeface="Helvetica Neue"/>
+              </a:rPr>
+              <a:t>Team 15 · Mahmoud El-Hassan &amp; Moayed Shawesh</a:t>
+            </a:r>
+          </a:p>
+        </p:txBody>
+      </p:sp>
+      <p:sp>
+        <p:nvSpPr>
+          <p:cNvPr id="4" name="09">
+            <a:extLst>
+              <a:ext uri="{FF2B5EF4-FFF2-40B4-BE49-F238E27FC236}">
+                <ns2:creationId id="{21F839A6-5B12-48CE-9DBD-C3A10D4AA9A9}"/>
+              </a:ext>
+            </a:extLst>
+          </p:cNvPr>
+          <p:cNvSpPr>
+            <a:spLocks noGrp="1"/>
+          </p:cNvSpPr>
+          <p:nvPr/>
+        </p:nvSpPr>
+        <p:spPr>
+          <a:xfrm>
+            <a:off x="11049000" y="6419850"/>
+            <a:ext cx="533400" cy="266700"/>
+          </a:xfrm>
+          <a:prstGeom prst="rect">
+            <a:avLst/>
+          </a:prstGeom>
+          <a:noFill/>
+          <a:ln w="0">
+            <a:noFill/>
+          </a:ln>
+        </p:spPr>
+        <p:txBody>
+          <a:bodyPr/>
+          <a:lstStyle>
+            <a:defPPr>
+              <a:defRPr sz="1200" b="0">
+                <a:solidFill>
+                  <a:srgbClr val="526B70"/>
+                </a:solidFill>
+                <a:latin typeface="Helvetica Neue"/>
+                <a:ea typeface="Helvetica Neue"/>
+                <a:cs typeface="Helvetica Neue"/>
+              </a:defRPr>
+            </a:defPPr>
+          </a:lstStyle>
+          <a:p>
+            <a:pPr>
+              <a:defRPr sz="1200" b="0">
+                <a:solidFill>
+                  <a:srgbClr val="526B70"/>
+                </a:solidFill>
+                <a:latin typeface="Helvetica Neue"/>
+                <a:ea typeface="Helvetica Neue"/>
+                <a:cs typeface="Helvetica Neue"/>
+              </a:defRPr>
+            </a:pPr>
+            <a:r>
+              <a:rPr sz="1200" b="0">
+                <a:solidFill>
+                  <a:srgbClr val="526B70"/>
+                </a:solidFill>
+                <a:latin typeface="Helvetica Neue"/>
+                <a:ea typeface="Helvetica Neue"/>
+                <a:cs typeface="Helvetica Neue"/>
+              </a:rPr>
+              <a:t>10</a:t>
+            </a:r>
+          </a:p>
+        </p:txBody>
+      </p:sp>
+      <p:pic>
+        <p:nvPicPr>
+          <p:cNvPr id="5" name="">
+            <a:extLst>
+              <a:ext uri="{FF2B5EF4-FFF2-40B4-BE49-F238E27FC236}">
+                <ns2:creationId id="{5B4A15C1-179F-4AF5-A36A-DE63BEBC5540}"/>
+              </a:ext>
+            </a:extLst>
+          </p:cNvPr>
+          <p:cNvPicPr>
+            <a:picLocks noChangeAspect="1"/>
+          </p:cNvPicPr>
+          <p:nvPr/>
+        </p:nvPicPr>
+        <p:blipFill>
+          <a:blip r:embed="Re2337e6fc3c2434d"/>
+          <a:stretch/>
+        </p:blipFill>
+        <p:spPr>
+          <a:xfrm>
+            <a:off x="609600" y="1924050"/>
+            <a:ext cx="3733800" cy="3733800"/>
+          </a:xfrm>
+          <a:prstGeom prst="rect">
+            <a:avLst/>
+          </a:prstGeom>
+        </p:spPr>
+      </p:pic>
+      <p:pic>
+        <p:nvPicPr>
+          <p:cNvPr id="6" name="">
+            <a:extLst>
+              <a:ext uri="{FF2B5EF4-FFF2-40B4-BE49-F238E27FC236}">
+                <ns2:creationId id="{EE23A9C9-EE08-4115-868A-36B887E13C00}"/>
+              </a:ext>
+            </a:extLst>
+          </p:cNvPr>
+          <p:cNvPicPr>
+            <a:picLocks noChangeAspect="1"/>
+          </p:cNvPicPr>
+          <p:nvPr/>
+        </p:nvPicPr>
+        <p:blipFill>
+          <a:blip r:embed="R4c0eb88b0e674139"/>
+          <a:stretch/>
+        </p:blipFill>
+        <p:spPr>
+          <a:xfrm>
+            <a:off x="4543425" y="1924050"/>
+            <a:ext cx="3733800" cy="3733800"/>
+          </a:xfrm>
+          <a:prstGeom prst="rect">
+            <a:avLst/>
+          </a:prstGeom>
+        </p:spPr>
+      </p:pic>
+      <p:sp>
+        <p:nvSpPr>
+          <p:cNvPr id="7" name="Schritt 23 · 0 : 0">
+            <a:extLst>
+              <a:ext uri="{FF2B5EF4-FFF2-40B4-BE49-F238E27FC236}">
+                <ns2:creationId id="{BE563A49-DAB7-4FAC-BC14-4BBE0559632A}"/>
+              </a:ext>
+            </a:extLst>
+          </p:cNvPr>
+          <p:cNvSpPr>
+            <a:spLocks noGrp="1"/>
+          </p:cNvSpPr>
+          <p:nvPr/>
+        </p:nvSpPr>
+        <p:spPr>
+          <a:xfrm>
+            <a:off x="609600" y="5800725"/>
+            <a:ext cx="3810000" cy="409575"/>
+          </a:xfrm>
+          <a:prstGeom prst="rect">
+            <a:avLst/>
+          </a:prstGeom>
+          <a:noFill/>
+          <a:ln w="0">
+            <a:noFill/>
+          </a:ln>
+        </p:spPr>
+        <p:txBody>
+          <a:bodyPr/>
+          <a:lstStyle>
+            <a:defPPr>
+              <a:defRPr sz="1950" b="1">
+                <a:solidFill>
+                  <a:srgbClr val="102D35"/>
+                </a:solidFill>
+                <a:latin typeface="Helvetica Neue"/>
+                <a:ea typeface="Helvetica Neue"/>
+                <a:cs typeface="Helvetica Neue"/>
+              </a:defRPr>
+            </a:defPPr>
+          </a:lstStyle>
+          <a:p>
+            <a:pPr>
+              <a:defRPr sz="1950" b="1">
+                <a:solidFill>
+                  <a:srgbClr val="102D35"/>
+                </a:solidFill>
+                <a:latin typeface="Helvetica Neue"/>
+                <a:ea typeface="Helvetica Neue"/>
+                <a:cs typeface="Helvetica Neue"/>
+              </a:defRPr>
+            </a:pPr>
+            <a:r>
+              <a:rPr sz="1950" b="1">
+                <a:solidFill>
+                  <a:srgbClr val="102D35"/>
+                </a:solidFill>
+                <a:latin typeface="Helvetica Neue"/>
+                <a:ea typeface="Helvetica Neue"/>
+                <a:cs typeface="Helvetica Neue"/>
+              </a:rPr>
+              <a:t>Schritt 23 · 0 : 0</a:t>
+            </a:r>
+          </a:p>
+        </p:txBody>
+      </p:sp>
+      <p:sp>
+        <p:nvSpPr>
+          <p:cNvPr id="8" name="Schritt 90 · 374 : 11">
+            <a:extLst>
+              <a:ext uri="{FF2B5EF4-FFF2-40B4-BE49-F238E27FC236}">
+                <ns2:creationId id="{15EA00B8-A570-4921-B800-06AC2AB009B3}"/>
+              </a:ext>
+            </a:extLst>
+          </p:cNvPr>
+          <p:cNvSpPr>
+            <a:spLocks noGrp="1"/>
+          </p:cNvSpPr>
+          <p:nvPr/>
+        </p:nvSpPr>
+        <p:spPr>
+          <a:xfrm>
+            <a:off x="4543425" y="5800725"/>
+            <a:ext cx="3810000" cy="409575"/>
+          </a:xfrm>
+          <a:prstGeom prst="rect">
+            <a:avLst/>
+          </a:prstGeom>
+          <a:noFill/>
+          <a:ln w="0">
+            <a:noFill/>
+          </a:ln>
+        </p:spPr>
+        <p:txBody>
+          <a:bodyPr/>
+          <a:lstStyle>
+            <a:defPPr>
+              <a:defRPr sz="1950" b="1">
+                <a:solidFill>
+                  <a:srgbClr val="102D35"/>
+                </a:solidFill>
+                <a:latin typeface="Helvetica Neue"/>
+                <a:ea typeface="Helvetica Neue"/>
+                <a:cs typeface="Helvetica Neue"/>
+              </a:defRPr>
+            </a:defPPr>
+          </a:lstStyle>
+          <a:p>
+            <a:pPr>
+              <a:defRPr sz="1950" b="1">
+                <a:solidFill>
+                  <a:srgbClr val="102D35"/>
+                </a:solidFill>
+                <a:latin typeface="Helvetica Neue"/>
+                <a:ea typeface="Helvetica Neue"/>
+                <a:cs typeface="Helvetica Neue"/>
+              </a:defRPr>
+            </a:pPr>
+            <a:r>
+              <a:rPr sz="1950" b="1">
+                <a:solidFill>
+                  <a:srgbClr val="102D35"/>
+                </a:solidFill>
+                <a:latin typeface="Helvetica Neue"/>
+                <a:ea typeface="Helvetica Neue"/>
+                <a:cs typeface="Helvetica Neue"/>
+              </a:rPr>
+              <a:t>Schritt 90 · 374 : 11</a:t>
+            </a:r>
+          </a:p>
+        </p:txBody>
+      </p:sp>
+      <p:sp>
+        <p:nvSpPr>
+          <p:cNvPr id="9" name="Sherlock: blau&#10;Gegner: rot">
+            <a:extLst>
+              <a:ext uri="{FF2B5EF4-FFF2-40B4-BE49-F238E27FC236}">
+                <ns2:creationId id="{A4849F7E-04F9-4CDB-9887-2CE754AAE9CA}"/>
+              </a:ext>
+            </a:extLst>
+          </p:cNvPr>
+          <p:cNvSpPr>
+            <a:spLocks noGrp="1"/>
+          </p:cNvSpPr>
+          <p:nvPr/>
+        </p:nvSpPr>
+        <p:spPr>
+          <a:xfrm>
+            <a:off x="8724900" y="2057400"/>
+            <a:ext cx="2857500" cy="952500"/>
+          </a:xfrm>
+          <a:prstGeom prst="rect">
+            <a:avLst/>
+          </a:prstGeom>
+          <a:noFill/>
+          <a:ln w="0">
+            <a:noFill/>
+          </a:ln>
+        </p:spPr>
+        <p:txBody>
+          <a:bodyPr>
+            <a:noAutofit/>
+          </a:bodyPr>
+          <a:lstStyle>
+            <a:defPPr algn="l">
+              <a:defRPr sz="2025" b="1">
+                <a:solidFill>
+                  <a:srgbClr val="007D7B"/>
+                </a:solidFill>
+                <a:latin typeface="Helvetica Neue"/>
+                <a:ea typeface="Helvetica Neue"/>
+                <a:cs typeface="Helvetica Neue"/>
+              </a:defRPr>
+            </a:defPPr>
+          </a:lstStyle>
+          <a:p>
+            <a:pPr marL="330200" indent="-254000" algn="l">
+              <a:spcAft>
+                <a:spcPts val="800"/>
+              </a:spcAft>
+              <a:buFont typeface="Helvetica Neue"/>
+              <a:buChar char="–"/>
+              <a:defRPr sz="2025" b="1">
+                <a:solidFill>
+                  <a:srgbClr val="007D7B"/>
+                </a:solidFill>
+                <a:latin typeface="Helvetica Neue"/>
+                <a:ea typeface="Helvetica Neue"/>
+                <a:cs typeface="Helvetica Neue"/>
+              </a:defRPr>
+            </a:pPr>
+            <a:r>
+              <a:rPr sz="2025" b="1">
+                <a:solidFill>
+                  <a:srgbClr val="007D7B"/>
+                </a:solidFill>
+                <a:latin typeface="Helvetica Neue"/>
+                <a:ea typeface="Helvetica Neue"/>
+                <a:cs typeface="Helvetica Neue"/>
+              </a:rPr>
+              <a:t>Sherlock: blau</a:t>
+            </a:r>
+          </a:p>
+          <a:p>
+            <a:pPr marL="330200" indent="-254000" algn="l">
+              <a:spcAft>
+                <a:spcPts val="800"/>
+              </a:spcAft>
+              <a:buFont typeface="Helvetica Neue"/>
+              <a:buChar char="–"/>
+              <a:defRPr sz="2025" b="1">
+                <a:solidFill>
+                  <a:srgbClr val="007D7B"/>
+                </a:solidFill>
+                <a:latin typeface="Helvetica Neue"/>
+                <a:ea typeface="Helvetica Neue"/>
+                <a:cs typeface="Helvetica Neue"/>
+              </a:defRPr>
+            </a:pPr>
+            <a:r>
+              <a:rPr sz="2025" b="1">
+                <a:solidFill>
+                  <a:srgbClr val="007D7B"/>
+                </a:solidFill>
+                <a:latin typeface="Helvetica Neue"/>
+                <a:ea typeface="Helvetica Neue"/>
+                <a:cs typeface="Helvetica Neue"/>
+              </a:rPr>
+              <a:t>Gegner: rot</a:t>
+            </a:r>
+          </a:p>
+        </p:txBody>
+      </p:sp>
+      <p:sp>
+        <p:nvSpPr>
+          <p:cNvPr id="10" name="Blaue Einheiten&#10;besetzen Punktefelder.&#10;&#10;Stehe">
+            <a:extLst>
+              <a:ext uri="{FF2B5EF4-FFF2-40B4-BE49-F238E27FC236}">
+                <ns2:creationId id="{F57BBD97-C9BE-4063-922D-45E9DF7DDCED}"/>
+              </a:ext>
+            </a:extLst>
+          </p:cNvPr>
+          <p:cNvSpPr>
+            <a:spLocks noGrp="1"/>
+          </p:cNvSpPr>
+          <p:nvPr/>
+        </p:nvSpPr>
+        <p:spPr>
+          <a:xfrm>
+            <a:off x="8724900" y="3343275"/>
+            <a:ext cx="2857500" cy="2238375"/>
+          </a:xfrm>
+          <a:prstGeom prst="rect">
+            <a:avLst/>
+          </a:prstGeom>
+          <a:noFill/>
+          <a:ln w="0">
+            <a:noFill/>
+          </a:ln>
+        </p:spPr>
+        <p:txBody>
+          <a:bodyPr>
+            <a:noAutofit/>
+          </a:bodyPr>
+          <a:lstStyle>
+            <a:defPPr algn="l">
+              <a:defRPr sz="2025" b="0">
+                <a:solidFill>
+                  <a:srgbClr val="102D35"/>
+                </a:solidFill>
+                <a:latin typeface="Helvetica Neue"/>
+                <a:ea typeface="Helvetica Neue"/>
+                <a:cs typeface="Helvetica Neue"/>
+              </a:defRPr>
+            </a:defPPr>
+          </a:lstStyle>
+          <a:p>
+            <a:pPr marL="330200" indent="-254000" algn="l">
+              <a:spcAft>
+                <a:spcPts val="1200"/>
+              </a:spcAft>
+              <a:buFont typeface="Helvetica Neue"/>
+              <a:buChar char="–"/>
+              <a:defRPr sz="2025" b="0">
+                <a:solidFill>
+                  <a:srgbClr val="102D35"/>
+                </a:solidFill>
+                <a:latin typeface="Helvetica Neue"/>
+                <a:ea typeface="Helvetica Neue"/>
+                <a:cs typeface="Helvetica Neue"/>
+              </a:defRPr>
+            </a:pPr>
+            <a:r>
+              <a:rPr sz="2025">
+                <a:solidFill>
+                  <a:srgbClr val="102D35"/>
+                </a:solidFill>
+                <a:latin typeface="Helvetica Neue"/>
+                <a:ea typeface="Helvetica Neue"/>
+                <a:cs typeface="Helvetica Neue"/>
+              </a:rPr>
+              <a:t>Blaue Einheiten besetzen Punktefelder</a:t>
+            </a:r>
+          </a:p>
+          <a:p>
+            <a:pPr marL="330200" indent="-254000" algn="l">
+              <a:spcAft>
+                <a:spcPts val="1200"/>
+              </a:spcAft>
+              <a:buFont typeface="Helvetica Neue"/>
+              <a:buChar char="–"/>
+              <a:defRPr sz="2025" b="0">
+                <a:solidFill>
+                  <a:srgbClr val="102D35"/>
+                </a:solidFill>
+                <a:latin typeface="Helvetica Neue"/>
+                <a:ea typeface="Helvetica Neue"/>
+                <a:cs typeface="Helvetica Neue"/>
+              </a:defRPr>
+            </a:pPr>
+            <a:r>
+              <a:rPr sz="2025">
+                <a:solidFill>
+                  <a:srgbClr val="102D35"/>
+                </a:solidFill>
+                <a:latin typeface="Helvetica Neue"/>
+                <a:ea typeface="Helvetica Neue"/>
+                <a:cs typeface="Helvetica Neue"/>
+              </a:rPr>
+              <a:t>Stehenbleiben kann sinnvoll sein</a:t>
+            </a:r>
+          </a:p>
+        </p:txBody>
+      </p:sp>
+      <p:sp>
+        <p:nvSpPr>
+          <p:cNvPr id="11" name="Seed 900011 · Match 1&#10;Vollständige Replay-Ans">
+            <a:extLst>
+              <a:ext uri="{FF2B5EF4-FFF2-40B4-BE49-F238E27FC236}">
+                <ns2:creationId id="{0FC615EC-C06C-4482-9275-6839DD877F5F}"/>
+              </a:ext>
+            </a:extLst>
+          </p:cNvPr>
+          <p:cNvSpPr>
+            <a:spLocks noGrp="1"/>
+          </p:cNvSpPr>
+          <p:nvPr/>
+        </p:nvSpPr>
+        <p:spPr>
+          <a:xfrm>
+            <a:off x="8724900" y="5619750"/>
+            <a:ext cx="2857500" cy="619125"/>
+          </a:xfrm>
+          <a:prstGeom prst="rect">
+            <a:avLst/>
+          </a:prstGeom>
+          <a:noFill/>
+          <a:ln w="0">
+            <a:noFill/>
+          </a:ln>
+        </p:spPr>
+        <p:txBody>
+          <a:bodyPr/>
+          <a:lstStyle>
+            <a:defPPr>
+              <a:defRPr sz="1500" b="0">
+                <a:solidFill>
+                  <a:srgbClr val="526B70"/>
+                </a:solidFill>
+                <a:latin typeface="Helvetica Neue"/>
+                <a:ea typeface="Helvetica Neue"/>
+                <a:cs typeface="Helvetica Neue"/>
+              </a:defRPr>
+            </a:defPPr>
+          </a:lstStyle>
+          <a:p>
+            <a:pPr>
+              <a:defRPr sz="1500" b="0">
+                <a:solidFill>
+                  <a:srgbClr val="526B70"/>
+                </a:solidFill>
+                <a:latin typeface="Helvetica Neue"/>
+                <a:ea typeface="Helvetica Neue"/>
+                <a:cs typeface="Helvetica Neue"/>
+              </a:defRPr>
+            </a:pPr>
+            <a:r>
+              <a:rPr sz="1500" b="0">
+                <a:solidFill>
+                  <a:srgbClr val="526B70"/>
+                </a:solidFill>
+                <a:latin typeface="Helvetica Neue"/>
+                <a:ea typeface="Helvetica Neue"/>
+                <a:cs typeface="Helvetica Neue"/>
+              </a:rPr>
+              <a:t>Seed 900011 · Match 1</a:t>
+            </a:r>
+          </a:p>
+          <a:p>
+            <a:pPr>
+              <a:defRPr sz="1500" b="0">
+                <a:solidFill>
+                  <a:srgbClr val="526B70"/>
+                </a:solidFill>
+                <a:latin typeface="Helvetica Neue"/>
+                <a:ea typeface="Helvetica Neue"/>
+                <a:cs typeface="Helvetica Neue"/>
+              </a:defRPr>
+            </a:pPr>
+            <a:r>
+              <a:rPr sz="1500" b="0">
+                <a:solidFill>
+                  <a:srgbClr val="526B70"/>
+                </a:solidFill>
+                <a:latin typeface="Helvetica Neue"/>
+                <a:ea typeface="Helvetica Neue"/>
+                <a:cs typeface="Helvetica Neue"/>
+              </a:rPr>
+              <a:t>Vollständige Replay-Ansicht</a:t>
+            </a:r>
+          </a:p>
+        </p:txBody>
+      </p:sp>
+    </p:spTree>
+    <p:extLst>
+      <p:ext uri="{BB962C8B-B14F-4D97-AF65-F5344CB8AC3E}">
+        <ns4:creationId val="1042096664"/>
+      </p:ext>
+    </p:extLst>
+  </p:cSld>
+</p:sld>
+</file>
+
+<file path=ppt/slides/slide11.xml><?xml version="1.0" encoding="utf-8"?>
 <p:sld xmlns:a="http://schemas.openxmlformats.org/drawingml/2006/main" xmlns:ns2="http://schemas.microsoft.com/office/drawing/2014/main" xmlns:ns3="http://schemas.microsoft.com/office/powerpoint/2010/main" xmlns:p="http://schemas.openxmlformats.org/presentationml/2006/main">
   <p:cSld>
     <p:bg>
@@ -4991,7 +5855,7 @@
                 <a:ea typeface="Helvetica Neue"/>
                 <a:cs typeface="Helvetica Neue"/>
               </a:rPr>
-              <a:t>10</a:t>
+              <a:t>11</a:t>
             </a:r>
           </a:p>
         </p:txBody>
@@ -5600,7 +6464,7 @@
 </p:sld>
 </file>
 
-<file path=ppt/slides/slide11.xml><?xml version="1.0" encoding="utf-8"?>
+<file path=ppt/slides/slide12.xml><?xml version="1.0" encoding="utf-8"?>
 <p:sld xmlns:a="http://schemas.openxmlformats.org/drawingml/2006/main" xmlns:ns2="http://schemas.microsoft.com/office/drawing/2014/main" xmlns:ns3="http://schemas.microsoft.com/office/powerpoint/2010/main" xmlns:p="http://schemas.openxmlformats.org/presentationml/2006/main">
   <p:cSld>
     <p:bg>
@@ -5879,7 +6743,7 @@
                 <a:ea typeface="Helvetica Neue"/>
                 <a:cs typeface="Helvetica Neue"/>
               </a:rPr>
-              <a:t>11</a:t>
+              <a:t>12</a:t>
             </a:r>
           </a:p>
         </p:txBody>
@@ -6136,7 +7000,7 @@
 </p:sld>
 </file>
 
-<file path=ppt/slides/slide12.xml><?xml version="1.0" encoding="utf-8"?>
+<file path=ppt/slides/slide13.xml><?xml version="1.0" encoding="utf-8"?>
 <p:sld xmlns:a="http://schemas.openxmlformats.org/drawingml/2006/main" xmlns:ns2="http://schemas.microsoft.com/office/drawing/2014/main" xmlns:ns3="http://schemas.microsoft.com/office/powerpoint/2010/main" xmlns:p="http://schemas.openxmlformats.org/presentationml/2006/main" show="0">
   <p:cSld>
     <p:bg>
@@ -6415,7 +7279,7 @@
                 <a:ea typeface="Helvetica Neue"/>
                 <a:cs typeface="Helvetica Neue"/>
               </a:rPr>
-              <a:t>12</a:t>
+              <a:t>13</a:t>
             </a:r>
           </a:p>
         </p:txBody>
@@ -6950,7 +7814,7 @@
 </p:sld>
 </file>
 
-<file path=ppt/slides/slide13.xml><?xml version="1.0" encoding="utf-8"?>
+<file path=ppt/slides/slide14.xml><?xml version="1.0" encoding="utf-8"?>
 <p:sld xmlns:a="http://schemas.openxmlformats.org/drawingml/2006/main" xmlns:ns2="http://schemas.microsoft.com/office/drawing/2014/main" xmlns:ns3="http://schemas.microsoft.com/office/powerpoint/2010/main" xmlns:p="http://schemas.openxmlformats.org/presentationml/2006/main" show="0">
   <p:cSld>
     <p:bg>
@@ -7229,7 +8093,7 @@
                 <a:ea typeface="Helvetica Neue"/>
                 <a:cs typeface="Helvetica Neue"/>
               </a:rPr>
-              <a:t>13</a:t>
+              <a:t>14</a:t>
             </a:r>
           </a:p>
         </p:txBody>
@@ -7751,6 +8615,1123 @@
 </file>
 
 <file path=ppt/slides/slide2.xml><?xml version="1.0" encoding="utf-8"?>
+<p:sld xmlns:p="http://schemas.openxmlformats.org/presentationml/2006/main">
+  <p:cSld>
+    <p:bg>
+      <p:bgPr>
+        <a:solidFill xmlns:a="http://schemas.openxmlformats.org/drawingml/2006/main">
+          <a:srgbClr val="F7F7F0"/>
+        </a:solidFill>
+      </p:bgPr>
+    </p:bg>
+    <p:spTree>
+      <p:nvGrpSpPr>
+        <p:cNvPr id="1" name=""/>
+        <p:cNvGrpSpPr/>
+        <p:nvPr/>
+      </p:nvGrpSpPr>
+      <p:grpSpPr>
+        <a:xfrm xmlns:a="http://schemas.openxmlformats.org/drawingml/2006/main"/>
+      </p:grpSpPr>
+      <p:sp>
+        <p:nvSpPr>
+          <p:cNvPr id="17" name="SHERLOCK / REVIEW 01">
+            <a:extLst xmlns:a="http://schemas.openxmlformats.org/drawingml/2006/main">
+              <a:ext uri="{FF2B5EF4-FFF2-40B4-BE49-F238E27FC236}">
+                <a16:creationId xmlns:a16="http://schemas.microsoft.com/office/drawing/2014/main" id="{4ABBEAE0-A954-41E9-A7C6-DDDF1B53548C}"/>
+              </a:ext>
+            </a:extLst>
+          </p:cNvPr>
+          <p:cNvSpPr>
+            <a:spLocks xmlns:a="http://schemas.openxmlformats.org/drawingml/2006/main" noGrp="1"/>
+          </p:cNvSpPr>
+          <p:nvPr/>
+        </p:nvSpPr>
+        <p:spPr>
+          <a:xfrm xmlns:a="http://schemas.openxmlformats.org/drawingml/2006/main">
+            <a:off x="609600" y="266700"/>
+            <a:ext cx="8572500" cy="304800"/>
+          </a:xfrm>
+          <a:prstGeom xmlns:a="http://schemas.openxmlformats.org/drawingml/2006/main" prst="rect">
+            <a:avLst/>
+          </a:prstGeom>
+          <a:noFill xmlns:a="http://schemas.openxmlformats.org/drawingml/2006/main"/>
+          <a:ln xmlns:a="http://schemas.openxmlformats.org/drawingml/2006/main" w="0">
+            <a:noFill/>
+          </a:ln>
+        </p:spPr>
+        <p:txBody>
+          <a:bodyPr xmlns:a="http://schemas.openxmlformats.org/drawingml/2006/main">
+            <a:noAutofit/>
+          </a:bodyPr>
+          <a:lstStyle xmlns:a="http://schemas.openxmlformats.org/drawingml/2006/main">
+            <a:defPPr>
+              <a:defRPr sz="1350" b="1">
+                <a:solidFill>
+                  <a:srgbClr val="007D7B"/>
+                </a:solidFill>
+                <a:latin typeface="Helvetica Neue"/>
+                <a:ea typeface="Helvetica Neue"/>
+                <a:cs typeface="Helvetica Neue"/>
+              </a:defRPr>
+            </a:defPPr>
+          </a:lstStyle>
+          <a:p xmlns:a="http://schemas.openxmlformats.org/drawingml/2006/main">
+            <a:pPr>
+              <a:defRPr sz="1350" b="1">
+                <a:solidFill>
+                  <a:srgbClr val="007D7B"/>
+                </a:solidFill>
+                <a:latin typeface="Helvetica Neue"/>
+                <a:ea typeface="Helvetica Neue"/>
+                <a:cs typeface="Helvetica Neue"/>
+              </a:defRPr>
+            </a:pPr>
+            <a:r>
+              <a:rPr sz="1350" b="1">
+                <a:solidFill>
+                  <a:srgbClr val="007D7B"/>
+                </a:solidFill>
+                <a:latin typeface="Helvetica Neue"/>
+                <a:ea typeface="Helvetica Neue"/>
+                <a:cs typeface="Helvetica Neue"/>
+              </a:rPr>
+              <a:t>SHERLOCK / REVIEW 01</a:t>
+            </a:r>
+          </a:p>
+        </p:txBody>
+      </p:sp>
+      <p:sp>
+        <p:nvSpPr>
+          <p:cNvPr id="2" name="Agenda">
+            <a:extLst xmlns:a="http://schemas.openxmlformats.org/drawingml/2006/main">
+              <a:ext uri="{FF2B5EF4-FFF2-40B4-BE49-F238E27FC236}">
+                <a16:creationId xmlns:a16="http://schemas.microsoft.com/office/drawing/2014/main" id="{CF15880C-FAC8-4E31-8F11-A298F5128FE6}"/>
+              </a:ext>
+            </a:extLst>
+          </p:cNvPr>
+          <p:cNvSpPr>
+            <a:spLocks xmlns:a="http://schemas.openxmlformats.org/drawingml/2006/main" noGrp="1"/>
+          </p:cNvSpPr>
+          <p:nvPr/>
+        </p:nvSpPr>
+        <p:spPr>
+          <a:xfrm xmlns:a="http://schemas.openxmlformats.org/drawingml/2006/main">
+            <a:off x="609600" y="781050"/>
+            <a:ext cx="10972800" cy="1028700"/>
+          </a:xfrm>
+          <a:prstGeom xmlns:a="http://schemas.openxmlformats.org/drawingml/2006/main" prst="rect">
+            <a:avLst/>
+          </a:prstGeom>
+          <a:noFill xmlns:a="http://schemas.openxmlformats.org/drawingml/2006/main"/>
+          <a:ln xmlns:a="http://schemas.openxmlformats.org/drawingml/2006/main" w="0">
+            <a:noFill/>
+          </a:ln>
+        </p:spPr>
+        <p:txBody>
+          <a:bodyPr xmlns:a="http://schemas.openxmlformats.org/drawingml/2006/main">
+            <a:noAutofit/>
+          </a:bodyPr>
+          <a:lstStyle xmlns:a="http://schemas.openxmlformats.org/drawingml/2006/main">
+            <a:defPPr>
+              <a:defRPr sz="3300" b="1">
+                <a:solidFill>
+                  <a:srgbClr val="102D35"/>
+                </a:solidFill>
+                <a:latin typeface="Helvetica Neue"/>
+                <a:ea typeface="Helvetica Neue"/>
+                <a:cs typeface="Helvetica Neue"/>
+              </a:defRPr>
+            </a:defPPr>
+          </a:lstStyle>
+          <a:p xmlns:a="http://schemas.openxmlformats.org/drawingml/2006/main">
+            <a:pPr>
+              <a:defRPr sz="3300" b="1">
+                <a:solidFill>
+                  <a:srgbClr val="102D35"/>
+                </a:solidFill>
+                <a:latin typeface="Helvetica Neue"/>
+                <a:ea typeface="Helvetica Neue"/>
+                <a:cs typeface="Helvetica Neue"/>
+              </a:defRPr>
+            </a:pPr>
+            <a:r>
+              <a:rPr sz="3300" b="1">
+                <a:solidFill>
+                  <a:srgbClr val="102D35"/>
+                </a:solidFill>
+                <a:latin typeface="Helvetica Neue"/>
+                <a:ea typeface="Helvetica Neue"/>
+                <a:cs typeface="Helvetica Neue"/>
+              </a:rPr>
+              <a:t>Agenda</a:t>
+            </a:r>
+          </a:p>
+        </p:txBody>
+      </p:sp>
+      <p:sp>
+        <p:nvSpPr>
+          <p:cNvPr id="3" name="Team 15 · Mahmoud El-Hassan &amp; Moayed Shawesh">
+            <a:extLst xmlns:a="http://schemas.openxmlformats.org/drawingml/2006/main">
+              <a:ext uri="{FF2B5EF4-FFF2-40B4-BE49-F238E27FC236}">
+                <a16:creationId xmlns:a16="http://schemas.microsoft.com/office/drawing/2014/main" id="{B3BD07BA-C22D-40E7-99FE-B531044E7E19}"/>
+              </a:ext>
+            </a:extLst>
+          </p:cNvPr>
+          <p:cNvSpPr>
+            <a:spLocks xmlns:a="http://schemas.openxmlformats.org/drawingml/2006/main" noGrp="1"/>
+          </p:cNvSpPr>
+          <p:nvPr/>
+        </p:nvSpPr>
+        <p:spPr>
+          <a:xfrm xmlns:a="http://schemas.openxmlformats.org/drawingml/2006/main">
+            <a:off x="609600" y="6419850"/>
+            <a:ext cx="9906000" cy="266700"/>
+          </a:xfrm>
+          <a:prstGeom xmlns:a="http://schemas.openxmlformats.org/drawingml/2006/main" prst="rect">
+            <a:avLst/>
+          </a:prstGeom>
+          <a:noFill xmlns:a="http://schemas.openxmlformats.org/drawingml/2006/main"/>
+          <a:ln xmlns:a="http://schemas.openxmlformats.org/drawingml/2006/main" w="0">
+            <a:noFill/>
+          </a:ln>
+        </p:spPr>
+        <p:txBody>
+          <a:bodyPr xmlns:a="http://schemas.openxmlformats.org/drawingml/2006/main">
+            <a:noAutofit/>
+          </a:bodyPr>
+          <a:lstStyle xmlns:a="http://schemas.openxmlformats.org/drawingml/2006/main">
+            <a:defPPr>
+              <a:defRPr sz="1200" b="0">
+                <a:solidFill>
+                  <a:srgbClr val="526B70"/>
+                </a:solidFill>
+                <a:latin typeface="Helvetica Neue"/>
+                <a:ea typeface="Helvetica Neue"/>
+                <a:cs typeface="Helvetica Neue"/>
+              </a:defRPr>
+            </a:defPPr>
+          </a:lstStyle>
+          <a:p xmlns:a="http://schemas.openxmlformats.org/drawingml/2006/main">
+            <a:pPr>
+              <a:defRPr sz="1200" b="0">
+                <a:solidFill>
+                  <a:srgbClr val="526B70"/>
+                </a:solidFill>
+                <a:latin typeface="Helvetica Neue"/>
+                <a:ea typeface="Helvetica Neue"/>
+                <a:cs typeface="Helvetica Neue"/>
+              </a:defRPr>
+            </a:pPr>
+            <a:r>
+              <a:rPr sz="1200" b="0">
+                <a:solidFill>
+                  <a:srgbClr val="526B70"/>
+                </a:solidFill>
+                <a:latin typeface="Helvetica Neue"/>
+                <a:ea typeface="Helvetica Neue"/>
+                <a:cs typeface="Helvetica Neue"/>
+              </a:rPr>
+              <a:t>Team 15 · Mahmoud El-Hassan &amp; Moayed Shawesh</a:t>
+            </a:r>
+          </a:p>
+        </p:txBody>
+      </p:sp>
+      <p:sp>
+        <p:nvSpPr>
+          <p:cNvPr id="4" name="02">
+            <a:extLst xmlns:a="http://schemas.openxmlformats.org/drawingml/2006/main">
+              <a:ext uri="{FF2B5EF4-FFF2-40B4-BE49-F238E27FC236}">
+                <a16:creationId xmlns:a16="http://schemas.microsoft.com/office/drawing/2014/main" id="{0C0B675C-18D9-4F40-9A99-CDA4B6653D24}"/>
+              </a:ext>
+            </a:extLst>
+          </p:cNvPr>
+          <p:cNvSpPr>
+            <a:spLocks xmlns:a="http://schemas.openxmlformats.org/drawingml/2006/main" noGrp="1"/>
+          </p:cNvSpPr>
+          <p:nvPr/>
+        </p:nvSpPr>
+        <p:spPr>
+          <a:xfrm xmlns:a="http://schemas.openxmlformats.org/drawingml/2006/main">
+            <a:off x="11049000" y="6419850"/>
+            <a:ext cx="533400" cy="266700"/>
+          </a:xfrm>
+          <a:prstGeom xmlns:a="http://schemas.openxmlformats.org/drawingml/2006/main" prst="rect">
+            <a:avLst/>
+          </a:prstGeom>
+          <a:noFill xmlns:a="http://schemas.openxmlformats.org/drawingml/2006/main"/>
+          <a:ln xmlns:a="http://schemas.openxmlformats.org/drawingml/2006/main" w="0">
+            <a:noFill/>
+          </a:ln>
+        </p:spPr>
+        <p:txBody>
+          <a:bodyPr xmlns:a="http://schemas.openxmlformats.org/drawingml/2006/main">
+            <a:noAutofit/>
+          </a:bodyPr>
+          <a:lstStyle xmlns:a="http://schemas.openxmlformats.org/drawingml/2006/main">
+            <a:defPPr>
+              <a:defRPr sz="1200" b="0">
+                <a:solidFill>
+                  <a:srgbClr val="526B70"/>
+                </a:solidFill>
+                <a:latin typeface="Helvetica Neue"/>
+                <a:ea typeface="Helvetica Neue"/>
+                <a:cs typeface="Helvetica Neue"/>
+              </a:defRPr>
+            </a:defPPr>
+          </a:lstStyle>
+          <a:p xmlns:a="http://schemas.openxmlformats.org/drawingml/2006/main">
+            <a:pPr>
+              <a:defRPr sz="1200" b="0">
+                <a:solidFill>
+                  <a:srgbClr val="526B70"/>
+                </a:solidFill>
+                <a:latin typeface="Helvetica Neue"/>
+                <a:ea typeface="Helvetica Neue"/>
+                <a:cs typeface="Helvetica Neue"/>
+              </a:defRPr>
+            </a:pPr>
+            <a:r>
+              <a:rPr sz="1200" b="0">
+                <a:solidFill>
+                  <a:srgbClr val="526B70"/>
+                </a:solidFill>
+                <a:latin typeface="Helvetica Neue"/>
+                <a:ea typeface="Helvetica Neue"/>
+                <a:cs typeface="Helvetica Neue"/>
+              </a:rPr>
+              <a:t>02</a:t>
+            </a:r>
+          </a:p>
+        </p:txBody>
+      </p:sp>
+      <p:sp>
+        <p:nvSpPr>
+          <p:cNvPr id="5" name="1.">
+            <a:extLst xmlns:a="http://schemas.openxmlformats.org/drawingml/2006/main">
+              <a:ext uri="{FF2B5EF4-FFF2-40B4-BE49-F238E27FC236}">
+                <a16:creationId xmlns:a16="http://schemas.microsoft.com/office/drawing/2014/main" id="{326581D1-8A36-4D6D-99D9-580D296121B9}"/>
+              </a:ext>
+            </a:extLst>
+          </p:cNvPr>
+          <p:cNvSpPr>
+            <a:spLocks xmlns:a="http://schemas.openxmlformats.org/drawingml/2006/main" noGrp="1"/>
+          </p:cNvSpPr>
+          <p:nvPr/>
+        </p:nvSpPr>
+        <p:spPr>
+          <a:xfrm xmlns:a="http://schemas.openxmlformats.org/drawingml/2006/main">
+            <a:off x="990600" y="1943100"/>
+            <a:ext cx="571500" cy="457200"/>
+          </a:xfrm>
+          <a:prstGeom xmlns:a="http://schemas.openxmlformats.org/drawingml/2006/main" prst="rect">
+            <a:avLst/>
+          </a:prstGeom>
+          <a:noFill xmlns:a="http://schemas.openxmlformats.org/drawingml/2006/main"/>
+          <a:ln xmlns:a="http://schemas.openxmlformats.org/drawingml/2006/main" w="0">
+            <a:noFill/>
+          </a:ln>
+        </p:spPr>
+        <p:txBody>
+          <a:bodyPr xmlns:a="http://schemas.openxmlformats.org/drawingml/2006/main">
+            <a:noAutofit/>
+          </a:bodyPr>
+          <a:lstStyle xmlns:a="http://schemas.openxmlformats.org/drawingml/2006/main">
+            <a:defPPr>
+              <a:defRPr sz="2400" b="1">
+                <a:solidFill>
+                  <a:srgbClr val="007D7B"/>
+                </a:solidFill>
+                <a:latin typeface="Helvetica Neue"/>
+                <a:ea typeface="Helvetica Neue"/>
+                <a:cs typeface="Helvetica Neue"/>
+              </a:defRPr>
+            </a:defPPr>
+          </a:lstStyle>
+          <a:p xmlns:a="http://schemas.openxmlformats.org/drawingml/2006/main">
+            <a:pPr>
+              <a:defRPr sz="2400" b="1">
+                <a:solidFill>
+                  <a:srgbClr val="007D7B"/>
+                </a:solidFill>
+                <a:latin typeface="Helvetica Neue"/>
+                <a:ea typeface="Helvetica Neue"/>
+                <a:cs typeface="Helvetica Neue"/>
+              </a:defRPr>
+            </a:pPr>
+            <a:r>
+              <a:rPr sz="2400" b="1">
+                <a:solidFill>
+                  <a:srgbClr val="007D7B"/>
+                </a:solidFill>
+                <a:latin typeface="Helvetica Neue"/>
+                <a:ea typeface="Helvetica Neue"/>
+                <a:cs typeface="Helvetica Neue"/>
+              </a:rPr>
+              <a:t>1.</a:t>
+            </a:r>
+          </a:p>
+        </p:txBody>
+      </p:sp>
+      <p:sp>
+        <p:nvSpPr>
+          <p:cNvPr id="6" name="Spielidee und Ziel">
+            <a:extLst xmlns:a="http://schemas.openxmlformats.org/drawingml/2006/main">
+              <a:ext uri="{FF2B5EF4-FFF2-40B4-BE49-F238E27FC236}">
+                <a16:creationId xmlns:a16="http://schemas.microsoft.com/office/drawing/2014/main" id="{765CF1AA-E43A-4D6F-87D7-D33E77B1C6F0}"/>
+              </a:ext>
+            </a:extLst>
+          </p:cNvPr>
+          <p:cNvSpPr>
+            <a:spLocks xmlns:a="http://schemas.openxmlformats.org/drawingml/2006/main" noGrp="1"/>
+          </p:cNvSpPr>
+          <p:nvPr/>
+        </p:nvSpPr>
+        <p:spPr>
+          <a:xfrm xmlns:a="http://schemas.openxmlformats.org/drawingml/2006/main">
+            <a:off x="1752600" y="1943100"/>
+            <a:ext cx="9429750" cy="457200"/>
+          </a:xfrm>
+          <a:prstGeom xmlns:a="http://schemas.openxmlformats.org/drawingml/2006/main" prst="rect">
+            <a:avLst/>
+          </a:prstGeom>
+          <a:noFill xmlns:a="http://schemas.openxmlformats.org/drawingml/2006/main"/>
+          <a:ln xmlns:a="http://schemas.openxmlformats.org/drawingml/2006/main" w="0">
+            <a:noFill/>
+          </a:ln>
+        </p:spPr>
+        <p:txBody>
+          <a:bodyPr xmlns:a="http://schemas.openxmlformats.org/drawingml/2006/main">
+            <a:noAutofit/>
+          </a:bodyPr>
+          <a:lstStyle xmlns:a="http://schemas.openxmlformats.org/drawingml/2006/main">
+            <a:defPPr>
+              <a:defRPr sz="2400" b="0">
+                <a:solidFill>
+                  <a:srgbClr val="102D35"/>
+                </a:solidFill>
+                <a:latin typeface="Helvetica Neue"/>
+                <a:ea typeface="Helvetica Neue"/>
+                <a:cs typeface="Helvetica Neue"/>
+              </a:defRPr>
+            </a:defPPr>
+          </a:lstStyle>
+          <a:p xmlns:a="http://schemas.openxmlformats.org/drawingml/2006/main">
+            <a:pPr>
+              <a:defRPr sz="2400" b="0">
+                <a:solidFill>
+                  <a:srgbClr val="102D35"/>
+                </a:solidFill>
+                <a:latin typeface="Helvetica Neue"/>
+                <a:ea typeface="Helvetica Neue"/>
+                <a:cs typeface="Helvetica Neue"/>
+              </a:defRPr>
+            </a:pPr>
+            <a:r>
+              <a:rPr sz="2400" b="0">
+                <a:solidFill>
+                  <a:srgbClr val="102D35"/>
+                </a:solidFill>
+                <a:latin typeface="Helvetica Neue"/>
+                <a:ea typeface="Helvetica Neue"/>
+                <a:cs typeface="Helvetica Neue"/>
+              </a:rPr>
+              <a:t>Spielidee und Ziel</a:t>
+            </a:r>
+          </a:p>
+        </p:txBody>
+      </p:sp>
+      <p:sp>
+        <p:nvSpPr>
+          <p:cNvPr id="7" name="2.">
+            <a:extLst xmlns:a="http://schemas.openxmlformats.org/drawingml/2006/main">
+              <a:ext uri="{FF2B5EF4-FFF2-40B4-BE49-F238E27FC236}">
+                <a16:creationId xmlns:a16="http://schemas.microsoft.com/office/drawing/2014/main" id="{16C7F777-7A13-447F-A78A-B8BD8CCA5AA2}"/>
+              </a:ext>
+            </a:extLst>
+          </p:cNvPr>
+          <p:cNvSpPr>
+            <a:spLocks xmlns:a="http://schemas.openxmlformats.org/drawingml/2006/main" noGrp="1"/>
+          </p:cNvSpPr>
+          <p:nvPr/>
+        </p:nvSpPr>
+        <p:spPr>
+          <a:xfrm xmlns:a="http://schemas.openxmlformats.org/drawingml/2006/main">
+            <a:off x="990600" y="2600325"/>
+            <a:ext cx="571500" cy="457200"/>
+          </a:xfrm>
+          <a:prstGeom xmlns:a="http://schemas.openxmlformats.org/drawingml/2006/main" prst="rect">
+            <a:avLst/>
+          </a:prstGeom>
+          <a:noFill xmlns:a="http://schemas.openxmlformats.org/drawingml/2006/main"/>
+          <a:ln xmlns:a="http://schemas.openxmlformats.org/drawingml/2006/main" w="0">
+            <a:noFill/>
+          </a:ln>
+        </p:spPr>
+        <p:txBody>
+          <a:bodyPr xmlns:a="http://schemas.openxmlformats.org/drawingml/2006/main">
+            <a:noAutofit/>
+          </a:bodyPr>
+          <a:lstStyle xmlns:a="http://schemas.openxmlformats.org/drawingml/2006/main">
+            <a:defPPr>
+              <a:defRPr sz="2400" b="1">
+                <a:solidFill>
+                  <a:srgbClr val="007D7B"/>
+                </a:solidFill>
+                <a:latin typeface="Helvetica Neue"/>
+                <a:ea typeface="Helvetica Neue"/>
+                <a:cs typeface="Helvetica Neue"/>
+              </a:defRPr>
+            </a:defPPr>
+          </a:lstStyle>
+          <a:p xmlns:a="http://schemas.openxmlformats.org/drawingml/2006/main">
+            <a:pPr>
+              <a:defRPr sz="2400" b="1">
+                <a:solidFill>
+                  <a:srgbClr val="007D7B"/>
+                </a:solidFill>
+                <a:latin typeface="Helvetica Neue"/>
+                <a:ea typeface="Helvetica Neue"/>
+                <a:cs typeface="Helvetica Neue"/>
+              </a:defRPr>
+            </a:pPr>
+            <a:r>
+              <a:rPr sz="2400" b="1">
+                <a:solidFill>
+                  <a:srgbClr val="007D7B"/>
+                </a:solidFill>
+                <a:latin typeface="Helvetica Neue"/>
+                <a:ea typeface="Helvetica Neue"/>
+                <a:cs typeface="Helvetica Neue"/>
+              </a:rPr>
+              <a:t>2.</a:t>
+            </a:r>
+          </a:p>
+        </p:txBody>
+      </p:sp>
+      <p:sp>
+        <p:nvSpPr>
+          <p:cNvPr id="8" name="Agent und Merkmale">
+            <a:extLst xmlns:a="http://schemas.openxmlformats.org/drawingml/2006/main">
+              <a:ext uri="{FF2B5EF4-FFF2-40B4-BE49-F238E27FC236}">
+                <a16:creationId xmlns:a16="http://schemas.microsoft.com/office/drawing/2014/main" id="{02D31940-4101-4615-A933-96D81F92AFAC}"/>
+              </a:ext>
+            </a:extLst>
+          </p:cNvPr>
+          <p:cNvSpPr>
+            <a:spLocks xmlns:a="http://schemas.openxmlformats.org/drawingml/2006/main" noGrp="1"/>
+          </p:cNvSpPr>
+          <p:nvPr/>
+        </p:nvSpPr>
+        <p:spPr>
+          <a:xfrm xmlns:a="http://schemas.openxmlformats.org/drawingml/2006/main">
+            <a:off x="1752600" y="2600325"/>
+            <a:ext cx="9429750" cy="457200"/>
+          </a:xfrm>
+          <a:prstGeom xmlns:a="http://schemas.openxmlformats.org/drawingml/2006/main" prst="rect">
+            <a:avLst/>
+          </a:prstGeom>
+          <a:noFill xmlns:a="http://schemas.openxmlformats.org/drawingml/2006/main"/>
+          <a:ln xmlns:a="http://schemas.openxmlformats.org/drawingml/2006/main" w="0">
+            <a:noFill/>
+          </a:ln>
+        </p:spPr>
+        <p:txBody>
+          <a:bodyPr xmlns:a="http://schemas.openxmlformats.org/drawingml/2006/main">
+            <a:noAutofit/>
+          </a:bodyPr>
+          <a:lstStyle xmlns:a="http://schemas.openxmlformats.org/drawingml/2006/main">
+            <a:defPPr>
+              <a:defRPr sz="2400" b="0">
+                <a:solidFill>
+                  <a:srgbClr val="102D35"/>
+                </a:solidFill>
+                <a:latin typeface="Helvetica Neue"/>
+                <a:ea typeface="Helvetica Neue"/>
+                <a:cs typeface="Helvetica Neue"/>
+              </a:defRPr>
+            </a:defPPr>
+          </a:lstStyle>
+          <a:p xmlns:a="http://schemas.openxmlformats.org/drawingml/2006/main">
+            <a:pPr>
+              <a:defRPr sz="2400" b="0">
+                <a:solidFill>
+                  <a:srgbClr val="102D35"/>
+                </a:solidFill>
+                <a:latin typeface="Helvetica Neue"/>
+                <a:ea typeface="Helvetica Neue"/>
+                <a:cs typeface="Helvetica Neue"/>
+              </a:defRPr>
+            </a:pPr>
+            <a:r>
+              <a:rPr sz="2400" b="0">
+                <a:solidFill>
+                  <a:srgbClr val="102D35"/>
+                </a:solidFill>
+                <a:latin typeface="Helvetica Neue"/>
+                <a:ea typeface="Helvetica Neue"/>
+                <a:cs typeface="Helvetica Neue"/>
+              </a:rPr>
+              <a:t>Agent und Merkmale</a:t>
+            </a:r>
+          </a:p>
+        </p:txBody>
+      </p:sp>
+      <p:sp>
+        <p:nvSpPr>
+          <p:cNvPr id="9" name="3.">
+            <a:extLst xmlns:a="http://schemas.openxmlformats.org/drawingml/2006/main">
+              <a:ext uri="{FF2B5EF4-FFF2-40B4-BE49-F238E27FC236}">
+                <a16:creationId xmlns:a16="http://schemas.microsoft.com/office/drawing/2014/main" id="{6980250E-EDA0-400F-89D6-73761753468F}"/>
+              </a:ext>
+            </a:extLst>
+          </p:cNvPr>
+          <p:cNvSpPr>
+            <a:spLocks xmlns:a="http://schemas.openxmlformats.org/drawingml/2006/main" noGrp="1"/>
+          </p:cNvSpPr>
+          <p:nvPr/>
+        </p:nvSpPr>
+        <p:spPr>
+          <a:xfrm xmlns:a="http://schemas.openxmlformats.org/drawingml/2006/main">
+            <a:off x="990600" y="3257550"/>
+            <a:ext cx="571500" cy="457200"/>
+          </a:xfrm>
+          <a:prstGeom xmlns:a="http://schemas.openxmlformats.org/drawingml/2006/main" prst="rect">
+            <a:avLst/>
+          </a:prstGeom>
+          <a:noFill xmlns:a="http://schemas.openxmlformats.org/drawingml/2006/main"/>
+          <a:ln xmlns:a="http://schemas.openxmlformats.org/drawingml/2006/main" w="0">
+            <a:noFill/>
+          </a:ln>
+        </p:spPr>
+        <p:txBody>
+          <a:bodyPr xmlns:a="http://schemas.openxmlformats.org/drawingml/2006/main">
+            <a:noAutofit/>
+          </a:bodyPr>
+          <a:lstStyle xmlns:a="http://schemas.openxmlformats.org/drawingml/2006/main">
+            <a:defPPr>
+              <a:defRPr sz="2400" b="1">
+                <a:solidFill>
+                  <a:srgbClr val="007D7B"/>
+                </a:solidFill>
+                <a:latin typeface="Helvetica Neue"/>
+                <a:ea typeface="Helvetica Neue"/>
+                <a:cs typeface="Helvetica Neue"/>
+              </a:defRPr>
+            </a:defPPr>
+          </a:lstStyle>
+          <a:p xmlns:a="http://schemas.openxmlformats.org/drawingml/2006/main">
+            <a:pPr>
+              <a:defRPr sz="2400" b="1">
+                <a:solidFill>
+                  <a:srgbClr val="007D7B"/>
+                </a:solidFill>
+                <a:latin typeface="Helvetica Neue"/>
+                <a:ea typeface="Helvetica Neue"/>
+                <a:cs typeface="Helvetica Neue"/>
+              </a:defRPr>
+            </a:pPr>
+            <a:r>
+              <a:rPr sz="2400" b="1">
+                <a:solidFill>
+                  <a:srgbClr val="007D7B"/>
+                </a:solidFill>
+                <a:latin typeface="Helvetica Neue"/>
+                <a:ea typeface="Helvetica Neue"/>
+                <a:cs typeface="Helvetica Neue"/>
+              </a:rPr>
+              <a:t>3.</a:t>
+            </a:r>
+          </a:p>
+        </p:txBody>
+      </p:sp>
+      <p:sp>
+        <p:nvSpPr>
+          <p:cNvPr id="10" name="Netzarchitektur und Lernverfahren">
+            <a:extLst xmlns:a="http://schemas.openxmlformats.org/drawingml/2006/main">
+              <a:ext uri="{FF2B5EF4-FFF2-40B4-BE49-F238E27FC236}">
+                <a16:creationId xmlns:a16="http://schemas.microsoft.com/office/drawing/2014/main" id="{567F9081-5523-44FC-BC71-20351ADBAA0B}"/>
+              </a:ext>
+            </a:extLst>
+          </p:cNvPr>
+          <p:cNvSpPr>
+            <a:spLocks xmlns:a="http://schemas.openxmlformats.org/drawingml/2006/main" noGrp="1"/>
+          </p:cNvSpPr>
+          <p:nvPr/>
+        </p:nvSpPr>
+        <p:spPr>
+          <a:xfrm xmlns:a="http://schemas.openxmlformats.org/drawingml/2006/main">
+            <a:off x="1752600" y="3257550"/>
+            <a:ext cx="9429750" cy="457200"/>
+          </a:xfrm>
+          <a:prstGeom xmlns:a="http://schemas.openxmlformats.org/drawingml/2006/main" prst="rect">
+            <a:avLst/>
+          </a:prstGeom>
+          <a:noFill xmlns:a="http://schemas.openxmlformats.org/drawingml/2006/main"/>
+          <a:ln xmlns:a="http://schemas.openxmlformats.org/drawingml/2006/main" w="0">
+            <a:noFill/>
+          </a:ln>
+        </p:spPr>
+        <p:txBody>
+          <a:bodyPr xmlns:a="http://schemas.openxmlformats.org/drawingml/2006/main">
+            <a:noAutofit/>
+          </a:bodyPr>
+          <a:lstStyle xmlns:a="http://schemas.openxmlformats.org/drawingml/2006/main">
+            <a:defPPr>
+              <a:defRPr sz="2400" b="0">
+                <a:solidFill>
+                  <a:srgbClr val="102D35"/>
+                </a:solidFill>
+                <a:latin typeface="Helvetica Neue"/>
+                <a:ea typeface="Helvetica Neue"/>
+                <a:cs typeface="Helvetica Neue"/>
+              </a:defRPr>
+            </a:defPPr>
+          </a:lstStyle>
+          <a:p xmlns:a="http://schemas.openxmlformats.org/drawingml/2006/main">
+            <a:pPr>
+              <a:defRPr sz="2400" b="0">
+                <a:solidFill>
+                  <a:srgbClr val="102D35"/>
+                </a:solidFill>
+                <a:latin typeface="Helvetica Neue"/>
+                <a:ea typeface="Helvetica Neue"/>
+                <a:cs typeface="Helvetica Neue"/>
+              </a:defRPr>
+            </a:pPr>
+            <a:r>
+              <a:rPr sz="2400" b="0">
+                <a:solidFill>
+                  <a:srgbClr val="102D35"/>
+                </a:solidFill>
+                <a:latin typeface="Helvetica Neue"/>
+                <a:ea typeface="Helvetica Neue"/>
+                <a:cs typeface="Helvetica Neue"/>
+              </a:rPr>
+              <a:t>Netzarchitektur und Lernverfahren</a:t>
+            </a:r>
+          </a:p>
+        </p:txBody>
+      </p:sp>
+      <p:sp>
+        <p:nvSpPr>
+          <p:cNvPr id="11" name="4.">
+            <a:extLst xmlns:a="http://schemas.openxmlformats.org/drawingml/2006/main">
+              <a:ext uri="{FF2B5EF4-FFF2-40B4-BE49-F238E27FC236}">
+                <a16:creationId xmlns:a16="http://schemas.microsoft.com/office/drawing/2014/main" id="{2D96320F-FFE4-4880-9A93-DF660873DCCD}"/>
+              </a:ext>
+            </a:extLst>
+          </p:cNvPr>
+          <p:cNvSpPr>
+            <a:spLocks xmlns:a="http://schemas.openxmlformats.org/drawingml/2006/main" noGrp="1"/>
+          </p:cNvSpPr>
+          <p:nvPr/>
+        </p:nvSpPr>
+        <p:spPr>
+          <a:xfrm xmlns:a="http://schemas.openxmlformats.org/drawingml/2006/main">
+            <a:off x="990600" y="3914775"/>
+            <a:ext cx="571500" cy="457200"/>
+          </a:xfrm>
+          <a:prstGeom xmlns:a="http://schemas.openxmlformats.org/drawingml/2006/main" prst="rect">
+            <a:avLst/>
+          </a:prstGeom>
+          <a:noFill xmlns:a="http://schemas.openxmlformats.org/drawingml/2006/main"/>
+          <a:ln xmlns:a="http://schemas.openxmlformats.org/drawingml/2006/main" w="0">
+            <a:noFill/>
+          </a:ln>
+        </p:spPr>
+        <p:txBody>
+          <a:bodyPr xmlns:a="http://schemas.openxmlformats.org/drawingml/2006/main">
+            <a:noAutofit/>
+          </a:bodyPr>
+          <a:lstStyle xmlns:a="http://schemas.openxmlformats.org/drawingml/2006/main">
+            <a:defPPr>
+              <a:defRPr sz="2400" b="1">
+                <a:solidFill>
+                  <a:srgbClr val="007D7B"/>
+                </a:solidFill>
+                <a:latin typeface="Helvetica Neue"/>
+                <a:ea typeface="Helvetica Neue"/>
+                <a:cs typeface="Helvetica Neue"/>
+              </a:defRPr>
+            </a:defPPr>
+          </a:lstStyle>
+          <a:p xmlns:a="http://schemas.openxmlformats.org/drawingml/2006/main">
+            <a:pPr>
+              <a:defRPr sz="2400" b="1">
+                <a:solidFill>
+                  <a:srgbClr val="007D7B"/>
+                </a:solidFill>
+                <a:latin typeface="Helvetica Neue"/>
+                <a:ea typeface="Helvetica Neue"/>
+                <a:cs typeface="Helvetica Neue"/>
+              </a:defRPr>
+            </a:pPr>
+            <a:r>
+              <a:rPr sz="2400" b="1">
+                <a:solidFill>
+                  <a:srgbClr val="007D7B"/>
+                </a:solidFill>
+                <a:latin typeface="Helvetica Neue"/>
+                <a:ea typeface="Helvetica Neue"/>
+                <a:cs typeface="Helvetica Neue"/>
+              </a:rPr>
+              <a:t>4.</a:t>
+            </a:r>
+          </a:p>
+        </p:txBody>
+      </p:sp>
+      <p:sp>
+        <p:nvSpPr>
+          <p:cNvPr id="12" name="Training und Auswertung">
+            <a:extLst xmlns:a="http://schemas.openxmlformats.org/drawingml/2006/main">
+              <a:ext uri="{FF2B5EF4-FFF2-40B4-BE49-F238E27FC236}">
+                <a16:creationId xmlns:a16="http://schemas.microsoft.com/office/drawing/2014/main" id="{D64CA8EA-DF54-4D54-8D1C-3EAA1E37236B}"/>
+              </a:ext>
+            </a:extLst>
+          </p:cNvPr>
+          <p:cNvSpPr>
+            <a:spLocks xmlns:a="http://schemas.openxmlformats.org/drawingml/2006/main" noGrp="1"/>
+          </p:cNvSpPr>
+          <p:nvPr/>
+        </p:nvSpPr>
+        <p:spPr>
+          <a:xfrm xmlns:a="http://schemas.openxmlformats.org/drawingml/2006/main">
+            <a:off x="1752600" y="3914775"/>
+            <a:ext cx="9429750" cy="457200"/>
+          </a:xfrm>
+          <a:prstGeom xmlns:a="http://schemas.openxmlformats.org/drawingml/2006/main" prst="rect">
+            <a:avLst/>
+          </a:prstGeom>
+          <a:noFill xmlns:a="http://schemas.openxmlformats.org/drawingml/2006/main"/>
+          <a:ln xmlns:a="http://schemas.openxmlformats.org/drawingml/2006/main" w="0">
+            <a:noFill/>
+          </a:ln>
+        </p:spPr>
+        <p:txBody>
+          <a:bodyPr xmlns:a="http://schemas.openxmlformats.org/drawingml/2006/main">
+            <a:noAutofit/>
+          </a:bodyPr>
+          <a:lstStyle xmlns:a="http://schemas.openxmlformats.org/drawingml/2006/main">
+            <a:defPPr>
+              <a:defRPr sz="2400" b="0">
+                <a:solidFill>
+                  <a:srgbClr val="102D35"/>
+                </a:solidFill>
+                <a:latin typeface="Helvetica Neue"/>
+                <a:ea typeface="Helvetica Neue"/>
+                <a:cs typeface="Helvetica Neue"/>
+              </a:defRPr>
+            </a:defPPr>
+          </a:lstStyle>
+          <a:p xmlns:a="http://schemas.openxmlformats.org/drawingml/2006/main">
+            <a:pPr>
+              <a:defRPr sz="2400" b="0">
+                <a:solidFill>
+                  <a:srgbClr val="102D35"/>
+                </a:solidFill>
+                <a:latin typeface="Helvetica Neue"/>
+                <a:ea typeface="Helvetica Neue"/>
+                <a:cs typeface="Helvetica Neue"/>
+              </a:defRPr>
+            </a:pPr>
+            <a:r>
+              <a:rPr sz="2400" b="0">
+                <a:solidFill>
+                  <a:srgbClr val="102D35"/>
+                </a:solidFill>
+                <a:latin typeface="Helvetica Neue"/>
+                <a:ea typeface="Helvetica Neue"/>
+                <a:cs typeface="Helvetica Neue"/>
+              </a:rPr>
+              <a:t>Training und Auswertung</a:t>
+            </a:r>
+          </a:p>
+        </p:txBody>
+      </p:sp>
+      <p:sp>
+        <p:nvSpPr>
+          <p:cNvPr id="13" name="5.">
+            <a:extLst xmlns:a="http://schemas.openxmlformats.org/drawingml/2006/main">
+              <a:ext uri="{FF2B5EF4-FFF2-40B4-BE49-F238E27FC236}">
+                <a16:creationId xmlns:a16="http://schemas.microsoft.com/office/drawing/2014/main" id="{F5266D6F-72D7-46E0-ADD8-B3D95FF6B80C}"/>
+              </a:ext>
+            </a:extLst>
+          </p:cNvPr>
+          <p:cNvSpPr>
+            <a:spLocks xmlns:a="http://schemas.openxmlformats.org/drawingml/2006/main" noGrp="1"/>
+          </p:cNvSpPr>
+          <p:nvPr/>
+        </p:nvSpPr>
+        <p:spPr>
+          <a:xfrm xmlns:a="http://schemas.openxmlformats.org/drawingml/2006/main">
+            <a:off x="990600" y="4572000"/>
+            <a:ext cx="571500" cy="457200"/>
+          </a:xfrm>
+          <a:prstGeom xmlns:a="http://schemas.openxmlformats.org/drawingml/2006/main" prst="rect">
+            <a:avLst/>
+          </a:prstGeom>
+          <a:noFill xmlns:a="http://schemas.openxmlformats.org/drawingml/2006/main"/>
+          <a:ln xmlns:a="http://schemas.openxmlformats.org/drawingml/2006/main" w="0">
+            <a:noFill/>
+          </a:ln>
+        </p:spPr>
+        <p:txBody>
+          <a:bodyPr xmlns:a="http://schemas.openxmlformats.org/drawingml/2006/main">
+            <a:noAutofit/>
+          </a:bodyPr>
+          <a:lstStyle xmlns:a="http://schemas.openxmlformats.org/drawingml/2006/main">
+            <a:defPPr>
+              <a:defRPr sz="2400" b="1">
+                <a:solidFill>
+                  <a:srgbClr val="007D7B"/>
+                </a:solidFill>
+                <a:latin typeface="Helvetica Neue"/>
+                <a:ea typeface="Helvetica Neue"/>
+                <a:cs typeface="Helvetica Neue"/>
+              </a:defRPr>
+            </a:defPPr>
+          </a:lstStyle>
+          <a:p xmlns:a="http://schemas.openxmlformats.org/drawingml/2006/main">
+            <a:pPr>
+              <a:defRPr sz="2400" b="1">
+                <a:solidFill>
+                  <a:srgbClr val="007D7B"/>
+                </a:solidFill>
+                <a:latin typeface="Helvetica Neue"/>
+                <a:ea typeface="Helvetica Neue"/>
+                <a:cs typeface="Helvetica Neue"/>
+              </a:defRPr>
+            </a:pPr>
+            <a:r>
+              <a:rPr sz="2400" b="1">
+                <a:solidFill>
+                  <a:srgbClr val="007D7B"/>
+                </a:solidFill>
+                <a:latin typeface="Helvetica Neue"/>
+                <a:ea typeface="Helvetica Neue"/>
+                <a:cs typeface="Helvetica Neue"/>
+              </a:rPr>
+              <a:t>5.</a:t>
+            </a:r>
+          </a:p>
+        </p:txBody>
+      </p:sp>
+      <p:sp>
+        <p:nvSpPr>
+          <p:cNvPr id="14" name="Ergebnisse und Spielbeispiel">
+            <a:extLst xmlns:a="http://schemas.openxmlformats.org/drawingml/2006/main">
+              <a:ext uri="{FF2B5EF4-FFF2-40B4-BE49-F238E27FC236}">
+                <a16:creationId xmlns:a16="http://schemas.microsoft.com/office/drawing/2014/main" id="{6D651846-F33A-4681-88BB-FCDD9C4E8809}"/>
+              </a:ext>
+            </a:extLst>
+          </p:cNvPr>
+          <p:cNvSpPr>
+            <a:spLocks xmlns:a="http://schemas.openxmlformats.org/drawingml/2006/main" noGrp="1"/>
+          </p:cNvSpPr>
+          <p:nvPr/>
+        </p:nvSpPr>
+        <p:spPr>
+          <a:xfrm xmlns:a="http://schemas.openxmlformats.org/drawingml/2006/main">
+            <a:off x="1752600" y="4572000"/>
+            <a:ext cx="9429750" cy="457200"/>
+          </a:xfrm>
+          <a:prstGeom xmlns:a="http://schemas.openxmlformats.org/drawingml/2006/main" prst="rect">
+            <a:avLst/>
+          </a:prstGeom>
+          <a:noFill xmlns:a="http://schemas.openxmlformats.org/drawingml/2006/main"/>
+          <a:ln xmlns:a="http://schemas.openxmlformats.org/drawingml/2006/main" w="0">
+            <a:noFill/>
+          </a:ln>
+        </p:spPr>
+        <p:txBody>
+          <a:bodyPr xmlns:a="http://schemas.openxmlformats.org/drawingml/2006/main">
+            <a:noAutofit/>
+          </a:bodyPr>
+          <a:lstStyle xmlns:a="http://schemas.openxmlformats.org/drawingml/2006/main">
+            <a:defPPr>
+              <a:defRPr sz="2400" b="0">
+                <a:solidFill>
+                  <a:srgbClr val="102D35"/>
+                </a:solidFill>
+                <a:latin typeface="Helvetica Neue"/>
+                <a:ea typeface="Helvetica Neue"/>
+                <a:cs typeface="Helvetica Neue"/>
+              </a:defRPr>
+            </a:defPPr>
+          </a:lstStyle>
+          <a:p xmlns:a="http://schemas.openxmlformats.org/drawingml/2006/main">
+            <a:pPr>
+              <a:defRPr sz="2400" b="0">
+                <a:solidFill>
+                  <a:srgbClr val="102D35"/>
+                </a:solidFill>
+                <a:latin typeface="Helvetica Neue"/>
+                <a:ea typeface="Helvetica Neue"/>
+                <a:cs typeface="Helvetica Neue"/>
+              </a:defRPr>
+            </a:pPr>
+            <a:r>
+              <a:rPr sz="2400" b="0">
+                <a:solidFill>
+                  <a:srgbClr val="102D35"/>
+                </a:solidFill>
+                <a:latin typeface="Helvetica Neue"/>
+                <a:ea typeface="Helvetica Neue"/>
+                <a:cs typeface="Helvetica Neue"/>
+              </a:rPr>
+              <a:t>Ergebnisse und Spielbeispiel</a:t>
+            </a:r>
+          </a:p>
+        </p:txBody>
+      </p:sp>
+      <p:sp>
+        <p:nvSpPr>
+          <p:cNvPr id="15" name="6.">
+            <a:extLst xmlns:a="http://schemas.openxmlformats.org/drawingml/2006/main">
+              <a:ext uri="{FF2B5EF4-FFF2-40B4-BE49-F238E27FC236}">
+                <a16:creationId xmlns:a16="http://schemas.microsoft.com/office/drawing/2014/main" id="{EE11B27D-EC8F-45BF-AB4A-95F95A4FAAC3}"/>
+              </a:ext>
+            </a:extLst>
+          </p:cNvPr>
+          <p:cNvSpPr>
+            <a:spLocks xmlns:a="http://schemas.openxmlformats.org/drawingml/2006/main" noGrp="1"/>
+          </p:cNvSpPr>
+          <p:nvPr/>
+        </p:nvSpPr>
+        <p:spPr>
+          <a:xfrm xmlns:a="http://schemas.openxmlformats.org/drawingml/2006/main">
+            <a:off x="990600" y="5229225"/>
+            <a:ext cx="571500" cy="457200"/>
+          </a:xfrm>
+          <a:prstGeom xmlns:a="http://schemas.openxmlformats.org/drawingml/2006/main" prst="rect">
+            <a:avLst/>
+          </a:prstGeom>
+          <a:noFill xmlns:a="http://schemas.openxmlformats.org/drawingml/2006/main"/>
+          <a:ln xmlns:a="http://schemas.openxmlformats.org/drawingml/2006/main" w="0">
+            <a:noFill/>
+          </a:ln>
+        </p:spPr>
+        <p:txBody>
+          <a:bodyPr xmlns:a="http://schemas.openxmlformats.org/drawingml/2006/main">
+            <a:noAutofit/>
+          </a:bodyPr>
+          <a:lstStyle xmlns:a="http://schemas.openxmlformats.org/drawingml/2006/main">
+            <a:defPPr>
+              <a:defRPr sz="2400" b="1">
+                <a:solidFill>
+                  <a:srgbClr val="007D7B"/>
+                </a:solidFill>
+                <a:latin typeface="Helvetica Neue"/>
+                <a:ea typeface="Helvetica Neue"/>
+                <a:cs typeface="Helvetica Neue"/>
+              </a:defRPr>
+            </a:defPPr>
+          </a:lstStyle>
+          <a:p xmlns:a="http://schemas.openxmlformats.org/drawingml/2006/main">
+            <a:pPr>
+              <a:defRPr sz="2400" b="1">
+                <a:solidFill>
+                  <a:srgbClr val="007D7B"/>
+                </a:solidFill>
+                <a:latin typeface="Helvetica Neue"/>
+                <a:ea typeface="Helvetica Neue"/>
+                <a:cs typeface="Helvetica Neue"/>
+              </a:defRPr>
+            </a:pPr>
+            <a:r>
+              <a:rPr sz="2400" b="1">
+                <a:solidFill>
+                  <a:srgbClr val="007D7B"/>
+                </a:solidFill>
+                <a:latin typeface="Helvetica Neue"/>
+                <a:ea typeface="Helvetica Neue"/>
+                <a:cs typeface="Helvetica Neue"/>
+              </a:rPr>
+              <a:t>6.</a:t>
+            </a:r>
+          </a:p>
+        </p:txBody>
+      </p:sp>
+      <p:sp>
+        <p:nvSpPr>
+          <p:cNvPr id="16" name="Erkenntnisse und Ausblick">
+            <a:extLst xmlns:a="http://schemas.openxmlformats.org/drawingml/2006/main">
+              <a:ext uri="{FF2B5EF4-FFF2-40B4-BE49-F238E27FC236}">
+                <a16:creationId xmlns:a16="http://schemas.microsoft.com/office/drawing/2014/main" id="{880088CE-1090-413E-AB50-E11D5F22B4BA}"/>
+              </a:ext>
+            </a:extLst>
+          </p:cNvPr>
+          <p:cNvSpPr>
+            <a:spLocks xmlns:a="http://schemas.openxmlformats.org/drawingml/2006/main" noGrp="1"/>
+          </p:cNvSpPr>
+          <p:nvPr/>
+        </p:nvSpPr>
+        <p:spPr>
+          <a:xfrm xmlns:a="http://schemas.openxmlformats.org/drawingml/2006/main">
+            <a:off x="1752600" y="5229225"/>
+            <a:ext cx="9429750" cy="457200"/>
+          </a:xfrm>
+          <a:prstGeom xmlns:a="http://schemas.openxmlformats.org/drawingml/2006/main" prst="rect">
+            <a:avLst/>
+          </a:prstGeom>
+          <a:noFill xmlns:a="http://schemas.openxmlformats.org/drawingml/2006/main"/>
+          <a:ln xmlns:a="http://schemas.openxmlformats.org/drawingml/2006/main" w="0">
+            <a:noFill/>
+          </a:ln>
+        </p:spPr>
+        <p:txBody>
+          <a:bodyPr xmlns:a="http://schemas.openxmlformats.org/drawingml/2006/main">
+            <a:noAutofit/>
+          </a:bodyPr>
+          <a:lstStyle xmlns:a="http://schemas.openxmlformats.org/drawingml/2006/main">
+            <a:defPPr>
+              <a:defRPr sz="2400" b="0">
+                <a:solidFill>
+                  <a:srgbClr val="102D35"/>
+                </a:solidFill>
+                <a:latin typeface="Helvetica Neue"/>
+                <a:ea typeface="Helvetica Neue"/>
+                <a:cs typeface="Helvetica Neue"/>
+              </a:defRPr>
+            </a:defPPr>
+          </a:lstStyle>
+          <a:p xmlns:a="http://schemas.openxmlformats.org/drawingml/2006/main">
+            <a:pPr>
+              <a:defRPr sz="2400" b="0">
+                <a:solidFill>
+                  <a:srgbClr val="102D35"/>
+                </a:solidFill>
+                <a:latin typeface="Helvetica Neue"/>
+                <a:ea typeface="Helvetica Neue"/>
+                <a:cs typeface="Helvetica Neue"/>
+              </a:defRPr>
+            </a:pPr>
+            <a:r>
+              <a:rPr sz="2400" b="0">
+                <a:solidFill>
+                  <a:srgbClr val="102D35"/>
+                </a:solidFill>
+                <a:latin typeface="Helvetica Neue"/>
+                <a:ea typeface="Helvetica Neue"/>
+                <a:cs typeface="Helvetica Neue"/>
+              </a:rPr>
+              <a:t>Erkenntnisse und Ausblick</a:t>
+            </a:r>
+          </a:p>
+        </p:txBody>
+      </p:sp>
+    </p:spTree>
+    <p:extLst>
+      <p:ext uri="{BB962C8B-B14F-4D97-AF65-F5344CB8AC3E}">
+        <p14:creationId xmlns:p14="http://schemas.microsoft.com/office/powerpoint/2010/main" val="1632561184"/>
+      </p:ext>
+    </p:extLst>
+  </p:cSld>
+</p:sld>
+</file>
+
+<file path=ppt/slides/slide3.xml><?xml version="1.0" encoding="utf-8"?>
 <p:sld xmlns:a="http://schemas.openxmlformats.org/drawingml/2006/main" xmlns:ns2="http://schemas.microsoft.com/office/drawing/2014/main" xmlns:ns4="http://schemas.microsoft.com/office/powerpoint/2010/main" xmlns:p="http://schemas.openxmlformats.org/presentationml/2006/main" xmlns:r="http://schemas.openxmlformats.org/officeDocument/2006/relationships">
   <p:cSld>
     <p:bg>
@@ -8029,7 +10010,7 @@
                 <a:ea typeface="Helvetica Neue"/>
                 <a:cs typeface="Helvetica Neue"/>
               </a:rPr>
-              <a:t>02</a:t>
+              <a:t>03</a:t>
             </a:r>
           </a:p>
         </p:txBody>
@@ -8375,7 +10356,7 @@
 </p:sld>
 </file>
 
-<file path=ppt/slides/slide3.xml><?xml version="1.0" encoding="utf-8"?>
+<file path=ppt/slides/slide4.xml><?xml version="1.0" encoding="utf-8"?>
 <p:sld xmlns:a="http://schemas.openxmlformats.org/drawingml/2006/main" xmlns:ns2="http://schemas.microsoft.com/office/drawing/2014/main" xmlns:ns3="http://schemas.microsoft.com/office/powerpoint/2010/main" xmlns:p="http://schemas.openxmlformats.org/presentationml/2006/main">
   <p:cSld>
     <p:bg>
@@ -8654,7 +10635,7 @@
                 <a:ea typeface="Helvetica Neue"/>
                 <a:cs typeface="Helvetica Neue"/>
               </a:rPr>
-              <a:t>03</a:t>
+              <a:t>04</a:t>
             </a:r>
           </a:p>
         </p:txBody>
@@ -9860,7 +11841,7 @@
 </p:sld>
 </file>
 
-<file path=ppt/slides/slide4.xml><?xml version="1.0" encoding="utf-8"?>
+<file path=ppt/slides/slide5.xml><?xml version="1.0" encoding="utf-8"?>
 <p:sld xmlns:a="http://schemas.openxmlformats.org/drawingml/2006/main" xmlns:ns2="http://schemas.microsoft.com/office/drawing/2014/main" xmlns:ns3="http://schemas.microsoft.com/office/powerpoint/2010/main" xmlns:p="http://schemas.openxmlformats.org/presentationml/2006/main">
   <p:cSld>
     <p:bg>
@@ -10139,7 +12120,7 @@
                 <a:ea typeface="Helvetica Neue"/>
                 <a:cs typeface="Helvetica Neue"/>
               </a:rPr>
-              <a:t>04</a:t>
+              <a:t>05</a:t>
             </a:r>
           </a:p>
         </p:txBody>
@@ -10660,7 +12641,7 @@
 </p:sld>
 </file>
 
-<file path=ppt/slides/slide5.xml><?xml version="1.0" encoding="utf-8"?>
+<file path=ppt/slides/slide6.xml><?xml version="1.0" encoding="utf-8"?>
 <p:sld xmlns:a="http://schemas.openxmlformats.org/drawingml/2006/main" xmlns:ns2="http://schemas.microsoft.com/office/drawing/2014/main" xmlns:ns3="http://schemas.microsoft.com/office/powerpoint/2010/main" xmlns:p="http://schemas.openxmlformats.org/presentationml/2006/main">
   <p:cSld>
     <p:bg>
@@ -10939,7 +12920,7 @@
                 <a:ea typeface="Helvetica Neue"/>
                 <a:cs typeface="Helvetica Neue"/>
               </a:rPr>
-              <a:t>05</a:t>
+              <a:t>06</a:t>
             </a:r>
           </a:p>
         </p:txBody>
@@ -11547,7 +13528,7 @@
 </p:sld>
 </file>
 
-<file path=ppt/slides/slide6.xml><?xml version="1.0" encoding="utf-8"?>
+<file path=ppt/slides/slide7.xml><?xml version="1.0" encoding="utf-8"?>
 <p:sld xmlns:a="http://schemas.openxmlformats.org/drawingml/2006/main" xmlns:ns2="http://schemas.microsoft.com/office/drawing/2014/main" xmlns:ns3="http://schemas.microsoft.com/office/powerpoint/2010/main" xmlns:p="http://schemas.openxmlformats.org/presentationml/2006/main">
   <p:cSld>
     <p:bg>
@@ -11826,7 +13807,7 @@
                 <a:ea typeface="Helvetica Neue"/>
                 <a:cs typeface="Helvetica Neue"/>
               </a:rPr>
-              <a:t>06</a:t>
+              <a:t>07</a:t>
             </a:r>
           </a:p>
         </p:txBody>
@@ -13100,7 +15081,7 @@
 </p:sld>
 </file>
 
-<file path=ppt/slides/slide7.xml><?xml version="1.0" encoding="utf-8"?>
+<file path=ppt/slides/slide8.xml><?xml version="1.0" encoding="utf-8"?>
 <p:sld xmlns:a="http://schemas.openxmlformats.org/drawingml/2006/main" xmlns:ns2="http://schemas.microsoft.com/office/drawing/2014/main" xmlns:ns3="http://schemas.microsoft.com/office/powerpoint/2010/main" xmlns:p="http://schemas.openxmlformats.org/presentationml/2006/main">
   <p:cSld>
     <p:bg>
@@ -13379,7 +15360,7 @@
                 <a:ea typeface="Helvetica Neue"/>
                 <a:cs typeface="Helvetica Neue"/>
               </a:rPr>
-              <a:t>07</a:t>
+              <a:t>08</a:t>
             </a:r>
           </a:p>
         </p:txBody>
@@ -14382,7 +16363,7 @@
 </p:sld>
 </file>
 
-<file path=ppt/slides/slide8.xml><?xml version="1.0" encoding="utf-8"?>
+<file path=ppt/slides/slide9.xml><?xml version="1.0" encoding="utf-8"?>
 <p:sld xmlns:a="http://schemas.openxmlformats.org/drawingml/2006/main" xmlns:ns2="http://schemas.microsoft.com/office/drawing/2014/main" xmlns:ns3="http://schemas.openxmlformats.org/drawingml/2006/chart" xmlns:ns5="http://schemas.microsoft.com/office/powerpoint/2010/main" xmlns:p="http://schemas.openxmlformats.org/presentationml/2006/main" xmlns:r="http://schemas.openxmlformats.org/officeDocument/2006/relationships">
   <p:cSld>
     <p:bg>
@@ -14661,7 +16642,7 @@
                 <a:ea typeface="Helvetica Neue"/>
                 <a:cs typeface="Helvetica Neue"/>
               </a:rPr>
-              <a:t>08</a:t>
+              <a:t>09</a:t>
             </a:r>
           </a:p>
         </p:txBody>
@@ -14913,779 +16894,6 @@
     <p:extLst>
       <p:ext uri="{BB962C8B-B14F-4D97-AF65-F5344CB8AC3E}">
         <ns5:creationId val="1247860106"/>
-      </p:ext>
-    </p:extLst>
-  </p:cSld>
-</p:sld>
-</file>
-
-<file path=ppt/slides/slide9.xml><?xml version="1.0" encoding="utf-8"?>
-<p:sld xmlns:a="http://schemas.openxmlformats.org/drawingml/2006/main" xmlns:ns2="http://schemas.microsoft.com/office/drawing/2014/main" xmlns:ns4="http://schemas.microsoft.com/office/powerpoint/2010/main" xmlns:p="http://schemas.openxmlformats.org/presentationml/2006/main" xmlns:r="http://schemas.openxmlformats.org/officeDocument/2006/relationships">
-  <p:cSld>
-    <p:bg>
-      <p:bgPr>
-        <a:solidFill>
-          <a:srgbClr val="F7F7F0"/>
-        </a:solidFill>
-      </p:bgPr>
-    </p:bg>
-    <p:spTree>
-      <p:nvGrpSpPr>
-        <p:cNvPr id="1" name=""/>
-        <p:cNvGrpSpPr/>
-        <p:nvPr/>
-      </p:nvGrpSpPr>
-      <p:grpSpPr>
-        <a:xfrm/>
-      </p:grpSpPr>
-      <p:sp>
-        <p:nvSpPr>
-          <p:cNvPr id="12" name="SHERLOCK / REVIEW 01">
-            <a:extLst>
-              <a:ext uri="{FF2B5EF4-FFF2-40B4-BE49-F238E27FC236}">
-                <ns2:creationId id="{D649A959-7497-4988-9EFE-00D58627A301}"/>
-              </a:ext>
-            </a:extLst>
-          </p:cNvPr>
-          <p:cNvSpPr>
-            <a:spLocks noGrp="1"/>
-          </p:cNvSpPr>
-          <p:nvPr/>
-        </p:nvSpPr>
-        <p:spPr>
-          <a:xfrm>
-            <a:off x="609600" y="266700"/>
-            <a:ext cx="8572500" cy="304800"/>
-          </a:xfrm>
-          <a:prstGeom prst="rect">
-            <a:avLst/>
-          </a:prstGeom>
-          <a:noFill/>
-          <a:ln w="0">
-            <a:noFill/>
-          </a:ln>
-        </p:spPr>
-        <p:txBody>
-          <a:bodyPr/>
-          <a:lstStyle>
-            <a:defPPr>
-              <a:defRPr sz="1350" b="1">
-                <a:solidFill>
-                  <a:srgbClr val="007D7B"/>
-                </a:solidFill>
-                <a:latin typeface="Helvetica Neue"/>
-                <a:ea typeface="Helvetica Neue"/>
-                <a:cs typeface="Helvetica Neue"/>
-              </a:defRPr>
-            </a:defPPr>
-          </a:lstStyle>
-          <a:p>
-            <a:pPr>
-              <a:defRPr sz="1350" b="1">
-                <a:solidFill>
-                  <a:srgbClr val="007D7B"/>
-                </a:solidFill>
-                <a:latin typeface="Helvetica Neue"/>
-                <a:ea typeface="Helvetica Neue"/>
-                <a:cs typeface="Helvetica Neue"/>
-              </a:defRPr>
-            </a:pPr>
-            <a:r>
-              <a:rPr sz="1350" b="1">
-                <a:solidFill>
-                  <a:srgbClr val="007D7B"/>
-                </a:solidFill>
-                <a:latin typeface="Helvetica Neue"/>
-                <a:ea typeface="Helvetica Neue"/>
-                <a:cs typeface="Helvetica Neue"/>
-              </a:rPr>
-              <a:t>SHERLOCK / REVIEW 01</a:t>
-            </a:r>
-          </a:p>
-        </p:txBody>
-      </p:sp>
-      <p:sp>
-        <p:nvSpPr>
-          <p:cNvPr id="2" name="Ein Spiel: erst verteilen, dann Punktefelder ">
-            <a:extLst>
-              <a:ext uri="{FF2B5EF4-FFF2-40B4-BE49-F238E27FC236}">
-                <ns2:creationId id="{57BEE2ED-FC67-4D2F-B7FA-21C62FDCD0DD}"/>
-              </a:ext>
-            </a:extLst>
-          </p:cNvPr>
-          <p:cNvSpPr>
-            <a:spLocks noGrp="1"/>
-          </p:cNvSpPr>
-          <p:nvPr/>
-        </p:nvSpPr>
-        <p:spPr>
-          <a:xfrm>
-            <a:off x="609600" y="781050"/>
-            <a:ext cx="10972800" cy="1028700"/>
-          </a:xfrm>
-          <a:prstGeom prst="rect">
-            <a:avLst/>
-          </a:prstGeom>
-          <a:noFill/>
-          <a:ln w="0">
-            <a:noFill/>
-          </a:ln>
-        </p:spPr>
-        <p:txBody>
-          <a:bodyPr/>
-          <a:lstStyle>
-            <a:defPPr>
-              <a:defRPr sz="3300" b="1">
-                <a:solidFill>
-                  <a:srgbClr val="102D35"/>
-                </a:solidFill>
-                <a:latin typeface="Helvetica Neue"/>
-                <a:ea typeface="Helvetica Neue"/>
-                <a:cs typeface="Helvetica Neue"/>
-              </a:defRPr>
-            </a:defPPr>
-          </a:lstStyle>
-          <a:p>
-            <a:pPr>
-              <a:buNone/>
-              <a:defRPr sz="3300" b="1">
-                <a:solidFill>
-                  <a:srgbClr val="102D35"/>
-                </a:solidFill>
-                <a:latin typeface="Helvetica Neue"/>
-                <a:ea typeface="Helvetica Neue"/>
-                <a:cs typeface="Helvetica Neue"/>
-              </a:defRPr>
-            </a:pPr>
-            <a:r>
-              <a:rPr sz="3300" b="1">
-                <a:solidFill>
-                  <a:srgbClr val="102D35"/>
-                </a:solidFill>
-                <a:latin typeface="Helvetica Neue"/>
-                <a:ea typeface="Helvetica Neue"/>
-                <a:cs typeface="Helvetica Neue"/>
-              </a:rPr>
-              <a:t>Spielbeispiel</a:t>
-            </a:r>
-          </a:p>
-        </p:txBody>
-      </p:sp>
-      <p:sp>
-        <p:nvSpPr>
-          <p:cNvPr id="3" name="Team 15 · Mahmoud El-Hassan &amp; Moayed Shawesh">
-            <a:extLst>
-              <a:ext uri="{FF2B5EF4-FFF2-40B4-BE49-F238E27FC236}">
-                <ns2:creationId id="{8A6E3A1D-ACC3-4871-9E94-ADE9E4C15B2C}"/>
-              </a:ext>
-            </a:extLst>
-          </p:cNvPr>
-          <p:cNvSpPr>
-            <a:spLocks noGrp="1"/>
-          </p:cNvSpPr>
-          <p:nvPr/>
-        </p:nvSpPr>
-        <p:spPr>
-          <a:xfrm>
-            <a:off x="609600" y="6419850"/>
-            <a:ext cx="9906000" cy="266700"/>
-          </a:xfrm>
-          <a:prstGeom prst="rect">
-            <a:avLst/>
-          </a:prstGeom>
-          <a:noFill/>
-          <a:ln w="0">
-            <a:noFill/>
-          </a:ln>
-        </p:spPr>
-        <p:txBody>
-          <a:bodyPr/>
-          <a:lstStyle>
-            <a:defPPr>
-              <a:defRPr sz="1200" b="0">
-                <a:solidFill>
-                  <a:srgbClr val="526B70"/>
-                </a:solidFill>
-                <a:latin typeface="Helvetica Neue"/>
-                <a:ea typeface="Helvetica Neue"/>
-                <a:cs typeface="Helvetica Neue"/>
-              </a:defRPr>
-            </a:defPPr>
-          </a:lstStyle>
-          <a:p>
-            <a:pPr>
-              <a:defRPr sz="1200" b="0">
-                <a:solidFill>
-                  <a:srgbClr val="526B70"/>
-                </a:solidFill>
-                <a:latin typeface="Helvetica Neue"/>
-                <a:ea typeface="Helvetica Neue"/>
-                <a:cs typeface="Helvetica Neue"/>
-              </a:defRPr>
-            </a:pPr>
-            <a:r>
-              <a:rPr sz="1200" b="0">
-                <a:solidFill>
-                  <a:srgbClr val="526B70"/>
-                </a:solidFill>
-                <a:latin typeface="Helvetica Neue"/>
-                <a:ea typeface="Helvetica Neue"/>
-                <a:cs typeface="Helvetica Neue"/>
-              </a:rPr>
-              <a:t>Team 15 · Mahmoud El-Hassan &amp; Moayed Shawesh</a:t>
-            </a:r>
-          </a:p>
-        </p:txBody>
-      </p:sp>
-      <p:sp>
-        <p:nvSpPr>
-          <p:cNvPr id="4" name="09">
-            <a:extLst>
-              <a:ext uri="{FF2B5EF4-FFF2-40B4-BE49-F238E27FC236}">
-                <ns2:creationId id="{21F839A6-5B12-48CE-9DBD-C3A10D4AA9A9}"/>
-              </a:ext>
-            </a:extLst>
-          </p:cNvPr>
-          <p:cNvSpPr>
-            <a:spLocks noGrp="1"/>
-          </p:cNvSpPr>
-          <p:nvPr/>
-        </p:nvSpPr>
-        <p:spPr>
-          <a:xfrm>
-            <a:off x="11049000" y="6419850"/>
-            <a:ext cx="533400" cy="266700"/>
-          </a:xfrm>
-          <a:prstGeom prst="rect">
-            <a:avLst/>
-          </a:prstGeom>
-          <a:noFill/>
-          <a:ln w="0">
-            <a:noFill/>
-          </a:ln>
-        </p:spPr>
-        <p:txBody>
-          <a:bodyPr/>
-          <a:lstStyle>
-            <a:defPPr>
-              <a:defRPr sz="1200" b="0">
-                <a:solidFill>
-                  <a:srgbClr val="526B70"/>
-                </a:solidFill>
-                <a:latin typeface="Helvetica Neue"/>
-                <a:ea typeface="Helvetica Neue"/>
-                <a:cs typeface="Helvetica Neue"/>
-              </a:defRPr>
-            </a:defPPr>
-          </a:lstStyle>
-          <a:p>
-            <a:pPr>
-              <a:defRPr sz="1200" b="0">
-                <a:solidFill>
-                  <a:srgbClr val="526B70"/>
-                </a:solidFill>
-                <a:latin typeface="Helvetica Neue"/>
-                <a:ea typeface="Helvetica Neue"/>
-                <a:cs typeface="Helvetica Neue"/>
-              </a:defRPr>
-            </a:pPr>
-            <a:r>
-              <a:rPr sz="1200" b="0">
-                <a:solidFill>
-                  <a:srgbClr val="526B70"/>
-                </a:solidFill>
-                <a:latin typeface="Helvetica Neue"/>
-                <a:ea typeface="Helvetica Neue"/>
-                <a:cs typeface="Helvetica Neue"/>
-              </a:rPr>
-              <a:t>09</a:t>
-            </a:r>
-          </a:p>
-        </p:txBody>
-      </p:sp>
-      <p:pic>
-        <p:nvPicPr>
-          <p:cNvPr id="5" name="">
-            <a:extLst>
-              <a:ext uri="{FF2B5EF4-FFF2-40B4-BE49-F238E27FC236}">
-                <ns2:creationId id="{5B4A15C1-179F-4AF5-A36A-DE63BEBC5540}"/>
-              </a:ext>
-            </a:extLst>
-          </p:cNvPr>
-          <p:cNvPicPr>
-            <a:picLocks noChangeAspect="1"/>
-          </p:cNvPicPr>
-          <p:nvPr/>
-        </p:nvPicPr>
-        <p:blipFill>
-          <a:blip r:embed="Re2337e6fc3c2434d"/>
-          <a:stretch/>
-        </p:blipFill>
-        <p:spPr>
-          <a:xfrm>
-            <a:off x="609600" y="1924050"/>
-            <a:ext cx="3733800" cy="3733800"/>
-          </a:xfrm>
-          <a:prstGeom prst="rect">
-            <a:avLst/>
-          </a:prstGeom>
-        </p:spPr>
-      </p:pic>
-      <p:pic>
-        <p:nvPicPr>
-          <p:cNvPr id="6" name="">
-            <a:extLst>
-              <a:ext uri="{FF2B5EF4-FFF2-40B4-BE49-F238E27FC236}">
-                <ns2:creationId id="{EE23A9C9-EE08-4115-868A-36B887E13C00}"/>
-              </a:ext>
-            </a:extLst>
-          </p:cNvPr>
-          <p:cNvPicPr>
-            <a:picLocks noChangeAspect="1"/>
-          </p:cNvPicPr>
-          <p:nvPr/>
-        </p:nvPicPr>
-        <p:blipFill>
-          <a:blip r:embed="R4c0eb88b0e674139"/>
-          <a:stretch/>
-        </p:blipFill>
-        <p:spPr>
-          <a:xfrm>
-            <a:off x="4543425" y="1924050"/>
-            <a:ext cx="3733800" cy="3733800"/>
-          </a:xfrm>
-          <a:prstGeom prst="rect">
-            <a:avLst/>
-          </a:prstGeom>
-        </p:spPr>
-      </p:pic>
-      <p:sp>
-        <p:nvSpPr>
-          <p:cNvPr id="7" name="Schritt 23 · 0 : 0">
-            <a:extLst>
-              <a:ext uri="{FF2B5EF4-FFF2-40B4-BE49-F238E27FC236}">
-                <ns2:creationId id="{BE563A49-DAB7-4FAC-BC14-4BBE0559632A}"/>
-              </a:ext>
-            </a:extLst>
-          </p:cNvPr>
-          <p:cNvSpPr>
-            <a:spLocks noGrp="1"/>
-          </p:cNvSpPr>
-          <p:nvPr/>
-        </p:nvSpPr>
-        <p:spPr>
-          <a:xfrm>
-            <a:off x="609600" y="5800725"/>
-            <a:ext cx="3810000" cy="409575"/>
-          </a:xfrm>
-          <a:prstGeom prst="rect">
-            <a:avLst/>
-          </a:prstGeom>
-          <a:noFill/>
-          <a:ln w="0">
-            <a:noFill/>
-          </a:ln>
-        </p:spPr>
-        <p:txBody>
-          <a:bodyPr/>
-          <a:lstStyle>
-            <a:defPPr>
-              <a:defRPr sz="1950" b="1">
-                <a:solidFill>
-                  <a:srgbClr val="102D35"/>
-                </a:solidFill>
-                <a:latin typeface="Helvetica Neue"/>
-                <a:ea typeface="Helvetica Neue"/>
-                <a:cs typeface="Helvetica Neue"/>
-              </a:defRPr>
-            </a:defPPr>
-          </a:lstStyle>
-          <a:p>
-            <a:pPr>
-              <a:defRPr sz="1950" b="1">
-                <a:solidFill>
-                  <a:srgbClr val="102D35"/>
-                </a:solidFill>
-                <a:latin typeface="Helvetica Neue"/>
-                <a:ea typeface="Helvetica Neue"/>
-                <a:cs typeface="Helvetica Neue"/>
-              </a:defRPr>
-            </a:pPr>
-            <a:r>
-              <a:rPr sz="1950" b="1">
-                <a:solidFill>
-                  <a:srgbClr val="102D35"/>
-                </a:solidFill>
-                <a:latin typeface="Helvetica Neue"/>
-                <a:ea typeface="Helvetica Neue"/>
-                <a:cs typeface="Helvetica Neue"/>
-              </a:rPr>
-              <a:t>Schritt 23 · 0 : 0</a:t>
-            </a:r>
-          </a:p>
-        </p:txBody>
-      </p:sp>
-      <p:sp>
-        <p:nvSpPr>
-          <p:cNvPr id="8" name="Schritt 90 · 374 : 11">
-            <a:extLst>
-              <a:ext uri="{FF2B5EF4-FFF2-40B4-BE49-F238E27FC236}">
-                <ns2:creationId id="{15EA00B8-A570-4921-B800-06AC2AB009B3}"/>
-              </a:ext>
-            </a:extLst>
-          </p:cNvPr>
-          <p:cNvSpPr>
-            <a:spLocks noGrp="1"/>
-          </p:cNvSpPr>
-          <p:nvPr/>
-        </p:nvSpPr>
-        <p:spPr>
-          <a:xfrm>
-            <a:off x="4543425" y="5800725"/>
-            <a:ext cx="3810000" cy="409575"/>
-          </a:xfrm>
-          <a:prstGeom prst="rect">
-            <a:avLst/>
-          </a:prstGeom>
-          <a:noFill/>
-          <a:ln w="0">
-            <a:noFill/>
-          </a:ln>
-        </p:spPr>
-        <p:txBody>
-          <a:bodyPr/>
-          <a:lstStyle>
-            <a:defPPr>
-              <a:defRPr sz="1950" b="1">
-                <a:solidFill>
-                  <a:srgbClr val="102D35"/>
-                </a:solidFill>
-                <a:latin typeface="Helvetica Neue"/>
-                <a:ea typeface="Helvetica Neue"/>
-                <a:cs typeface="Helvetica Neue"/>
-              </a:defRPr>
-            </a:defPPr>
-          </a:lstStyle>
-          <a:p>
-            <a:pPr>
-              <a:defRPr sz="1950" b="1">
-                <a:solidFill>
-                  <a:srgbClr val="102D35"/>
-                </a:solidFill>
-                <a:latin typeface="Helvetica Neue"/>
-                <a:ea typeface="Helvetica Neue"/>
-                <a:cs typeface="Helvetica Neue"/>
-              </a:defRPr>
-            </a:pPr>
-            <a:r>
-              <a:rPr sz="1950" b="1">
-                <a:solidFill>
-                  <a:srgbClr val="102D35"/>
-                </a:solidFill>
-                <a:latin typeface="Helvetica Neue"/>
-                <a:ea typeface="Helvetica Neue"/>
-                <a:cs typeface="Helvetica Neue"/>
-              </a:rPr>
-              <a:t>Schritt 90 · 374 : 11</a:t>
-            </a:r>
-          </a:p>
-        </p:txBody>
-      </p:sp>
-      <p:sp>
-        <p:nvSpPr>
-          <p:cNvPr id="9" name="Sherlock: blau&#10;Gegner: rot">
-            <a:extLst>
-              <a:ext uri="{FF2B5EF4-FFF2-40B4-BE49-F238E27FC236}">
-                <ns2:creationId id="{A4849F7E-04F9-4CDB-9887-2CE754AAE9CA}"/>
-              </a:ext>
-            </a:extLst>
-          </p:cNvPr>
-          <p:cNvSpPr>
-            <a:spLocks noGrp="1"/>
-          </p:cNvSpPr>
-          <p:nvPr/>
-        </p:nvSpPr>
-        <p:spPr>
-          <a:xfrm>
-            <a:off x="8724900" y="2057400"/>
-            <a:ext cx="2857500" cy="952500"/>
-          </a:xfrm>
-          <a:prstGeom prst="rect">
-            <a:avLst/>
-          </a:prstGeom>
-          <a:noFill/>
-          <a:ln w="0">
-            <a:noFill/>
-          </a:ln>
-        </p:spPr>
-        <p:txBody>
-          <a:bodyPr>
-            <a:noAutofit/>
-          </a:bodyPr>
-          <a:lstStyle>
-            <a:defPPr algn="l">
-              <a:defRPr sz="2025" b="1">
-                <a:solidFill>
-                  <a:srgbClr val="007D7B"/>
-                </a:solidFill>
-                <a:latin typeface="Helvetica Neue"/>
-                <a:ea typeface="Helvetica Neue"/>
-                <a:cs typeface="Helvetica Neue"/>
-              </a:defRPr>
-            </a:defPPr>
-          </a:lstStyle>
-          <a:p>
-            <a:pPr marL="330200" indent="-254000" algn="l">
-              <a:spcAft>
-                <a:spcPts val="800"/>
-              </a:spcAft>
-              <a:buFont typeface="Helvetica Neue"/>
-              <a:buChar char="–"/>
-              <a:defRPr sz="2025" b="1">
-                <a:solidFill>
-                  <a:srgbClr val="007D7B"/>
-                </a:solidFill>
-                <a:latin typeface="Helvetica Neue"/>
-                <a:ea typeface="Helvetica Neue"/>
-                <a:cs typeface="Helvetica Neue"/>
-              </a:defRPr>
-            </a:pPr>
-            <a:r>
-              <a:rPr sz="2025" b="1">
-                <a:solidFill>
-                  <a:srgbClr val="007D7B"/>
-                </a:solidFill>
-                <a:latin typeface="Helvetica Neue"/>
-                <a:ea typeface="Helvetica Neue"/>
-                <a:cs typeface="Helvetica Neue"/>
-              </a:rPr>
-              <a:t>Sherlock: blau</a:t>
-            </a:r>
-          </a:p>
-          <a:p>
-            <a:pPr marL="330200" indent="-254000" algn="l">
-              <a:spcAft>
-                <a:spcPts val="800"/>
-              </a:spcAft>
-              <a:buFont typeface="Helvetica Neue"/>
-              <a:buChar char="–"/>
-              <a:defRPr sz="2025" b="1">
-                <a:solidFill>
-                  <a:srgbClr val="007D7B"/>
-                </a:solidFill>
-                <a:latin typeface="Helvetica Neue"/>
-                <a:ea typeface="Helvetica Neue"/>
-                <a:cs typeface="Helvetica Neue"/>
-              </a:defRPr>
-            </a:pPr>
-            <a:r>
-              <a:rPr sz="2025" b="1">
-                <a:solidFill>
-                  <a:srgbClr val="007D7B"/>
-                </a:solidFill>
-                <a:latin typeface="Helvetica Neue"/>
-                <a:ea typeface="Helvetica Neue"/>
-                <a:cs typeface="Helvetica Neue"/>
-              </a:rPr>
-              <a:t>Gegner: rot</a:t>
-            </a:r>
-          </a:p>
-        </p:txBody>
-      </p:sp>
-      <p:sp>
-        <p:nvSpPr>
-          <p:cNvPr id="10" name="Blaue Einheiten&#10;besetzen Punktefelder.&#10;&#10;Stehe">
-            <a:extLst>
-              <a:ext uri="{FF2B5EF4-FFF2-40B4-BE49-F238E27FC236}">
-                <ns2:creationId id="{F57BBD97-C9BE-4063-922D-45E9DF7DDCED}"/>
-              </a:ext>
-            </a:extLst>
-          </p:cNvPr>
-          <p:cNvSpPr>
-            <a:spLocks noGrp="1"/>
-          </p:cNvSpPr>
-          <p:nvPr/>
-        </p:nvSpPr>
-        <p:spPr>
-          <a:xfrm>
-            <a:off x="8724900" y="3343275"/>
-            <a:ext cx="2857500" cy="2238375"/>
-          </a:xfrm>
-          <a:prstGeom prst="rect">
-            <a:avLst/>
-          </a:prstGeom>
-          <a:noFill/>
-          <a:ln w="0">
-            <a:noFill/>
-          </a:ln>
-        </p:spPr>
-        <p:txBody>
-          <a:bodyPr>
-            <a:noAutofit/>
-          </a:bodyPr>
-          <a:lstStyle>
-            <a:defPPr algn="l">
-              <a:defRPr sz="2025" b="0">
-                <a:solidFill>
-                  <a:srgbClr val="102D35"/>
-                </a:solidFill>
-                <a:latin typeface="Helvetica Neue"/>
-                <a:ea typeface="Helvetica Neue"/>
-                <a:cs typeface="Helvetica Neue"/>
-              </a:defRPr>
-            </a:defPPr>
-          </a:lstStyle>
-          <a:p>
-            <a:pPr marL="330200" indent="-254000" algn="l">
-              <a:spcAft>
-                <a:spcPts val="1200"/>
-              </a:spcAft>
-              <a:buFont typeface="Helvetica Neue"/>
-              <a:buChar char="–"/>
-              <a:defRPr sz="2025" b="0">
-                <a:solidFill>
-                  <a:srgbClr val="102D35"/>
-                </a:solidFill>
-                <a:latin typeface="Helvetica Neue"/>
-                <a:ea typeface="Helvetica Neue"/>
-                <a:cs typeface="Helvetica Neue"/>
-              </a:defRPr>
-            </a:pPr>
-            <a:r>
-              <a:rPr sz="2025">
-                <a:solidFill>
-                  <a:srgbClr val="102D35"/>
-                </a:solidFill>
-                <a:latin typeface="Helvetica Neue"/>
-                <a:ea typeface="Helvetica Neue"/>
-                <a:cs typeface="Helvetica Neue"/>
-              </a:rPr>
-              <a:t>Blaue Einheiten besetzen Punktefelder</a:t>
-            </a:r>
-          </a:p>
-          <a:p>
-            <a:pPr marL="330200" indent="-254000" algn="l">
-              <a:spcAft>
-                <a:spcPts val="1200"/>
-              </a:spcAft>
-              <a:buFont typeface="Helvetica Neue"/>
-              <a:buChar char="–"/>
-              <a:defRPr sz="2025" b="0">
-                <a:solidFill>
-                  <a:srgbClr val="102D35"/>
-                </a:solidFill>
-                <a:latin typeface="Helvetica Neue"/>
-                <a:ea typeface="Helvetica Neue"/>
-                <a:cs typeface="Helvetica Neue"/>
-              </a:defRPr>
-            </a:pPr>
-            <a:r>
-              <a:rPr sz="2025">
-                <a:solidFill>
-                  <a:srgbClr val="102D35"/>
-                </a:solidFill>
-                <a:latin typeface="Helvetica Neue"/>
-                <a:ea typeface="Helvetica Neue"/>
-                <a:cs typeface="Helvetica Neue"/>
-              </a:rPr>
-              <a:t>Stehenbleiben kann sinnvoll sein</a:t>
-            </a:r>
-          </a:p>
-        </p:txBody>
-      </p:sp>
-      <p:sp>
-        <p:nvSpPr>
-          <p:cNvPr id="11" name="Seed 900011 · Match 1&#10;Vollständige Replay-Ans">
-            <a:extLst>
-              <a:ext uri="{FF2B5EF4-FFF2-40B4-BE49-F238E27FC236}">
-                <ns2:creationId id="{0FC615EC-C06C-4482-9275-6839DD877F5F}"/>
-              </a:ext>
-            </a:extLst>
-          </p:cNvPr>
-          <p:cNvSpPr>
-            <a:spLocks noGrp="1"/>
-          </p:cNvSpPr>
-          <p:nvPr/>
-        </p:nvSpPr>
-        <p:spPr>
-          <a:xfrm>
-            <a:off x="8724900" y="5619750"/>
-            <a:ext cx="2857500" cy="619125"/>
-          </a:xfrm>
-          <a:prstGeom prst="rect">
-            <a:avLst/>
-          </a:prstGeom>
-          <a:noFill/>
-          <a:ln w="0">
-            <a:noFill/>
-          </a:ln>
-        </p:spPr>
-        <p:txBody>
-          <a:bodyPr/>
-          <a:lstStyle>
-            <a:defPPr>
-              <a:defRPr sz="1500" b="0">
-                <a:solidFill>
-                  <a:srgbClr val="526B70"/>
-                </a:solidFill>
-                <a:latin typeface="Helvetica Neue"/>
-                <a:ea typeface="Helvetica Neue"/>
-                <a:cs typeface="Helvetica Neue"/>
-              </a:defRPr>
-            </a:defPPr>
-          </a:lstStyle>
-          <a:p>
-            <a:pPr>
-              <a:defRPr sz="1500" b="0">
-                <a:solidFill>
-                  <a:srgbClr val="526B70"/>
-                </a:solidFill>
-                <a:latin typeface="Helvetica Neue"/>
-                <a:ea typeface="Helvetica Neue"/>
-                <a:cs typeface="Helvetica Neue"/>
-              </a:defRPr>
-            </a:pPr>
-            <a:r>
-              <a:rPr sz="1500" b="0">
-                <a:solidFill>
-                  <a:srgbClr val="526B70"/>
-                </a:solidFill>
-                <a:latin typeface="Helvetica Neue"/>
-                <a:ea typeface="Helvetica Neue"/>
-                <a:cs typeface="Helvetica Neue"/>
-              </a:rPr>
-              <a:t>Seed 900011 · Match 1</a:t>
-            </a:r>
-          </a:p>
-          <a:p>
-            <a:pPr>
-              <a:defRPr sz="1500" b="0">
-                <a:solidFill>
-                  <a:srgbClr val="526B70"/>
-                </a:solidFill>
-                <a:latin typeface="Helvetica Neue"/>
-                <a:ea typeface="Helvetica Neue"/>
-                <a:cs typeface="Helvetica Neue"/>
-              </a:defRPr>
-            </a:pPr>
-            <a:r>
-              <a:rPr sz="1500" b="0">
-                <a:solidFill>
-                  <a:srgbClr val="526B70"/>
-                </a:solidFill>
-                <a:latin typeface="Helvetica Neue"/>
-                <a:ea typeface="Helvetica Neue"/>
-                <a:cs typeface="Helvetica Neue"/>
-              </a:rPr>
-              <a:t>Vollständige Replay-Ansicht</a:t>
-            </a:r>
-          </a:p>
-        </p:txBody>
-      </p:sp>
-    </p:spTree>
-    <p:extLst>
-      <p:ext uri="{BB962C8B-B14F-4D97-AF65-F5344CB8AC3E}">
-        <ns4:creationId val="1042096664"/>
       </p:ext>
     </p:extLst>
   </p:cSld>

</xml_diff>

<commit_message>
docs: Erkenntnisfolie, Reservefolie Belohnung und Stichpunkte zum Review 16.10.
</commit_message>
<xml_diff>
--- a/docs/presentation/Sherlock_Review_16-10-2026.pptx
+++ b/docs/presentation/Sherlock_Review_16-10-2026.pptx
@@ -22,6 +22,7 @@
     <p:sldId id="266" r:id="R14fd2b0f78a1438d"/>
     <p:sldId id="267" r:id="Rb6dbdcbeed01465d"/>
     <p:sldId id="268" r:id="Rd16c706467ac45df"/>
+    <p:sldId id="270" r:id="rIdReward20261015"/>
   </p:sldIdLst>
   <p:sldSz cx="12192000" cy="6858000"/>
   <p:notesSz cx="6858000" cy="9144000"/>
@@ -655,7 +656,7 @@
           <a:lstStyle xmlns:a="http://schemas.openxmlformats.org/drawingml/2006/main"/>
           <a:p xmlns:a="http://schemas.openxmlformats.org/drawingml/2006/main">
             <a:r>
-              <a:t>Mahmoud · 55 Sekunden</a:t>
+              <a:t>Mahmoud · 65 Sekunden</a:t>
             </a:r>
           </a:p>
           <a:p xmlns:a="http://schemas.openxmlformats.org/drawingml/2006/main">
@@ -665,7 +666,7 @@
           </a:p>
           <a:p xmlns:a="http://schemas.openxmlformats.org/drawingml/2006/main">
             <a:r>
-              <a:t>Unser Agent kombiniert gelernte Entscheidungen mit explizitem Wissen über das Spiel. Die bisherigen Versuche sprechen dafür, Gedächtnis und mehrere Netzbewertungen zu kombinieren. Weitertraining und Self-Play haben in den getesteten Varianten keinen klaren zusätzlichen Gewinn gebracht; das ist keine allgemeine Aussage gegen diese Verfahren. Eine Arbeitshypothese ist, dass bessere frühe Erkundung und frühere Inferenz im ersten Match helfen. Der Kandidat m1_early ist untersucht, aber noch nicht in der Abgabe aktiviert. Vor weiterem Training prüfen wir außerdem Reward und Einheitenübergänge. Für die nächste belastbare Bewertung wollen wir neue Testkarten zurückhalten. Der Präsentationsstand und seine Gewichte bleiben dabei fest.</a:t>
+              <a:t>Drei Erkenntnisse. Erstens: Am meisten haben gezielte Verbesserungen gebracht. Wir haben Niederlagen ausgewertet und daraus konkrete Änderungen abgeleitet. Die Karte ist spiegelsymmetrisch: Wer ein Relic sieht, kennt auch das gegenüberliegende. Außerdem merkt sich der Agent jetzt über Matches hinweg, welche Gebiete er schon erkundet hat; vorher fand er auf manchen Karten nie ein Relic. Zusammen mit sechs statt einem Netz stieg die Siegquote gegen Solution_92 auf denselben 30 Testkarten von 12 auf 28 von 60 Spielen. Zweitens: Weitertraining und Self-Play haben in unseren Versuchen keinen klaren Zusatzgewinn gebracht; das ist keine allgemeine Aussage über diese Verfahren. Drittens: Im ersten Match finden wir Relics oft spät. Als Nächstes wollen wir das beschleunigen und auf neuen, bisher unbenutzten Testkarten prüfen.</a:t>
             </a:r>
           </a:p>
           <a:p xmlns:a="http://schemas.openxmlformats.org/drawingml/2006/main">
@@ -675,22 +676,32 @@
           </a:p>
           <a:p xmlns:a="http://schemas.openxmlformats.org/drawingml/2006/main">
             <a:r>
-              <a:t>Quellen / Nachweise (Repository, Stand 14.10.2026):</a:t>
+              <a:t>Quellen / Nachweise (Repository, Stand 15.10.2026):</a:t>
             </a:r>
           </a:p>
           <a:p xmlns:a="http://schemas.openxmlformats.org/drawingml/2006/main">
             <a:r>
+              <a:t>Hintergrund, nicht vorlesen: gepaarter Karten-Bootstrap (scripts/compare_report.py) altes Einzelnetz full_s0 gegen old3_sym3, je 30 Karten × 2 Seiten: Solution_92 +26,7 pp, 95-%-KI [+13,3; +41,7]; default +15,0 pp, KI [+3,3; +28,3]. Ohne Korrektur für Mehrfachvergleiche und Modellauswahl; die Testkarten wurden mehrfach ausgewertet. Der Kandidat m1_early (frühere Inferenz) ist untersucht, aber nicht aktiv. Vor weiterem Training prüfen wir Reward und Einheitenübergänge.</a:t>
+            </a:r>
+          </a:p>
+          <a:p xmlns:a="http://schemas.openxmlformats.org/drawingml/2006/main">
+            <a:r>
+              <a:t>experiments/compare/TEST_full_s0.csv</a:t>
+            </a:r>
+          </a:p>
+          <a:p xmlns:a="http://schemas.openxmlformats.org/drawingml/2006/main">
+            <a:r>
+              <a:t>experiments/compare/TEST_old3_sym3_points_v2.csv</a:t>
+            </a:r>
+          </a:p>
+          <a:p xmlns:a="http://schemas.openxmlformats.org/drawingml/2006/main">
+            <a:r>
               <a:t>docs/EXPERIMENT_PROTOKOLL.md</a:t>
             </a:r>
           </a:p>
           <a:p xmlns:a="http://schemas.openxmlformats.org/drawingml/2006/main">
             <a:r>
               <a:t>docs/ARBEITSSTAND.md</a:t>
-            </a:r>
-          </a:p>
-          <a:p xmlns:a="http://schemas.openxmlformats.org/drawingml/2006/main">
-            <a:r>
-              <a:t>docs/STATISTIK_20261014.md</a:t>
             </a:r>
           </a:p>
         </p:txBody>
@@ -1040,6 +1051,116 @@
 </p:notes>
 </file>
 
+<file path=ppt/notesSlides/notesSlide15.xml><?xml version="1.0" encoding="utf-8"?>
+<p:notes xmlns:p="http://schemas.openxmlformats.org/presentationml/2006/main">
+  <p:cSld>
+    <p:spTree>
+      <p:nvGrpSpPr>
+        <p:cNvPr id="1" name=""/>
+        <p:cNvGrpSpPr/>
+        <p:nvPr/>
+      </p:nvGrpSpPr>
+      <p:grpSpPr>
+        <a:xfrm xmlns:a="http://schemas.openxmlformats.org/drawingml/2006/main"/>
+      </p:grpSpPr>
+      <p:sp>
+        <p:nvSpPr>
+          <p:cNvPr id="2" name="Slide Image Placeholder 1"/>
+          <p:cNvSpPr>
+            <a:spLocks xmlns:a="http://schemas.openxmlformats.org/drawingml/2006/main" noGrp="1"/>
+          </p:cNvSpPr>
+          <p:nvPr>
+            <p:ph type="sldImg" idx="0"/>
+          </p:nvPr>
+        </p:nvSpPr>
+        <p:spPr/>
+      </p:sp>
+      <p:sp>
+        <p:nvSpPr>
+          <p:cNvPr id="3" name="Notes Placeholder 2"/>
+          <p:cNvSpPr>
+            <a:spLocks xmlns:a="http://schemas.openxmlformats.org/drawingml/2006/main" noGrp="1"/>
+          </p:cNvSpPr>
+          <p:nvPr>
+            <p:ph type="body" idx="1"/>
+          </p:nvPr>
+        </p:nvSpPr>
+        <p:spPr/>
+        <p:txBody>
+          <a:bodyPr xmlns:a="http://schemas.openxmlformats.org/drawingml/2006/main"/>
+          <a:lstStyle xmlns:a="http://schemas.openxmlformats.org/drawingml/2006/main"/>
+          <a:p xmlns:a="http://schemas.openxmlformats.org/drawingml/2006/main">
+            <a:r>
+              <a:t>Mahmoud · nur bei Rückfragen</a:t>
+            </a:r>
+          </a:p>
+          <a:p xmlns:a="http://schemas.openxmlformats.org/drawingml/2006/main">
+            <a:r>
+              <a:t/>
+            </a:r>
+          </a:p>
+          <a:p xmlns:a="http://schemas.openxmlformats.org/drawingml/2006/main">
+            <a:r>
+              <a:t>Reservefolie, nicht Teil des geplanten Vortrags. Das Spiel liefert nur am Matchende ein Team-Signal; für DQN ist das zu spärlich. Deshalb bekommt jede Einheit in jedem Schritt eine eigene Belohnung. Wichtigster Teil: Wer zuerst auf einem bewiesenen Punktefeld steht, bekommt +1; eine zweite Einheit auf demselben Feld bekommt einen Abzug, weil das Feld nur einmal zählt. Die Annäherung ans zugewiesene Ziel ist potentialbasiertes Shaping nach Ng, Harada und Russell (1999): Potential gleich minus Abstand zum Ziel. Erkundungs- und Entdeckungsbonus werden auf das Team aufgeteilt. Ein gewonnenes Match gibt jeder Einheit +2. Bekannte offene Punkte für das nächste Training: Punktebelohnung bei negativer Energie, terminales Potential und wiederverwendete Einheiten-IDs.</a:t>
+            </a:r>
+          </a:p>
+          <a:p xmlns:a="http://schemas.openxmlformats.org/drawingml/2006/main">
+            <a:r>
+              <a:t/>
+            </a:r>
+          </a:p>
+          <a:p xmlns:a="http://schemas.openxmlformats.org/drawingml/2006/main">
+            <a:r>
+              <a:t>Quellen / Nachweise (Repository, Stand 15.10.2026):</a:t>
+            </a:r>
+          </a:p>
+          <a:p xmlns:a="http://schemas.openxmlformats.org/drawingml/2006/main">
+            <a:r>
+              <a:t>agents/sherlock/reward.py</a:t>
+            </a:r>
+          </a:p>
+          <a:p xmlns:a="http://schemas.openxmlformats.org/drawingml/2006/main">
+            <a:r>
+              <a:t>agents/sherlock/config.py</a:t>
+            </a:r>
+          </a:p>
+          <a:p xmlns:a="http://schemas.openxmlformats.org/drawingml/2006/main">
+            <a:r>
+              <a:t>experiments/runs/*full*/manifest.json · gleiche Gewichte in allen sechs Basisläufen</a:t>
+            </a:r>
+          </a:p>
+          <a:p xmlns:a="http://schemas.openxmlformats.org/drawingml/2006/main">
+            <a:r>
+              <a:t>docs/ARBEITSSTAND.md · offene Punkte</a:t>
+            </a:r>
+          </a:p>
+        </p:txBody>
+      </p:sp>
+      <p:sp>
+        <p:nvSpPr>
+          <p:cNvPr id="4" name="Slide Number Placeholder 3"/>
+          <p:cNvSpPr>
+            <a:spLocks xmlns:a="http://schemas.openxmlformats.org/drawingml/2006/main" noGrp="1"/>
+          </p:cNvSpPr>
+          <p:nvPr>
+            <p:ph type="sldNum" idx="5"/>
+          </p:nvPr>
+        </p:nvSpPr>
+        <p:spPr/>
+        <p:txBody>
+          <a:bodyPr xmlns:a="http://schemas.openxmlformats.org/drawingml/2006/main"/>
+          <a:lstStyle xmlns:a="http://schemas.openxmlformats.org/drawingml/2006/main"/>
+          <a:p xmlns:a="http://schemas.openxmlformats.org/drawingml/2006/main"/>
+        </p:txBody>
+      </p:sp>
+    </p:spTree>
+  </p:cSld>
+  <p:clrMapOvr>
+    <a:masterClrMapping xmlns:a="http://schemas.openxmlformats.org/drawingml/2006/main"/>
+  </p:clrMapOvr>
+</p:notes>
+</file>
+
 <file path=ppt/notesSlides/notesSlide2.xml><?xml version="1.0" encoding="utf-8"?>
 <p:notes xmlns:p="http://schemas.openxmlformats.org/presentationml/2006/main">
   <p:cSld>
@@ -1180,7 +1301,7 @@
           </a:p>
           <a:p xmlns:a="http://schemas.openxmlformats.org/drawingml/2006/main">
             <a:r>
-              <a:t>Lux AI ist ein Strategiespiel auf einer Karte mit 24 mal 24 Feldern. Zwei Teams steuern jeweils bis zu 16 Einheiten. Im Kurs besteht ein Spiel aus drei Matches. Wer mehr Matches gewinnt, gewinnt das Spiel. Die Herausforderung ist, dass der Agent nicht die ganze Karte sieht und die Punktefelder zunächst unbekannt sind. Er muss erkunden, Energie sinnvoll einsetzen und geeignete Felder besetzen. Auf dem Bild ist Sherlock blau und der Gegner rot. Die gelben Markierungen gehören zu Relics und Punktefeldern. Wichtig: Das ist die vollständige Replay-Ansicht für uns Zuschauer. Der Agent bekommt diese vollständige Information nicht.</a:t>
+              <a:t>Lux AI ist ein Strategiespiel auf einer Karte mit 24 mal 24 Feldern. Zwei Teams steuern jeweils bis zu 16 Einheiten. Im Kurs besteht ein Spiel aus drei Matches. Wer mehr Matches gewinnt, gewinnt das Spiel. Die Herausforderung ist, dass der Agent nicht die ganze Karte sieht und die Punktefelder zunächst unbekannt sind. Er muss erkunden, Energie sinnvoll einsetzen und die unsichtbaren Punktefelder finden und besetzen. Deshalb braucht er ein Gedächtnis. Auf dem Bild ist Sherlock blau und der Gegner rot. Die gelben Markierungen gehören zu Relics und Punktefeldern. Wichtig: Das ist die vollständige Replay-Ansicht für uns Zuschauer. Der Agent bekommt diese vollständige Information nicht.</a:t>
             </a:r>
           </a:p>
           <a:p xmlns:a="http://schemas.openxmlformats.org/drawingml/2006/main">
@@ -1502,7 +1623,7 @@
           </a:p>
           <a:p xmlns:a="http://schemas.openxmlformats.org/drawingml/2006/main">
             <a:r>
-              <a:t>Jedes Mitglied des Ensembles ist ein Dueling-Netz. Es bekommt 79 Merkmale. Der gemeinsame Teil besteht aus zwei voll verbundenen Schichten mit jeweils 256 Neuronen und ReLU. Danach gibt es einen Kopf für den Zustandswert und einen Kopf für die Vorteile der sechs Aktionen; beide haben eine Zwischenschicht mit 128 Neuronen. Daraus entstehen sechs Q-Werte. Beim Spielen mitteln wir die Q-Werte der sechs trainierten Netze und wählen dann die beste erlaubte Aktion. Die sechs Aktionen sind Stehenbleiben, vier Bewegungsrichtungen und Sap. Das konkrete Sap-Ziel wird heuristisch gewählt. Double DQN bezeichnet unser Lernverfahren, Dueling die Netzarchitektur und Ensemble die Kombination mehrerer trainierter Netze.</a:t>
+              <a:t>Jedes Mitglied des Ensembles ist ein Dueling-Netz. Es bekommt 79 Merkmale. Der gemeinsame Teil besteht aus zwei voll verbundenen Schichten mit jeweils 256 Neuronen und ReLU. Danach gibt es einen Kopf für den Zustandswert und einen Kopf für die Vorteile der sechs Aktionen; beide haben eine Zwischenschicht mit 128 Neuronen. Daraus entstehen sechs Q-Werte. Beim Spielen mitteln wir die Q-Werte der sechs trainierten Netze und wählen dann die beste erlaubte Aktion. Drei Netze wurden ohne, drei mit Spiegelsymmetrie im Gedächtnis trainiert; beim Spielen ist die Symmetrie für alle aktiv. Die sechs Aktionen sind Stehenbleiben, vier Bewegungsrichtungen und Sap. Das konkrete Sap-Ziel wird heuristisch gewählt. Double DQN bezeichnet unser Lernverfahren, Dueling die Netzarchitektur und Ensemble die Kombination mehrerer trainierter Netze.</a:t>
             </a:r>
           </a:p>
           <a:p xmlns:a="http://schemas.openxmlformats.org/drawingml/2006/main">
@@ -1512,7 +1633,7 @@
           </a:p>
           <a:p xmlns:a="http://schemas.openxmlformats.org/drawingml/2006/main">
             <a:r>
-              <a:t>Quellen / Nachweise (Repository, Stand 14.10.2026):</a:t>
+              <a:t>Quellen / Nachweise (Repository, Stand 15.10.2026):</a:t>
             </a:r>
           </a:p>
           <a:p xmlns:a="http://schemas.openxmlformats.org/drawingml/2006/main">
@@ -1527,7 +1648,7 @@
           </a:p>
           <a:p xmlns:a="http://schemas.openxmlformats.org/drawingml/2006/main">
             <a:r>
-              <a:t>agents/sherlock/weights/agent_p0.pth · gespeicherte cfg</a:t>
+              <a:t>agents/sherlock/weights/agent_p0.pth · gespeicherte cfg und ensemble_sources</a:t>
             </a:r>
           </a:p>
         </p:txBody>
@@ -5928,7 +6049,7 @@
       </p:sp>
       <p:sp>
         <p:nvSpPr>
-          <p:cNvPr id="6" name="Beobachtung">
+          <p:cNvPr id="6" name="Gezielte Verbesserungen wirken">
             <a:extLst>
               <a:ext uri="{FF2B5EF4-FFF2-40B4-BE49-F238E27FC236}">
                 <ns2:creationId id="{1820C6B8-74D4-449F-81D3-C1BE271F8C66}"/>
@@ -5987,14 +6108,14 @@
                 <a:ea typeface="Helvetica Neue"/>
                 <a:cs typeface="Helvetica Neue"/>
               </a:rPr>
-              <a:t>Beobachtung</a:t>
+              <a:t>Gezielte Verbesserungen wirken</a:t>
             </a:r>
           </a:p>
         </p:txBody>
       </p:sp>
       <p:sp>
         <p:nvSpPr>
-          <p:cNvPr id="7" name="Weitertraining und Self-Play: bisher kein kla">
+          <p:cNvPr id="7" name="Sechs Netze, Spiegelsymmetrie, Erkundungsgedä">
             <a:extLst>
               <a:ext uri="{FF2B5EF4-FFF2-40B4-BE49-F238E27FC236}">
                 <ns2:creationId id="{BE9A7020-621E-4955-BD51-3E87C5A2D3C0}"/>
@@ -6009,6 +6130,226 @@
         <p:spPr>
           <a:xfrm>
             <a:off x="1524000" y="2409825"/>
+            <a:ext cx="9715500" cy="762000"/>
+          </a:xfrm>
+          <a:prstGeom prst="rect">
+            <a:avLst/>
+          </a:prstGeom>
+          <a:noFill/>
+          <a:ln w="0">
+            <a:noFill/>
+          </a:ln>
+        </p:spPr>
+        <p:txBody>
+          <a:bodyPr/>
+          <a:lstStyle>
+            <a:defPPr>
+              <a:defRPr sz="1950" b="0">
+                <a:solidFill>
+                  <a:srgbClr val="526B70"/>
+                </a:solidFill>
+                <a:latin typeface="Helvetica Neue"/>
+                <a:ea typeface="Helvetica Neue"/>
+                <a:cs typeface="Helvetica Neue"/>
+              </a:defRPr>
+            </a:defPPr>
+          </a:lstStyle>
+          <a:p>
+            <a:pPr>
+              <a:defRPr sz="1950" b="0">
+                <a:solidFill>
+                  <a:srgbClr val="526B70"/>
+                </a:solidFill>
+                <a:latin typeface="Helvetica Neue"/>
+                <a:ea typeface="Helvetica Neue"/>
+                <a:cs typeface="Helvetica Neue"/>
+              </a:defRPr>
+            </a:pPr>
+            <a:r>
+              <a:rPr sz="1950" b="0">
+                <a:solidFill>
+                  <a:srgbClr val="526B70"/>
+                </a:solidFill>
+                <a:latin typeface="Helvetica Neue"/>
+                <a:ea typeface="Helvetica Neue"/>
+                <a:cs typeface="Helvetica Neue"/>
+              </a:rPr>
+              <a:t>Sechs Netze, Spiegelsymmetrie, Erkundungsgedächtnis: gegen Solution_92 von </a:t>
+            </a:r>
+            <a:r>
+              <a:rPr sz="1950" b="1">
+                <a:solidFill>
+                  <a:srgbClr val="007D7B"/>
+                </a:solidFill>
+                <a:latin typeface="Helvetica Neue"/>
+                <a:ea typeface="Helvetica Neue"/>
+                <a:cs typeface="Helvetica Neue"/>
+              </a:rPr>
+              <a:t>12/60 auf 28/60 Siege</a:t>
+            </a:r>
+            <a:r>
+              <a:rPr sz="1950" b="0">
+                <a:solidFill>
+                  <a:srgbClr val="526B70"/>
+                </a:solidFill>
+                <a:latin typeface="Helvetica Neue"/>
+                <a:ea typeface="Helvetica Neue"/>
+                <a:cs typeface="Helvetica Neue"/>
+              </a:rPr>
+              <a:t> (gleiche Testkarten).</a:t>
+            </a:r>
+          </a:p>
+        </p:txBody>
+      </p:sp>
+      <p:sp>
+        <p:nvSpPr>
+          <p:cNvPr id="8" name="02">
+            <a:extLst>
+              <a:ext uri="{FF2B5EF4-FFF2-40B4-BE49-F238E27FC236}">
+                <ns2:creationId id="{9CB94756-3BDB-47E5-80A2-C23BD1DB5456}"/>
+              </a:ext>
+            </a:extLst>
+          </p:cNvPr>
+          <p:cNvSpPr>
+            <a:spLocks noGrp="1"/>
+          </p:cNvSpPr>
+          <p:nvPr/>
+        </p:nvSpPr>
+        <p:spPr>
+          <a:xfrm>
+            <a:off x="609600" y="3476625"/>
+            <a:ext cx="666750" cy="523875"/>
+          </a:xfrm>
+          <a:prstGeom prst="rect">
+            <a:avLst/>
+          </a:prstGeom>
+          <a:noFill/>
+          <a:ln w="0">
+            <a:noFill/>
+          </a:ln>
+        </p:spPr>
+        <p:txBody>
+          <a:bodyPr/>
+          <a:lstStyle>
+            <a:defPPr>
+              <a:defRPr sz="2850" b="1">
+                <a:solidFill>
+                  <a:srgbClr val="007D7B"/>
+                </a:solidFill>
+                <a:latin typeface="Helvetica Neue"/>
+                <a:ea typeface="Helvetica Neue"/>
+                <a:cs typeface="Helvetica Neue"/>
+              </a:defRPr>
+            </a:defPPr>
+          </a:lstStyle>
+          <a:p>
+            <a:pPr>
+              <a:defRPr sz="2850" b="1">
+                <a:solidFill>
+                  <a:srgbClr val="007D7B"/>
+                </a:solidFill>
+                <a:latin typeface="Helvetica Neue"/>
+                <a:ea typeface="Helvetica Neue"/>
+                <a:cs typeface="Helvetica Neue"/>
+              </a:defRPr>
+            </a:pPr>
+            <a:r>
+              <a:rPr sz="2850" b="1">
+                <a:solidFill>
+                  <a:srgbClr val="007D7B"/>
+                </a:solidFill>
+                <a:latin typeface="Helvetica Neue"/>
+                <a:ea typeface="Helvetica Neue"/>
+                <a:cs typeface="Helvetica Neue"/>
+              </a:rPr>
+              <a:t>02</a:t>
+            </a:r>
+          </a:p>
+        </p:txBody>
+      </p:sp>
+      <p:sp>
+        <p:nvSpPr>
+          <p:cNvPr id="9" name="Mehr Training half kaum">
+            <a:extLst>
+              <a:ext uri="{FF2B5EF4-FFF2-40B4-BE49-F238E27FC236}">
+                <ns2:creationId id="{01656370-F555-4D41-A0F2-E4AC260C770C}"/>
+              </a:ext>
+            </a:extLst>
+          </p:cNvPr>
+          <p:cNvSpPr>
+            <a:spLocks noGrp="1"/>
+          </p:cNvSpPr>
+          <p:nvPr/>
+        </p:nvSpPr>
+        <p:spPr>
+          <a:xfrm>
+            <a:off x="1524000" y="3476625"/>
+            <a:ext cx="9715500" cy="428625"/>
+          </a:xfrm>
+          <a:prstGeom prst="rect">
+            <a:avLst/>
+          </a:prstGeom>
+          <a:noFill/>
+          <a:ln w="0">
+            <a:noFill/>
+          </a:ln>
+        </p:spPr>
+        <p:txBody>
+          <a:bodyPr/>
+          <a:lstStyle>
+            <a:defPPr>
+              <a:defRPr sz="2250" b="1">
+                <a:solidFill>
+                  <a:srgbClr val="102D35"/>
+                </a:solidFill>
+                <a:latin typeface="Helvetica Neue"/>
+                <a:ea typeface="Helvetica Neue"/>
+                <a:cs typeface="Helvetica Neue"/>
+              </a:defRPr>
+            </a:defPPr>
+          </a:lstStyle>
+          <a:p>
+            <a:pPr>
+              <a:defRPr sz="2250" b="1">
+                <a:solidFill>
+                  <a:srgbClr val="102D35"/>
+                </a:solidFill>
+                <a:latin typeface="Helvetica Neue"/>
+                <a:ea typeface="Helvetica Neue"/>
+                <a:cs typeface="Helvetica Neue"/>
+              </a:defRPr>
+            </a:pPr>
+            <a:r>
+              <a:rPr sz="2250" b="1">
+                <a:solidFill>
+                  <a:srgbClr val="102D35"/>
+                </a:solidFill>
+                <a:latin typeface="Helvetica Neue"/>
+                <a:ea typeface="Helvetica Neue"/>
+                <a:cs typeface="Helvetica Neue"/>
+              </a:rPr>
+              <a:t>Mehr Training half kaum</a:t>
+            </a:r>
+          </a:p>
+        </p:txBody>
+      </p:sp>
+      <p:sp>
+        <p:nvSpPr>
+          <p:cNvPr id="10" name="Weitertraining und Self-Play: in unseren Ver">
+            <a:extLst>
+              <a:ext uri="{FF2B5EF4-FFF2-40B4-BE49-F238E27FC236}">
+                <ns2:creationId id="{BCF394DA-3212-4BBD-957A-66337048739E}"/>
+              </a:ext>
+            </a:extLst>
+          </p:cNvPr>
+          <p:cNvSpPr>
+            <a:spLocks noGrp="1"/>
+          </p:cNvSpPr>
+          <p:nvPr/>
+        </p:nvSpPr>
+        <p:spPr>
+          <a:xfrm>
+            <a:off x="1524000" y="3943350"/>
             <a:ext cx="9715500" cy="619125"/>
           </a:xfrm>
           <a:prstGeom prst="rect">
@@ -6053,17 +6394,17 @@
                 <a:ea typeface="Helvetica Neue"/>
                 <a:cs typeface="Helvetica Neue"/>
               </a:rPr>
-              <a:t>Weitertraining und Self-Play: bisher kein klarer Zusatzgewinn.</a:t>
+              <a:t>Weitertraining und Self-Play: in unseren Versuchen kein klarer Zusatzgewinn.</a:t>
             </a:r>
           </a:p>
         </p:txBody>
       </p:sp>
       <p:sp>
         <p:nvSpPr>
-          <p:cNvPr id="8" name="02">
+          <p:cNvPr id="11" name="03">
             <a:extLst>
               <a:ext uri="{FF2B5EF4-FFF2-40B4-BE49-F238E27FC236}">
-                <ns2:creationId id="{9CB94756-3BDB-47E5-80A2-C23BD1DB5456}"/>
+                <ns2:creationId id="{D43F2B56-AF30-4829-ABF0-98A2A1D87295}"/>
               </a:ext>
             </a:extLst>
           </p:cNvPr>
@@ -6074,7 +6415,7 @@
         </p:nvSpPr>
         <p:spPr>
           <a:xfrm>
-            <a:off x="609600" y="3286125"/>
+            <a:off x="609600" y="4819650"/>
             <a:ext cx="666750" cy="523875"/>
           </a:xfrm>
           <a:prstGeom prst="rect">
@@ -6119,17 +6460,17 @@
                 <a:ea typeface="Helvetica Neue"/>
                 <a:cs typeface="Helvetica Neue"/>
               </a:rPr>
-              <a:t>02</a:t>
+              <a:t>03</a:t>
             </a:r>
           </a:p>
         </p:txBody>
       </p:sp>
       <p:sp>
         <p:nvSpPr>
-          <p:cNvPr id="9" name="Offene Hypothese">
+          <p:cNvPr id="12" name="Nächster Schritt">
             <a:extLst>
               <a:ext uri="{FF2B5EF4-FFF2-40B4-BE49-F238E27FC236}">
-                <ns2:creationId id="{01656370-F555-4D41-A0F2-E4AC260C770C}"/>
+                <ns2:creationId id="{7717E4D7-7EC3-4B42-B964-0E4596618185}"/>
               </a:ext>
             </a:extLst>
           </p:cNvPr>
@@ -6140,7 +6481,7 @@
         </p:nvSpPr>
         <p:spPr>
           <a:xfrm>
-            <a:off x="1524000" y="3286125"/>
+            <a:off x="1524000" y="4819650"/>
             <a:ext cx="9715500" cy="428625"/>
           </a:xfrm>
           <a:prstGeom prst="rect">
@@ -6185,17 +6526,17 @@
                 <a:ea typeface="Helvetica Neue"/>
                 <a:cs typeface="Helvetica Neue"/>
               </a:rPr>
-              <a:t>Offene Hypothese</a:t>
+              <a:t>Nächster Schritt</a:t>
             </a:r>
           </a:p>
         </p:txBody>
       </p:sp>
       <p:sp>
         <p:nvSpPr>
-          <p:cNvPr id="10" name="Frühere Erkundung und Inferenz könnten Match ">
+          <p:cNvPr id="13" name="Match 1 beschleunigen: Relics früher finden">
             <a:extLst>
               <a:ext uri="{FF2B5EF4-FFF2-40B4-BE49-F238E27FC236}">
-                <ns2:creationId id="{BCF394DA-3212-4BBD-957A-66337048739E}"/>
+                <ns2:creationId id="{B53B8A02-3C24-4672-BCBA-C1BBE8CB3779}"/>
               </a:ext>
             </a:extLst>
           </p:cNvPr>
@@ -6206,7 +6547,7 @@
         </p:nvSpPr>
         <p:spPr>
           <a:xfrm>
-            <a:off x="1524000" y="3752850"/>
+            <a:off x="1524000" y="5286375"/>
             <a:ext cx="9715500" cy="619125"/>
           </a:xfrm>
           <a:prstGeom prst="rect">
@@ -6251,205 +6592,7 @@
                 <a:ea typeface="Helvetica Neue"/>
                 <a:cs typeface="Helvetica Neue"/>
               </a:rPr>
-              <a:t>Frühere Erkundung und Inferenz könnten Match 1 verbessern.</a:t>
-            </a:r>
-          </a:p>
-        </p:txBody>
-      </p:sp>
-      <p:sp>
-        <p:nvSpPr>
-          <p:cNvPr id="11" name="03">
-            <a:extLst>
-              <a:ext uri="{FF2B5EF4-FFF2-40B4-BE49-F238E27FC236}">
-                <ns2:creationId id="{D43F2B56-AF30-4829-ABF0-98A2A1D87295}"/>
-              </a:ext>
-            </a:extLst>
-          </p:cNvPr>
-          <p:cNvSpPr>
-            <a:spLocks noGrp="1"/>
-          </p:cNvSpPr>
-          <p:nvPr/>
-        </p:nvSpPr>
-        <p:spPr>
-          <a:xfrm>
-            <a:off x="609600" y="4629150"/>
-            <a:ext cx="666750" cy="523875"/>
-          </a:xfrm>
-          <a:prstGeom prst="rect">
-            <a:avLst/>
-          </a:prstGeom>
-          <a:noFill/>
-          <a:ln w="0">
-            <a:noFill/>
-          </a:ln>
-        </p:spPr>
-        <p:txBody>
-          <a:bodyPr/>
-          <a:lstStyle>
-            <a:defPPr>
-              <a:defRPr sz="2850" b="1">
-                <a:solidFill>
-                  <a:srgbClr val="007D7B"/>
-                </a:solidFill>
-                <a:latin typeface="Helvetica Neue"/>
-                <a:ea typeface="Helvetica Neue"/>
-                <a:cs typeface="Helvetica Neue"/>
-              </a:defRPr>
-            </a:defPPr>
-          </a:lstStyle>
-          <a:p>
-            <a:pPr>
-              <a:defRPr sz="2850" b="1">
-                <a:solidFill>
-                  <a:srgbClr val="007D7B"/>
-                </a:solidFill>
-                <a:latin typeface="Helvetica Neue"/>
-                <a:ea typeface="Helvetica Neue"/>
-                <a:cs typeface="Helvetica Neue"/>
-              </a:defRPr>
-            </a:pPr>
-            <a:r>
-              <a:rPr sz="2850" b="1">
-                <a:solidFill>
-                  <a:srgbClr val="007D7B"/>
-                </a:solidFill>
-                <a:latin typeface="Helvetica Neue"/>
-                <a:ea typeface="Helvetica Neue"/>
-                <a:cs typeface="Helvetica Neue"/>
-              </a:rPr>
-              <a:t>03</a:t>
-            </a:r>
-          </a:p>
-        </p:txBody>
-      </p:sp>
-      <p:sp>
-        <p:nvSpPr>
-          <p:cNvPr id="12" name="Nächster Schritt">
-            <a:extLst>
-              <a:ext uri="{FF2B5EF4-FFF2-40B4-BE49-F238E27FC236}">
-                <ns2:creationId id="{7717E4D7-7EC3-4B42-B964-0E4596618185}"/>
-              </a:ext>
-            </a:extLst>
-          </p:cNvPr>
-          <p:cNvSpPr>
-            <a:spLocks noGrp="1"/>
-          </p:cNvSpPr>
-          <p:nvPr/>
-        </p:nvSpPr>
-        <p:spPr>
-          <a:xfrm>
-            <a:off x="1524000" y="4629150"/>
-            <a:ext cx="9715500" cy="428625"/>
-          </a:xfrm>
-          <a:prstGeom prst="rect">
-            <a:avLst/>
-          </a:prstGeom>
-          <a:noFill/>
-          <a:ln w="0">
-            <a:noFill/>
-          </a:ln>
-        </p:spPr>
-        <p:txBody>
-          <a:bodyPr/>
-          <a:lstStyle>
-            <a:defPPr>
-              <a:defRPr sz="2250" b="1">
-                <a:solidFill>
-                  <a:srgbClr val="102D35"/>
-                </a:solidFill>
-                <a:latin typeface="Helvetica Neue"/>
-                <a:ea typeface="Helvetica Neue"/>
-                <a:cs typeface="Helvetica Neue"/>
-              </a:defRPr>
-            </a:defPPr>
-          </a:lstStyle>
-          <a:p>
-            <a:pPr>
-              <a:defRPr sz="2250" b="1">
-                <a:solidFill>
-                  <a:srgbClr val="102D35"/>
-                </a:solidFill>
-                <a:latin typeface="Helvetica Neue"/>
-                <a:ea typeface="Helvetica Neue"/>
-                <a:cs typeface="Helvetica Neue"/>
-              </a:defRPr>
-            </a:pPr>
-            <a:r>
-              <a:rPr sz="2250" b="1">
-                <a:solidFill>
-                  <a:srgbClr val="102D35"/>
-                </a:solidFill>
-                <a:latin typeface="Helvetica Neue"/>
-                <a:ea typeface="Helvetica Neue"/>
-                <a:cs typeface="Helvetica Neue"/>
-              </a:rPr>
-              <a:t>Nächster Schritt</a:t>
-            </a:r>
-          </a:p>
-        </p:txBody>
-      </p:sp>
-      <p:sp>
-        <p:nvSpPr>
-          <p:cNvPr id="13" name="Training absichern; m1_early prüfen; neue Tes">
-            <a:extLst>
-              <a:ext uri="{FF2B5EF4-FFF2-40B4-BE49-F238E27FC236}">
-                <ns2:creationId id="{B53B8A02-3C24-4672-BCBA-C1BBE8CB3779}"/>
-              </a:ext>
-            </a:extLst>
-          </p:cNvPr>
-          <p:cNvSpPr>
-            <a:spLocks noGrp="1"/>
-          </p:cNvSpPr>
-          <p:nvPr/>
-        </p:nvSpPr>
-        <p:spPr>
-          <a:xfrm>
-            <a:off x="1524000" y="5095875"/>
-            <a:ext cx="9715500" cy="619125"/>
-          </a:xfrm>
-          <a:prstGeom prst="rect">
-            <a:avLst/>
-          </a:prstGeom>
-          <a:noFill/>
-          <a:ln w="0">
-            <a:noFill/>
-          </a:ln>
-        </p:spPr>
-        <p:txBody>
-          <a:bodyPr/>
-          <a:lstStyle>
-            <a:defPPr>
-              <a:defRPr sz="1950" b="0">
-                <a:solidFill>
-                  <a:srgbClr val="526B70"/>
-                </a:solidFill>
-                <a:latin typeface="Helvetica Neue"/>
-                <a:ea typeface="Helvetica Neue"/>
-                <a:cs typeface="Helvetica Neue"/>
-              </a:defRPr>
-            </a:defPPr>
-          </a:lstStyle>
-          <a:p>
-            <a:pPr>
-              <a:defRPr sz="1950" b="0">
-                <a:solidFill>
-                  <a:srgbClr val="526B70"/>
-                </a:solidFill>
-                <a:latin typeface="Helvetica Neue"/>
-                <a:ea typeface="Helvetica Neue"/>
-                <a:cs typeface="Helvetica Neue"/>
-              </a:defRPr>
-            </a:pPr>
-            <a:r>
-              <a:rPr sz="1950" b="0">
-                <a:solidFill>
-                  <a:srgbClr val="526B70"/>
-                </a:solidFill>
-                <a:latin typeface="Helvetica Neue"/>
-                <a:ea typeface="Helvetica Neue"/>
-                <a:cs typeface="Helvetica Neue"/>
-              </a:rPr>
-              <a:t>Training absichern; m1_early prüfen; neue Testkarten zurückhalten.</a:t>
+              <a:t>Match 1 beschleunigen: Relics früher finden, auf neuen Testkarten prüfen.</a:t>
             </a:r>
           </a:p>
         </p:txBody>
@@ -8614,6 +8757,1060 @@
 </p:sld>
 </file>
 
+<file path=ppt/slides/slide15.xml><?xml version="1.0" encoding="utf-8"?>
+<p:sld xmlns:a="http://schemas.openxmlformats.org/drawingml/2006/main" xmlns:ns2="http://schemas.microsoft.com/office/drawing/2014/main" xmlns:ns3="http://schemas.microsoft.com/office/powerpoint/2010/main" xmlns:p="http://schemas.openxmlformats.org/presentationml/2006/main" show="0">
+  <p:cSld>
+    <p:bg>
+      <p:bgPr>
+        <a:solidFill>
+          <a:srgbClr val="F7F7F0"/>
+        </a:solidFill>
+      </p:bgPr>
+    </p:bg>
+    <p:spTree>
+      <p:nvGrpSpPr>
+        <p:cNvPr id="1" name=""/>
+        <p:cNvGrpSpPr/>
+        <p:nvPr/>
+      </p:nvGrpSpPr>
+      <p:grpSpPr>
+        <a:xfrm/>
+      </p:grpSpPr>
+      <p:sp>
+        <p:nvSpPr>
+          <p:cNvPr id="6" name="ANHANG · NUR FÜR RÜCKFRAGEN">
+            <a:extLst>
+              <a:ext uri="{FF2B5EF4-FFF2-40B4-BE49-F238E27FC236}">
+                <ns2:creationId id="{F34C4FBC-18B6-4CC2-A8C1-AE2938ADB76B}"/>
+              </a:ext>
+            </a:extLst>
+          </p:cNvPr>
+          <p:cNvSpPr>
+            <a:spLocks noGrp="1"/>
+          </p:cNvSpPr>
+          <p:nvPr/>
+        </p:nvSpPr>
+        <p:spPr>
+          <a:xfrm>
+            <a:off x="609600" y="266700"/>
+            <a:ext cx="8572500" cy="304800"/>
+          </a:xfrm>
+          <a:prstGeom prst="rect">
+            <a:avLst/>
+          </a:prstGeom>
+          <a:noFill/>
+          <a:ln w="0">
+            <a:noFill/>
+          </a:ln>
+        </p:spPr>
+        <p:txBody>
+          <a:bodyPr/>
+          <a:lstStyle>
+            <a:defPPr>
+              <a:defRPr sz="1350" b="1">
+                <a:solidFill>
+                  <a:srgbClr val="007D7B"/>
+                </a:solidFill>
+                <a:latin typeface="Helvetica Neue"/>
+                <a:ea typeface="Helvetica Neue"/>
+                <a:cs typeface="Helvetica Neue"/>
+              </a:defRPr>
+            </a:defPPr>
+          </a:lstStyle>
+          <a:p>
+            <a:pPr>
+              <a:defRPr sz="1350" b="1">
+                <a:solidFill>
+                  <a:srgbClr val="007D7B"/>
+                </a:solidFill>
+                <a:latin typeface="Helvetica Neue"/>
+                <a:ea typeface="Helvetica Neue"/>
+                <a:cs typeface="Helvetica Neue"/>
+              </a:defRPr>
+            </a:pPr>
+            <a:r>
+              <a:rPr sz="1350" b="1">
+                <a:solidFill>
+                  <a:srgbClr val="007D7B"/>
+                </a:solidFill>
+                <a:latin typeface="Helvetica Neue"/>
+                <a:ea typeface="Helvetica Neue"/>
+                <a:cs typeface="Helvetica Neue"/>
+              </a:rPr>
+              <a:t>ANHANG · NUR FÜR RÜCKFRAGEN</a:t>
+            </a:r>
+          </a:p>
+        </p:txBody>
+      </p:sp>
+      <p:sp>
+        <p:nvSpPr>
+          <p:cNvPr id="2" name="Trainingsparameter zum Nachschlagen">
+            <a:extLst>
+              <a:ext uri="{FF2B5EF4-FFF2-40B4-BE49-F238E27FC236}">
+                <ns2:creationId id="{854FBA0B-D65C-4E95-A0B3-B65B9DA638CE}"/>
+              </a:ext>
+            </a:extLst>
+          </p:cNvPr>
+          <p:cNvSpPr>
+            <a:spLocks noGrp="1"/>
+          </p:cNvSpPr>
+          <p:nvPr/>
+        </p:nvSpPr>
+        <p:spPr>
+          <a:xfrm>
+            <a:off x="609600" y="781050"/>
+            <a:ext cx="10972800" cy="1028700"/>
+          </a:xfrm>
+          <a:prstGeom prst="rect">
+            <a:avLst/>
+          </a:prstGeom>
+          <a:noFill/>
+          <a:ln w="0">
+            <a:noFill/>
+          </a:ln>
+        </p:spPr>
+        <p:txBody>
+          <a:bodyPr/>
+          <a:lstStyle>
+            <a:defPPr>
+              <a:defRPr sz="3300" b="1">
+                <a:solidFill>
+                  <a:srgbClr val="102D35"/>
+                </a:solidFill>
+                <a:latin typeface="Helvetica Neue"/>
+                <a:ea typeface="Helvetica Neue"/>
+                <a:cs typeface="Helvetica Neue"/>
+              </a:defRPr>
+            </a:defPPr>
+          </a:lstStyle>
+          <a:p>
+            <a:pPr>
+              <a:buNone/>
+              <a:defRPr sz="3300" b="1">
+                <a:solidFill>
+                  <a:srgbClr val="102D35"/>
+                </a:solidFill>
+                <a:latin typeface="Helvetica Neue"/>
+                <a:ea typeface="Helvetica Neue"/>
+                <a:cs typeface="Helvetica Neue"/>
+              </a:defRPr>
+            </a:pPr>
+            <a:r>
+              <a:rPr sz="3300" b="1">
+                <a:solidFill>
+                  <a:srgbClr val="102D35"/>
+                </a:solidFill>
+                <a:latin typeface="Helvetica Neue"/>
+                <a:ea typeface="Helvetica Neue"/>
+                <a:cs typeface="Helvetica Neue"/>
+              </a:rPr>
+              <a:t>Belohnung im Training</a:t>
+            </a:r>
+          </a:p>
+        </p:txBody>
+      </p:sp>
+      <p:sp>
+        <p:nvSpPr>
+          <p:cNvPr id="3" name="Team 15 · Mahmoud El-Hassan &amp; Moayed Shawesh">
+            <a:extLst>
+              <a:ext uri="{FF2B5EF4-FFF2-40B4-BE49-F238E27FC236}">
+                <ns2:creationId id="{14489D25-722B-49BF-BFE9-2288786330B5}"/>
+              </a:ext>
+            </a:extLst>
+          </p:cNvPr>
+          <p:cNvSpPr>
+            <a:spLocks noGrp="1"/>
+          </p:cNvSpPr>
+          <p:nvPr/>
+        </p:nvSpPr>
+        <p:spPr>
+          <a:xfrm>
+            <a:off x="609600" y="6419850"/>
+            <a:ext cx="9906000" cy="266700"/>
+          </a:xfrm>
+          <a:prstGeom prst="rect">
+            <a:avLst/>
+          </a:prstGeom>
+          <a:noFill/>
+          <a:ln w="0">
+            <a:noFill/>
+          </a:ln>
+        </p:spPr>
+        <p:txBody>
+          <a:bodyPr/>
+          <a:lstStyle>
+            <a:defPPr>
+              <a:defRPr sz="1200" b="0">
+                <a:solidFill>
+                  <a:srgbClr val="526B70"/>
+                </a:solidFill>
+                <a:latin typeface="Helvetica Neue"/>
+                <a:ea typeface="Helvetica Neue"/>
+                <a:cs typeface="Helvetica Neue"/>
+              </a:defRPr>
+            </a:defPPr>
+          </a:lstStyle>
+          <a:p>
+            <a:pPr>
+              <a:defRPr sz="1200" b="0">
+                <a:solidFill>
+                  <a:srgbClr val="526B70"/>
+                </a:solidFill>
+                <a:latin typeface="Helvetica Neue"/>
+                <a:ea typeface="Helvetica Neue"/>
+                <a:cs typeface="Helvetica Neue"/>
+              </a:defRPr>
+            </a:pPr>
+            <a:r>
+              <a:rPr sz="1200" b="0">
+                <a:solidFill>
+                  <a:srgbClr val="526B70"/>
+                </a:solidFill>
+                <a:latin typeface="Helvetica Neue"/>
+                <a:ea typeface="Helvetica Neue"/>
+                <a:cs typeface="Helvetica Neue"/>
+              </a:rPr>
+              <a:t>Team 15 · Mahmoud El-Hassan &amp; Moayed Shawesh</a:t>
+            </a:r>
+          </a:p>
+        </p:txBody>
+      </p:sp>
+      <p:sp>
+        <p:nvSpPr>
+          <p:cNvPr id="4" name="12">
+            <a:extLst>
+              <a:ext uri="{FF2B5EF4-FFF2-40B4-BE49-F238E27FC236}">
+                <ns2:creationId id="{8F02A6D8-B2DE-4687-AA59-00FEB49481AD}"/>
+              </a:ext>
+            </a:extLst>
+          </p:cNvPr>
+          <p:cNvSpPr>
+            <a:spLocks noGrp="1"/>
+          </p:cNvSpPr>
+          <p:nvPr/>
+        </p:nvSpPr>
+        <p:spPr>
+          <a:xfrm>
+            <a:off x="11049000" y="6419850"/>
+            <a:ext cx="533400" cy="266700"/>
+          </a:xfrm>
+          <a:prstGeom prst="rect">
+            <a:avLst/>
+          </a:prstGeom>
+          <a:noFill/>
+          <a:ln w="0">
+            <a:noFill/>
+          </a:ln>
+        </p:spPr>
+        <p:txBody>
+          <a:bodyPr/>
+          <a:lstStyle>
+            <a:defPPr>
+              <a:defRPr sz="1200" b="0">
+                <a:solidFill>
+                  <a:srgbClr val="526B70"/>
+                </a:solidFill>
+                <a:latin typeface="Helvetica Neue"/>
+                <a:ea typeface="Helvetica Neue"/>
+                <a:cs typeface="Helvetica Neue"/>
+              </a:defRPr>
+            </a:defPPr>
+          </a:lstStyle>
+          <a:p>
+            <a:pPr>
+              <a:defRPr sz="1200" b="0">
+                <a:solidFill>
+                  <a:srgbClr val="526B70"/>
+                </a:solidFill>
+                <a:latin typeface="Helvetica Neue"/>
+                <a:ea typeface="Helvetica Neue"/>
+                <a:cs typeface="Helvetica Neue"/>
+              </a:defRPr>
+            </a:pPr>
+            <a:r>
+              <a:rPr sz="1200" b="0">
+                <a:solidFill>
+                  <a:srgbClr val="526B70"/>
+                </a:solidFill>
+                <a:latin typeface="Helvetica Neue"/>
+                <a:ea typeface="Helvetica Neue"/>
+                <a:cs typeface="Helvetica Neue"/>
+              </a:rPr>
+              <a:t>15</a:t>
+            </a:r>
+          </a:p>
+        </p:txBody>
+      </p:sp>
+      <p:graphicFrame>
+        <p:nvGraphicFramePr>
+          <p:cNvPr id="5" name="">
+            <a:extLst>
+              <a:ext uri="{FF2B5EF4-FFF2-40B4-BE49-F238E27FC236}">
+                <ns2:creationId id="{F2640AFA-9FE6-443F-9020-275C98B0F2D7}"/>
+              </a:ext>
+            </a:extLst>
+          </p:cNvPr>
+          <p:cNvGraphicFramePr/>
+          <p:nvPr/>
+        </p:nvGraphicFramePr>
+        <p:xfrm>
+          <a:off x="609600" y="1943100"/>
+          <a:ext cx="10972800" cy="3943350"/>
+        </p:xfrm>
+        <a:graphic>
+          <a:graphicData uri="http://schemas.openxmlformats.org/drawingml/2006/table">
+            <a:tbl>
+              <a:tblPr/>
+              <a:tblGrid>
+                <a:gridCol w="7315200"/>
+                <a:gridCol w="3657600"/>
+              </a:tblGrid>
+              <a:tr h="438150">
+                <a:tc>
+                  <a:txBody>
+                    <a:bodyPr/>
+                    <a:lstStyle/>
+                    <a:p>
+                      <a:r>
+                        <a:rPr sz="1950" b="1">
+                          <a:solidFill>
+                            <a:srgbClr val="FFFFFF"/>
+                          </a:solidFill>
+                          <a:latin typeface="Helvetica Neue"/>
+                          <a:ea typeface="Helvetica Neue"/>
+                          <a:cs typeface="Helvetica Neue"/>
+                        </a:rPr>
+                        <a:t>Signal je Einheit und Schritt</a:t>
+                      </a:r>
+                    </a:p>
+                  </a:txBody>
+                  <a:tcPr marL="91440" marR="91440" marT="45720" marB="45720">
+                    <a:lnL w="9525">
+                      <a:solidFill>
+                        <a:srgbClr val="CFDBD7"/>
+                      </a:solidFill>
+                      <a:prstDash val="solid"/>
+                    </a:lnL>
+                    <a:lnR w="9525">
+                      <a:solidFill>
+                        <a:srgbClr val="CFDBD7"/>
+                      </a:solidFill>
+                      <a:prstDash val="solid"/>
+                    </a:lnR>
+                    <a:lnT w="9525">
+                      <a:solidFill>
+                        <a:srgbClr val="CFDBD7"/>
+                      </a:solidFill>
+                      <a:prstDash val="solid"/>
+                    </a:lnT>
+                    <a:lnB w="9525">
+                      <a:solidFill>
+                        <a:srgbClr val="CFDBD7"/>
+                      </a:solidFill>
+                      <a:prstDash val="solid"/>
+                    </a:lnB>
+                    <a:solidFill>
+                      <a:srgbClr val="102D35"/>
+                    </a:solidFill>
+                  </a:tcPr>
+                </a:tc>
+                <a:tc>
+                  <a:txBody>
+                    <a:bodyPr/>
+                    <a:lstStyle/>
+                    <a:p>
+                      <a:r>
+                        <a:rPr sz="1950" b="1">
+                          <a:solidFill>
+                            <a:srgbClr val="FFFFFF"/>
+                          </a:solidFill>
+                          <a:latin typeface="Helvetica Neue"/>
+                          <a:ea typeface="Helvetica Neue"/>
+                          <a:cs typeface="Helvetica Neue"/>
+                        </a:rPr>
+                        <a:t>Gewicht</a:t>
+                      </a:r>
+                    </a:p>
+                  </a:txBody>
+                  <a:tcPr marL="91440" marR="91440" marT="45720" marB="45720">
+                    <a:lnR w="9525">
+                      <a:solidFill>
+                        <a:srgbClr val="CFDBD7"/>
+                      </a:solidFill>
+                      <a:prstDash val="solid"/>
+                    </a:lnR>
+                    <a:lnT w="9525">
+                      <a:solidFill>
+                        <a:srgbClr val="CFDBD7"/>
+                      </a:solidFill>
+                      <a:prstDash val="solid"/>
+                    </a:lnT>
+                    <a:lnB w="9525">
+                      <a:solidFill>
+                        <a:srgbClr val="CFDBD7"/>
+                      </a:solidFill>
+                      <a:prstDash val="solid"/>
+                    </a:lnB>
+                    <a:solidFill>
+                      <a:srgbClr val="102D35"/>
+                    </a:solidFill>
+                  </a:tcPr>
+                </a:tc>
+              </a:tr>
+              <a:tr h="438150">
+                <a:tc>
+                  <a:txBody>
+                    <a:bodyPr/>
+                    <a:lstStyle/>
+                    <a:p>
+                      <a:r>
+                        <a:rPr sz="1950" b="0">
+                          <a:solidFill>
+                            <a:srgbClr val="102D35"/>
+                          </a:solidFill>
+                          <a:latin typeface="Helvetica Neue"/>
+                          <a:ea typeface="Helvetica Neue"/>
+                          <a:cs typeface="Helvetica Neue"/>
+                        </a:rPr>
+                        <a:t>Erste Einheit auf bewiesenem Punktefeld</a:t>
+                      </a:r>
+                    </a:p>
+                  </a:txBody>
+                  <a:tcPr marL="91440" marR="91440" marT="45720" marB="45720">
+                    <a:lnL w="9525">
+                      <a:solidFill>
+                        <a:srgbClr val="CFDBD7"/>
+                      </a:solidFill>
+                      <a:prstDash val="solid"/>
+                    </a:lnL>
+                    <a:lnR w="9525">
+                      <a:solidFill>
+                        <a:srgbClr val="CFDBD7"/>
+                      </a:solidFill>
+                      <a:prstDash val="solid"/>
+                    </a:lnR>
+                    <a:lnB w="9525">
+                      <a:solidFill>
+                        <a:srgbClr val="CFDBD7"/>
+                      </a:solidFill>
+                      <a:prstDash val="solid"/>
+                    </a:lnB>
+                    <a:solidFill>
+                      <a:srgbClr val="FFFFFF"/>
+                    </a:solidFill>
+                  </a:tcPr>
+                </a:tc>
+                <a:tc>
+                  <a:txBody>
+                    <a:bodyPr/>
+                    <a:lstStyle/>
+                    <a:p>
+                      <a:r>
+                        <a:rPr sz="1950" b="0">
+                          <a:solidFill>
+                            <a:srgbClr val="102D35"/>
+                          </a:solidFill>
+                          <a:latin typeface="Helvetica Neue"/>
+                          <a:ea typeface="Helvetica Neue"/>
+                          <a:cs typeface="Helvetica Neue"/>
+                        </a:rPr>
+                        <a:t>+1,0</a:t>
+                      </a:r>
+                    </a:p>
+                  </a:txBody>
+                  <a:tcPr marL="91440" marR="91440" marT="45720" marB="45720">
+                    <a:lnR w="9525">
+                      <a:solidFill>
+                        <a:srgbClr val="CFDBD7"/>
+                      </a:solidFill>
+                      <a:prstDash val="solid"/>
+                    </a:lnR>
+                    <a:lnB w="9525">
+                      <a:solidFill>
+                        <a:srgbClr val="CFDBD7"/>
+                      </a:solidFill>
+                      <a:prstDash val="solid"/>
+                    </a:lnB>
+                    <a:solidFill>
+                      <a:srgbClr val="FFFFFF"/>
+                    </a:solidFill>
+                  </a:tcPr>
+                </a:tc>
+              </a:tr>
+              <a:tr h="438150">
+                <a:tc>
+                  <a:txBody>
+                    <a:bodyPr/>
+                    <a:lstStyle/>
+                    <a:p>
+                      <a:r>
+                        <a:rPr sz="1950" b="0">
+                          <a:solidFill>
+                            <a:srgbClr val="102D35"/>
+                          </a:solidFill>
+                          <a:latin typeface="Helvetica Neue"/>
+                          <a:ea typeface="Helvetica Neue"/>
+                          <a:cs typeface="Helvetica Neue"/>
+                        </a:rPr>
+                        <a:t>Weitere Einheit auf demselben Punktefeld</a:t>
+                      </a:r>
+                    </a:p>
+                  </a:txBody>
+                  <a:tcPr marL="91440" marR="91440" marT="45720" marB="45720">
+                    <a:lnL w="9525">
+                      <a:solidFill>
+                        <a:srgbClr val="CFDBD7"/>
+                      </a:solidFill>
+                      <a:prstDash val="solid"/>
+                    </a:lnL>
+                    <a:lnR w="9525">
+                      <a:solidFill>
+                        <a:srgbClr val="CFDBD7"/>
+                      </a:solidFill>
+                      <a:prstDash val="solid"/>
+                    </a:lnR>
+                    <a:lnB w="9525">
+                      <a:solidFill>
+                        <a:srgbClr val="CFDBD7"/>
+                      </a:solidFill>
+                      <a:prstDash val="solid"/>
+                    </a:lnB>
+                    <a:solidFill>
+                      <a:srgbClr val="EDF2ED"/>
+                    </a:solidFill>
+                  </a:tcPr>
+                </a:tc>
+                <a:tc>
+                  <a:txBody>
+                    <a:bodyPr/>
+                    <a:lstStyle/>
+                    <a:p>
+                      <a:r>
+                        <a:rPr sz="1950" b="0">
+                          <a:solidFill>
+                            <a:srgbClr val="102D35"/>
+                          </a:solidFill>
+                          <a:latin typeface="Helvetica Neue"/>
+                          <a:ea typeface="Helvetica Neue"/>
+                          <a:cs typeface="Helvetica Neue"/>
+                        </a:rPr>
+                        <a:t>−0,3</a:t>
+                      </a:r>
+                    </a:p>
+                  </a:txBody>
+                  <a:tcPr marL="91440" marR="91440" marT="45720" marB="45720">
+                    <a:lnR w="9525">
+                      <a:solidFill>
+                        <a:srgbClr val="CFDBD7"/>
+                      </a:solidFill>
+                      <a:prstDash val="solid"/>
+                    </a:lnR>
+                    <a:lnB w="9525">
+                      <a:solidFill>
+                        <a:srgbClr val="CFDBD7"/>
+                      </a:solidFill>
+                      <a:prstDash val="solid"/>
+                    </a:lnB>
+                    <a:solidFill>
+                      <a:srgbClr val="EDF2ED"/>
+                    </a:solidFill>
+                  </a:tcPr>
+                </a:tc>
+              </a:tr>
+              <a:tr h="438150">
+                <a:tc>
+                  <a:txBody>
+                    <a:bodyPr/>
+                    <a:lstStyle/>
+                    <a:p>
+                      <a:r>
+                        <a:rPr sz="1950" b="0">
+                          <a:solidFill>
+                            <a:srgbClr val="102D35"/>
+                          </a:solidFill>
+                          <a:latin typeface="Helvetica Neue"/>
+                          <a:ea typeface="Helvetica Neue"/>
+                          <a:cs typeface="Helvetica Neue"/>
+                        </a:rPr>
+                        <a:t>Annäherung an zugewiesenes Ziel (potentialbasiert)</a:t>
+                      </a:r>
+                    </a:p>
+                  </a:txBody>
+                  <a:tcPr marL="91440" marR="91440" marT="45720" marB="45720">
+                    <a:lnL w="9525">
+                      <a:solidFill>
+                        <a:srgbClr val="CFDBD7"/>
+                      </a:solidFill>
+                      <a:prstDash val="solid"/>
+                    </a:lnL>
+                    <a:lnR w="9525">
+                      <a:solidFill>
+                        <a:srgbClr val="CFDBD7"/>
+                      </a:solidFill>
+                      <a:prstDash val="solid"/>
+                    </a:lnR>
+                    <a:lnB w="9525">
+                      <a:solidFill>
+                        <a:srgbClr val="CFDBD7"/>
+                      </a:solidFill>
+                      <a:prstDash val="solid"/>
+                    </a:lnB>
+                    <a:solidFill>
+                      <a:srgbClr val="FFFFFF"/>
+                    </a:solidFill>
+                  </a:tcPr>
+                </a:tc>
+                <a:tc>
+                  <a:txBody>
+                    <a:bodyPr/>
+                    <a:lstStyle/>
+                    <a:p>
+                      <a:r>
+                        <a:rPr sz="1950" b="0">
+                          <a:solidFill>
+                            <a:srgbClr val="102D35"/>
+                          </a:solidFill>
+                          <a:latin typeface="Helvetica Neue"/>
+                          <a:ea typeface="Helvetica Neue"/>
+                          <a:cs typeface="Helvetica Neue"/>
+                        </a:rPr>
+                        <a:t>0,5</a:t>
+                      </a:r>
+                    </a:p>
+                  </a:txBody>
+                  <a:tcPr marL="91440" marR="91440" marT="45720" marB="45720">
+                    <a:lnR w="9525">
+                      <a:solidFill>
+                        <a:srgbClr val="CFDBD7"/>
+                      </a:solidFill>
+                      <a:prstDash val="solid"/>
+                    </a:lnR>
+                    <a:lnB w="9525">
+                      <a:solidFill>
+                        <a:srgbClr val="CFDBD7"/>
+                      </a:solidFill>
+                      <a:prstDash val="solid"/>
+                    </a:lnB>
+                    <a:solidFill>
+                      <a:srgbClr val="FFFFFF"/>
+                    </a:solidFill>
+                  </a:tcPr>
+                </a:tc>
+              </a:tr>
+              <a:tr h="438150">
+                <a:tc>
+                  <a:txBody>
+                    <a:bodyPr/>
+                    <a:lstStyle/>
+                    <a:p>
+                      <a:r>
+                        <a:rPr sz="1950" b="0">
+                          <a:solidFill>
+                            <a:srgbClr val="102D35"/>
+                          </a:solidFill>
+                          <a:latin typeface="Helvetica Neue"/>
+                          <a:ea typeface="Helvetica Neue"/>
+                          <a:cs typeface="Helvetica Neue"/>
+                        </a:rPr>
+                        <a:t>Neu erkundete Felder / neue Punktefelder (Team)</a:t>
+                      </a:r>
+                    </a:p>
+                  </a:txBody>
+                  <a:tcPr marL="91440" marR="91440" marT="45720" marB="45720">
+                    <a:lnL w="9525">
+                      <a:solidFill>
+                        <a:srgbClr val="CFDBD7"/>
+                      </a:solidFill>
+                      <a:prstDash val="solid"/>
+                    </a:lnL>
+                    <a:lnR w="9525">
+                      <a:solidFill>
+                        <a:srgbClr val="CFDBD7"/>
+                      </a:solidFill>
+                      <a:prstDash val="solid"/>
+                    </a:lnR>
+                    <a:lnB w="9525">
+                      <a:solidFill>
+                        <a:srgbClr val="CFDBD7"/>
+                      </a:solidFill>
+                      <a:prstDash val="solid"/>
+                    </a:lnB>
+                    <a:solidFill>
+                      <a:srgbClr val="EDF2ED"/>
+                    </a:solidFill>
+                  </a:tcPr>
+                </a:tc>
+                <a:tc>
+                  <a:txBody>
+                    <a:bodyPr/>
+                    <a:lstStyle/>
+                    <a:p>
+                      <a:r>
+                        <a:rPr sz="1950" b="0">
+                          <a:solidFill>
+                            <a:srgbClr val="102D35"/>
+                          </a:solidFill>
+                          <a:latin typeface="Helvetica Neue"/>
+                          <a:ea typeface="Helvetica Neue"/>
+                          <a:cs typeface="Helvetica Neue"/>
+                        </a:rPr>
+                        <a:t>+0,3 / +0,5</a:t>
+                      </a:r>
+                    </a:p>
+                  </a:txBody>
+                  <a:tcPr marL="91440" marR="91440" marT="45720" marB="45720">
+                    <a:lnR w="9525">
+                      <a:solidFill>
+                        <a:srgbClr val="CFDBD7"/>
+                      </a:solidFill>
+                      <a:prstDash val="solid"/>
+                    </a:lnR>
+                    <a:lnB w="9525">
+                      <a:solidFill>
+                        <a:srgbClr val="CFDBD7"/>
+                      </a:solidFill>
+                      <a:prstDash val="solid"/>
+                    </a:lnB>
+                    <a:solidFill>
+                      <a:srgbClr val="EDF2ED"/>
+                    </a:solidFill>
+                  </a:tcPr>
+                </a:tc>
+              </a:tr>
+              <a:tr h="438150">
+                <a:tc>
+                  <a:txBody>
+                    <a:bodyPr/>
+                    <a:lstStyle/>
+                    <a:p>
+                      <a:r>
+                        <a:rPr sz="1950" b="0">
+                          <a:solidFill>
+                            <a:srgbClr val="102D35"/>
+                          </a:solidFill>
+                          <a:latin typeface="Helvetica Neue"/>
+                          <a:ea typeface="Helvetica Neue"/>
+                          <a:cs typeface="Helvetica Neue"/>
+                        </a:rPr>
+                        <a:t>Energieänderung (÷ 400)</a:t>
+                      </a:r>
+                    </a:p>
+                  </a:txBody>
+                  <a:tcPr marL="91440" marR="91440" marT="45720" marB="45720">
+                    <a:lnL w="9525">
+                      <a:solidFill>
+                        <a:srgbClr val="CFDBD7"/>
+                      </a:solidFill>
+                      <a:prstDash val="solid"/>
+                    </a:lnL>
+                    <a:lnR w="9525">
+                      <a:solidFill>
+                        <a:srgbClr val="CFDBD7"/>
+                      </a:solidFill>
+                      <a:prstDash val="solid"/>
+                    </a:lnR>
+                    <a:lnB w="9525">
+                      <a:solidFill>
+                        <a:srgbClr val="CFDBD7"/>
+                      </a:solidFill>
+                      <a:prstDash val="solid"/>
+                    </a:lnB>
+                    <a:solidFill>
+                      <a:srgbClr val="FFFFFF"/>
+                    </a:solidFill>
+                  </a:tcPr>
+                </a:tc>
+                <a:tc>
+                  <a:txBody>
+                    <a:bodyPr/>
+                    <a:lstStyle/>
+                    <a:p>
+                      <a:r>
+                        <a:rPr sz="1950" b="0">
+                          <a:solidFill>
+                            <a:srgbClr val="102D35"/>
+                          </a:solidFill>
+                          <a:latin typeface="Helvetica Neue"/>
+                          <a:ea typeface="Helvetica Neue"/>
+                          <a:cs typeface="Helvetica Neue"/>
+                        </a:rPr>
+                        <a:t>0,1</a:t>
+                      </a:r>
+                    </a:p>
+                  </a:txBody>
+                  <a:tcPr marL="91440" marR="91440" marT="45720" marB="45720">
+                    <a:lnR w="9525">
+                      <a:solidFill>
+                        <a:srgbClr val="CFDBD7"/>
+                      </a:solidFill>
+                      <a:prstDash val="solid"/>
+                    </a:lnR>
+                    <a:lnB w="9525">
+                      <a:solidFill>
+                        <a:srgbClr val="CFDBD7"/>
+                      </a:solidFill>
+                      <a:prstDash val="solid"/>
+                    </a:lnB>
+                    <a:solidFill>
+                      <a:srgbClr val="FFFFFF"/>
+                    </a:solidFill>
+                  </a:tcPr>
+                </a:tc>
+              </a:tr>
+              <a:tr h="438150">
+                <a:tc>
+                  <a:txBody>
+                    <a:bodyPr/>
+                    <a:lstStyle/>
+                    <a:p>
+                      <a:r>
+                        <a:rPr sz="1950" b="0">
+                          <a:solidFill>
+                            <a:srgbClr val="102D35"/>
+                          </a:solidFill>
+                          <a:latin typeface="Helvetica Neue"/>
+                          <a:ea typeface="Helvetica Neue"/>
+                          <a:cs typeface="Helvetica Neue"/>
+                        </a:rPr>
+                        <a:t>Einheit verloren</a:t>
+                      </a:r>
+                    </a:p>
+                  </a:txBody>
+                  <a:tcPr marL="91440" marR="91440" marT="45720" marB="45720">
+                    <a:lnL w="9525">
+                      <a:solidFill>
+                        <a:srgbClr val="CFDBD7"/>
+                      </a:solidFill>
+                      <a:prstDash val="solid"/>
+                    </a:lnL>
+                    <a:lnR w="9525">
+                      <a:solidFill>
+                        <a:srgbClr val="CFDBD7"/>
+                      </a:solidFill>
+                      <a:prstDash val="solid"/>
+                    </a:lnR>
+                    <a:lnB w="9525">
+                      <a:solidFill>
+                        <a:srgbClr val="CFDBD7"/>
+                      </a:solidFill>
+                      <a:prstDash val="solid"/>
+                    </a:lnB>
+                    <a:solidFill>
+                      <a:srgbClr val="EDF2ED"/>
+                    </a:solidFill>
+                  </a:tcPr>
+                </a:tc>
+                <a:tc>
+                  <a:txBody>
+                    <a:bodyPr/>
+                    <a:lstStyle/>
+                    <a:p>
+                      <a:r>
+                        <a:rPr sz="1950" b="0">
+                          <a:solidFill>
+                            <a:srgbClr val="102D35"/>
+                          </a:solidFill>
+                          <a:latin typeface="Helvetica Neue"/>
+                          <a:ea typeface="Helvetica Neue"/>
+                          <a:cs typeface="Helvetica Neue"/>
+                        </a:rPr>
+                        <a:t>−0,5</a:t>
+                      </a:r>
+                    </a:p>
+                  </a:txBody>
+                  <a:tcPr marL="91440" marR="91440" marT="45720" marB="45720">
+                    <a:lnR w="9525">
+                      <a:solidFill>
+                        <a:srgbClr val="CFDBD7"/>
+                      </a:solidFill>
+                      <a:prstDash val="solid"/>
+                    </a:lnR>
+                    <a:lnB w="9525">
+                      <a:solidFill>
+                        <a:srgbClr val="CFDBD7"/>
+                      </a:solidFill>
+                      <a:prstDash val="solid"/>
+                    </a:lnB>
+                    <a:solidFill>
+                      <a:srgbClr val="EDF2ED"/>
+                    </a:solidFill>
+                  </a:tcPr>
+                </a:tc>
+              </a:tr>
+              <a:tr h="438150">
+                <a:tc>
+                  <a:txBody>
+                    <a:bodyPr/>
+                    <a:lstStyle/>
+                    <a:p>
+                      <a:r>
+                        <a:rPr sz="1950" b="0">
+                          <a:solidFill>
+                            <a:srgbClr val="102D35"/>
+                          </a:solidFill>
+                          <a:latin typeface="Helvetica Neue"/>
+                          <a:ea typeface="Helvetica Neue"/>
+                          <a:cs typeface="Helvetica Neue"/>
+                        </a:rPr>
+                        <a:t>Sap: je Treffer / Fehlschuss</a:t>
+                      </a:r>
+                    </a:p>
+                  </a:txBody>
+                  <a:tcPr marL="91440" marR="91440" marT="45720" marB="45720">
+                    <a:lnL w="9525">
+                      <a:solidFill>
+                        <a:srgbClr val="CFDBD7"/>
+                      </a:solidFill>
+                      <a:prstDash val="solid"/>
+                    </a:lnL>
+                    <a:lnR w="9525">
+                      <a:solidFill>
+                        <a:srgbClr val="CFDBD7"/>
+                      </a:solidFill>
+                      <a:prstDash val="solid"/>
+                    </a:lnR>
+                    <a:lnB w="9525">
+                      <a:solidFill>
+                        <a:srgbClr val="CFDBD7"/>
+                      </a:solidFill>
+                      <a:prstDash val="solid"/>
+                    </a:lnB>
+                    <a:solidFill>
+                      <a:srgbClr val="FFFFFF"/>
+                    </a:solidFill>
+                  </a:tcPr>
+                </a:tc>
+                <a:tc>
+                  <a:txBody>
+                    <a:bodyPr/>
+                    <a:lstStyle/>
+                    <a:p>
+                      <a:r>
+                        <a:rPr sz="1950" b="0">
+                          <a:solidFill>
+                            <a:srgbClr val="102D35"/>
+                          </a:solidFill>
+                          <a:latin typeface="Helvetica Neue"/>
+                          <a:ea typeface="Helvetica Neue"/>
+                          <a:cs typeface="Helvetica Neue"/>
+                        </a:rPr>
+                        <a:t>+0,3 / −0,3</a:t>
+                      </a:r>
+                    </a:p>
+                  </a:txBody>
+                  <a:tcPr marL="91440" marR="91440" marT="45720" marB="45720">
+                    <a:lnR w="9525">
+                      <a:solidFill>
+                        <a:srgbClr val="CFDBD7"/>
+                      </a:solidFill>
+                      <a:prstDash val="solid"/>
+                    </a:lnR>
+                    <a:lnB w="9525">
+                      <a:solidFill>
+                        <a:srgbClr val="CFDBD7"/>
+                      </a:solidFill>
+                      <a:prstDash val="solid"/>
+                    </a:lnB>
+                    <a:solidFill>
+                      <a:srgbClr val="FFFFFF"/>
+                    </a:solidFill>
+                  </a:tcPr>
+                </a:tc>
+              </a:tr>
+              <a:tr h="438150">
+                <a:tc>
+                  <a:txBody>
+                    <a:bodyPr/>
+                    <a:lstStyle/>
+                    <a:p>
+                      <a:r>
+                        <a:rPr sz="1950" b="0">
+                          <a:solidFill>
+                            <a:srgbClr val="102D35"/>
+                          </a:solidFill>
+                          <a:latin typeface="Helvetica Neue"/>
+                          <a:ea typeface="Helvetica Neue"/>
+                          <a:cs typeface="Helvetica Neue"/>
+                        </a:rPr>
+                        <a:t>Match gewonnen / verloren</a:t>
+                      </a:r>
+                    </a:p>
+                  </a:txBody>
+                  <a:tcPr marL="91440" marR="91440" marT="45720" marB="45720">
+                    <a:lnL w="9525">
+                      <a:solidFill>
+                        <a:srgbClr val="CFDBD7"/>
+                      </a:solidFill>
+                      <a:prstDash val="solid"/>
+                    </a:lnL>
+                    <a:lnR w="9525">
+                      <a:solidFill>
+                        <a:srgbClr val="CFDBD7"/>
+                      </a:solidFill>
+                      <a:prstDash val="solid"/>
+                    </a:lnR>
+                    <a:lnB w="9525">
+                      <a:solidFill>
+                        <a:srgbClr val="CFDBD7"/>
+                      </a:solidFill>
+                      <a:prstDash val="solid"/>
+                    </a:lnB>
+                    <a:solidFill>
+                      <a:srgbClr val="EDF2ED"/>
+                    </a:solidFill>
+                  </a:tcPr>
+                </a:tc>
+                <a:tc>
+                  <a:txBody>
+                    <a:bodyPr/>
+                    <a:lstStyle/>
+                    <a:p>
+                      <a:r>
+                        <a:rPr sz="1950" b="0">
+                          <a:solidFill>
+                            <a:srgbClr val="102D35"/>
+                          </a:solidFill>
+                          <a:latin typeface="Helvetica Neue"/>
+                          <a:ea typeface="Helvetica Neue"/>
+                          <a:cs typeface="Helvetica Neue"/>
+                        </a:rPr>
+                        <a:t>+2,0 / −2,0</a:t>
+                      </a:r>
+                    </a:p>
+                  </a:txBody>
+                  <a:tcPr marL="91440" marR="91440" marT="45720" marB="45720">
+                    <a:lnR w="9525">
+                      <a:solidFill>
+                        <a:srgbClr val="CFDBD7"/>
+                      </a:solidFill>
+                      <a:prstDash val="solid"/>
+                    </a:lnR>
+                    <a:lnB w="9525">
+                      <a:solidFill>
+                        <a:srgbClr val="CFDBD7"/>
+                      </a:solidFill>
+                      <a:prstDash val="solid"/>
+                    </a:lnB>
+                    <a:solidFill>
+                      <a:srgbClr val="EDF2ED"/>
+                    </a:solidFill>
+                  </a:tcPr>
+                </a:tc>
+              </a:tr>
+            </a:tbl>
+          </a:graphicData>
+        </a:graphic>
+      </p:graphicFrame>
+    </p:spTree>
+    <p:extLst>
+      <p:ext uri="{BB962C8B-B14F-4D97-AF65-F5344CB8AC3E}">
+        <ns3:creationId val="1610201515"/>
+      </p:ext>
+    </p:extLst>
+  </p:cSld>
+</p:sld>
+</file>
+
 <file path=ppt/slides/slide2.xml><?xml version="1.0" encoding="utf-8"?>
 <p:sld xmlns:p="http://schemas.openxmlformats.org/presentationml/2006/main">
   <p:cSld>
@@ -10240,7 +11437,7 @@
                 <a:ea typeface="Helvetica Neue"/>
                 <a:cs typeface="Helvetica Neue"/>
               </a:rPr>
-              <a:t>Punkten: geeignete Felder besetzen</a:t>
+              <a:t>Punkten: unsichtbare Felder besetzen</a:t>
             </a:r>
           </a:p>
         </p:txBody>
@@ -12567,7 +13764,7 @@
       </p:graphicFrame>
       <p:sp>
         <p:nvSpPr>
-          <p:cNvPr id="6" name="Belief: aus Beobachtungen Wissen über die Kar">
+          <p:cNvPr id="6" name="Belief: aus dem Punktezuwachs ableiten">
             <a:extLst>
               <a:ext uri="{FF2B5EF4-FFF2-40B4-BE49-F238E27FC236}">
                 <ns2:creationId id="{7BB15468-0F41-4F95-B835-1637FFF8AD61}"/>
@@ -12626,7 +13823,7 @@
                 <a:ea typeface="Helvetica Neue"/>
                 <a:cs typeface="Helvetica Neue"/>
               </a:rPr>
-              <a:t>Belief: aus Beobachtungen Wissen über die Karte ableiten.</a:t>
+              <a:t>Belief: aus dem Punktezuwachs ableiten, welche Felder Punkte bringen.</a:t>
             </a:r>
           </a:p>
         </p:txBody>
@@ -13454,7 +14651,7 @@
       </p:graphicFrame>
       <p:sp>
         <p:nvSpPr>
-          <p:cNvPr id="8" name="Ensemble: 3 × full + 3 × full_sym → Q-Mittelw">
+          <p:cNvPr id="8" name="Ensemble: 6 Netze → Q-Mittelwert">
             <a:extLst>
               <a:ext uri="{FF2B5EF4-FFF2-40B4-BE49-F238E27FC236}">
                 <ns2:creationId id="{DD4376FB-0FF7-4608-9C9E-293F0DA546E3}"/>
@@ -13513,7 +14710,7 @@
                 <a:ea typeface="Helvetica Neue"/>
                 <a:cs typeface="Helvetica Neue"/>
               </a:rPr>
-              <a:t>Ensemble: 3 × full + 3 × full_sym → Q-Mittelwert → Aktionsmaske</a:t>
+              <a:t>Ensemble: 6 Netze (3 + 3 mit Symmetrie) → Q-Mittelwert → Aktionsmaske</a:t>
             </a:r>
           </a:p>
         </p:txBody>

</xml_diff>